<commit_message>
style: switch sales meeting to white base + record workflow in CLAUDE.md
- HTML/PPTX both updated to white background with blue accent
- CLAUDE.md: added 営業会議スライド section with design rules and workflow

https://claude.ai/code/session_013LUtg8kZ6SCk9upzYYqLj7
</commit_message>
<xml_diff>
--- a/slides/exports/sales-meeting.pptx
+++ b/slides/exports/sales-meeting.pptx
@@ -1302,7 +1302,7 @@
     <p:bg>
       <p:bgPr>
         <a:solidFill>
-          <a:srgbClr val="0F1B2D"/>
+          <a:srgbClr val="FFFFFF"/>
         </a:solidFill>
       </p:bgPr>
     </p:bg>
@@ -1335,7 +1335,7 @@
             <a:avLst/>
           </a:prstGeom>
           <a:solidFill>
-            <a:srgbClr val="3B82F6"/>
+            <a:srgbClr val="2563EB"/>
           </a:solidFill>
           <a:ln/>
         </p:spPr>
@@ -1355,7 +1355,7 @@
             <a:avLst/>
           </a:prstGeom>
           <a:solidFill>
-            <a:srgbClr val="3B82F6"/>
+            <a:srgbClr val="2563EB"/>
           </a:solidFill>
           <a:ln/>
         </p:spPr>
@@ -1375,7 +1375,7 @@
             <a:avLst/>
           </a:prstGeom>
           <a:solidFill>
-            <a:srgbClr val="3B82F6"/>
+            <a:srgbClr val="2563EB"/>
           </a:solidFill>
           <a:ln/>
         </p:spPr>
@@ -1446,7 +1446,7 @@
             <a:r>
               <a:rPr lang="en-US" sz="6200" b="1" dirty="0">
                 <a:solidFill>
-                  <a:srgbClr val="E8F4FF"/>
+                  <a:srgbClr val="1A1A2E"/>
                 </a:solidFill>
                 <a:latin typeface="游ゴシック" pitchFamily="34" charset="0"/>
                 <a:ea typeface="游ゴシック" pitchFamily="34" charset="-122"/>
@@ -1485,7 +1485,7 @@
             <a:r>
               <a:rPr lang="en-US" sz="2000" dirty="0">
                 <a:solidFill>
-                  <a:srgbClr val="8094B4"/>
+                  <a:srgbClr val="6B7280"/>
                 </a:solidFill>
                 <a:latin typeface="游ゴシック" pitchFamily="34" charset="0"/>
                 <a:ea typeface="游ゴシック" pitchFamily="34" charset="-122"/>
@@ -1524,7 +1524,7 @@
             <a:r>
               <a:rPr lang="en-US" sz="1400" dirty="0">
                 <a:solidFill>
-                  <a:srgbClr val="8094B4"/>
+                  <a:srgbClr val="6B7280"/>
                 </a:solidFill>
                 <a:latin typeface="游ゴシック" pitchFamily="34" charset="0"/>
                 <a:ea typeface="游ゴシック" pitchFamily="34" charset="-122"/>
@@ -1550,7 +1550,7 @@
     <p:bg>
       <p:bgPr>
         <a:solidFill>
-          <a:srgbClr val="0F1B2D"/>
+          <a:srgbClr val="FFFFFF"/>
         </a:solidFill>
       </p:bgPr>
     </p:bg>
@@ -1595,7 +1595,7 @@
             <a:r>
               <a:rPr lang="en-US" sz="2600" b="1" dirty="0">
                 <a:solidFill>
-                  <a:srgbClr val="E8F4FF"/>
+                  <a:srgbClr val="1A1A2E"/>
                 </a:solidFill>
                 <a:latin typeface="游ゴシック" pitchFamily="34" charset="0"/>
                 <a:ea typeface="游ゴシック" pitchFamily="34" charset="-122"/>
@@ -1622,7 +1622,7 @@
             <a:avLst/>
           </a:prstGeom>
           <a:solidFill>
-            <a:srgbClr val="3B82F6"/>
+            <a:srgbClr val="2563EB"/>
           </a:solidFill>
           <a:ln/>
         </p:spPr>
@@ -1642,7 +1642,7 @@
             <a:avLst/>
           </a:prstGeom>
           <a:solidFill>
-            <a:srgbClr val="162A4A"/>
+            <a:srgbClr val="F5F7FA"/>
           </a:solidFill>
           <a:ln/>
         </p:spPr>
@@ -1674,7 +1674,7 @@
             <a:r>
               <a:rPr lang="en-US" sz="1300" dirty="0">
                 <a:solidFill>
-                  <a:srgbClr val="8094B4"/>
+                  <a:srgbClr val="6B7280"/>
                 </a:solidFill>
                 <a:latin typeface="游ゴシック" pitchFamily="34" charset="0"/>
                 <a:ea typeface="游ゴシック" pitchFamily="34" charset="-122"/>
@@ -1713,7 +1713,7 @@
             <a:r>
               <a:rPr lang="en-US" sz="4000" b="1" dirty="0">
                 <a:solidFill>
-                  <a:srgbClr val="3B82F6"/>
+                  <a:srgbClr val="2563EB"/>
                 </a:solidFill>
                 <a:latin typeface="游ゴシック" pitchFamily="34" charset="0"/>
                 <a:ea typeface="游ゴシック" pitchFamily="34" charset="-122"/>
@@ -1752,7 +1752,7 @@
             <a:r>
               <a:rPr lang="en-US" sz="1400" b="1" dirty="0">
                 <a:solidFill>
-                  <a:srgbClr val="22C55E"/>
+                  <a:srgbClr val="16A34A"/>
                 </a:solidFill>
                 <a:latin typeface="游ゴシック" pitchFamily="34" charset="0"/>
                 <a:ea typeface="游ゴシック" pitchFamily="34" charset="-122"/>
@@ -1791,7 +1791,7 @@
             <a:r>
               <a:rPr lang="en-US" sz="1100" dirty="0">
                 <a:solidFill>
-                  <a:srgbClr val="8094B4"/>
+                  <a:srgbClr val="6B7280"/>
                 </a:solidFill>
                 <a:latin typeface="游ゴシック" pitchFamily="34" charset="0"/>
                 <a:ea typeface="游ゴシック" pitchFamily="34" charset="-122"/>
@@ -1818,7 +1818,7 @@
             <a:avLst/>
           </a:prstGeom>
           <a:solidFill>
-            <a:srgbClr val="162A4A"/>
+            <a:srgbClr val="F5F7FA"/>
           </a:solidFill>
           <a:ln/>
         </p:spPr>
@@ -1850,7 +1850,7 @@
             <a:r>
               <a:rPr lang="en-US" sz="1300" dirty="0">
                 <a:solidFill>
-                  <a:srgbClr val="8094B4"/>
+                  <a:srgbClr val="6B7280"/>
                 </a:solidFill>
                 <a:latin typeface="游ゴシック" pitchFamily="34" charset="0"/>
                 <a:ea typeface="游ゴシック" pitchFamily="34" charset="-122"/>
@@ -1889,7 +1889,7 @@
             <a:r>
               <a:rPr lang="en-US" sz="4000" b="1" dirty="0">
                 <a:solidFill>
-                  <a:srgbClr val="3B82F6"/>
+                  <a:srgbClr val="2563EB"/>
                 </a:solidFill>
                 <a:latin typeface="游ゴシック" pitchFamily="34" charset="0"/>
                 <a:ea typeface="游ゴシック" pitchFamily="34" charset="-122"/>
@@ -1928,7 +1928,7 @@
             <a:r>
               <a:rPr lang="en-US" sz="1400" b="1" dirty="0">
                 <a:solidFill>
-                  <a:srgbClr val="22C55E"/>
+                  <a:srgbClr val="16A34A"/>
                 </a:solidFill>
                 <a:latin typeface="游ゴシック" pitchFamily="34" charset="0"/>
                 <a:ea typeface="游ゴシック" pitchFamily="34" charset="-122"/>
@@ -1967,7 +1967,7 @@
             <a:r>
               <a:rPr lang="en-US" sz="1100" dirty="0">
                 <a:solidFill>
-                  <a:srgbClr val="8094B4"/>
+                  <a:srgbClr val="6B7280"/>
                 </a:solidFill>
                 <a:latin typeface="游ゴシック" pitchFamily="34" charset="0"/>
                 <a:ea typeface="游ゴシック" pitchFamily="34" charset="-122"/>
@@ -1994,7 +1994,7 @@
             <a:avLst/>
           </a:prstGeom>
           <a:solidFill>
-            <a:srgbClr val="162A4A"/>
+            <a:srgbClr val="F5F7FA"/>
           </a:solidFill>
           <a:ln/>
         </p:spPr>
@@ -2026,7 +2026,7 @@
             <a:r>
               <a:rPr lang="en-US" sz="1300" dirty="0">
                 <a:solidFill>
-                  <a:srgbClr val="8094B4"/>
+                  <a:srgbClr val="6B7280"/>
                 </a:solidFill>
                 <a:latin typeface="游ゴシック" pitchFamily="34" charset="0"/>
                 <a:ea typeface="游ゴシック" pitchFamily="34" charset="-122"/>
@@ -2065,7 +2065,7 @@
             <a:r>
               <a:rPr lang="en-US" sz="4000" b="1" dirty="0">
                 <a:solidFill>
-                  <a:srgbClr val="3B82F6"/>
+                  <a:srgbClr val="2563EB"/>
                 </a:solidFill>
                 <a:latin typeface="游ゴシック" pitchFamily="34" charset="0"/>
                 <a:ea typeface="游ゴシック" pitchFamily="34" charset="-122"/>
@@ -2104,7 +2104,7 @@
             <a:r>
               <a:rPr lang="en-US" sz="1400" b="1" dirty="0">
                 <a:solidFill>
-                  <a:srgbClr val="EF4444"/>
+                  <a:srgbClr val="DC2626"/>
                 </a:solidFill>
                 <a:latin typeface="游ゴシック" pitchFamily="34" charset="0"/>
                 <a:ea typeface="游ゴシック" pitchFamily="34" charset="-122"/>
@@ -2143,7 +2143,7 @@
             <a:r>
               <a:rPr lang="en-US" sz="1100" dirty="0">
                 <a:solidFill>
-                  <a:srgbClr val="8094B4"/>
+                  <a:srgbClr val="6B7280"/>
                 </a:solidFill>
                 <a:latin typeface="游ゴシック" pitchFamily="34" charset="0"/>
                 <a:ea typeface="游ゴシック" pitchFamily="34" charset="-122"/>
@@ -2170,7 +2170,7 @@
             <a:avLst/>
           </a:prstGeom>
           <a:solidFill>
-            <a:srgbClr val="1A2D4A"/>
+            <a:srgbClr val="EEF2F7"/>
           </a:solidFill>
           <a:ln/>
         </p:spPr>
@@ -2190,7 +2190,7 @@
             <a:avLst/>
           </a:prstGeom>
           <a:solidFill>
-            <a:srgbClr val="3B82F6"/>
+            <a:srgbClr val="2563EB"/>
           </a:solidFill>
           <a:ln/>
         </p:spPr>
@@ -2222,7 +2222,7 @@
             <a:r>
               <a:rPr lang="en-US" sz="1400" dirty="0">
                 <a:solidFill>
-                  <a:srgbClr val="E8F4FF"/>
+                  <a:srgbClr val="1A1A2E"/>
                 </a:solidFill>
                 <a:latin typeface="游ゴシック" pitchFamily="34" charset="0"/>
                 <a:ea typeface="游ゴシック" pitchFamily="34" charset="-122"/>
@@ -2248,7 +2248,7 @@
     <p:bg>
       <p:bgPr>
         <a:solidFill>
-          <a:srgbClr val="0F1B2D"/>
+          <a:srgbClr val="FFFFFF"/>
         </a:solidFill>
       </p:bgPr>
     </p:bg>
@@ -2293,7 +2293,7 @@
             <a:r>
               <a:rPr lang="en-US" sz="2600" b="1" dirty="0">
                 <a:solidFill>
-                  <a:srgbClr val="E8F4FF"/>
+                  <a:srgbClr val="1A1A2E"/>
                 </a:solidFill>
                 <a:latin typeface="游ゴシック" pitchFamily="34" charset="0"/>
                 <a:ea typeface="游ゴシック" pitchFamily="34" charset="-122"/>
@@ -2320,7 +2320,7 @@
             <a:avLst/>
           </a:prstGeom>
           <a:solidFill>
-            <a:srgbClr val="3B82F6"/>
+            <a:srgbClr val="2563EB"/>
           </a:solidFill>
           <a:ln/>
         </p:spPr>
@@ -2352,7 +2352,7 @@
             <a:r>
               <a:rPr lang="en-US" sz="1500" b="1" dirty="0">
                 <a:solidFill>
-                  <a:srgbClr val="E8F4FF"/>
+                  <a:srgbClr val="1A1A2E"/>
                 </a:solidFill>
                 <a:latin typeface="游ゴシック" pitchFamily="34" charset="0"/>
                 <a:ea typeface="游ゴシック" pitchFamily="34" charset="-122"/>
@@ -2379,7 +2379,7 @@
             <a:avLst/>
           </a:prstGeom>
           <a:solidFill>
-            <a:srgbClr val="1E3A5F"/>
+            <a:srgbClr val="E0E4EA"/>
           </a:solidFill>
           <a:ln/>
         </p:spPr>
@@ -2411,7 +2411,7 @@
             <a:r>
               <a:rPr lang="en-US" sz="1300" dirty="0">
                 <a:solidFill>
-                  <a:srgbClr val="8094B4"/>
+                  <a:srgbClr val="6B7280"/>
                 </a:solidFill>
                 <a:latin typeface="游ゴシック" pitchFamily="34" charset="0"/>
                 <a:ea typeface="游ゴシック" pitchFamily="34" charset="-122"/>
@@ -2438,7 +2438,7 @@
             <a:avLst/>
           </a:prstGeom>
           <a:solidFill>
-            <a:srgbClr val="1E3A5F"/>
+            <a:srgbClr val="E0E4EA"/>
           </a:solidFill>
           <a:ln/>
         </p:spPr>
@@ -2458,7 +2458,7 @@
             <a:avLst/>
           </a:prstGeom>
           <a:solidFill>
-            <a:srgbClr val="3B82F6"/>
+            <a:srgbClr val="2563EB"/>
           </a:solidFill>
           <a:ln/>
         </p:spPr>
@@ -2529,7 +2529,7 @@
             <a:r>
               <a:rPr lang="en-US" sz="1300" dirty="0">
                 <a:solidFill>
-                  <a:srgbClr val="8094B4"/>
+                  <a:srgbClr val="6B7280"/>
                 </a:solidFill>
                 <a:latin typeface="游ゴシック" pitchFamily="34" charset="0"/>
                 <a:ea typeface="游ゴシック" pitchFamily="34" charset="-122"/>
@@ -2556,7 +2556,7 @@
             <a:avLst/>
           </a:prstGeom>
           <a:solidFill>
-            <a:srgbClr val="1E3A5F"/>
+            <a:srgbClr val="E0E4EA"/>
           </a:solidFill>
           <a:ln/>
         </p:spPr>
@@ -2647,7 +2647,7 @@
             <a:r>
               <a:rPr lang="en-US" sz="1300" dirty="0">
                 <a:solidFill>
-                  <a:srgbClr val="8094B4"/>
+                  <a:srgbClr val="6B7280"/>
                 </a:solidFill>
                 <a:latin typeface="游ゴシック" pitchFamily="34" charset="0"/>
                 <a:ea typeface="游ゴシック" pitchFamily="34" charset="-122"/>
@@ -2674,7 +2674,7 @@
             <a:avLst/>
           </a:prstGeom>
           <a:solidFill>
-            <a:srgbClr val="1E3A5F"/>
+            <a:srgbClr val="E0E4EA"/>
           </a:solidFill>
           <a:ln/>
         </p:spPr>
@@ -2765,7 +2765,7 @@
             <a:r>
               <a:rPr lang="en-US" sz="1500" b="1" dirty="0">
                 <a:solidFill>
-                  <a:srgbClr val="E8F4FF"/>
+                  <a:srgbClr val="1A1A2E"/>
                 </a:solidFill>
                 <a:latin typeface="游ゴシック" pitchFamily="34" charset="0"/>
                 <a:ea typeface="游ゴシック" pitchFamily="34" charset="-122"/>
@@ -2792,7 +2792,7 @@
             <a:avLst/>
           </a:prstGeom>
           <a:solidFill>
-            <a:srgbClr val="1E3A5F"/>
+            <a:srgbClr val="E0E4EA"/>
           </a:solidFill>
           <a:ln/>
         </p:spPr>
@@ -2812,7 +2812,7 @@
             <a:avLst/>
           </a:prstGeom>
           <a:solidFill>
-            <a:srgbClr val="162A4A"/>
+            <a:srgbClr val="F5F7FA"/>
           </a:solidFill>
           <a:ln/>
         </p:spPr>
@@ -2844,7 +2844,7 @@
             <a:r>
               <a:rPr lang="en-US" sz="1700" b="1" dirty="0">
                 <a:solidFill>
-                  <a:srgbClr val="E8F4FF"/>
+                  <a:srgbClr val="1A1A2E"/>
                 </a:solidFill>
                 <a:latin typeface="游ゴシック" pitchFamily="34" charset="0"/>
                 <a:ea typeface="游ゴシック" pitchFamily="34" charset="-122"/>
@@ -2883,7 +2883,7 @@
             <a:r>
               <a:rPr lang="en-US" sz="1100" dirty="0">
                 <a:solidFill>
-                  <a:srgbClr val="8094B4"/>
+                  <a:srgbClr val="6B7280"/>
                 </a:solidFill>
                 <a:latin typeface="游ゴシック" pitchFamily="34" charset="0"/>
                 <a:ea typeface="游ゴシック" pitchFamily="34" charset="-122"/>
@@ -2922,7 +2922,7 @@
             <a:r>
               <a:rPr lang="en-US" sz="2400" b="1" dirty="0">
                 <a:solidFill>
-                  <a:srgbClr val="3B82F6"/>
+                  <a:srgbClr val="2563EB"/>
                 </a:solidFill>
                 <a:latin typeface="游ゴシック" pitchFamily="34" charset="0"/>
                 <a:ea typeface="游ゴシック" pitchFamily="34" charset="-122"/>
@@ -2961,7 +2961,7 @@
             <a:r>
               <a:rPr lang="en-US" sz="1200" b="1" dirty="0">
                 <a:solidFill>
-                  <a:srgbClr val="22C55E"/>
+                  <a:srgbClr val="16A34A"/>
                 </a:solidFill>
                 <a:latin typeface="游ゴシック" pitchFamily="34" charset="0"/>
                 <a:ea typeface="游ゴシック" pitchFamily="34" charset="-122"/>
@@ -2988,7 +2988,7 @@
             <a:avLst/>
           </a:prstGeom>
           <a:solidFill>
-            <a:srgbClr val="162A4A"/>
+            <a:srgbClr val="F5F7FA"/>
           </a:solidFill>
           <a:ln/>
         </p:spPr>
@@ -3020,7 +3020,7 @@
             <a:r>
               <a:rPr lang="en-US" sz="1700" b="1" dirty="0">
                 <a:solidFill>
-                  <a:srgbClr val="E8F4FF"/>
+                  <a:srgbClr val="1A1A2E"/>
                 </a:solidFill>
                 <a:latin typeface="游ゴシック" pitchFamily="34" charset="0"/>
                 <a:ea typeface="游ゴシック" pitchFamily="34" charset="-122"/>
@@ -3059,7 +3059,7 @@
             <a:r>
               <a:rPr lang="en-US" sz="1100" dirty="0">
                 <a:solidFill>
-                  <a:srgbClr val="8094B4"/>
+                  <a:srgbClr val="6B7280"/>
                 </a:solidFill>
                 <a:latin typeface="游ゴシック" pitchFamily="34" charset="0"/>
                 <a:ea typeface="游ゴシック" pitchFamily="34" charset="-122"/>
@@ -3098,7 +3098,7 @@
             <a:r>
               <a:rPr lang="en-US" sz="2400" b="1" dirty="0">
                 <a:solidFill>
-                  <a:srgbClr val="3B82F6"/>
+                  <a:srgbClr val="2563EB"/>
                 </a:solidFill>
                 <a:latin typeface="游ゴシック" pitchFamily="34" charset="0"/>
                 <a:ea typeface="游ゴシック" pitchFamily="34" charset="-122"/>
@@ -3137,7 +3137,7 @@
             <a:r>
               <a:rPr lang="en-US" sz="1200" b="1" dirty="0">
                 <a:solidFill>
-                  <a:srgbClr val="22C55E"/>
+                  <a:srgbClr val="16A34A"/>
                 </a:solidFill>
                 <a:latin typeface="游ゴシック" pitchFamily="34" charset="0"/>
                 <a:ea typeface="游ゴシック" pitchFamily="34" charset="-122"/>
@@ -3164,7 +3164,7 @@
             <a:avLst/>
           </a:prstGeom>
           <a:solidFill>
-            <a:srgbClr val="162A4A"/>
+            <a:srgbClr val="F5F7FA"/>
           </a:solidFill>
           <a:ln/>
         </p:spPr>
@@ -3196,7 +3196,7 @@
             <a:r>
               <a:rPr lang="en-US" sz="1700" b="1" dirty="0">
                 <a:solidFill>
-                  <a:srgbClr val="E8F4FF"/>
+                  <a:srgbClr val="1A1A2E"/>
                 </a:solidFill>
                 <a:latin typeface="游ゴシック" pitchFamily="34" charset="0"/>
                 <a:ea typeface="游ゴシック" pitchFamily="34" charset="-122"/>
@@ -3235,7 +3235,7 @@
             <a:r>
               <a:rPr lang="en-US" sz="1100" dirty="0">
                 <a:solidFill>
-                  <a:srgbClr val="8094B4"/>
+                  <a:srgbClr val="6B7280"/>
                 </a:solidFill>
                 <a:latin typeface="游ゴシック" pitchFamily="34" charset="0"/>
                 <a:ea typeface="游ゴシック" pitchFamily="34" charset="-122"/>
@@ -3274,7 +3274,7 @@
             <a:r>
               <a:rPr lang="en-US" sz="2400" b="1" dirty="0">
                 <a:solidFill>
-                  <a:srgbClr val="3B82F6"/>
+                  <a:srgbClr val="2563EB"/>
                 </a:solidFill>
                 <a:latin typeface="游ゴシック" pitchFamily="34" charset="0"/>
                 <a:ea typeface="游ゴシック" pitchFamily="34" charset="-122"/>
@@ -3313,7 +3313,7 @@
             <a:r>
               <a:rPr lang="en-US" sz="1200" b="1" dirty="0">
                 <a:solidFill>
-                  <a:srgbClr val="EF4444"/>
+                  <a:srgbClr val="DC2626"/>
                 </a:solidFill>
                 <a:latin typeface="游ゴシック" pitchFamily="34" charset="0"/>
                 <a:ea typeface="游ゴシック" pitchFamily="34" charset="-122"/>
@@ -3339,7 +3339,7 @@
     <p:bg>
       <p:bgPr>
         <a:solidFill>
-          <a:srgbClr val="0F1B2D"/>
+          <a:srgbClr val="FFFFFF"/>
         </a:solidFill>
       </p:bgPr>
     </p:bg>
@@ -3384,7 +3384,7 @@
             <a:r>
               <a:rPr lang="en-US" sz="2600" b="1" dirty="0">
                 <a:solidFill>
-                  <a:srgbClr val="E8F4FF"/>
+                  <a:srgbClr val="1A1A2E"/>
                 </a:solidFill>
                 <a:latin typeface="游ゴシック" pitchFamily="34" charset="0"/>
                 <a:ea typeface="游ゴシック" pitchFamily="34" charset="-122"/>
@@ -3411,7 +3411,7 @@
             <a:avLst/>
           </a:prstGeom>
           <a:solidFill>
-            <a:srgbClr val="3B82F6"/>
+            <a:srgbClr val="2563EB"/>
           </a:solidFill>
           <a:ln/>
         </p:spPr>
@@ -3443,7 +3443,7 @@
             <a:r>
               <a:rPr lang="en-US" sz="1400" dirty="0">
                 <a:solidFill>
-                  <a:srgbClr val="8094B4"/>
+                  <a:srgbClr val="6B7280"/>
                 </a:solidFill>
                 <a:latin typeface="游ゴシック" pitchFamily="34" charset="0"/>
                 <a:ea typeface="游ゴシック" pitchFamily="34" charset="-122"/>
@@ -3470,7 +3470,7 @@
             <a:avLst/>
           </a:prstGeom>
           <a:solidFill>
-            <a:srgbClr val="1E3A5F"/>
+            <a:srgbClr val="E0E4EA"/>
           </a:solidFill>
           <a:ln/>
         </p:spPr>
@@ -3490,7 +3490,7 @@
             <a:avLst/>
           </a:prstGeom>
           <a:solidFill>
-            <a:srgbClr val="1E3A5F"/>
+            <a:srgbClr val="DBEAFE"/>
           </a:solidFill>
           <a:ln/>
         </p:spPr>
@@ -3522,7 +3522,7 @@
             <a:r>
               <a:rPr lang="en-US" sz="1500" b="1" dirty="0">
                 <a:solidFill>
-                  <a:srgbClr val="FFFFFF"/>
+                  <a:srgbClr val="1A1A2E"/>
                 </a:solidFill>
                 <a:latin typeface="游ゴシック" pitchFamily="34" charset="0"/>
                 <a:ea typeface="游ゴシック" pitchFamily="34" charset="-122"/>
@@ -3536,7 +3536,7 @@
             <a:r>
               <a:rPr lang="en-US" sz="1200" b="1" dirty="0">
                 <a:solidFill>
-                  <a:srgbClr val="8094B4"/>
+                  <a:srgbClr val="6B7280"/>
                 </a:solidFill>
                 <a:latin typeface="游ゴシック" pitchFamily="34" charset="0"/>
                 <a:ea typeface="游ゴシック" pitchFamily="34" charset="-122"/>
@@ -3575,7 +3575,7 @@
             <a:r>
               <a:rPr lang="en-US" sz="1400" dirty="0">
                 <a:solidFill>
-                  <a:srgbClr val="8094B4"/>
+                  <a:srgbClr val="6B7280"/>
                 </a:solidFill>
                 <a:latin typeface="游ゴシック" pitchFamily="34" charset="0"/>
                 <a:ea typeface="游ゴシック" pitchFamily="34" charset="-122"/>
@@ -3602,7 +3602,7 @@
             <a:avLst/>
           </a:prstGeom>
           <a:solidFill>
-            <a:srgbClr val="1E3A5F"/>
+            <a:srgbClr val="E0E4EA"/>
           </a:solidFill>
           <a:ln/>
         </p:spPr>
@@ -3622,7 +3622,7 @@
             <a:avLst/>
           </a:prstGeom>
           <a:solidFill>
-            <a:srgbClr val="254F87"/>
+            <a:srgbClr val="BFDBFE"/>
           </a:solidFill>
           <a:ln/>
         </p:spPr>
@@ -3654,7 +3654,7 @@
             <a:r>
               <a:rPr lang="en-US" sz="1500" b="1" dirty="0">
                 <a:solidFill>
-                  <a:srgbClr val="FFFFFF"/>
+                  <a:srgbClr val="1A1A2E"/>
                 </a:solidFill>
                 <a:latin typeface="游ゴシック" pitchFamily="34" charset="0"/>
                 <a:ea typeface="游ゴシック" pitchFamily="34" charset="-122"/>
@@ -3668,7 +3668,7 @@
             <a:r>
               <a:rPr lang="en-US" sz="1200" b="1" dirty="0">
                 <a:solidFill>
-                  <a:srgbClr val="8094B4"/>
+                  <a:srgbClr val="6B7280"/>
                 </a:solidFill>
                 <a:latin typeface="游ゴシック" pitchFamily="34" charset="0"/>
                 <a:ea typeface="游ゴシック" pitchFamily="34" charset="-122"/>
@@ -3707,7 +3707,7 @@
             <a:r>
               <a:rPr lang="en-US" sz="1400" dirty="0">
                 <a:solidFill>
-                  <a:srgbClr val="8094B4"/>
+                  <a:srgbClr val="6B7280"/>
                 </a:solidFill>
                 <a:latin typeface="游ゴシック" pitchFamily="34" charset="0"/>
                 <a:ea typeface="游ゴシック" pitchFamily="34" charset="-122"/>
@@ -3734,7 +3734,7 @@
             <a:avLst/>
           </a:prstGeom>
           <a:solidFill>
-            <a:srgbClr val="1E3A5F"/>
+            <a:srgbClr val="E0E4EA"/>
           </a:solidFill>
           <a:ln/>
         </p:spPr>
@@ -3754,7 +3754,7 @@
             <a:avLst/>
           </a:prstGeom>
           <a:solidFill>
-            <a:srgbClr val="2D63A8"/>
+            <a:srgbClr val="93C5FD"/>
           </a:solidFill>
           <a:ln/>
         </p:spPr>
@@ -3786,7 +3786,7 @@
             <a:r>
               <a:rPr lang="en-US" sz="1500" b="1" dirty="0">
                 <a:solidFill>
-                  <a:srgbClr val="FFFFFF"/>
+                  <a:srgbClr val="1A1A2E"/>
                 </a:solidFill>
                 <a:latin typeface="游ゴシック" pitchFamily="34" charset="0"/>
                 <a:ea typeface="游ゴシック" pitchFamily="34" charset="-122"/>
@@ -3800,7 +3800,7 @@
             <a:r>
               <a:rPr lang="en-US" sz="1200" b="1" dirty="0">
                 <a:solidFill>
-                  <a:srgbClr val="8094B4"/>
+                  <a:srgbClr val="6B7280"/>
                 </a:solidFill>
                 <a:latin typeface="游ゴシック" pitchFamily="34" charset="0"/>
                 <a:ea typeface="游ゴシック" pitchFamily="34" charset="-122"/>
@@ -3839,7 +3839,7 @@
             <a:r>
               <a:rPr lang="en-US" sz="1400" dirty="0">
                 <a:solidFill>
-                  <a:srgbClr val="8094B4"/>
+                  <a:srgbClr val="6B7280"/>
                 </a:solidFill>
                 <a:latin typeface="游ゴシック" pitchFamily="34" charset="0"/>
                 <a:ea typeface="游ゴシック" pitchFamily="34" charset="-122"/>
@@ -3866,7 +3866,7 @@
             <a:avLst/>
           </a:prstGeom>
           <a:solidFill>
-            <a:srgbClr val="1E3A5F"/>
+            <a:srgbClr val="E0E4EA"/>
           </a:solidFill>
           <a:ln/>
         </p:spPr>
@@ -3886,7 +3886,7 @@
             <a:avLst/>
           </a:prstGeom>
           <a:solidFill>
-            <a:srgbClr val="3B82F6"/>
+            <a:srgbClr val="2563EB"/>
           </a:solidFill>
           <a:ln/>
         </p:spPr>
@@ -3918,7 +3918,7 @@
             <a:r>
               <a:rPr lang="en-US" sz="1500" b="1" dirty="0">
                 <a:solidFill>
-                  <a:srgbClr val="FFFFFF"/>
+                  <a:srgbClr val="1A1A2E"/>
                 </a:solidFill>
                 <a:latin typeface="游ゴシック" pitchFamily="34" charset="0"/>
                 <a:ea typeface="游ゴシック" pitchFamily="34" charset="-122"/>
@@ -3932,7 +3932,7 @@
             <a:r>
               <a:rPr lang="en-US" sz="1200" b="1" dirty="0">
                 <a:solidFill>
-                  <a:srgbClr val="8094B4"/>
+                  <a:srgbClr val="6B7280"/>
                 </a:solidFill>
                 <a:latin typeface="游ゴシック" pitchFamily="34" charset="0"/>
                 <a:ea typeface="游ゴシック" pitchFamily="34" charset="-122"/>
@@ -3971,7 +3971,7 @@
             <a:r>
               <a:rPr lang="en-US" sz="3200" b="1" dirty="0">
                 <a:solidFill>
-                  <a:srgbClr val="3B82F6"/>
+                  <a:srgbClr val="2563EB"/>
                 </a:solidFill>
                 <a:latin typeface="游ゴシック" pitchFamily="34" charset="0"/>
                 <a:ea typeface="游ゴシック" pitchFamily="34" charset="-122"/>
@@ -4010,7 +4010,7 @@
             <a:r>
               <a:rPr lang="en-US" sz="1200" dirty="0">
                 <a:solidFill>
-                  <a:srgbClr val="8094B4"/>
+                  <a:srgbClr val="6B7280"/>
                 </a:solidFill>
                 <a:latin typeface="游ゴシック" pitchFamily="34" charset="0"/>
                 <a:ea typeface="游ゴシック" pitchFamily="34" charset="-122"/>
@@ -4049,7 +4049,7 @@
             <a:r>
               <a:rPr lang="en-US" sz="3200" b="1" dirty="0">
                 <a:solidFill>
-                  <a:srgbClr val="3B82F6"/>
+                  <a:srgbClr val="2563EB"/>
                 </a:solidFill>
                 <a:latin typeface="游ゴシック" pitchFamily="34" charset="0"/>
                 <a:ea typeface="游ゴシック" pitchFamily="34" charset="-122"/>
@@ -4088,7 +4088,7 @@
             <a:r>
               <a:rPr lang="en-US" sz="1200" dirty="0">
                 <a:solidFill>
-                  <a:srgbClr val="8094B4"/>
+                  <a:srgbClr val="6B7280"/>
                 </a:solidFill>
                 <a:latin typeface="游ゴシック" pitchFamily="34" charset="0"/>
                 <a:ea typeface="游ゴシック" pitchFamily="34" charset="-122"/>
@@ -4127,7 +4127,7 @@
             <a:r>
               <a:rPr lang="en-US" sz="3200" b="1" dirty="0">
                 <a:solidFill>
-                  <a:srgbClr val="3B82F6"/>
+                  <a:srgbClr val="2563EB"/>
                 </a:solidFill>
                 <a:latin typeface="游ゴシック" pitchFamily="34" charset="0"/>
                 <a:ea typeface="游ゴシック" pitchFamily="34" charset="-122"/>
@@ -4166,7 +4166,7 @@
             <a:r>
               <a:rPr lang="en-US" sz="1200" dirty="0">
                 <a:solidFill>
-                  <a:srgbClr val="8094B4"/>
+                  <a:srgbClr val="6B7280"/>
                 </a:solidFill>
                 <a:latin typeface="游ゴシック" pitchFamily="34" charset="0"/>
                 <a:ea typeface="游ゴシック" pitchFamily="34" charset="-122"/>
@@ -4192,7 +4192,7 @@
     <p:bg>
       <p:bgPr>
         <a:solidFill>
-          <a:srgbClr val="0F1B2D"/>
+          <a:srgbClr val="FFFFFF"/>
         </a:solidFill>
       </p:bgPr>
     </p:bg>
@@ -4237,7 +4237,7 @@
             <a:r>
               <a:rPr lang="en-US" sz="2600" b="1" dirty="0">
                 <a:solidFill>
-                  <a:srgbClr val="E8F4FF"/>
+                  <a:srgbClr val="1A1A2E"/>
                 </a:solidFill>
                 <a:latin typeface="游ゴシック" pitchFamily="34" charset="0"/>
                 <a:ea typeface="游ゴシック" pitchFamily="34" charset="-122"/>
@@ -4264,7 +4264,7 @@
             <a:avLst/>
           </a:prstGeom>
           <a:solidFill>
-            <a:srgbClr val="3B82F6"/>
+            <a:srgbClr val="2563EB"/>
           </a:solidFill>
           <a:ln/>
         </p:spPr>
@@ -4296,7 +4296,7 @@
             <a:r>
               <a:rPr lang="en-US" sz="1500" b="1" dirty="0">
                 <a:solidFill>
-                  <a:srgbClr val="3B82F6"/>
+                  <a:srgbClr val="2563EB"/>
                 </a:solidFill>
                 <a:latin typeface="游ゴシック" pitchFamily="34" charset="0"/>
                 <a:ea typeface="游ゴシック" pitchFamily="34" charset="-122"/>
@@ -4323,7 +4323,7 @@
             <a:avLst/>
           </a:prstGeom>
           <a:solidFill>
-            <a:srgbClr val="3B82F6"/>
+            <a:srgbClr val="2563EB"/>
           </a:solidFill>
           <a:ln/>
         </p:spPr>
@@ -4397,7 +4397,7 @@
             <a:r>
               <a:rPr lang="en-US" sz="1500" b="1" dirty="0">
                 <a:solidFill>
-                  <a:srgbClr val="E8F4FF"/>
+                  <a:srgbClr val="1A1A2E"/>
                 </a:solidFill>
                 <a:latin typeface="游ゴシック" pitchFamily="34" charset="0"/>
                 <a:ea typeface="游ゴシック" pitchFamily="34" charset="-122"/>
@@ -4418,7 +4418,7 @@
             <a:r>
               <a:rPr lang="en-US" sz="1100" b="1" dirty="0">
                 <a:solidFill>
-                  <a:srgbClr val="8094B4"/>
+                  <a:srgbClr val="6B7280"/>
                 </a:solidFill>
                 <a:latin typeface="游ゴシック" pitchFamily="34" charset="0"/>
                 <a:ea typeface="游ゴシック" pitchFamily="34" charset="-122"/>
@@ -4445,7 +4445,7 @@
             <a:avLst/>
           </a:prstGeom>
           <a:solidFill>
-            <a:srgbClr val="1E3A5F"/>
+            <a:srgbClr val="E0E4EA"/>
           </a:solidFill>
           <a:ln/>
         </p:spPr>
@@ -4465,7 +4465,7 @@
             <a:avLst/>
           </a:prstGeom>
           <a:solidFill>
-            <a:srgbClr val="3B82F6"/>
+            <a:srgbClr val="2563EB"/>
           </a:solidFill>
           <a:ln/>
         </p:spPr>
@@ -4539,7 +4539,7 @@
             <a:r>
               <a:rPr lang="en-US" sz="1500" b="1" dirty="0">
                 <a:solidFill>
-                  <a:srgbClr val="E8F4FF"/>
+                  <a:srgbClr val="1A1A2E"/>
                 </a:solidFill>
                 <a:latin typeface="游ゴシック" pitchFamily="34" charset="0"/>
                 <a:ea typeface="游ゴシック" pitchFamily="34" charset="-122"/>
@@ -4560,7 +4560,7 @@
             <a:r>
               <a:rPr lang="en-US" sz="1100" b="1" dirty="0">
                 <a:solidFill>
-                  <a:srgbClr val="8094B4"/>
+                  <a:srgbClr val="6B7280"/>
                 </a:solidFill>
                 <a:latin typeface="游ゴシック" pitchFamily="34" charset="0"/>
                 <a:ea typeface="游ゴシック" pitchFamily="34" charset="-122"/>
@@ -4587,7 +4587,7 @@
             <a:avLst/>
           </a:prstGeom>
           <a:solidFill>
-            <a:srgbClr val="1E3A5F"/>
+            <a:srgbClr val="E0E4EA"/>
           </a:solidFill>
           <a:ln/>
         </p:spPr>
@@ -4607,7 +4607,7 @@
             <a:avLst/>
           </a:prstGeom>
           <a:solidFill>
-            <a:srgbClr val="3B82F6"/>
+            <a:srgbClr val="2563EB"/>
           </a:solidFill>
           <a:ln/>
         </p:spPr>
@@ -4681,7 +4681,7 @@
             <a:r>
               <a:rPr lang="en-US" sz="1500" b="1" dirty="0">
                 <a:solidFill>
-                  <a:srgbClr val="E8F4FF"/>
+                  <a:srgbClr val="1A1A2E"/>
                 </a:solidFill>
                 <a:latin typeface="游ゴシック" pitchFamily="34" charset="0"/>
                 <a:ea typeface="游ゴシック" pitchFamily="34" charset="-122"/>
@@ -4702,7 +4702,7 @@
             <a:r>
               <a:rPr lang="en-US" sz="1100" b="1" dirty="0">
                 <a:solidFill>
-                  <a:srgbClr val="8094B4"/>
+                  <a:srgbClr val="6B7280"/>
                 </a:solidFill>
                 <a:latin typeface="游ゴシック" pitchFamily="34" charset="0"/>
                 <a:ea typeface="游ゴシック" pitchFamily="34" charset="-122"/>
@@ -4729,7 +4729,7 @@
             <a:avLst/>
           </a:prstGeom>
           <a:solidFill>
-            <a:srgbClr val="1E3A5F"/>
+            <a:srgbClr val="E0E4EA"/>
           </a:solidFill>
           <a:ln/>
         </p:spPr>
@@ -4761,7 +4761,7 @@
             <a:r>
               <a:rPr lang="en-US" sz="1500" b="1" dirty="0">
                 <a:solidFill>
-                  <a:srgbClr val="3B82F6"/>
+                  <a:srgbClr val="2563EB"/>
                 </a:solidFill>
                 <a:latin typeface="游ゴシック" pitchFamily="34" charset="0"/>
                 <a:ea typeface="游ゴシック" pitchFamily="34" charset="-122"/>
@@ -4788,7 +4788,7 @@
             <a:avLst/>
           </a:prstGeom>
           <a:solidFill>
-            <a:srgbClr val="162A4A"/>
+            <a:srgbClr val="F5F7FA"/>
           </a:solidFill>
           <a:ln/>
         </p:spPr>
@@ -4820,7 +4820,7 @@
             <a:r>
               <a:rPr lang="en-US" sz="1600" b="1" dirty="0">
                 <a:solidFill>
-                  <a:srgbClr val="E8F4FF"/>
+                  <a:srgbClr val="1A1A2E"/>
                 </a:solidFill>
                 <a:latin typeface="游ゴシック" pitchFamily="34" charset="0"/>
                 <a:ea typeface="游ゴシック" pitchFamily="34" charset="-122"/>
@@ -4859,7 +4859,7 @@
             <a:r>
               <a:rPr lang="en-US" sz="2600" b="1" dirty="0">
                 <a:solidFill>
-                  <a:srgbClr val="3B82F6"/>
+                  <a:srgbClr val="2563EB"/>
                 </a:solidFill>
                 <a:latin typeface="游ゴシック" pitchFamily="34" charset="0"/>
                 <a:ea typeface="游ゴシック" pitchFamily="34" charset="-122"/>
@@ -4886,7 +4886,7 @@
             <a:avLst/>
           </a:prstGeom>
           <a:solidFill>
-            <a:srgbClr val="162A4A"/>
+            <a:srgbClr val="F5F7FA"/>
           </a:solidFill>
           <a:ln/>
         </p:spPr>
@@ -4918,7 +4918,7 @@
             <a:r>
               <a:rPr lang="en-US" sz="1600" b="1" dirty="0">
                 <a:solidFill>
-                  <a:srgbClr val="E8F4FF"/>
+                  <a:srgbClr val="1A1A2E"/>
                 </a:solidFill>
                 <a:latin typeface="游ゴシック" pitchFamily="34" charset="0"/>
                 <a:ea typeface="游ゴシック" pitchFamily="34" charset="-122"/>
@@ -4957,7 +4957,7 @@
             <a:r>
               <a:rPr lang="en-US" sz="2600" b="1" dirty="0">
                 <a:solidFill>
-                  <a:srgbClr val="3B82F6"/>
+                  <a:srgbClr val="2563EB"/>
                 </a:solidFill>
                 <a:latin typeface="游ゴシック" pitchFamily="34" charset="0"/>
                 <a:ea typeface="游ゴシック" pitchFamily="34" charset="-122"/>
@@ -4984,7 +4984,7 @@
             <a:avLst/>
           </a:prstGeom>
           <a:solidFill>
-            <a:srgbClr val="162A4A"/>
+            <a:srgbClr val="F5F7FA"/>
           </a:solidFill>
           <a:ln/>
         </p:spPr>
@@ -5016,7 +5016,7 @@
             <a:r>
               <a:rPr lang="en-US" sz="1600" b="1" dirty="0">
                 <a:solidFill>
-                  <a:srgbClr val="E8F4FF"/>
+                  <a:srgbClr val="1A1A2E"/>
                 </a:solidFill>
                 <a:latin typeface="游ゴシック" pitchFamily="34" charset="0"/>
                 <a:ea typeface="游ゴシック" pitchFamily="34" charset="-122"/>
@@ -5055,7 +5055,7 @@
             <a:r>
               <a:rPr lang="en-US" sz="2600" b="1" dirty="0">
                 <a:solidFill>
-                  <a:srgbClr val="3B82F6"/>
+                  <a:srgbClr val="2563EB"/>
                 </a:solidFill>
                 <a:latin typeface="游ゴシック" pitchFamily="34" charset="0"/>
                 <a:ea typeface="游ゴシック" pitchFamily="34" charset="-122"/>
@@ -5082,7 +5082,7 @@
             <a:avLst/>
           </a:prstGeom>
           <a:solidFill>
-            <a:srgbClr val="1A2D4A"/>
+            <a:srgbClr val="EEF2F7"/>
           </a:solidFill>
           <a:ln/>
         </p:spPr>
@@ -5102,7 +5102,7 @@
             <a:avLst/>
           </a:prstGeom>
           <a:solidFill>
-            <a:srgbClr val="3B82F6"/>
+            <a:srgbClr val="2563EB"/>
           </a:solidFill>
           <a:ln/>
         </p:spPr>
@@ -5134,7 +5134,7 @@
             <a:r>
               <a:rPr lang="en-US" sz="1400" dirty="0">
                 <a:solidFill>
-                  <a:srgbClr val="E8F4FF"/>
+                  <a:srgbClr val="1A1A2E"/>
                 </a:solidFill>
                 <a:latin typeface="游ゴシック" pitchFamily="34" charset="0"/>
                 <a:ea typeface="游ゴシック" pitchFamily="34" charset="-122"/>
@@ -5160,7 +5160,7 @@
     <p:bg>
       <p:bgPr>
         <a:solidFill>
-          <a:srgbClr val="0F1B2D"/>
+          <a:srgbClr val="FFFFFF"/>
         </a:solidFill>
       </p:bgPr>
     </p:bg>
@@ -5205,7 +5205,7 @@
             <a:r>
               <a:rPr lang="en-US" sz="2600" b="1" dirty="0">
                 <a:solidFill>
-                  <a:srgbClr val="E8F4FF"/>
+                  <a:srgbClr val="1A1A2E"/>
                 </a:solidFill>
                 <a:latin typeface="游ゴシック" pitchFamily="34" charset="0"/>
                 <a:ea typeface="游ゴシック" pitchFamily="34" charset="-122"/>
@@ -5232,7 +5232,7 @@
             <a:avLst/>
           </a:prstGeom>
           <a:solidFill>
-            <a:srgbClr val="3B82F6"/>
+            <a:srgbClr val="2563EB"/>
           </a:solidFill>
           <a:ln/>
         </p:spPr>
@@ -5252,7 +5252,7 @@
             <a:avLst/>
           </a:prstGeom>
           <a:solidFill>
-            <a:srgbClr val="1E3A5F"/>
+            <a:srgbClr val="E8EDF5"/>
           </a:solidFill>
           <a:ln/>
         </p:spPr>
@@ -5284,7 +5284,7 @@
             <a:r>
               <a:rPr lang="en-US" sz="1100" b="1" dirty="0">
                 <a:solidFill>
-                  <a:srgbClr val="8094B4"/>
+                  <a:srgbClr val="6B7280"/>
                 </a:solidFill>
                 <a:latin typeface="游ゴシック" pitchFamily="34" charset="0"/>
                 <a:ea typeface="游ゴシック" pitchFamily="34" charset="-122"/>
@@ -5323,7 +5323,7 @@
             <a:r>
               <a:rPr lang="en-US" sz="1100" b="1" dirty="0">
                 <a:solidFill>
-                  <a:srgbClr val="8094B4"/>
+                  <a:srgbClr val="6B7280"/>
                 </a:solidFill>
                 <a:latin typeface="游ゴシック" pitchFamily="34" charset="0"/>
                 <a:ea typeface="游ゴシック" pitchFamily="34" charset="-122"/>
@@ -5362,7 +5362,7 @@
             <a:r>
               <a:rPr lang="en-US" sz="1100" b="1" dirty="0">
                 <a:solidFill>
-                  <a:srgbClr val="8094B4"/>
+                  <a:srgbClr val="6B7280"/>
                 </a:solidFill>
                 <a:latin typeface="游ゴシック" pitchFamily="34" charset="0"/>
                 <a:ea typeface="游ゴシック" pitchFamily="34" charset="-122"/>
@@ -5401,7 +5401,7 @@
             <a:r>
               <a:rPr lang="en-US" sz="1100" b="1" dirty="0">
                 <a:solidFill>
-                  <a:srgbClr val="8094B4"/>
+                  <a:srgbClr val="6B7280"/>
                 </a:solidFill>
                 <a:latin typeface="游ゴシック" pitchFamily="34" charset="0"/>
                 <a:ea typeface="游ゴシック" pitchFamily="34" charset="-122"/>
@@ -5440,7 +5440,7 @@
             <a:r>
               <a:rPr lang="en-US" sz="1100" b="1" dirty="0">
                 <a:solidFill>
-                  <a:srgbClr val="8094B4"/>
+                  <a:srgbClr val="6B7280"/>
                 </a:solidFill>
                 <a:latin typeface="游ゴシック" pitchFamily="34" charset="0"/>
                 <a:ea typeface="游ゴシック" pitchFamily="34" charset="-122"/>
@@ -5467,7 +5467,7 @@
             <a:avLst/>
           </a:prstGeom>
           <a:solidFill>
-            <a:srgbClr val="0F1B2D"/>
+            <a:srgbClr val="FFFFFF"/>
           </a:solidFill>
           <a:ln/>
         </p:spPr>
@@ -5499,7 +5499,7 @@
             <a:r>
               <a:rPr lang="en-US" sz="1200" dirty="0">
                 <a:solidFill>
-                  <a:srgbClr val="6A80A0"/>
+                  <a:srgbClr val="1A1A2E"/>
                 </a:solidFill>
                 <a:latin typeface="游ゴシック" pitchFamily="34" charset="0"/>
                 <a:ea typeface="游ゴシック" pitchFamily="34" charset="-122"/>
@@ -5538,7 +5538,7 @@
             <a:r>
               <a:rPr lang="en-US" sz="1100" dirty="0">
                 <a:solidFill>
-                  <a:srgbClr val="8094B4"/>
+                  <a:srgbClr val="6B7280"/>
                 </a:solidFill>
                 <a:latin typeface="游ゴシック" pitchFamily="34" charset="0"/>
                 <a:ea typeface="游ゴシック" pitchFamily="34" charset="-122"/>
@@ -5577,7 +5577,7 @@
             <a:r>
               <a:rPr lang="en-US" sz="1300" dirty="0">
                 <a:solidFill>
-                  <a:srgbClr val="6A80A0"/>
+                  <a:srgbClr val="1A1A2E"/>
                 </a:solidFill>
                 <a:latin typeface="游ゴシック" pitchFamily="34" charset="0"/>
                 <a:ea typeface="游ゴシック" pitchFamily="34" charset="-122"/>
@@ -5616,7 +5616,7 @@
             <a:r>
               <a:rPr lang="en-US" sz="1300" b="1" dirty="0">
                 <a:solidFill>
-                  <a:srgbClr val="E8F4FF"/>
+                  <a:srgbClr val="1A1A2E"/>
                 </a:solidFill>
                 <a:latin typeface="游ゴシック" pitchFamily="34" charset="0"/>
                 <a:ea typeface="游ゴシック" pitchFamily="34" charset="-122"/>
@@ -5655,7 +5655,7 @@
             <a:r>
               <a:rPr lang="en-US" sz="1300" b="1" dirty="0">
                 <a:solidFill>
-                  <a:srgbClr val="22C55E"/>
+                  <a:srgbClr val="16A34A"/>
                 </a:solidFill>
                 <a:latin typeface="游ゴシック" pitchFamily="34" charset="0"/>
                 <a:ea typeface="游ゴシック" pitchFamily="34" charset="-122"/>
@@ -5682,7 +5682,7 @@
             <a:avLst/>
           </a:prstGeom>
           <a:solidFill>
-            <a:srgbClr val="111E2E"/>
+            <a:srgbClr val="F5F7FA"/>
           </a:solidFill>
           <a:ln/>
         </p:spPr>
@@ -5714,7 +5714,7 @@
             <a:r>
               <a:rPr lang="en-US" sz="1200" dirty="0">
                 <a:solidFill>
-                  <a:srgbClr val="E8F4FF"/>
+                  <a:srgbClr val="1A1A2E"/>
                 </a:solidFill>
                 <a:latin typeface="游ゴシック" pitchFamily="34" charset="0"/>
                 <a:ea typeface="游ゴシック" pitchFamily="34" charset="-122"/>
@@ -5753,7 +5753,7 @@
             <a:r>
               <a:rPr lang="en-US" sz="1100" dirty="0">
                 <a:solidFill>
-                  <a:srgbClr val="8094B4"/>
+                  <a:srgbClr val="6B7280"/>
                 </a:solidFill>
                 <a:latin typeface="游ゴシック" pitchFamily="34" charset="0"/>
                 <a:ea typeface="游ゴシック" pitchFamily="34" charset="-122"/>
@@ -5792,7 +5792,7 @@
             <a:r>
               <a:rPr lang="en-US" sz="1300" dirty="0">
                 <a:solidFill>
-                  <a:srgbClr val="E8F4FF"/>
+                  <a:srgbClr val="1A1A2E"/>
                 </a:solidFill>
                 <a:latin typeface="游ゴシック" pitchFamily="34" charset="0"/>
                 <a:ea typeface="游ゴシック" pitchFamily="34" charset="-122"/>
@@ -5831,7 +5831,7 @@
             <a:r>
               <a:rPr lang="en-US" sz="1300" b="1" dirty="0">
                 <a:solidFill>
-                  <a:srgbClr val="E8F4FF"/>
+                  <a:srgbClr val="1A1A2E"/>
                 </a:solidFill>
                 <a:latin typeface="游ゴシック" pitchFamily="34" charset="0"/>
                 <a:ea typeface="游ゴシック" pitchFamily="34" charset="-122"/>
@@ -5870,7 +5870,7 @@
             <a:r>
               <a:rPr lang="en-US" sz="1300" b="1" dirty="0">
                 <a:solidFill>
-                  <a:srgbClr val="22C55E"/>
+                  <a:srgbClr val="16A34A"/>
                 </a:solidFill>
                 <a:latin typeface="游ゴシック" pitchFamily="34" charset="0"/>
                 <a:ea typeface="游ゴシック" pitchFamily="34" charset="-122"/>
@@ -5897,7 +5897,7 @@
             <a:avLst/>
           </a:prstGeom>
           <a:solidFill>
-            <a:srgbClr val="0F1B2D"/>
+            <a:srgbClr val="FFFFFF"/>
           </a:solidFill>
           <a:ln/>
         </p:spPr>
@@ -5929,7 +5929,7 @@
             <a:r>
               <a:rPr lang="en-US" sz="1200" dirty="0">
                 <a:solidFill>
-                  <a:srgbClr val="6A80A0"/>
+                  <a:srgbClr val="1A1A2E"/>
                 </a:solidFill>
                 <a:latin typeface="游ゴシック" pitchFamily="34" charset="0"/>
                 <a:ea typeface="游ゴシック" pitchFamily="34" charset="-122"/>
@@ -5968,7 +5968,7 @@
             <a:r>
               <a:rPr lang="en-US" sz="1100" dirty="0">
                 <a:solidFill>
-                  <a:srgbClr val="8094B4"/>
+                  <a:srgbClr val="6B7280"/>
                 </a:solidFill>
                 <a:latin typeface="游ゴシック" pitchFamily="34" charset="0"/>
                 <a:ea typeface="游ゴシック" pitchFamily="34" charset="-122"/>
@@ -6007,7 +6007,7 @@
             <a:r>
               <a:rPr lang="en-US" sz="1300" dirty="0">
                 <a:solidFill>
-                  <a:srgbClr val="6A80A0"/>
+                  <a:srgbClr val="1A1A2E"/>
                 </a:solidFill>
                 <a:latin typeface="游ゴシック" pitchFamily="34" charset="0"/>
                 <a:ea typeface="游ゴシック" pitchFamily="34" charset="-122"/>
@@ -6046,7 +6046,7 @@
             <a:r>
               <a:rPr lang="en-US" sz="1300" b="1" dirty="0">
                 <a:solidFill>
-                  <a:srgbClr val="E8F4FF"/>
+                  <a:srgbClr val="1A1A2E"/>
                 </a:solidFill>
                 <a:latin typeface="游ゴシック" pitchFamily="34" charset="0"/>
                 <a:ea typeface="游ゴシック" pitchFamily="34" charset="-122"/>
@@ -6085,7 +6085,7 @@
             <a:r>
               <a:rPr lang="en-US" sz="1300" b="1" dirty="0">
                 <a:solidFill>
-                  <a:srgbClr val="EF4444"/>
+                  <a:srgbClr val="DC2626"/>
                 </a:solidFill>
                 <a:latin typeface="游ゴシック" pitchFamily="34" charset="0"/>
                 <a:ea typeface="游ゴシック" pitchFamily="34" charset="-122"/>
@@ -6112,7 +6112,7 @@
             <a:avLst/>
           </a:prstGeom>
           <a:solidFill>
-            <a:srgbClr val="111E2E"/>
+            <a:srgbClr val="F5F7FA"/>
           </a:solidFill>
           <a:ln/>
         </p:spPr>
@@ -6144,7 +6144,7 @@
             <a:r>
               <a:rPr lang="en-US" sz="1200" dirty="0">
                 <a:solidFill>
-                  <a:srgbClr val="E8F4FF"/>
+                  <a:srgbClr val="1A1A2E"/>
                 </a:solidFill>
                 <a:latin typeface="游ゴシック" pitchFamily="34" charset="0"/>
                 <a:ea typeface="游ゴシック" pitchFamily="34" charset="-122"/>
@@ -6183,7 +6183,7 @@
             <a:r>
               <a:rPr lang="en-US" sz="1100" dirty="0">
                 <a:solidFill>
-                  <a:srgbClr val="8094B4"/>
+                  <a:srgbClr val="6B7280"/>
                 </a:solidFill>
                 <a:latin typeface="游ゴシック" pitchFamily="34" charset="0"/>
                 <a:ea typeface="游ゴシック" pitchFamily="34" charset="-122"/>
@@ -6222,7 +6222,7 @@
             <a:r>
               <a:rPr lang="en-US" sz="1300" dirty="0">
                 <a:solidFill>
-                  <a:srgbClr val="E8F4FF"/>
+                  <a:srgbClr val="1A1A2E"/>
                 </a:solidFill>
                 <a:latin typeface="游ゴシック" pitchFamily="34" charset="0"/>
                 <a:ea typeface="游ゴシック" pitchFamily="34" charset="-122"/>
@@ -6261,7 +6261,7 @@
             <a:r>
               <a:rPr lang="en-US" sz="1300" b="1" dirty="0">
                 <a:solidFill>
-                  <a:srgbClr val="E8F4FF"/>
+                  <a:srgbClr val="1A1A2E"/>
                 </a:solidFill>
                 <a:latin typeface="游ゴシック" pitchFamily="34" charset="0"/>
                 <a:ea typeface="游ゴシック" pitchFamily="34" charset="-122"/>
@@ -6300,7 +6300,7 @@
             <a:r>
               <a:rPr lang="en-US" sz="1300" b="1" dirty="0">
                 <a:solidFill>
-                  <a:srgbClr val="22C55E"/>
+                  <a:srgbClr val="16A34A"/>
                 </a:solidFill>
                 <a:latin typeface="游ゴシック" pitchFamily="34" charset="0"/>
                 <a:ea typeface="游ゴシック" pitchFamily="34" charset="-122"/>
@@ -6327,7 +6327,7 @@
             <a:avLst/>
           </a:prstGeom>
           <a:solidFill>
-            <a:srgbClr val="0F1B2D"/>
+            <a:srgbClr val="FFFFFF"/>
           </a:solidFill>
           <a:ln/>
         </p:spPr>
@@ -6359,7 +6359,7 @@
             <a:r>
               <a:rPr lang="en-US" sz="1200" dirty="0">
                 <a:solidFill>
-                  <a:srgbClr val="6A80A0"/>
+                  <a:srgbClr val="1A1A2E"/>
                 </a:solidFill>
                 <a:latin typeface="游ゴシック" pitchFamily="34" charset="0"/>
                 <a:ea typeface="游ゴシック" pitchFamily="34" charset="-122"/>
@@ -6398,7 +6398,7 @@
             <a:r>
               <a:rPr lang="en-US" sz="1100" dirty="0">
                 <a:solidFill>
-                  <a:srgbClr val="8094B4"/>
+                  <a:srgbClr val="6B7280"/>
                 </a:solidFill>
                 <a:latin typeface="游ゴシック" pitchFamily="34" charset="0"/>
                 <a:ea typeface="游ゴシック" pitchFamily="34" charset="-122"/>
@@ -6437,7 +6437,7 @@
             <a:r>
               <a:rPr lang="en-US" sz="1300" dirty="0">
                 <a:solidFill>
-                  <a:srgbClr val="6A80A0"/>
+                  <a:srgbClr val="1A1A2E"/>
                 </a:solidFill>
                 <a:latin typeface="游ゴシック" pitchFamily="34" charset="0"/>
                 <a:ea typeface="游ゴシック" pitchFamily="34" charset="-122"/>
@@ -6476,7 +6476,7 @@
             <a:r>
               <a:rPr lang="en-US" sz="1300" b="1" dirty="0">
                 <a:solidFill>
-                  <a:srgbClr val="E8F4FF"/>
+                  <a:srgbClr val="1A1A2E"/>
                 </a:solidFill>
                 <a:latin typeface="游ゴシック" pitchFamily="34" charset="0"/>
                 <a:ea typeface="游ゴシック" pitchFamily="34" charset="-122"/>
@@ -6515,7 +6515,7 @@
             <a:r>
               <a:rPr lang="en-US" sz="1300" b="1" dirty="0">
                 <a:solidFill>
-                  <a:srgbClr val="22C55E"/>
+                  <a:srgbClr val="16A34A"/>
                 </a:solidFill>
                 <a:latin typeface="游ゴシック" pitchFamily="34" charset="0"/>
                 <a:ea typeface="游ゴシック" pitchFamily="34" charset="-122"/>
@@ -6542,7 +6542,7 @@
             <a:avLst/>
           </a:prstGeom>
           <a:solidFill>
-            <a:srgbClr val="111E2E"/>
+            <a:srgbClr val="F5F7FA"/>
           </a:solidFill>
           <a:ln/>
         </p:spPr>
@@ -6574,7 +6574,7 @@
             <a:r>
               <a:rPr lang="en-US" sz="1200" dirty="0">
                 <a:solidFill>
-                  <a:srgbClr val="E8F4FF"/>
+                  <a:srgbClr val="1A1A2E"/>
                 </a:solidFill>
                 <a:latin typeface="游ゴシック" pitchFamily="34" charset="0"/>
                 <a:ea typeface="游ゴシック" pitchFamily="34" charset="-122"/>
@@ -6613,7 +6613,7 @@
             <a:r>
               <a:rPr lang="en-US" sz="1100" dirty="0">
                 <a:solidFill>
-                  <a:srgbClr val="8094B4"/>
+                  <a:srgbClr val="6B7280"/>
                 </a:solidFill>
                 <a:latin typeface="游ゴシック" pitchFamily="34" charset="0"/>
                 <a:ea typeface="游ゴシック" pitchFamily="34" charset="-122"/>
@@ -6652,7 +6652,7 @@
             <a:r>
               <a:rPr lang="en-US" sz="1300" dirty="0">
                 <a:solidFill>
-                  <a:srgbClr val="E8F4FF"/>
+                  <a:srgbClr val="1A1A2E"/>
                 </a:solidFill>
                 <a:latin typeface="游ゴシック" pitchFamily="34" charset="0"/>
                 <a:ea typeface="游ゴシック" pitchFamily="34" charset="-122"/>
@@ -6691,7 +6691,7 @@
             <a:r>
               <a:rPr lang="en-US" sz="1300" b="1" dirty="0">
                 <a:solidFill>
-                  <a:srgbClr val="E8F4FF"/>
+                  <a:srgbClr val="1A1A2E"/>
                 </a:solidFill>
                 <a:latin typeface="游ゴシック" pitchFamily="34" charset="0"/>
                 <a:ea typeface="游ゴシック" pitchFamily="34" charset="-122"/>
@@ -6730,7 +6730,7 @@
             <a:r>
               <a:rPr lang="en-US" sz="1300" b="1" dirty="0">
                 <a:solidFill>
-                  <a:srgbClr val="22C55E"/>
+                  <a:srgbClr val="16A34A"/>
                 </a:solidFill>
                 <a:latin typeface="游ゴシック" pitchFamily="34" charset="0"/>
                 <a:ea typeface="游ゴシック" pitchFamily="34" charset="-122"/>
@@ -6757,7 +6757,7 @@
             <a:avLst/>
           </a:prstGeom>
           <a:solidFill>
-            <a:srgbClr val="0F1B2D"/>
+            <a:srgbClr val="FFFFFF"/>
           </a:solidFill>
           <a:ln/>
         </p:spPr>
@@ -6789,7 +6789,7 @@
             <a:r>
               <a:rPr lang="en-US" sz="1200" dirty="0">
                 <a:solidFill>
-                  <a:srgbClr val="6A80A0"/>
+                  <a:srgbClr val="1A1A2E"/>
                 </a:solidFill>
                 <a:latin typeface="游ゴシック" pitchFamily="34" charset="0"/>
                 <a:ea typeface="游ゴシック" pitchFamily="34" charset="-122"/>
@@ -6828,7 +6828,7 @@
             <a:r>
               <a:rPr lang="en-US" sz="1100" dirty="0">
                 <a:solidFill>
-                  <a:srgbClr val="8094B4"/>
+                  <a:srgbClr val="6B7280"/>
                 </a:solidFill>
                 <a:latin typeface="游ゴシック" pitchFamily="34" charset="0"/>
                 <a:ea typeface="游ゴシック" pitchFamily="34" charset="-122"/>
@@ -6867,7 +6867,7 @@
             <a:r>
               <a:rPr lang="en-US" sz="1300" dirty="0">
                 <a:solidFill>
-                  <a:srgbClr val="6A80A0"/>
+                  <a:srgbClr val="1A1A2E"/>
                 </a:solidFill>
                 <a:latin typeface="游ゴシック" pitchFamily="34" charset="0"/>
                 <a:ea typeface="游ゴシック" pitchFamily="34" charset="-122"/>
@@ -6906,7 +6906,7 @@
             <a:r>
               <a:rPr lang="en-US" sz="1300" b="1" dirty="0">
                 <a:solidFill>
-                  <a:srgbClr val="E8F4FF"/>
+                  <a:srgbClr val="1A1A2E"/>
                 </a:solidFill>
                 <a:latin typeface="游ゴシック" pitchFamily="34" charset="0"/>
                 <a:ea typeface="游ゴシック" pitchFamily="34" charset="-122"/>
@@ -6945,7 +6945,7 @@
             <a:r>
               <a:rPr lang="en-US" sz="1300" b="1" dirty="0">
                 <a:solidFill>
-                  <a:srgbClr val="22C55E"/>
+                  <a:srgbClr val="16A34A"/>
                 </a:solidFill>
                 <a:latin typeface="游ゴシック" pitchFamily="34" charset="0"/>
                 <a:ea typeface="游ゴシック" pitchFamily="34" charset="-122"/>
@@ -6972,7 +6972,7 @@
             <a:avLst/>
           </a:prstGeom>
           <a:solidFill>
-            <a:srgbClr val="111E2E"/>
+            <a:srgbClr val="F5F7FA"/>
           </a:solidFill>
           <a:ln/>
         </p:spPr>
@@ -7004,7 +7004,7 @@
             <a:r>
               <a:rPr lang="en-US" sz="1200" dirty="0">
                 <a:solidFill>
-                  <a:srgbClr val="E8F4FF"/>
+                  <a:srgbClr val="1A1A2E"/>
                 </a:solidFill>
                 <a:latin typeface="游ゴシック" pitchFamily="34" charset="0"/>
                 <a:ea typeface="游ゴシック" pitchFamily="34" charset="-122"/>
@@ -7043,7 +7043,7 @@
             <a:r>
               <a:rPr lang="en-US" sz="1100" dirty="0">
                 <a:solidFill>
-                  <a:srgbClr val="8094B4"/>
+                  <a:srgbClr val="6B7280"/>
                 </a:solidFill>
                 <a:latin typeface="游ゴシック" pitchFamily="34" charset="0"/>
                 <a:ea typeface="游ゴシック" pitchFamily="34" charset="-122"/>
@@ -7082,7 +7082,7 @@
             <a:r>
               <a:rPr lang="en-US" sz="1300" dirty="0">
                 <a:solidFill>
-                  <a:srgbClr val="E8F4FF"/>
+                  <a:srgbClr val="1A1A2E"/>
                 </a:solidFill>
                 <a:latin typeface="游ゴシック" pitchFamily="34" charset="0"/>
                 <a:ea typeface="游ゴシック" pitchFamily="34" charset="-122"/>
@@ -7121,7 +7121,7 @@
             <a:r>
               <a:rPr lang="en-US" sz="1300" b="1" dirty="0">
                 <a:solidFill>
-                  <a:srgbClr val="E8F4FF"/>
+                  <a:srgbClr val="1A1A2E"/>
                 </a:solidFill>
                 <a:latin typeface="游ゴシック" pitchFamily="34" charset="0"/>
                 <a:ea typeface="游ゴシック" pitchFamily="34" charset="-122"/>
@@ -7160,7 +7160,7 @@
             <a:r>
               <a:rPr lang="en-US" sz="1300" b="1" dirty="0">
                 <a:solidFill>
-                  <a:srgbClr val="22C55E"/>
+                  <a:srgbClr val="16A34A"/>
                 </a:solidFill>
                 <a:latin typeface="游ゴシック" pitchFamily="34" charset="0"/>
                 <a:ea typeface="游ゴシック" pitchFamily="34" charset="-122"/>
@@ -7187,7 +7187,7 @@
             <a:avLst/>
           </a:prstGeom>
           <a:solidFill>
-            <a:srgbClr val="0F1B2D"/>
+            <a:srgbClr val="FFFFFF"/>
           </a:solidFill>
           <a:ln/>
         </p:spPr>
@@ -7219,7 +7219,7 @@
             <a:r>
               <a:rPr lang="en-US" sz="1200" dirty="0">
                 <a:solidFill>
-                  <a:srgbClr val="6A80A0"/>
+                  <a:srgbClr val="1A1A2E"/>
                 </a:solidFill>
                 <a:latin typeface="游ゴシック" pitchFamily="34" charset="0"/>
                 <a:ea typeface="游ゴシック" pitchFamily="34" charset="-122"/>
@@ -7258,7 +7258,7 @@
             <a:r>
               <a:rPr lang="en-US" sz="1100" dirty="0">
                 <a:solidFill>
-                  <a:srgbClr val="8094B4"/>
+                  <a:srgbClr val="6B7280"/>
                 </a:solidFill>
                 <a:latin typeface="游ゴシック" pitchFamily="34" charset="0"/>
                 <a:ea typeface="游ゴシック" pitchFamily="34" charset="-122"/>
@@ -7297,7 +7297,7 @@
             <a:r>
               <a:rPr lang="en-US" sz="1300" dirty="0">
                 <a:solidFill>
-                  <a:srgbClr val="6A80A0"/>
+                  <a:srgbClr val="1A1A2E"/>
                 </a:solidFill>
                 <a:latin typeface="游ゴシック" pitchFamily="34" charset="0"/>
                 <a:ea typeface="游ゴシック" pitchFamily="34" charset="-122"/>
@@ -7336,7 +7336,7 @@
             <a:r>
               <a:rPr lang="en-US" sz="1300" b="1" dirty="0">
                 <a:solidFill>
-                  <a:srgbClr val="E8F4FF"/>
+                  <a:srgbClr val="1A1A2E"/>
                 </a:solidFill>
                 <a:latin typeface="游ゴシック" pitchFamily="34" charset="0"/>
                 <a:ea typeface="游ゴシック" pitchFamily="34" charset="-122"/>
@@ -7375,7 +7375,7 @@
             <a:r>
               <a:rPr lang="en-US" sz="1300" b="1" dirty="0">
                 <a:solidFill>
-                  <a:srgbClr val="22C55E"/>
+                  <a:srgbClr val="16A34A"/>
                 </a:solidFill>
                 <a:latin typeface="游ゴシック" pitchFamily="34" charset="0"/>
                 <a:ea typeface="游ゴシック" pitchFamily="34" charset="-122"/>
@@ -7402,7 +7402,7 @@
             <a:avLst/>
           </a:prstGeom>
           <a:solidFill>
-            <a:srgbClr val="1A3255"/>
+            <a:srgbClr val="DBEAFE"/>
           </a:solidFill>
           <a:ln/>
         </p:spPr>
@@ -7422,7 +7422,7 @@
             <a:avLst/>
           </a:prstGeom>
           <a:solidFill>
-            <a:srgbClr val="3B82F6"/>
+            <a:srgbClr val="2563EB"/>
           </a:solidFill>
           <a:ln/>
         </p:spPr>
@@ -7454,7 +7454,7 @@
             <a:r>
               <a:rPr lang="en-US" sz="1200" b="1" dirty="0">
                 <a:solidFill>
-                  <a:srgbClr val="3B82F6"/>
+                  <a:srgbClr val="2563EB"/>
                 </a:solidFill>
                 <a:latin typeface="游ゴシック" pitchFamily="34" charset="0"/>
                 <a:ea typeface="游ゴシック" pitchFamily="34" charset="-122"/>
@@ -7493,7 +7493,7 @@
             <a:r>
               <a:rPr lang="en-US" sz="1100" dirty="0">
                 <a:solidFill>
-                  <a:srgbClr val="8094B4"/>
+                  <a:srgbClr val="6B7280"/>
                 </a:solidFill>
                 <a:latin typeface="游ゴシック" pitchFamily="34" charset="0"/>
                 <a:ea typeface="游ゴシック" pitchFamily="34" charset="-122"/>
@@ -7532,7 +7532,7 @@
             <a:r>
               <a:rPr lang="en-US" sz="1300" b="1" dirty="0">
                 <a:solidFill>
-                  <a:srgbClr val="E8F4FF"/>
+                  <a:srgbClr val="1A1A2E"/>
                 </a:solidFill>
                 <a:latin typeface="游ゴシック" pitchFamily="34" charset="0"/>
                 <a:ea typeface="游ゴシック" pitchFamily="34" charset="-122"/>
@@ -7571,7 +7571,7 @@
             <a:r>
               <a:rPr lang="en-US" sz="1300" b="1" dirty="0">
                 <a:solidFill>
-                  <a:srgbClr val="3B82F6"/>
+                  <a:srgbClr val="2563EB"/>
                 </a:solidFill>
                 <a:latin typeface="游ゴシック" pitchFamily="34" charset="0"/>
                 <a:ea typeface="游ゴシック" pitchFamily="34" charset="-122"/>
@@ -7610,7 +7610,7 @@
             <a:r>
               <a:rPr lang="en-US" sz="1300" b="1" dirty="0">
                 <a:solidFill>
-                  <a:srgbClr val="22C55E"/>
+                  <a:srgbClr val="16A34A"/>
                 </a:solidFill>
                 <a:latin typeface="游ゴシック" pitchFamily="34" charset="0"/>
                 <a:ea typeface="游ゴシック" pitchFamily="34" charset="-122"/>
@@ -7637,7 +7637,7 @@
             <a:avLst/>
           </a:prstGeom>
           <a:solidFill>
-            <a:srgbClr val="0F1B2D"/>
+            <a:srgbClr val="FFFFFF"/>
           </a:solidFill>
           <a:ln/>
         </p:spPr>
@@ -7669,7 +7669,7 @@
             <a:r>
               <a:rPr lang="en-US" sz="1200" dirty="0">
                 <a:solidFill>
-                  <a:srgbClr val="6A80A0"/>
+                  <a:srgbClr val="1A1A2E"/>
                 </a:solidFill>
                 <a:latin typeface="游ゴシック" pitchFamily="34" charset="0"/>
                 <a:ea typeface="游ゴシック" pitchFamily="34" charset="-122"/>
@@ -7708,7 +7708,7 @@
             <a:r>
               <a:rPr lang="en-US" sz="1100" dirty="0">
                 <a:solidFill>
-                  <a:srgbClr val="8094B4"/>
+                  <a:srgbClr val="6B7280"/>
                 </a:solidFill>
                 <a:latin typeface="游ゴシック" pitchFamily="34" charset="0"/>
                 <a:ea typeface="游ゴシック" pitchFamily="34" charset="-122"/>
@@ -7747,7 +7747,7 @@
             <a:r>
               <a:rPr lang="en-US" sz="1300" dirty="0">
                 <a:solidFill>
-                  <a:srgbClr val="6A80A0"/>
+                  <a:srgbClr val="1A1A2E"/>
                 </a:solidFill>
                 <a:latin typeface="游ゴシック" pitchFamily="34" charset="0"/>
                 <a:ea typeface="游ゴシック" pitchFamily="34" charset="-122"/>
@@ -7786,7 +7786,7 @@
             <a:r>
               <a:rPr lang="en-US" sz="1300" b="1" dirty="0">
                 <a:solidFill>
-                  <a:srgbClr val="E8F4FF"/>
+                  <a:srgbClr val="1A1A2E"/>
                 </a:solidFill>
                 <a:latin typeface="游ゴシック" pitchFamily="34" charset="0"/>
                 <a:ea typeface="游ゴシック" pitchFamily="34" charset="-122"/>
@@ -7825,7 +7825,7 @@
             <a:r>
               <a:rPr lang="en-US" sz="1300" b="1" dirty="0">
                 <a:solidFill>
-                  <a:srgbClr val="22C55E"/>
+                  <a:srgbClr val="16A34A"/>
                 </a:solidFill>
                 <a:latin typeface="游ゴシック" pitchFamily="34" charset="0"/>
                 <a:ea typeface="游ゴシック" pitchFamily="34" charset="-122"/>
@@ -7852,7 +7852,7 @@
             <a:avLst/>
           </a:prstGeom>
           <a:solidFill>
-            <a:srgbClr val="111E2E"/>
+            <a:srgbClr val="F5F7FA"/>
           </a:solidFill>
           <a:ln/>
         </p:spPr>
@@ -7884,7 +7884,7 @@
             <a:r>
               <a:rPr lang="en-US" sz="1200" dirty="0">
                 <a:solidFill>
-                  <a:srgbClr val="E8F4FF"/>
+                  <a:srgbClr val="1A1A2E"/>
                 </a:solidFill>
                 <a:latin typeface="游ゴシック" pitchFamily="34" charset="0"/>
                 <a:ea typeface="游ゴシック" pitchFamily="34" charset="-122"/>
@@ -7923,7 +7923,7 @@
             <a:r>
               <a:rPr lang="en-US" sz="1100" dirty="0">
                 <a:solidFill>
-                  <a:srgbClr val="8094B4"/>
+                  <a:srgbClr val="6B7280"/>
                 </a:solidFill>
                 <a:latin typeface="游ゴシック" pitchFamily="34" charset="0"/>
                 <a:ea typeface="游ゴシック" pitchFamily="34" charset="-122"/>
@@ -7962,7 +7962,7 @@
             <a:r>
               <a:rPr lang="en-US" sz="1300" dirty="0">
                 <a:solidFill>
-                  <a:srgbClr val="E8F4FF"/>
+                  <a:srgbClr val="1A1A2E"/>
                 </a:solidFill>
                 <a:latin typeface="游ゴシック" pitchFamily="34" charset="0"/>
                 <a:ea typeface="游ゴシック" pitchFamily="34" charset="-122"/>
@@ -8001,7 +8001,7 @@
             <a:r>
               <a:rPr lang="en-US" sz="1300" b="1" dirty="0">
                 <a:solidFill>
-                  <a:srgbClr val="E8F4FF"/>
+                  <a:srgbClr val="1A1A2E"/>
                 </a:solidFill>
                 <a:latin typeface="游ゴシック" pitchFamily="34" charset="0"/>
                 <a:ea typeface="游ゴシック" pitchFamily="34" charset="-122"/>
@@ -8040,7 +8040,7 @@
             <a:r>
               <a:rPr lang="en-US" sz="1300" b="1" dirty="0">
                 <a:solidFill>
-                  <a:srgbClr val="22C55E"/>
+                  <a:srgbClr val="16A34A"/>
                 </a:solidFill>
                 <a:latin typeface="游ゴシック" pitchFamily="34" charset="0"/>
                 <a:ea typeface="游ゴシック" pitchFamily="34" charset="-122"/>
@@ -8067,7 +8067,7 @@
             <a:avLst/>
           </a:prstGeom>
           <a:solidFill>
-            <a:srgbClr val="0F1B2D"/>
+            <a:srgbClr val="FFFFFF"/>
           </a:solidFill>
           <a:ln/>
         </p:spPr>
@@ -8099,7 +8099,7 @@
             <a:r>
               <a:rPr lang="en-US" sz="1200" dirty="0">
                 <a:solidFill>
-                  <a:srgbClr val="6A80A0"/>
+                  <a:srgbClr val="1A1A2E"/>
                 </a:solidFill>
                 <a:latin typeface="游ゴシック" pitchFamily="34" charset="0"/>
                 <a:ea typeface="游ゴシック" pitchFamily="34" charset="-122"/>
@@ -8138,7 +8138,7 @@
             <a:r>
               <a:rPr lang="en-US" sz="1100" dirty="0">
                 <a:solidFill>
-                  <a:srgbClr val="8094B4"/>
+                  <a:srgbClr val="6B7280"/>
                 </a:solidFill>
                 <a:latin typeface="游ゴシック" pitchFamily="34" charset="0"/>
                 <a:ea typeface="游ゴシック" pitchFamily="34" charset="-122"/>
@@ -8177,7 +8177,7 @@
             <a:r>
               <a:rPr lang="en-US" sz="1300" dirty="0">
                 <a:solidFill>
-                  <a:srgbClr val="6A80A0"/>
+                  <a:srgbClr val="1A1A2E"/>
                 </a:solidFill>
                 <a:latin typeface="游ゴシック" pitchFamily="34" charset="0"/>
                 <a:ea typeface="游ゴシック" pitchFamily="34" charset="-122"/>
@@ -8216,7 +8216,7 @@
             <a:r>
               <a:rPr lang="en-US" sz="1300" b="1" dirty="0">
                 <a:solidFill>
-                  <a:srgbClr val="E8F4FF"/>
+                  <a:srgbClr val="1A1A2E"/>
                 </a:solidFill>
                 <a:latin typeface="游ゴシック" pitchFamily="34" charset="0"/>
                 <a:ea typeface="游ゴシック" pitchFamily="34" charset="-122"/>
@@ -8255,7 +8255,7 @@
             <a:r>
               <a:rPr lang="en-US" sz="1300" b="1" dirty="0">
                 <a:solidFill>
-                  <a:srgbClr val="22C55E"/>
+                  <a:srgbClr val="16A34A"/>
                 </a:solidFill>
                 <a:latin typeface="游ゴシック" pitchFamily="34" charset="0"/>
                 <a:ea typeface="游ゴシック" pitchFamily="34" charset="-122"/>
@@ -8282,7 +8282,7 @@
             <a:avLst/>
           </a:prstGeom>
           <a:solidFill>
-            <a:srgbClr val="111E2E"/>
+            <a:srgbClr val="F5F7FA"/>
           </a:solidFill>
           <a:ln/>
         </p:spPr>
@@ -8314,7 +8314,7 @@
             <a:r>
               <a:rPr lang="en-US" sz="1200" dirty="0">
                 <a:solidFill>
-                  <a:srgbClr val="E8F4FF"/>
+                  <a:srgbClr val="1A1A2E"/>
                 </a:solidFill>
                 <a:latin typeface="游ゴシック" pitchFamily="34" charset="0"/>
                 <a:ea typeface="游ゴシック" pitchFamily="34" charset="-122"/>
@@ -8353,7 +8353,7 @@
             <a:r>
               <a:rPr lang="en-US" sz="1100" dirty="0">
                 <a:solidFill>
-                  <a:srgbClr val="8094B4"/>
+                  <a:srgbClr val="6B7280"/>
                 </a:solidFill>
                 <a:latin typeface="游ゴシック" pitchFamily="34" charset="0"/>
                 <a:ea typeface="游ゴシック" pitchFamily="34" charset="-122"/>
@@ -8392,7 +8392,7 @@
             <a:r>
               <a:rPr lang="en-US" sz="1300" dirty="0">
                 <a:solidFill>
-                  <a:srgbClr val="E8F4FF"/>
+                  <a:srgbClr val="1A1A2E"/>
                 </a:solidFill>
                 <a:latin typeface="游ゴシック" pitchFamily="34" charset="0"/>
                 <a:ea typeface="游ゴシック" pitchFamily="34" charset="-122"/>
@@ -8431,7 +8431,7 @@
             <a:r>
               <a:rPr lang="en-US" sz="1300" b="1" dirty="0">
                 <a:solidFill>
-                  <a:srgbClr val="E8F4FF"/>
+                  <a:srgbClr val="1A1A2E"/>
                 </a:solidFill>
                 <a:latin typeface="游ゴシック" pitchFamily="34" charset="0"/>
                 <a:ea typeface="游ゴシック" pitchFamily="34" charset="-122"/>
@@ -8470,7 +8470,7 @@
             <a:r>
               <a:rPr lang="en-US" sz="1300" b="1" dirty="0">
                 <a:solidFill>
-                  <a:srgbClr val="EF4444"/>
+                  <a:srgbClr val="DC2626"/>
                 </a:solidFill>
                 <a:latin typeface="游ゴシック" pitchFamily="34" charset="0"/>
                 <a:ea typeface="游ゴシック" pitchFamily="34" charset="-122"/>
@@ -8497,7 +8497,7 @@
             <a:avLst/>
           </a:prstGeom>
           <a:solidFill>
-            <a:srgbClr val="0F1B2D"/>
+            <a:srgbClr val="FFFFFF"/>
           </a:solidFill>
           <a:ln/>
         </p:spPr>
@@ -8529,7 +8529,7 @@
             <a:r>
               <a:rPr lang="en-US" sz="1200" dirty="0">
                 <a:solidFill>
-                  <a:srgbClr val="6A80A0"/>
+                  <a:srgbClr val="1A1A2E"/>
                 </a:solidFill>
                 <a:latin typeface="游ゴシック" pitchFamily="34" charset="0"/>
                 <a:ea typeface="游ゴシック" pitchFamily="34" charset="-122"/>
@@ -8568,7 +8568,7 @@
             <a:r>
               <a:rPr lang="en-US" sz="1100" dirty="0">
                 <a:solidFill>
-                  <a:srgbClr val="8094B4"/>
+                  <a:srgbClr val="6B7280"/>
                 </a:solidFill>
                 <a:latin typeface="游ゴシック" pitchFamily="34" charset="0"/>
                 <a:ea typeface="游ゴシック" pitchFamily="34" charset="-122"/>
@@ -8607,7 +8607,7 @@
             <a:r>
               <a:rPr lang="en-US" sz="1300" dirty="0">
                 <a:solidFill>
-                  <a:srgbClr val="6A80A0"/>
+                  <a:srgbClr val="1A1A2E"/>
                 </a:solidFill>
                 <a:latin typeface="游ゴシック" pitchFamily="34" charset="0"/>
                 <a:ea typeface="游ゴシック" pitchFamily="34" charset="-122"/>
@@ -8646,7 +8646,7 @@
             <a:r>
               <a:rPr lang="en-US" sz="1300" b="1" dirty="0">
                 <a:solidFill>
-                  <a:srgbClr val="E8F4FF"/>
+                  <a:srgbClr val="1A1A2E"/>
                 </a:solidFill>
                 <a:latin typeface="游ゴシック" pitchFamily="34" charset="0"/>
                 <a:ea typeface="游ゴシック" pitchFamily="34" charset="-122"/>
@@ -8685,7 +8685,7 @@
             <a:r>
               <a:rPr lang="en-US" sz="1300" b="1" dirty="0">
                 <a:solidFill>
-                  <a:srgbClr val="22C55E"/>
+                  <a:srgbClr val="16A34A"/>
                 </a:solidFill>
                 <a:latin typeface="游ゴシック" pitchFamily="34" charset="0"/>
                 <a:ea typeface="游ゴシック" pitchFamily="34" charset="-122"/>

</xml_diff>

<commit_message>
data: update ranking to April — 名古屋 3rd place (29.5% YoY)
https://claude.ai/code/session_013LUtg8kZ6SCk9upzYYqLj7
</commit_message>
<xml_diff>
--- a/slides/exports/sales-meeting.pptx
+++ b/slides/exports/sales-meeting.pptx
@@ -5211,7 +5211,7 @@
                 <a:ea typeface="游ゴシック" pitchFamily="34" charset="-122"/>
                 <a:cs typeface="游ゴシック" pitchFamily="34" charset="-120"/>
               </a:rPr>
-              <a:t>5月度 売上ランキング　（単位：円）</a:t>
+              <a:t>4月度 売上ランキング　（単位：円）</a:t>
             </a:r>
             <a:endParaRPr lang="en-US" sz="2600" dirty="0"/>
           </a:p>
@@ -5622,7 +5622,7 @@
                 <a:ea typeface="游ゴシック" pitchFamily="34" charset="-122"/>
                 <a:cs typeface="游ゴシック" pitchFamily="34" charset="-120"/>
               </a:rPr>
-              <a:t>141,916,484</a:t>
+              <a:t>158,811,604</a:t>
             </a:r>
             <a:endParaRPr lang="en-US" sz="1300" dirty="0"/>
           </a:p>
@@ -5661,7 +5661,7 @@
                 <a:ea typeface="游ゴシック" pitchFamily="34" charset="-122"/>
                 <a:cs typeface="游ゴシック" pitchFamily="34" charset="-120"/>
               </a:rPr>
-              <a:t>8.4%</a:t>
+              <a:t>18.3%</a:t>
             </a:r>
             <a:endParaRPr lang="en-US" sz="1300" dirty="0"/>
           </a:p>
@@ -5837,7 +5837,7 @@
                 <a:ea typeface="游ゴシック" pitchFamily="34" charset="-122"/>
                 <a:cs typeface="游ゴシック" pitchFamily="34" charset="-120"/>
               </a:rPr>
-              <a:t>87,722,501</a:t>
+              <a:t>54,676,382</a:t>
             </a:r>
             <a:endParaRPr lang="en-US" sz="1300" dirty="0"/>
           </a:p>
@@ -5870,13 +5870,248 @@
             <a:r>
               <a:rPr lang="en-US" sz="1300" b="1" dirty="0">
                 <a:solidFill>
+                  <a:srgbClr val="DC2626"/>
+                </a:solidFill>
+                <a:latin typeface="游ゴシック" pitchFamily="34" charset="0"/>
+                <a:ea typeface="游ゴシック" pitchFamily="34" charset="-122"/>
+                <a:cs typeface="游ゴシック" pitchFamily="34" charset="-120"/>
+              </a:rPr>
+              <a:t>▲25.9%</a:t>
+            </a:r>
+            <a:endParaRPr lang="en-US" sz="1300" dirty="0"/>
+          </a:p>
+        </p:txBody>
+      </p:sp>
+      <p:sp>
+        <p:nvSpPr>
+          <p:cNvPr id="22" name="Shape 20"/>
+          <p:cNvSpPr/>
+          <p:nvPr/>
+        </p:nvSpPr>
+        <p:spPr>
+          <a:xfrm>
+            <a:off x="548640" y="2144268"/>
+            <a:ext cx="11091672" cy="333756"/>
+          </a:xfrm>
+          <a:prstGeom prst="rect">
+            <a:avLst/>
+          </a:prstGeom>
+          <a:solidFill>
+            <a:srgbClr val="DBEAFE"/>
+          </a:solidFill>
+          <a:ln/>
+        </p:spPr>
+      </p:sp>
+      <p:sp>
+        <p:nvSpPr>
+          <p:cNvPr id="23" name="Shape 21"/>
+          <p:cNvSpPr/>
+          <p:nvPr/>
+        </p:nvSpPr>
+        <p:spPr>
+          <a:xfrm>
+            <a:off x="548640" y="2144268"/>
+            <a:ext cx="41148" cy="333756"/>
+          </a:xfrm>
+          <a:prstGeom prst="rect">
+            <a:avLst/>
+          </a:prstGeom>
+          <a:solidFill>
+            <a:srgbClr val="2563EB"/>
+          </a:solidFill>
+          <a:ln/>
+        </p:spPr>
+      </p:sp>
+      <p:sp>
+        <p:nvSpPr>
+          <p:cNvPr id="24" name="Text 22"/>
+          <p:cNvSpPr/>
+          <p:nvPr/>
+        </p:nvSpPr>
+        <p:spPr>
+          <a:xfrm>
+            <a:off x="548640" y="2144268"/>
+            <a:ext cx="594360" cy="333756"/>
+          </a:xfrm>
+          <a:prstGeom prst="rect">
+            <a:avLst/>
+          </a:prstGeom>
+          <a:noFill/>
+          <a:ln/>
+        </p:spPr>
+        <p:txBody>
+          <a:bodyPr wrap="square" rtlCol="0" anchor="ctr"/>
+          <a:lstStyle/>
+          <a:p>
+            <a:pPr algn="ctr" indent="0" marL="0">
+              <a:buNone/>
+            </a:pPr>
+            <a:r>
+              <a:rPr lang="en-US" sz="1200" b="1" dirty="0">
+                <a:solidFill>
+                  <a:srgbClr val="2563EB"/>
+                </a:solidFill>
+                <a:latin typeface="游ゴシック" pitchFamily="34" charset="0"/>
+                <a:ea typeface="游ゴシック" pitchFamily="34" charset="-122"/>
+                <a:cs typeface="游ゴシック" pitchFamily="34" charset="-120"/>
+              </a:rPr>
+              <a:t>3</a:t>
+            </a:r>
+            <a:endParaRPr lang="en-US" sz="1200" dirty="0"/>
+          </a:p>
+        </p:txBody>
+      </p:sp>
+      <p:sp>
+        <p:nvSpPr>
+          <p:cNvPr id="25" name="Text 23"/>
+          <p:cNvSpPr/>
+          <p:nvPr/>
+        </p:nvSpPr>
+        <p:spPr>
+          <a:xfrm>
+            <a:off x="1143000" y="2144268"/>
+            <a:ext cx="594360" cy="333756"/>
+          </a:xfrm>
+          <a:prstGeom prst="rect">
+            <a:avLst/>
+          </a:prstGeom>
+          <a:noFill/>
+          <a:ln/>
+        </p:spPr>
+        <p:txBody>
+          <a:bodyPr wrap="square" rtlCol="0" anchor="ctr"/>
+          <a:lstStyle/>
+          <a:p>
+            <a:pPr algn="ctr" indent="0" marL="0">
+              <a:buNone/>
+            </a:pPr>
+            <a:r>
+              <a:rPr lang="en-US" sz="1100" dirty="0">
+                <a:solidFill>
+                  <a:srgbClr val="6B7280"/>
+                </a:solidFill>
+                <a:latin typeface="游ゴシック" pitchFamily="34" charset="0"/>
+                <a:ea typeface="游ゴシック" pitchFamily="34" charset="-122"/>
+                <a:cs typeface="游ゴシック" pitchFamily="34" charset="-120"/>
+              </a:rPr>
+              <a:t>24</a:t>
+            </a:r>
+            <a:endParaRPr lang="en-US" sz="1100" dirty="0"/>
+          </a:p>
+        </p:txBody>
+      </p:sp>
+      <p:sp>
+        <p:nvSpPr>
+          <p:cNvPr id="26" name="Text 24"/>
+          <p:cNvSpPr/>
+          <p:nvPr/>
+        </p:nvSpPr>
+        <p:spPr>
+          <a:xfrm>
+            <a:off x="1828800" y="2144268"/>
+            <a:ext cx="7040880" cy="333756"/>
+          </a:xfrm>
+          <a:prstGeom prst="rect">
+            <a:avLst/>
+          </a:prstGeom>
+          <a:noFill/>
+          <a:ln/>
+        </p:spPr>
+        <p:txBody>
+          <a:bodyPr wrap="square" rtlCol="0" anchor="ctr"/>
+          <a:lstStyle/>
+          <a:p>
+            <a:pPr algn="l" indent="0" marL="0">
+              <a:buNone/>
+            </a:pPr>
+            <a:r>
+              <a:rPr lang="en-US" sz="1300" b="1" dirty="0">
+                <a:solidFill>
+                  <a:srgbClr val="1A1A2E"/>
+                </a:solidFill>
+                <a:latin typeface="游ゴシック" pitchFamily="34" charset="0"/>
+                <a:ea typeface="游ゴシック" pitchFamily="34" charset="-122"/>
+                <a:cs typeface="游ゴシック" pitchFamily="34" charset="-120"/>
+              </a:rPr>
+              <a:t>名古屋イベントセンター</a:t>
+            </a:r>
+            <a:endParaRPr lang="en-US" sz="1300" dirty="0"/>
+          </a:p>
+        </p:txBody>
+      </p:sp>
+      <p:sp>
+        <p:nvSpPr>
+          <p:cNvPr id="27" name="Text 25"/>
+          <p:cNvSpPr/>
+          <p:nvPr/>
+        </p:nvSpPr>
+        <p:spPr>
+          <a:xfrm>
+            <a:off x="8778240" y="2144268"/>
+            <a:ext cx="1920240" cy="333756"/>
+          </a:xfrm>
+          <a:prstGeom prst="rect">
+            <a:avLst/>
+          </a:prstGeom>
+          <a:noFill/>
+          <a:ln/>
+        </p:spPr>
+        <p:txBody>
+          <a:bodyPr wrap="square" rtlCol="0" anchor="ctr"/>
+          <a:lstStyle/>
+          <a:p>
+            <a:pPr algn="r" indent="0" marL="0">
+              <a:buNone/>
+            </a:pPr>
+            <a:r>
+              <a:rPr lang="en-US" sz="1300" b="1" dirty="0">
+                <a:solidFill>
+                  <a:srgbClr val="2563EB"/>
+                </a:solidFill>
+                <a:latin typeface="游ゴシック" pitchFamily="34" charset="0"/>
+                <a:ea typeface="游ゴシック" pitchFamily="34" charset="-122"/>
+                <a:cs typeface="游ゴシック" pitchFamily="34" charset="-120"/>
+              </a:rPr>
+              <a:t>54,377,853</a:t>
+            </a:r>
+            <a:endParaRPr lang="en-US" sz="1300" dirty="0"/>
+          </a:p>
+        </p:txBody>
+      </p:sp>
+      <p:sp>
+        <p:nvSpPr>
+          <p:cNvPr id="28" name="Text 26"/>
+          <p:cNvSpPr/>
+          <p:nvPr/>
+        </p:nvSpPr>
+        <p:spPr>
+          <a:xfrm>
+            <a:off x="10698480" y="2144268"/>
+            <a:ext cx="941832" cy="333756"/>
+          </a:xfrm>
+          <a:prstGeom prst="rect">
+            <a:avLst/>
+          </a:prstGeom>
+          <a:noFill/>
+          <a:ln/>
+        </p:spPr>
+        <p:txBody>
+          <a:bodyPr wrap="square" rtlCol="0" anchor="ctr"/>
+          <a:lstStyle/>
+          <a:p>
+            <a:pPr algn="r" indent="0" marL="0">
+              <a:buNone/>
+            </a:pPr>
+            <a:r>
+              <a:rPr lang="en-US" sz="1300" b="1" dirty="0">
+                <a:solidFill>
                   <a:srgbClr val="16A34A"/>
                 </a:solidFill>
                 <a:latin typeface="游ゴシック" pitchFamily="34" charset="0"/>
                 <a:ea typeface="游ゴシック" pitchFamily="34" charset="-122"/>
                 <a:cs typeface="游ゴシック" pitchFamily="34" charset="-120"/>
               </a:rPr>
-              <a:t>62.1%</a:t>
+              <a:t>29.5%</a:t>
             </a:r>
             <a:endParaRPr lang="en-US" sz="1300" dirty="0"/>
           </a:p>
@@ -5884,13 +6119,228 @@
       </p:sp>
       <p:sp>
         <p:nvSpPr>
-          <p:cNvPr id="22" name="Shape 20"/>
-          <p:cNvSpPr/>
-          <p:nvPr/>
-        </p:nvSpPr>
-        <p:spPr>
-          <a:xfrm>
-            <a:off x="548640" y="2144268"/>
+          <p:cNvPr id="29" name="Shape 27"/>
+          <p:cNvSpPr/>
+          <p:nvPr/>
+        </p:nvSpPr>
+        <p:spPr>
+          <a:xfrm>
+            <a:off x="548640" y="2478024"/>
+            <a:ext cx="11091672" cy="333756"/>
+          </a:xfrm>
+          <a:prstGeom prst="rect">
+            <a:avLst/>
+          </a:prstGeom>
+          <a:solidFill>
+            <a:srgbClr val="F5F7FA"/>
+          </a:solidFill>
+          <a:ln/>
+        </p:spPr>
+      </p:sp>
+      <p:sp>
+        <p:nvSpPr>
+          <p:cNvPr id="30" name="Text 28"/>
+          <p:cNvSpPr/>
+          <p:nvPr/>
+        </p:nvSpPr>
+        <p:spPr>
+          <a:xfrm>
+            <a:off x="548640" y="2478024"/>
+            <a:ext cx="594360" cy="333756"/>
+          </a:xfrm>
+          <a:prstGeom prst="rect">
+            <a:avLst/>
+          </a:prstGeom>
+          <a:noFill/>
+          <a:ln/>
+        </p:spPr>
+        <p:txBody>
+          <a:bodyPr wrap="square" rtlCol="0" anchor="ctr"/>
+          <a:lstStyle/>
+          <a:p>
+            <a:pPr algn="ctr" indent="0" marL="0">
+              <a:buNone/>
+            </a:pPr>
+            <a:r>
+              <a:rPr lang="en-US" sz="1200" dirty="0">
+                <a:solidFill>
+                  <a:srgbClr val="1A1A2E"/>
+                </a:solidFill>
+                <a:latin typeface="游ゴシック" pitchFamily="34" charset="0"/>
+                <a:ea typeface="游ゴシック" pitchFamily="34" charset="-122"/>
+                <a:cs typeface="游ゴシック" pitchFamily="34" charset="-120"/>
+              </a:rPr>
+              <a:t>4</a:t>
+            </a:r>
+            <a:endParaRPr lang="en-US" sz="1200" dirty="0"/>
+          </a:p>
+        </p:txBody>
+      </p:sp>
+      <p:sp>
+        <p:nvSpPr>
+          <p:cNvPr id="31" name="Text 29"/>
+          <p:cNvSpPr/>
+          <p:nvPr/>
+        </p:nvSpPr>
+        <p:spPr>
+          <a:xfrm>
+            <a:off x="1143000" y="2478024"/>
+            <a:ext cx="594360" cy="333756"/>
+          </a:xfrm>
+          <a:prstGeom prst="rect">
+            <a:avLst/>
+          </a:prstGeom>
+          <a:noFill/>
+          <a:ln/>
+        </p:spPr>
+        <p:txBody>
+          <a:bodyPr wrap="square" rtlCol="0" anchor="ctr"/>
+          <a:lstStyle/>
+          <a:p>
+            <a:pPr algn="ctr" indent="0" marL="0">
+              <a:buNone/>
+            </a:pPr>
+            <a:r>
+              <a:rPr lang="en-US" sz="1100" dirty="0">
+                <a:solidFill>
+                  <a:srgbClr val="6B7280"/>
+                </a:solidFill>
+                <a:latin typeface="游ゴシック" pitchFamily="34" charset="0"/>
+                <a:ea typeface="游ゴシック" pitchFamily="34" charset="-122"/>
+                <a:cs typeface="游ゴシック" pitchFamily="34" charset="-120"/>
+              </a:rPr>
+              <a:t>398</a:t>
+            </a:r>
+            <a:endParaRPr lang="en-US" sz="1100" dirty="0"/>
+          </a:p>
+        </p:txBody>
+      </p:sp>
+      <p:sp>
+        <p:nvSpPr>
+          <p:cNvPr id="32" name="Text 30"/>
+          <p:cNvSpPr/>
+          <p:nvPr/>
+        </p:nvSpPr>
+        <p:spPr>
+          <a:xfrm>
+            <a:off x="1828800" y="2478024"/>
+            <a:ext cx="7040880" cy="333756"/>
+          </a:xfrm>
+          <a:prstGeom prst="rect">
+            <a:avLst/>
+          </a:prstGeom>
+          <a:noFill/>
+          <a:ln/>
+        </p:spPr>
+        <p:txBody>
+          <a:bodyPr wrap="square" rtlCol="0" anchor="ctr"/>
+          <a:lstStyle/>
+          <a:p>
+            <a:pPr algn="l" indent="0" marL="0">
+              <a:buNone/>
+            </a:pPr>
+            <a:r>
+              <a:rPr lang="en-US" sz="1300" dirty="0">
+                <a:solidFill>
+                  <a:srgbClr val="1A1A2E"/>
+                </a:solidFill>
+                <a:latin typeface="游ゴシック" pitchFamily="34" charset="0"/>
+                <a:ea typeface="游ゴシック" pitchFamily="34" charset="-122"/>
+                <a:cs typeface="游ゴシック" pitchFamily="34" charset="-120"/>
+              </a:rPr>
+              <a:t>大阪中央イベントセンター</a:t>
+            </a:r>
+            <a:endParaRPr lang="en-US" sz="1300" dirty="0"/>
+          </a:p>
+        </p:txBody>
+      </p:sp>
+      <p:sp>
+        <p:nvSpPr>
+          <p:cNvPr id="33" name="Text 31"/>
+          <p:cNvSpPr/>
+          <p:nvPr/>
+        </p:nvSpPr>
+        <p:spPr>
+          <a:xfrm>
+            <a:off x="8778240" y="2478024"/>
+            <a:ext cx="1920240" cy="333756"/>
+          </a:xfrm>
+          <a:prstGeom prst="rect">
+            <a:avLst/>
+          </a:prstGeom>
+          <a:noFill/>
+          <a:ln/>
+        </p:spPr>
+        <p:txBody>
+          <a:bodyPr wrap="square" rtlCol="0" anchor="ctr"/>
+          <a:lstStyle/>
+          <a:p>
+            <a:pPr algn="r" indent="0" marL="0">
+              <a:buNone/>
+            </a:pPr>
+            <a:r>
+              <a:rPr lang="en-US" sz="1300" b="1" dirty="0">
+                <a:solidFill>
+                  <a:srgbClr val="1A1A2E"/>
+                </a:solidFill>
+                <a:latin typeface="游ゴシック" pitchFamily="34" charset="0"/>
+                <a:ea typeface="游ゴシック" pitchFamily="34" charset="-122"/>
+                <a:cs typeface="游ゴシック" pitchFamily="34" charset="-120"/>
+              </a:rPr>
+              <a:t>48,768,831</a:t>
+            </a:r>
+            <a:endParaRPr lang="en-US" sz="1300" dirty="0"/>
+          </a:p>
+        </p:txBody>
+      </p:sp>
+      <p:sp>
+        <p:nvSpPr>
+          <p:cNvPr id="34" name="Text 32"/>
+          <p:cNvSpPr/>
+          <p:nvPr/>
+        </p:nvSpPr>
+        <p:spPr>
+          <a:xfrm>
+            <a:off x="10698480" y="2478024"/>
+            <a:ext cx="941832" cy="333756"/>
+          </a:xfrm>
+          <a:prstGeom prst="rect">
+            <a:avLst/>
+          </a:prstGeom>
+          <a:noFill/>
+          <a:ln/>
+        </p:spPr>
+        <p:txBody>
+          <a:bodyPr wrap="square" rtlCol="0" anchor="ctr"/>
+          <a:lstStyle/>
+          <a:p>
+            <a:pPr algn="r" indent="0" marL="0">
+              <a:buNone/>
+            </a:pPr>
+            <a:r>
+              <a:rPr lang="en-US" sz="1300" b="1" dirty="0">
+                <a:solidFill>
+                  <a:srgbClr val="DC2626"/>
+                </a:solidFill>
+                <a:latin typeface="游ゴシック" pitchFamily="34" charset="0"/>
+                <a:ea typeface="游ゴシック" pitchFamily="34" charset="-122"/>
+                <a:cs typeface="游ゴシック" pitchFamily="34" charset="-120"/>
+              </a:rPr>
+              <a:t>▲45.3%</a:t>
+            </a:r>
+            <a:endParaRPr lang="en-US" sz="1300" dirty="0"/>
+          </a:p>
+        </p:txBody>
+      </p:sp>
+      <p:sp>
+        <p:nvSpPr>
+          <p:cNvPr id="35" name="Shape 33"/>
+          <p:cNvSpPr/>
+          <p:nvPr/>
+        </p:nvSpPr>
+        <p:spPr>
+          <a:xfrm>
+            <a:off x="548640" y="2811780"/>
             <a:ext cx="11091672" cy="333756"/>
           </a:xfrm>
           <a:prstGeom prst="rect">
@@ -5904,13 +6354,13 @@
       </p:sp>
       <p:sp>
         <p:nvSpPr>
-          <p:cNvPr id="23" name="Text 21"/>
-          <p:cNvSpPr/>
-          <p:nvPr/>
-        </p:nvSpPr>
-        <p:spPr>
-          <a:xfrm>
-            <a:off x="548640" y="2144268"/>
+          <p:cNvPr id="36" name="Text 34"/>
+          <p:cNvSpPr/>
+          <p:nvPr/>
+        </p:nvSpPr>
+        <p:spPr>
+          <a:xfrm>
+            <a:off x="548640" y="2811780"/>
             <a:ext cx="594360" cy="333756"/>
           </a:xfrm>
           <a:prstGeom prst="rect">
@@ -5935,7 +6385,7 @@
                 <a:ea typeface="游ゴシック" pitchFamily="34" charset="-122"/>
                 <a:cs typeface="游ゴシック" pitchFamily="34" charset="-120"/>
               </a:rPr>
-              <a:t>3</a:t>
+              <a:t>5</a:t>
             </a:r>
             <a:endParaRPr lang="en-US" sz="1200" dirty="0"/>
           </a:p>
@@ -5943,13 +6393,13 @@
       </p:sp>
       <p:sp>
         <p:nvSpPr>
-          <p:cNvPr id="24" name="Text 22"/>
-          <p:cNvSpPr/>
-          <p:nvPr/>
-        </p:nvSpPr>
-        <p:spPr>
-          <a:xfrm>
-            <a:off x="1143000" y="2144268"/>
+          <p:cNvPr id="37" name="Text 35"/>
+          <p:cNvSpPr/>
+          <p:nvPr/>
+        </p:nvSpPr>
+        <p:spPr>
+          <a:xfrm>
+            <a:off x="1143000" y="2811780"/>
             <a:ext cx="594360" cy="333756"/>
           </a:xfrm>
           <a:prstGeom prst="rect">
@@ -5974,7 +6424,7 @@
                 <a:ea typeface="游ゴシック" pitchFamily="34" charset="-122"/>
                 <a:cs typeface="游ゴシック" pitchFamily="34" charset="-120"/>
               </a:rPr>
-              <a:t>150</a:t>
+              <a:t>330</a:t>
             </a:r>
             <a:endParaRPr lang="en-US" sz="1100" dirty="0"/>
           </a:p>
@@ -5982,13 +6432,13 @@
       </p:sp>
       <p:sp>
         <p:nvSpPr>
-          <p:cNvPr id="25" name="Text 23"/>
-          <p:cNvSpPr/>
-          <p:nvPr/>
-        </p:nvSpPr>
-        <p:spPr>
-          <a:xfrm>
-            <a:off x="1828800" y="2144268"/>
+          <p:cNvPr id="38" name="Text 36"/>
+          <p:cNvSpPr/>
+          <p:nvPr/>
+        </p:nvSpPr>
+        <p:spPr>
+          <a:xfrm>
+            <a:off x="1828800" y="2811780"/>
             <a:ext cx="7040880" cy="333756"/>
           </a:xfrm>
           <a:prstGeom prst="rect">
@@ -6013,7 +6463,7 @@
                 <a:ea typeface="游ゴシック" pitchFamily="34" charset="-122"/>
                 <a:cs typeface="游ゴシック" pitchFamily="34" charset="-120"/>
               </a:rPr>
-              <a:t>仙台イベントセンター</a:t>
+              <a:t>新宿新都心イベントセンター</a:t>
             </a:r>
             <a:endParaRPr lang="en-US" sz="1300" dirty="0"/>
           </a:p>
@@ -6021,13 +6471,13 @@
       </p:sp>
       <p:sp>
         <p:nvSpPr>
-          <p:cNvPr id="26" name="Text 24"/>
-          <p:cNvSpPr/>
-          <p:nvPr/>
-        </p:nvSpPr>
-        <p:spPr>
-          <a:xfrm>
-            <a:off x="8778240" y="2144268"/>
+          <p:cNvPr id="39" name="Text 37"/>
+          <p:cNvSpPr/>
+          <p:nvPr/>
+        </p:nvSpPr>
+        <p:spPr>
+          <a:xfrm>
+            <a:off x="8778240" y="2811780"/>
             <a:ext cx="1920240" cy="333756"/>
           </a:xfrm>
           <a:prstGeom prst="rect">
@@ -6052,7 +6502,7 @@
                 <a:ea typeface="游ゴシック" pitchFamily="34" charset="-122"/>
                 <a:cs typeface="游ゴシック" pitchFamily="34" charset="-120"/>
               </a:rPr>
-              <a:t>83,606,860</a:t>
+              <a:t>42,173,962</a:t>
             </a:r>
             <a:endParaRPr lang="en-US" sz="1300" dirty="0"/>
           </a:p>
@@ -6060,13 +6510,13 @@
       </p:sp>
       <p:sp>
         <p:nvSpPr>
-          <p:cNvPr id="27" name="Text 25"/>
-          <p:cNvSpPr/>
-          <p:nvPr/>
-        </p:nvSpPr>
-        <p:spPr>
-          <a:xfrm>
-            <a:off x="10698480" y="2144268"/>
+          <p:cNvPr id="40" name="Text 38"/>
+          <p:cNvSpPr/>
+          <p:nvPr/>
+        </p:nvSpPr>
+        <p:spPr>
+          <a:xfrm>
+            <a:off x="10698480" y="2811780"/>
             <a:ext cx="941832" cy="333756"/>
           </a:xfrm>
           <a:prstGeom prst="rect">
@@ -6085,13 +6535,13 @@
             <a:r>
               <a:rPr lang="en-US" sz="1300" b="1" dirty="0">
                 <a:solidFill>
-                  <a:srgbClr val="DC2626"/>
-                </a:solidFill>
-                <a:latin typeface="游ゴシック" pitchFamily="34" charset="0"/>
-                <a:ea typeface="游ゴシック" pitchFamily="34" charset="-122"/>
-                <a:cs typeface="游ゴシック" pitchFamily="34" charset="-120"/>
-              </a:rPr>
-              <a:t>▲7.0%</a:t>
+                  <a:srgbClr val="16A34A"/>
+                </a:solidFill>
+                <a:latin typeface="游ゴシック" pitchFamily="34" charset="0"/>
+                <a:ea typeface="游ゴシック" pitchFamily="34" charset="-122"/>
+                <a:cs typeface="游ゴシック" pitchFamily="34" charset="-120"/>
+              </a:rPr>
+              <a:t>89.1%</a:t>
             </a:r>
             <a:endParaRPr lang="en-US" sz="1300" dirty="0"/>
           </a:p>
@@ -6099,13 +6549,13 @@
       </p:sp>
       <p:sp>
         <p:nvSpPr>
-          <p:cNvPr id="28" name="Shape 26"/>
-          <p:cNvSpPr/>
-          <p:nvPr/>
-        </p:nvSpPr>
-        <p:spPr>
-          <a:xfrm>
-            <a:off x="548640" y="2478024"/>
+          <p:cNvPr id="41" name="Shape 39"/>
+          <p:cNvSpPr/>
+          <p:nvPr/>
+        </p:nvSpPr>
+        <p:spPr>
+          <a:xfrm>
+            <a:off x="548640" y="3145536"/>
             <a:ext cx="11091672" cy="333756"/>
           </a:xfrm>
           <a:prstGeom prst="rect">
@@ -6119,13 +6569,13 @@
       </p:sp>
       <p:sp>
         <p:nvSpPr>
-          <p:cNvPr id="29" name="Text 27"/>
-          <p:cNvSpPr/>
-          <p:nvPr/>
-        </p:nvSpPr>
-        <p:spPr>
-          <a:xfrm>
-            <a:off x="548640" y="2478024"/>
+          <p:cNvPr id="42" name="Text 40"/>
+          <p:cNvSpPr/>
+          <p:nvPr/>
+        </p:nvSpPr>
+        <p:spPr>
+          <a:xfrm>
+            <a:off x="548640" y="3145536"/>
             <a:ext cx="594360" cy="333756"/>
           </a:xfrm>
           <a:prstGeom prst="rect">
@@ -6150,7 +6600,7 @@
                 <a:ea typeface="游ゴシック" pitchFamily="34" charset="-122"/>
                 <a:cs typeface="游ゴシック" pitchFamily="34" charset="-120"/>
               </a:rPr>
-              <a:t>4</a:t>
+              <a:t>6</a:t>
             </a:r>
             <a:endParaRPr lang="en-US" sz="1200" dirty="0"/>
           </a:p>
@@ -6158,13 +6608,13 @@
       </p:sp>
       <p:sp>
         <p:nvSpPr>
-          <p:cNvPr id="30" name="Text 28"/>
-          <p:cNvSpPr/>
-          <p:nvPr/>
-        </p:nvSpPr>
-        <p:spPr>
-          <a:xfrm>
-            <a:off x="1143000" y="2478024"/>
+          <p:cNvPr id="43" name="Text 41"/>
+          <p:cNvSpPr/>
+          <p:nvPr/>
+        </p:nvSpPr>
+        <p:spPr>
+          <a:xfrm>
+            <a:off x="1143000" y="3145536"/>
             <a:ext cx="594360" cy="333756"/>
           </a:xfrm>
           <a:prstGeom prst="rect">
@@ -6189,7 +6639,7 @@
                 <a:ea typeface="游ゴシック" pitchFamily="34" charset="-122"/>
                 <a:cs typeface="游ゴシック" pitchFamily="34" charset="-120"/>
               </a:rPr>
-              <a:t>398</a:t>
+              <a:t>78</a:t>
             </a:r>
             <a:endParaRPr lang="en-US" sz="1100" dirty="0"/>
           </a:p>
@@ -6197,13 +6647,13 @@
       </p:sp>
       <p:sp>
         <p:nvSpPr>
-          <p:cNvPr id="31" name="Text 29"/>
-          <p:cNvSpPr/>
-          <p:nvPr/>
-        </p:nvSpPr>
-        <p:spPr>
-          <a:xfrm>
-            <a:off x="1828800" y="2478024"/>
+          <p:cNvPr id="44" name="Text 42"/>
+          <p:cNvSpPr/>
+          <p:nvPr/>
+        </p:nvSpPr>
+        <p:spPr>
+          <a:xfrm>
+            <a:off x="1828800" y="3145536"/>
             <a:ext cx="7040880" cy="333756"/>
           </a:xfrm>
           <a:prstGeom prst="rect">
@@ -6228,7 +6678,7 @@
                 <a:ea typeface="游ゴシック" pitchFamily="34" charset="-122"/>
                 <a:cs typeface="游ゴシック" pitchFamily="34" charset="-120"/>
               </a:rPr>
-              <a:t>大阪中央イベントセンター</a:t>
+              <a:t>所沢イベントセンター</a:t>
             </a:r>
             <a:endParaRPr lang="en-US" sz="1300" dirty="0"/>
           </a:p>
@@ -6236,13 +6686,13 @@
       </p:sp>
       <p:sp>
         <p:nvSpPr>
-          <p:cNvPr id="32" name="Text 30"/>
-          <p:cNvSpPr/>
-          <p:nvPr/>
-        </p:nvSpPr>
-        <p:spPr>
-          <a:xfrm>
-            <a:off x="8778240" y="2478024"/>
+          <p:cNvPr id="45" name="Text 43"/>
+          <p:cNvSpPr/>
+          <p:nvPr/>
+        </p:nvSpPr>
+        <p:spPr>
+          <a:xfrm>
+            <a:off x="8778240" y="3145536"/>
             <a:ext cx="1920240" cy="333756"/>
           </a:xfrm>
           <a:prstGeom prst="rect">
@@ -6267,7 +6717,7 @@
                 <a:ea typeface="游ゴシック" pitchFamily="34" charset="-122"/>
                 <a:cs typeface="游ゴシック" pitchFamily="34" charset="-120"/>
               </a:rPr>
-              <a:t>80,502,402</a:t>
+              <a:t>36,427,140</a:t>
             </a:r>
             <a:endParaRPr lang="en-US" sz="1300" dirty="0"/>
           </a:p>
@@ -6275,13 +6725,13 @@
       </p:sp>
       <p:sp>
         <p:nvSpPr>
-          <p:cNvPr id="33" name="Text 31"/>
-          <p:cNvSpPr/>
-          <p:nvPr/>
-        </p:nvSpPr>
-        <p:spPr>
-          <a:xfrm>
-            <a:off x="10698480" y="2478024"/>
+          <p:cNvPr id="46" name="Text 44"/>
+          <p:cNvSpPr/>
+          <p:nvPr/>
+        </p:nvSpPr>
+        <p:spPr>
+          <a:xfrm>
+            <a:off x="10698480" y="3145536"/>
             <a:ext cx="941832" cy="333756"/>
           </a:xfrm>
           <a:prstGeom prst="rect">
@@ -6306,7 +6756,7 @@
                 <a:ea typeface="游ゴシック" pitchFamily="34" charset="-122"/>
                 <a:cs typeface="游ゴシック" pitchFamily="34" charset="-120"/>
               </a:rPr>
-              <a:t>0.9%</a:t>
+              <a:t>30.6%</a:t>
             </a:r>
             <a:endParaRPr lang="en-US" sz="1300" dirty="0"/>
           </a:p>
@@ -6314,13 +6764,13 @@
       </p:sp>
       <p:sp>
         <p:nvSpPr>
-          <p:cNvPr id="34" name="Shape 32"/>
-          <p:cNvSpPr/>
-          <p:nvPr/>
-        </p:nvSpPr>
-        <p:spPr>
-          <a:xfrm>
-            <a:off x="548640" y="2811780"/>
+          <p:cNvPr id="47" name="Shape 45"/>
+          <p:cNvSpPr/>
+          <p:nvPr/>
+        </p:nvSpPr>
+        <p:spPr>
+          <a:xfrm>
+            <a:off x="548640" y="3479292"/>
             <a:ext cx="11091672" cy="333756"/>
           </a:xfrm>
           <a:prstGeom prst="rect">
@@ -6334,13 +6784,13 @@
       </p:sp>
       <p:sp>
         <p:nvSpPr>
-          <p:cNvPr id="35" name="Text 33"/>
-          <p:cNvSpPr/>
-          <p:nvPr/>
-        </p:nvSpPr>
-        <p:spPr>
-          <a:xfrm>
-            <a:off x="548640" y="2811780"/>
+          <p:cNvPr id="48" name="Text 46"/>
+          <p:cNvSpPr/>
+          <p:nvPr/>
+        </p:nvSpPr>
+        <p:spPr>
+          <a:xfrm>
+            <a:off x="548640" y="3479292"/>
             <a:ext cx="594360" cy="333756"/>
           </a:xfrm>
           <a:prstGeom prst="rect">
@@ -6365,7 +6815,7 @@
                 <a:ea typeface="游ゴシック" pitchFamily="34" charset="-122"/>
                 <a:cs typeface="游ゴシック" pitchFamily="34" charset="-120"/>
               </a:rPr>
-              <a:t>5</a:t>
+              <a:t>7</a:t>
             </a:r>
             <a:endParaRPr lang="en-US" sz="1200" dirty="0"/>
           </a:p>
@@ -6373,13 +6823,13 @@
       </p:sp>
       <p:sp>
         <p:nvSpPr>
-          <p:cNvPr id="36" name="Text 34"/>
-          <p:cNvSpPr/>
-          <p:nvPr/>
-        </p:nvSpPr>
-        <p:spPr>
-          <a:xfrm>
-            <a:off x="1143000" y="2811780"/>
+          <p:cNvPr id="49" name="Text 47"/>
+          <p:cNvSpPr/>
+          <p:nvPr/>
+        </p:nvSpPr>
+        <p:spPr>
+          <a:xfrm>
+            <a:off x="1143000" y="3479292"/>
             <a:ext cx="594360" cy="333756"/>
           </a:xfrm>
           <a:prstGeom prst="rect">
@@ -6404,7 +6854,7 @@
                 <a:ea typeface="游ゴシック" pitchFamily="34" charset="-122"/>
                 <a:cs typeface="游ゴシック" pitchFamily="34" charset="-120"/>
               </a:rPr>
-              <a:t>145</a:t>
+              <a:t>417</a:t>
             </a:r>
             <a:endParaRPr lang="en-US" sz="1100" dirty="0"/>
           </a:p>
@@ -6412,13 +6862,13 @@
       </p:sp>
       <p:sp>
         <p:nvSpPr>
-          <p:cNvPr id="37" name="Text 35"/>
-          <p:cNvSpPr/>
-          <p:nvPr/>
-        </p:nvSpPr>
-        <p:spPr>
-          <a:xfrm>
-            <a:off x="1828800" y="2811780"/>
+          <p:cNvPr id="50" name="Text 48"/>
+          <p:cNvSpPr/>
+          <p:nvPr/>
+        </p:nvSpPr>
+        <p:spPr>
+          <a:xfrm>
+            <a:off x="1828800" y="3479292"/>
             <a:ext cx="7040880" cy="333756"/>
           </a:xfrm>
           <a:prstGeom prst="rect">
@@ -6443,7 +6893,7 @@
                 <a:ea typeface="游ゴシック" pitchFamily="34" charset="-122"/>
                 <a:cs typeface="游ゴシック" pitchFamily="34" charset="-120"/>
               </a:rPr>
-              <a:t>札幌イベントセンター</a:t>
+              <a:t>銀座イベントセンター</a:t>
             </a:r>
             <a:endParaRPr lang="en-US" sz="1300" dirty="0"/>
           </a:p>
@@ -6451,13 +6901,13 @@
       </p:sp>
       <p:sp>
         <p:nvSpPr>
-          <p:cNvPr id="38" name="Text 36"/>
-          <p:cNvSpPr/>
-          <p:nvPr/>
-        </p:nvSpPr>
-        <p:spPr>
-          <a:xfrm>
-            <a:off x="8778240" y="2811780"/>
+          <p:cNvPr id="51" name="Text 49"/>
+          <p:cNvSpPr/>
+          <p:nvPr/>
+        </p:nvSpPr>
+        <p:spPr>
+          <a:xfrm>
+            <a:off x="8778240" y="3479292"/>
             <a:ext cx="1920240" cy="333756"/>
           </a:xfrm>
           <a:prstGeom prst="rect">
@@ -6482,7 +6932,7 @@
                 <a:ea typeface="游ゴシック" pitchFamily="34" charset="-122"/>
                 <a:cs typeface="游ゴシック" pitchFamily="34" charset="-120"/>
               </a:rPr>
-              <a:t>53,712,021</a:t>
+              <a:t>35,492,992</a:t>
             </a:r>
             <a:endParaRPr lang="en-US" sz="1300" dirty="0"/>
           </a:p>
@@ -6490,13 +6940,13 @@
       </p:sp>
       <p:sp>
         <p:nvSpPr>
-          <p:cNvPr id="39" name="Text 37"/>
-          <p:cNvSpPr/>
-          <p:nvPr/>
-        </p:nvSpPr>
-        <p:spPr>
-          <a:xfrm>
-            <a:off x="10698480" y="2811780"/>
+          <p:cNvPr id="52" name="Text 50"/>
+          <p:cNvSpPr/>
+          <p:nvPr/>
+        </p:nvSpPr>
+        <p:spPr>
+          <a:xfrm>
+            <a:off x="10698480" y="3479292"/>
             <a:ext cx="941832" cy="333756"/>
           </a:xfrm>
           <a:prstGeom prst="rect">
@@ -6521,7 +6971,7 @@
                 <a:ea typeface="游ゴシック" pitchFamily="34" charset="-122"/>
                 <a:cs typeface="游ゴシック" pitchFamily="34" charset="-120"/>
               </a:rPr>
-              <a:t>105.4%</a:t>
+              <a:t>79.1%</a:t>
             </a:r>
             <a:endParaRPr lang="en-US" sz="1300" dirty="0"/>
           </a:p>
@@ -6529,13 +6979,13 @@
       </p:sp>
       <p:sp>
         <p:nvSpPr>
-          <p:cNvPr id="40" name="Shape 38"/>
-          <p:cNvSpPr/>
-          <p:nvPr/>
-        </p:nvSpPr>
-        <p:spPr>
-          <a:xfrm>
-            <a:off x="548640" y="3145536"/>
+          <p:cNvPr id="53" name="Shape 51"/>
+          <p:cNvSpPr/>
+          <p:nvPr/>
+        </p:nvSpPr>
+        <p:spPr>
+          <a:xfrm>
+            <a:off x="548640" y="3813048"/>
             <a:ext cx="11091672" cy="333756"/>
           </a:xfrm>
           <a:prstGeom prst="rect">
@@ -6549,13 +6999,13 @@
       </p:sp>
       <p:sp>
         <p:nvSpPr>
-          <p:cNvPr id="41" name="Text 39"/>
-          <p:cNvSpPr/>
-          <p:nvPr/>
-        </p:nvSpPr>
-        <p:spPr>
-          <a:xfrm>
-            <a:off x="548640" y="3145536"/>
+          <p:cNvPr id="54" name="Text 52"/>
+          <p:cNvSpPr/>
+          <p:nvPr/>
+        </p:nvSpPr>
+        <p:spPr>
+          <a:xfrm>
+            <a:off x="548640" y="3813048"/>
             <a:ext cx="594360" cy="333756"/>
           </a:xfrm>
           <a:prstGeom prst="rect">
@@ -6580,7 +7030,7 @@
                 <a:ea typeface="游ゴシック" pitchFamily="34" charset="-122"/>
                 <a:cs typeface="游ゴシック" pitchFamily="34" charset="-120"/>
               </a:rPr>
-              <a:t>6</a:t>
+              <a:t>8</a:t>
             </a:r>
             <a:endParaRPr lang="en-US" sz="1200" dirty="0"/>
           </a:p>
@@ -6588,13 +7038,13 @@
       </p:sp>
       <p:sp>
         <p:nvSpPr>
-          <p:cNvPr id="42" name="Text 40"/>
-          <p:cNvSpPr/>
-          <p:nvPr/>
-        </p:nvSpPr>
-        <p:spPr>
-          <a:xfrm>
-            <a:off x="1143000" y="3145536"/>
+          <p:cNvPr id="55" name="Text 53"/>
+          <p:cNvSpPr/>
+          <p:nvPr/>
+        </p:nvSpPr>
+        <p:spPr>
+          <a:xfrm>
+            <a:off x="1143000" y="3813048"/>
             <a:ext cx="594360" cy="333756"/>
           </a:xfrm>
           <a:prstGeom prst="rect">
@@ -6619,7 +7069,7 @@
                 <a:ea typeface="游ゴシック" pitchFamily="34" charset="-122"/>
                 <a:cs typeface="游ゴシック" pitchFamily="34" charset="-120"/>
               </a:rPr>
-              <a:t>330</a:t>
+              <a:t>150</a:t>
             </a:r>
             <a:endParaRPr lang="en-US" sz="1100" dirty="0"/>
           </a:p>
@@ -6627,13 +7077,13 @@
       </p:sp>
       <p:sp>
         <p:nvSpPr>
-          <p:cNvPr id="43" name="Text 41"/>
-          <p:cNvSpPr/>
-          <p:nvPr/>
-        </p:nvSpPr>
-        <p:spPr>
-          <a:xfrm>
-            <a:off x="1828800" y="3145536"/>
+          <p:cNvPr id="56" name="Text 54"/>
+          <p:cNvSpPr/>
+          <p:nvPr/>
+        </p:nvSpPr>
+        <p:spPr>
+          <a:xfrm>
+            <a:off x="1828800" y="3813048"/>
             <a:ext cx="7040880" cy="333756"/>
           </a:xfrm>
           <a:prstGeom prst="rect">
@@ -6658,7 +7108,7 @@
                 <a:ea typeface="游ゴシック" pitchFamily="34" charset="-122"/>
                 <a:cs typeface="游ゴシック" pitchFamily="34" charset="-120"/>
               </a:rPr>
-              <a:t>新宿新都心イベントセンター</a:t>
+              <a:t>仙台イベントセンター</a:t>
             </a:r>
             <a:endParaRPr lang="en-US" sz="1300" dirty="0"/>
           </a:p>
@@ -6666,13 +7116,13 @@
       </p:sp>
       <p:sp>
         <p:nvSpPr>
-          <p:cNvPr id="44" name="Text 42"/>
-          <p:cNvSpPr/>
-          <p:nvPr/>
-        </p:nvSpPr>
-        <p:spPr>
-          <a:xfrm>
-            <a:off x="8778240" y="3145536"/>
+          <p:cNvPr id="57" name="Text 55"/>
+          <p:cNvSpPr/>
+          <p:nvPr/>
+        </p:nvSpPr>
+        <p:spPr>
+          <a:xfrm>
+            <a:off x="8778240" y="3813048"/>
             <a:ext cx="1920240" cy="333756"/>
           </a:xfrm>
           <a:prstGeom prst="rect">
@@ -6697,7 +7147,7 @@
                 <a:ea typeface="游ゴシック" pitchFamily="34" charset="-122"/>
                 <a:cs typeface="游ゴシック" pitchFamily="34" charset="-120"/>
               </a:rPr>
-              <a:t>40,101,320</a:t>
+              <a:t>34,904,540</a:t>
             </a:r>
             <a:endParaRPr lang="en-US" sz="1300" dirty="0"/>
           </a:p>
@@ -6705,13 +7155,13 @@
       </p:sp>
       <p:sp>
         <p:nvSpPr>
-          <p:cNvPr id="45" name="Text 43"/>
-          <p:cNvSpPr/>
-          <p:nvPr/>
-        </p:nvSpPr>
-        <p:spPr>
-          <a:xfrm>
-            <a:off x="10698480" y="3145536"/>
+          <p:cNvPr id="58" name="Text 56"/>
+          <p:cNvSpPr/>
+          <p:nvPr/>
+        </p:nvSpPr>
+        <p:spPr>
+          <a:xfrm>
+            <a:off x="10698480" y="3813048"/>
             <a:ext cx="941832" cy="333756"/>
           </a:xfrm>
           <a:prstGeom prst="rect">
@@ -6736,7 +7186,7 @@
                 <a:ea typeface="游ゴシック" pitchFamily="34" charset="-122"/>
                 <a:cs typeface="游ゴシック" pitchFamily="34" charset="-120"/>
               </a:rPr>
-              <a:t>125.0%</a:t>
+              <a:t>13.3%</a:t>
             </a:r>
             <a:endParaRPr lang="en-US" sz="1300" dirty="0"/>
           </a:p>
@@ -6744,13 +7194,13 @@
       </p:sp>
       <p:sp>
         <p:nvSpPr>
-          <p:cNvPr id="46" name="Shape 44"/>
-          <p:cNvSpPr/>
-          <p:nvPr/>
-        </p:nvSpPr>
-        <p:spPr>
-          <a:xfrm>
-            <a:off x="548640" y="3479292"/>
+          <p:cNvPr id="59" name="Shape 57"/>
+          <p:cNvSpPr/>
+          <p:nvPr/>
+        </p:nvSpPr>
+        <p:spPr>
+          <a:xfrm>
+            <a:off x="548640" y="4146804"/>
             <a:ext cx="11091672" cy="333756"/>
           </a:xfrm>
           <a:prstGeom prst="rect">
@@ -6764,13 +7214,13 @@
       </p:sp>
       <p:sp>
         <p:nvSpPr>
-          <p:cNvPr id="47" name="Text 45"/>
-          <p:cNvSpPr/>
-          <p:nvPr/>
-        </p:nvSpPr>
-        <p:spPr>
-          <a:xfrm>
-            <a:off x="548640" y="3479292"/>
+          <p:cNvPr id="60" name="Text 58"/>
+          <p:cNvSpPr/>
+          <p:nvPr/>
+        </p:nvSpPr>
+        <p:spPr>
+          <a:xfrm>
+            <a:off x="548640" y="4146804"/>
             <a:ext cx="594360" cy="333756"/>
           </a:xfrm>
           <a:prstGeom prst="rect">
@@ -6795,7 +7245,7 @@
                 <a:ea typeface="游ゴシック" pitchFamily="34" charset="-122"/>
                 <a:cs typeface="游ゴシック" pitchFamily="34" charset="-120"/>
               </a:rPr>
-              <a:t>7</a:t>
+              <a:t>9</a:t>
             </a:r>
             <a:endParaRPr lang="en-US" sz="1200" dirty="0"/>
           </a:p>
@@ -6803,13 +7253,13 @@
       </p:sp>
       <p:sp>
         <p:nvSpPr>
-          <p:cNvPr id="48" name="Text 46"/>
-          <p:cNvSpPr/>
-          <p:nvPr/>
-        </p:nvSpPr>
-        <p:spPr>
-          <a:xfrm>
-            <a:off x="1143000" y="3479292"/>
+          <p:cNvPr id="61" name="Text 59"/>
+          <p:cNvSpPr/>
+          <p:nvPr/>
+        </p:nvSpPr>
+        <p:spPr>
+          <a:xfrm>
+            <a:off x="1143000" y="4146804"/>
             <a:ext cx="594360" cy="333756"/>
           </a:xfrm>
           <a:prstGeom prst="rect">
@@ -6834,7 +7284,7 @@
                 <a:ea typeface="游ゴシック" pitchFamily="34" charset="-122"/>
                 <a:cs typeface="游ゴシック" pitchFamily="34" charset="-120"/>
               </a:rPr>
-              <a:t>172</a:t>
+              <a:t>176</a:t>
             </a:r>
             <a:endParaRPr lang="en-US" sz="1100" dirty="0"/>
           </a:p>
@@ -6842,13 +7292,13 @@
       </p:sp>
       <p:sp>
         <p:nvSpPr>
-          <p:cNvPr id="49" name="Text 47"/>
-          <p:cNvSpPr/>
-          <p:nvPr/>
-        </p:nvSpPr>
-        <p:spPr>
-          <a:xfrm>
-            <a:off x="1828800" y="3479292"/>
+          <p:cNvPr id="62" name="Text 60"/>
+          <p:cNvSpPr/>
+          <p:nvPr/>
+        </p:nvSpPr>
+        <p:spPr>
+          <a:xfrm>
+            <a:off x="1828800" y="4146804"/>
             <a:ext cx="7040880" cy="333756"/>
           </a:xfrm>
           <a:prstGeom prst="rect">
@@ -6873,7 +7323,7 @@
                 <a:ea typeface="游ゴシック" pitchFamily="34" charset="-122"/>
                 <a:cs typeface="游ゴシック" pitchFamily="34" charset="-120"/>
               </a:rPr>
-              <a:t>神戸西イベントセンター</a:t>
+              <a:t>静岡三島イベントセンター</a:t>
             </a:r>
             <a:endParaRPr lang="en-US" sz="1300" dirty="0"/>
           </a:p>
@@ -6881,13 +7331,13 @@
       </p:sp>
       <p:sp>
         <p:nvSpPr>
-          <p:cNvPr id="50" name="Text 48"/>
-          <p:cNvSpPr/>
-          <p:nvPr/>
-        </p:nvSpPr>
-        <p:spPr>
-          <a:xfrm>
-            <a:off x="8778240" y="3479292"/>
+          <p:cNvPr id="63" name="Text 61"/>
+          <p:cNvSpPr/>
+          <p:nvPr/>
+        </p:nvSpPr>
+        <p:spPr>
+          <a:xfrm>
+            <a:off x="8778240" y="4146804"/>
             <a:ext cx="1920240" cy="333756"/>
           </a:xfrm>
           <a:prstGeom prst="rect">
@@ -6912,7 +7362,7 @@
                 <a:ea typeface="游ゴシック" pitchFamily="34" charset="-122"/>
                 <a:cs typeface="游ゴシック" pitchFamily="34" charset="-120"/>
               </a:rPr>
-              <a:t>36,361,979</a:t>
+              <a:t>31,379,720</a:t>
             </a:r>
             <a:endParaRPr lang="en-US" sz="1300" dirty="0"/>
           </a:p>
@@ -6920,13 +7370,13 @@
       </p:sp>
       <p:sp>
         <p:nvSpPr>
-          <p:cNvPr id="51" name="Text 49"/>
-          <p:cNvSpPr/>
-          <p:nvPr/>
-        </p:nvSpPr>
-        <p:spPr>
-          <a:xfrm>
-            <a:off x="10698480" y="3479292"/>
+          <p:cNvPr id="64" name="Text 62"/>
+          <p:cNvSpPr/>
+          <p:nvPr/>
+        </p:nvSpPr>
+        <p:spPr>
+          <a:xfrm>
+            <a:off x="10698480" y="4146804"/>
             <a:ext cx="941832" cy="333756"/>
           </a:xfrm>
           <a:prstGeom prst="rect">
@@ -6951,7 +7401,7 @@
                 <a:ea typeface="游ゴシック" pitchFamily="34" charset="-122"/>
                 <a:cs typeface="游ゴシック" pitchFamily="34" charset="-120"/>
               </a:rPr>
-              <a:t>5.1%</a:t>
+              <a:t>26.4%</a:t>
             </a:r>
             <a:endParaRPr lang="en-US" sz="1300" dirty="0"/>
           </a:p>
@@ -6959,13 +7409,13 @@
       </p:sp>
       <p:sp>
         <p:nvSpPr>
-          <p:cNvPr id="52" name="Shape 50"/>
-          <p:cNvSpPr/>
-          <p:nvPr/>
-        </p:nvSpPr>
-        <p:spPr>
-          <a:xfrm>
-            <a:off x="548640" y="3813048"/>
+          <p:cNvPr id="65" name="Shape 63"/>
+          <p:cNvSpPr/>
+          <p:nvPr/>
+        </p:nvSpPr>
+        <p:spPr>
+          <a:xfrm>
+            <a:off x="548640" y="4480560"/>
             <a:ext cx="11091672" cy="333756"/>
           </a:xfrm>
           <a:prstGeom prst="rect">
@@ -6979,13 +7429,13 @@
       </p:sp>
       <p:sp>
         <p:nvSpPr>
-          <p:cNvPr id="53" name="Text 51"/>
-          <p:cNvSpPr/>
-          <p:nvPr/>
-        </p:nvSpPr>
-        <p:spPr>
-          <a:xfrm>
-            <a:off x="548640" y="3813048"/>
+          <p:cNvPr id="66" name="Text 64"/>
+          <p:cNvSpPr/>
+          <p:nvPr/>
+        </p:nvSpPr>
+        <p:spPr>
+          <a:xfrm>
+            <a:off x="548640" y="4480560"/>
             <a:ext cx="594360" cy="333756"/>
           </a:xfrm>
           <a:prstGeom prst="rect">
@@ -7010,7 +7460,7 @@
                 <a:ea typeface="游ゴシック" pitchFamily="34" charset="-122"/>
                 <a:cs typeface="游ゴシック" pitchFamily="34" charset="-120"/>
               </a:rPr>
-              <a:t>8</a:t>
+              <a:t>10</a:t>
             </a:r>
             <a:endParaRPr lang="en-US" sz="1200" dirty="0"/>
           </a:p>
@@ -7018,13 +7468,13 @@
       </p:sp>
       <p:sp>
         <p:nvSpPr>
-          <p:cNvPr id="54" name="Text 52"/>
-          <p:cNvSpPr/>
-          <p:nvPr/>
-        </p:nvSpPr>
-        <p:spPr>
-          <a:xfrm>
-            <a:off x="1143000" y="3813048"/>
+          <p:cNvPr id="67" name="Text 65"/>
+          <p:cNvSpPr/>
+          <p:nvPr/>
+        </p:nvSpPr>
+        <p:spPr>
+          <a:xfrm>
+            <a:off x="1143000" y="4480560"/>
             <a:ext cx="594360" cy="333756"/>
           </a:xfrm>
           <a:prstGeom prst="rect">
@@ -7049,7 +7499,7 @@
                 <a:ea typeface="游ゴシック" pitchFamily="34" charset="-122"/>
                 <a:cs typeface="游ゴシック" pitchFamily="34" charset="-120"/>
               </a:rPr>
-              <a:t>204</a:t>
+              <a:t>107</a:t>
             </a:r>
             <a:endParaRPr lang="en-US" sz="1100" dirty="0"/>
           </a:p>
@@ -7057,13 +7507,13 @@
       </p:sp>
       <p:sp>
         <p:nvSpPr>
-          <p:cNvPr id="55" name="Text 53"/>
-          <p:cNvSpPr/>
-          <p:nvPr/>
-        </p:nvSpPr>
-        <p:spPr>
-          <a:xfrm>
-            <a:off x="1828800" y="3813048"/>
+          <p:cNvPr id="68" name="Text 66"/>
+          <p:cNvSpPr/>
+          <p:nvPr/>
+        </p:nvSpPr>
+        <p:spPr>
+          <a:xfrm>
+            <a:off x="1828800" y="4480560"/>
             <a:ext cx="7040880" cy="333756"/>
           </a:xfrm>
           <a:prstGeom prst="rect">
@@ -7088,7 +7538,7 @@
                 <a:ea typeface="游ゴシック" pitchFamily="34" charset="-122"/>
                 <a:cs typeface="游ゴシック" pitchFamily="34" charset="-120"/>
               </a:rPr>
-              <a:t>広島イベントセンター</a:t>
+              <a:t>岡山イベントセンター</a:t>
             </a:r>
             <a:endParaRPr lang="en-US" sz="1300" dirty="0"/>
           </a:p>
@@ -7096,13 +7546,13 @@
       </p:sp>
       <p:sp>
         <p:nvSpPr>
-          <p:cNvPr id="56" name="Text 54"/>
-          <p:cNvSpPr/>
-          <p:nvPr/>
-        </p:nvSpPr>
-        <p:spPr>
-          <a:xfrm>
-            <a:off x="8778240" y="3813048"/>
+          <p:cNvPr id="69" name="Text 67"/>
+          <p:cNvSpPr/>
+          <p:nvPr/>
+        </p:nvSpPr>
+        <p:spPr>
+          <a:xfrm>
+            <a:off x="8778240" y="4480560"/>
             <a:ext cx="1920240" cy="333756"/>
           </a:xfrm>
           <a:prstGeom prst="rect">
@@ -7127,7 +7577,7 @@
                 <a:ea typeface="游ゴシック" pitchFamily="34" charset="-122"/>
                 <a:cs typeface="游ゴシック" pitchFamily="34" charset="-120"/>
               </a:rPr>
-              <a:t>36,063,194</a:t>
+              <a:t>28,224,605</a:t>
             </a:r>
             <a:endParaRPr lang="en-US" sz="1300" dirty="0"/>
           </a:p>
@@ -7135,13 +7585,13 @@
       </p:sp>
       <p:sp>
         <p:nvSpPr>
-          <p:cNvPr id="57" name="Text 55"/>
-          <p:cNvSpPr/>
-          <p:nvPr/>
-        </p:nvSpPr>
-        <p:spPr>
-          <a:xfrm>
-            <a:off x="10698480" y="3813048"/>
+          <p:cNvPr id="70" name="Text 68"/>
+          <p:cNvSpPr/>
+          <p:nvPr/>
+        </p:nvSpPr>
+        <p:spPr>
+          <a:xfrm>
+            <a:off x="10698480" y="4480560"/>
             <a:ext cx="941832" cy="333756"/>
           </a:xfrm>
           <a:prstGeom prst="rect">
@@ -7160,13 +7610,13 @@
             <a:r>
               <a:rPr lang="en-US" sz="1300" b="1" dirty="0">
                 <a:solidFill>
-                  <a:srgbClr val="16A34A"/>
-                </a:solidFill>
-                <a:latin typeface="游ゴシック" pitchFamily="34" charset="0"/>
-                <a:ea typeface="游ゴシック" pitchFamily="34" charset="-122"/>
-                <a:cs typeface="游ゴシック" pitchFamily="34" charset="-120"/>
-              </a:rPr>
-              <a:t>5.8%</a:t>
+                  <a:srgbClr val="DC2626"/>
+                </a:solidFill>
+                <a:latin typeface="游ゴシック" pitchFamily="34" charset="0"/>
+                <a:ea typeface="游ゴシック" pitchFamily="34" charset="-122"/>
+                <a:cs typeface="游ゴシック" pitchFamily="34" charset="-120"/>
+              </a:rPr>
+              <a:t>▲6.4%</a:t>
             </a:r>
             <a:endParaRPr lang="en-US" sz="1300" dirty="0"/>
           </a:p>
@@ -7174,13 +7624,13 @@
       </p:sp>
       <p:sp>
         <p:nvSpPr>
-          <p:cNvPr id="58" name="Shape 56"/>
-          <p:cNvSpPr/>
-          <p:nvPr/>
-        </p:nvSpPr>
-        <p:spPr>
-          <a:xfrm>
-            <a:off x="548640" y="4146804"/>
+          <p:cNvPr id="71" name="Shape 69"/>
+          <p:cNvSpPr/>
+          <p:nvPr/>
+        </p:nvSpPr>
+        <p:spPr>
+          <a:xfrm>
+            <a:off x="548640" y="4814316"/>
             <a:ext cx="11091672" cy="333756"/>
           </a:xfrm>
           <a:prstGeom prst="rect">
@@ -7194,13 +7644,13 @@
       </p:sp>
       <p:sp>
         <p:nvSpPr>
-          <p:cNvPr id="59" name="Text 57"/>
-          <p:cNvSpPr/>
-          <p:nvPr/>
-        </p:nvSpPr>
-        <p:spPr>
-          <a:xfrm>
-            <a:off x="548640" y="4146804"/>
+          <p:cNvPr id="72" name="Text 70"/>
+          <p:cNvSpPr/>
+          <p:nvPr/>
+        </p:nvSpPr>
+        <p:spPr>
+          <a:xfrm>
+            <a:off x="548640" y="4814316"/>
             <a:ext cx="594360" cy="333756"/>
           </a:xfrm>
           <a:prstGeom prst="rect">
@@ -7225,7 +7675,7 @@
                 <a:ea typeface="游ゴシック" pitchFamily="34" charset="-122"/>
                 <a:cs typeface="游ゴシック" pitchFamily="34" charset="-120"/>
               </a:rPr>
-              <a:t>9</a:t>
+              <a:t>11</a:t>
             </a:r>
             <a:endParaRPr lang="en-US" sz="1200" dirty="0"/>
           </a:p>
@@ -7233,13 +7683,13 @@
       </p:sp>
       <p:sp>
         <p:nvSpPr>
-          <p:cNvPr id="60" name="Text 58"/>
-          <p:cNvSpPr/>
-          <p:nvPr/>
-        </p:nvSpPr>
-        <p:spPr>
-          <a:xfrm>
-            <a:off x="1143000" y="4146804"/>
+          <p:cNvPr id="73" name="Text 71"/>
+          <p:cNvSpPr/>
+          <p:nvPr/>
+        </p:nvSpPr>
+        <p:spPr>
+          <a:xfrm>
+            <a:off x="1143000" y="4814316"/>
             <a:ext cx="594360" cy="333756"/>
           </a:xfrm>
           <a:prstGeom prst="rect">
@@ -7264,7 +7714,7 @@
                 <a:ea typeface="游ゴシック" pitchFamily="34" charset="-122"/>
                 <a:cs typeface="游ゴシック" pitchFamily="34" charset="-120"/>
               </a:rPr>
-              <a:t>107</a:t>
+              <a:t>85</a:t>
             </a:r>
             <a:endParaRPr lang="en-US" sz="1100" dirty="0"/>
           </a:p>
@@ -7272,13 +7722,13 @@
       </p:sp>
       <p:sp>
         <p:nvSpPr>
-          <p:cNvPr id="61" name="Text 59"/>
-          <p:cNvSpPr/>
-          <p:nvPr/>
-        </p:nvSpPr>
-        <p:spPr>
-          <a:xfrm>
-            <a:off x="1828800" y="4146804"/>
+          <p:cNvPr id="74" name="Text 72"/>
+          <p:cNvSpPr/>
+          <p:nvPr/>
+        </p:nvSpPr>
+        <p:spPr>
+          <a:xfrm>
+            <a:off x="1828800" y="4814316"/>
             <a:ext cx="7040880" cy="333756"/>
           </a:xfrm>
           <a:prstGeom prst="rect">
@@ -7303,7 +7753,7 @@
                 <a:ea typeface="游ゴシック" pitchFamily="34" charset="-122"/>
                 <a:cs typeface="游ゴシック" pitchFamily="34" charset="-120"/>
               </a:rPr>
-              <a:t>岡山イベントセンター</a:t>
+              <a:t>姫路イベントセンター</a:t>
             </a:r>
             <a:endParaRPr lang="en-US" sz="1300" dirty="0"/>
           </a:p>
@@ -7311,13 +7761,13 @@
       </p:sp>
       <p:sp>
         <p:nvSpPr>
-          <p:cNvPr id="62" name="Text 60"/>
-          <p:cNvSpPr/>
-          <p:nvPr/>
-        </p:nvSpPr>
-        <p:spPr>
-          <a:xfrm>
-            <a:off x="8778240" y="4146804"/>
+          <p:cNvPr id="75" name="Text 73"/>
+          <p:cNvSpPr/>
+          <p:nvPr/>
+        </p:nvSpPr>
+        <p:spPr>
+          <a:xfrm>
+            <a:off x="8778240" y="4814316"/>
             <a:ext cx="1920240" cy="333756"/>
           </a:xfrm>
           <a:prstGeom prst="rect">
@@ -7342,7 +7792,7 @@
                 <a:ea typeface="游ゴシック" pitchFamily="34" charset="-122"/>
                 <a:cs typeface="游ゴシック" pitchFamily="34" charset="-120"/>
               </a:rPr>
-              <a:t>35,056,186</a:t>
+              <a:t>27,404,979</a:t>
             </a:r>
             <a:endParaRPr lang="en-US" sz="1300" dirty="0"/>
           </a:p>
@@ -7350,13 +7800,13 @@
       </p:sp>
       <p:sp>
         <p:nvSpPr>
-          <p:cNvPr id="63" name="Text 61"/>
-          <p:cNvSpPr/>
-          <p:nvPr/>
-        </p:nvSpPr>
-        <p:spPr>
-          <a:xfrm>
-            <a:off x="10698480" y="4146804"/>
+          <p:cNvPr id="76" name="Text 74"/>
+          <p:cNvSpPr/>
+          <p:nvPr/>
+        </p:nvSpPr>
+        <p:spPr>
+          <a:xfrm>
+            <a:off x="10698480" y="4814316"/>
             <a:ext cx="941832" cy="333756"/>
           </a:xfrm>
           <a:prstGeom prst="rect">
@@ -7375,13 +7825,13 @@
             <a:r>
               <a:rPr lang="en-US" sz="1300" b="1" dirty="0">
                 <a:solidFill>
-                  <a:srgbClr val="16A34A"/>
-                </a:solidFill>
-                <a:latin typeface="游ゴシック" pitchFamily="34" charset="0"/>
-                <a:ea typeface="游ゴシック" pitchFamily="34" charset="-122"/>
-                <a:cs typeface="游ゴシック" pitchFamily="34" charset="-120"/>
-              </a:rPr>
-              <a:t>149.9%</a:t>
+                  <a:srgbClr val="DC2626"/>
+                </a:solidFill>
+                <a:latin typeface="游ゴシック" pitchFamily="34" charset="0"/>
+                <a:ea typeface="游ゴシック" pitchFamily="34" charset="-122"/>
+                <a:cs typeface="游ゴシック" pitchFamily="34" charset="-120"/>
+              </a:rPr>
+              <a:t>▲9.0%</a:t>
             </a:r>
             <a:endParaRPr lang="en-US" sz="1300" dirty="0"/>
           </a:p>
@@ -7389,53 +7839,33 @@
       </p:sp>
       <p:sp>
         <p:nvSpPr>
-          <p:cNvPr id="64" name="Shape 62"/>
-          <p:cNvSpPr/>
-          <p:nvPr/>
-        </p:nvSpPr>
-        <p:spPr>
-          <a:xfrm>
-            <a:off x="548640" y="4480560"/>
+          <p:cNvPr id="77" name="Shape 75"/>
+          <p:cNvSpPr/>
+          <p:nvPr/>
+        </p:nvSpPr>
+        <p:spPr>
+          <a:xfrm>
+            <a:off x="548640" y="5148072"/>
             <a:ext cx="11091672" cy="333756"/>
           </a:xfrm>
           <a:prstGeom prst="rect">
             <a:avLst/>
           </a:prstGeom>
           <a:solidFill>
-            <a:srgbClr val="DBEAFE"/>
+            <a:srgbClr val="F5F7FA"/>
           </a:solidFill>
           <a:ln/>
         </p:spPr>
       </p:sp>
       <p:sp>
         <p:nvSpPr>
-          <p:cNvPr id="65" name="Shape 63"/>
-          <p:cNvSpPr/>
-          <p:nvPr/>
-        </p:nvSpPr>
-        <p:spPr>
-          <a:xfrm>
-            <a:off x="548640" y="4480560"/>
-            <a:ext cx="41148" cy="333756"/>
-          </a:xfrm>
-          <a:prstGeom prst="rect">
-            <a:avLst/>
-          </a:prstGeom>
-          <a:solidFill>
-            <a:srgbClr val="2563EB"/>
-          </a:solidFill>
-          <a:ln/>
-        </p:spPr>
-      </p:sp>
-      <p:sp>
-        <p:nvSpPr>
-          <p:cNvPr id="66" name="Text 64"/>
-          <p:cNvSpPr/>
-          <p:nvPr/>
-        </p:nvSpPr>
-        <p:spPr>
-          <a:xfrm>
-            <a:off x="548640" y="4480560"/>
+          <p:cNvPr id="78" name="Text 76"/>
+          <p:cNvSpPr/>
+          <p:nvPr/>
+        </p:nvSpPr>
+        <p:spPr>
+          <a:xfrm>
+            <a:off x="548640" y="5148072"/>
             <a:ext cx="594360" cy="333756"/>
           </a:xfrm>
           <a:prstGeom prst="rect">
@@ -7452,15 +7882,15 @@
               <a:buNone/>
             </a:pPr>
             <a:r>
-              <a:rPr lang="en-US" sz="1200" b="1" dirty="0">
-                <a:solidFill>
-                  <a:srgbClr val="2563EB"/>
-                </a:solidFill>
-                <a:latin typeface="游ゴシック" pitchFamily="34" charset="0"/>
-                <a:ea typeface="游ゴシック" pitchFamily="34" charset="-122"/>
-                <a:cs typeface="游ゴシック" pitchFamily="34" charset="-120"/>
-              </a:rPr>
-              <a:t>10</a:t>
+              <a:rPr lang="en-US" sz="1200" dirty="0">
+                <a:solidFill>
+                  <a:srgbClr val="1A1A2E"/>
+                </a:solidFill>
+                <a:latin typeface="游ゴシック" pitchFamily="34" charset="0"/>
+                <a:ea typeface="游ゴシック" pitchFamily="34" charset="-122"/>
+                <a:cs typeface="游ゴシック" pitchFamily="34" charset="-120"/>
+              </a:rPr>
+              <a:t>12</a:t>
             </a:r>
             <a:endParaRPr lang="en-US" sz="1200" dirty="0"/>
           </a:p>
@@ -7468,13 +7898,13 @@
       </p:sp>
       <p:sp>
         <p:nvSpPr>
-          <p:cNvPr id="67" name="Text 65"/>
-          <p:cNvSpPr/>
-          <p:nvPr/>
-        </p:nvSpPr>
-        <p:spPr>
-          <a:xfrm>
-            <a:off x="1143000" y="4480560"/>
+          <p:cNvPr id="79" name="Text 77"/>
+          <p:cNvSpPr/>
+          <p:nvPr/>
+        </p:nvSpPr>
+        <p:spPr>
+          <a:xfrm>
+            <a:off x="1143000" y="5148072"/>
             <a:ext cx="594360" cy="333756"/>
           </a:xfrm>
           <a:prstGeom prst="rect">
@@ -7499,7 +7929,7 @@
                 <a:ea typeface="游ゴシック" pitchFamily="34" charset="-122"/>
                 <a:cs typeface="游ゴシック" pitchFamily="34" charset="-120"/>
               </a:rPr>
-              <a:t>24</a:t>
+              <a:t>145</a:t>
             </a:r>
             <a:endParaRPr lang="en-US" sz="1100" dirty="0"/>
           </a:p>
@@ -7507,13 +7937,13 @@
       </p:sp>
       <p:sp>
         <p:nvSpPr>
-          <p:cNvPr id="68" name="Text 66"/>
-          <p:cNvSpPr/>
-          <p:nvPr/>
-        </p:nvSpPr>
-        <p:spPr>
-          <a:xfrm>
-            <a:off x="1828800" y="4480560"/>
+          <p:cNvPr id="80" name="Text 78"/>
+          <p:cNvSpPr/>
+          <p:nvPr/>
+        </p:nvSpPr>
+        <p:spPr>
+          <a:xfrm>
+            <a:off x="1828800" y="5148072"/>
             <a:ext cx="7040880" cy="333756"/>
           </a:xfrm>
           <a:prstGeom prst="rect">
@@ -7530,6 +7960,45 @@
               <a:buNone/>
             </a:pPr>
             <a:r>
+              <a:rPr lang="en-US" sz="1300" dirty="0">
+                <a:solidFill>
+                  <a:srgbClr val="1A1A2E"/>
+                </a:solidFill>
+                <a:latin typeface="游ゴシック" pitchFamily="34" charset="0"/>
+                <a:ea typeface="游ゴシック" pitchFamily="34" charset="-122"/>
+                <a:cs typeface="游ゴシック" pitchFamily="34" charset="-120"/>
+              </a:rPr>
+              <a:t>札幌イベントセンター</a:t>
+            </a:r>
+            <a:endParaRPr lang="en-US" sz="1300" dirty="0"/>
+          </a:p>
+        </p:txBody>
+      </p:sp>
+      <p:sp>
+        <p:nvSpPr>
+          <p:cNvPr id="81" name="Text 79"/>
+          <p:cNvSpPr/>
+          <p:nvPr/>
+        </p:nvSpPr>
+        <p:spPr>
+          <a:xfrm>
+            <a:off x="8778240" y="5148072"/>
+            <a:ext cx="1920240" cy="333756"/>
+          </a:xfrm>
+          <a:prstGeom prst="rect">
+            <a:avLst/>
+          </a:prstGeom>
+          <a:noFill/>
+          <a:ln/>
+        </p:spPr>
+        <p:txBody>
+          <a:bodyPr wrap="square" rtlCol="0" anchor="ctr"/>
+          <a:lstStyle/>
+          <a:p>
+            <a:pPr algn="r" indent="0" marL="0">
+              <a:buNone/>
+            </a:pPr>
+            <a:r>
               <a:rPr lang="en-US" sz="1300" b="1" dirty="0">
                 <a:solidFill>
                   <a:srgbClr val="1A1A2E"/>
@@ -7538,7 +8007,7 @@
                 <a:ea typeface="游ゴシック" pitchFamily="34" charset="-122"/>
                 <a:cs typeface="游ゴシック" pitchFamily="34" charset="-120"/>
               </a:rPr>
-              <a:t>名古屋イベントセンター</a:t>
+              <a:t>24,245,240</a:t>
             </a:r>
             <a:endParaRPr lang="en-US" sz="1300" dirty="0"/>
           </a:p>
@@ -7546,14 +8015,14 @@
       </p:sp>
       <p:sp>
         <p:nvSpPr>
-          <p:cNvPr id="69" name="Text 67"/>
-          <p:cNvSpPr/>
-          <p:nvPr/>
-        </p:nvSpPr>
-        <p:spPr>
-          <a:xfrm>
-            <a:off x="8778240" y="4480560"/>
-            <a:ext cx="1920240" cy="333756"/>
+          <p:cNvPr id="82" name="Text 80"/>
+          <p:cNvSpPr/>
+          <p:nvPr/>
+        </p:nvSpPr>
+        <p:spPr>
+          <a:xfrm>
+            <a:off x="10698480" y="5148072"/>
+            <a:ext cx="941832" cy="333756"/>
           </a:xfrm>
           <a:prstGeom prst="rect">
             <a:avLst/>
@@ -7571,13 +8040,13 @@
             <a:r>
               <a:rPr lang="en-US" sz="1300" b="1" dirty="0">
                 <a:solidFill>
-                  <a:srgbClr val="2563EB"/>
-                </a:solidFill>
-                <a:latin typeface="游ゴシック" pitchFamily="34" charset="0"/>
-                <a:ea typeface="游ゴシック" pitchFamily="34" charset="-122"/>
-                <a:cs typeface="游ゴシック" pitchFamily="34" charset="-120"/>
-              </a:rPr>
-              <a:t>33,447,345</a:t>
+                  <a:srgbClr val="DC2626"/>
+                </a:solidFill>
+                <a:latin typeface="游ゴシック" pitchFamily="34" charset="0"/>
+                <a:ea typeface="游ゴシック" pitchFamily="34" charset="-122"/>
+                <a:cs typeface="游ゴシック" pitchFamily="34" charset="-120"/>
+              </a:rPr>
+              <a:t>▲20.2%</a:t>
             </a:r>
             <a:endParaRPr lang="en-US" sz="1300" dirty="0"/>
           </a:p>
@@ -7585,52 +8054,13 @@
       </p:sp>
       <p:sp>
         <p:nvSpPr>
-          <p:cNvPr id="70" name="Text 68"/>
-          <p:cNvSpPr/>
-          <p:nvPr/>
-        </p:nvSpPr>
-        <p:spPr>
-          <a:xfrm>
-            <a:off x="10698480" y="4480560"/>
-            <a:ext cx="941832" cy="333756"/>
-          </a:xfrm>
-          <a:prstGeom prst="rect">
-            <a:avLst/>
-          </a:prstGeom>
-          <a:noFill/>
-          <a:ln/>
-        </p:spPr>
-        <p:txBody>
-          <a:bodyPr wrap="square" rtlCol="0" anchor="ctr"/>
-          <a:lstStyle/>
-          <a:p>
-            <a:pPr algn="r" indent="0" marL="0">
-              <a:buNone/>
-            </a:pPr>
-            <a:r>
-              <a:rPr lang="en-US" sz="1300" b="1" dirty="0">
-                <a:solidFill>
-                  <a:srgbClr val="16A34A"/>
-                </a:solidFill>
-                <a:latin typeface="游ゴシック" pitchFamily="34" charset="0"/>
-                <a:ea typeface="游ゴシック" pitchFamily="34" charset="-122"/>
-                <a:cs typeface="游ゴシック" pitchFamily="34" charset="-120"/>
-              </a:rPr>
-              <a:t>126.2%</a:t>
-            </a:r>
-            <a:endParaRPr lang="en-US" sz="1300" dirty="0"/>
-          </a:p>
-        </p:txBody>
-      </p:sp>
-      <p:sp>
-        <p:nvSpPr>
-          <p:cNvPr id="71" name="Shape 69"/>
-          <p:cNvSpPr/>
-          <p:nvPr/>
-        </p:nvSpPr>
-        <p:spPr>
-          <a:xfrm>
-            <a:off x="548640" y="4814316"/>
+          <p:cNvPr id="83" name="Shape 81"/>
+          <p:cNvSpPr/>
+          <p:nvPr/>
+        </p:nvSpPr>
+        <p:spPr>
+          <a:xfrm>
+            <a:off x="548640" y="5481828"/>
             <a:ext cx="11091672" cy="333756"/>
           </a:xfrm>
           <a:prstGeom prst="rect">
@@ -7644,13 +8074,13 @@
       </p:sp>
       <p:sp>
         <p:nvSpPr>
-          <p:cNvPr id="72" name="Text 70"/>
-          <p:cNvSpPr/>
-          <p:nvPr/>
-        </p:nvSpPr>
-        <p:spPr>
-          <a:xfrm>
-            <a:off x="548640" y="4814316"/>
+          <p:cNvPr id="84" name="Text 82"/>
+          <p:cNvSpPr/>
+          <p:nvPr/>
+        </p:nvSpPr>
+        <p:spPr>
+          <a:xfrm>
+            <a:off x="548640" y="5481828"/>
             <a:ext cx="594360" cy="333756"/>
           </a:xfrm>
           <a:prstGeom prst="rect">
@@ -7675,7 +8105,7 @@
                 <a:ea typeface="游ゴシック" pitchFamily="34" charset="-122"/>
                 <a:cs typeface="游ゴシック" pitchFamily="34" charset="-120"/>
               </a:rPr>
-              <a:t>11</a:t>
+              <a:t>13</a:t>
             </a:r>
             <a:endParaRPr lang="en-US" sz="1200" dirty="0"/>
           </a:p>
@@ -7683,13 +8113,13 @@
       </p:sp>
       <p:sp>
         <p:nvSpPr>
-          <p:cNvPr id="73" name="Text 71"/>
-          <p:cNvSpPr/>
-          <p:nvPr/>
-        </p:nvSpPr>
-        <p:spPr>
-          <a:xfrm>
-            <a:off x="1143000" y="4814316"/>
+          <p:cNvPr id="85" name="Text 83"/>
+          <p:cNvSpPr/>
+          <p:nvPr/>
+        </p:nvSpPr>
+        <p:spPr>
+          <a:xfrm>
+            <a:off x="1143000" y="5481828"/>
             <a:ext cx="594360" cy="333756"/>
           </a:xfrm>
           <a:prstGeom prst="rect">
@@ -7714,7 +8144,7 @@
                 <a:ea typeface="游ゴシック" pitchFamily="34" charset="-122"/>
                 <a:cs typeface="游ゴシック" pitchFamily="34" charset="-120"/>
               </a:rPr>
-              <a:t>417</a:t>
+              <a:t>186</a:t>
             </a:r>
             <a:endParaRPr lang="en-US" sz="1100" dirty="0"/>
           </a:p>
@@ -7722,13 +8152,13 @@
       </p:sp>
       <p:sp>
         <p:nvSpPr>
-          <p:cNvPr id="74" name="Text 72"/>
-          <p:cNvSpPr/>
-          <p:nvPr/>
-        </p:nvSpPr>
-        <p:spPr>
-          <a:xfrm>
-            <a:off x="1828800" y="4814316"/>
+          <p:cNvPr id="86" name="Text 84"/>
+          <p:cNvSpPr/>
+          <p:nvPr/>
+        </p:nvSpPr>
+        <p:spPr>
+          <a:xfrm>
+            <a:off x="1828800" y="5481828"/>
             <a:ext cx="7040880" cy="333756"/>
           </a:xfrm>
           <a:prstGeom prst="rect">
@@ -7753,7 +8183,7 @@
                 <a:ea typeface="游ゴシック" pitchFamily="34" charset="-122"/>
                 <a:cs typeface="游ゴシック" pitchFamily="34" charset="-120"/>
               </a:rPr>
-              <a:t>銀座イベントセンター</a:t>
+              <a:t>大阪南港イベントセンター</a:t>
             </a:r>
             <a:endParaRPr lang="en-US" sz="1300" dirty="0"/>
           </a:p>
@@ -7761,13 +8191,13 @@
       </p:sp>
       <p:sp>
         <p:nvSpPr>
-          <p:cNvPr id="75" name="Text 73"/>
-          <p:cNvSpPr/>
-          <p:nvPr/>
-        </p:nvSpPr>
-        <p:spPr>
-          <a:xfrm>
-            <a:off x="8778240" y="4814316"/>
+          <p:cNvPr id="87" name="Text 85"/>
+          <p:cNvSpPr/>
+          <p:nvPr/>
+        </p:nvSpPr>
+        <p:spPr>
+          <a:xfrm>
+            <a:off x="8778240" y="5481828"/>
             <a:ext cx="1920240" cy="333756"/>
           </a:xfrm>
           <a:prstGeom prst="rect">
@@ -7792,7 +8222,7 @@
                 <a:ea typeface="游ゴシック" pitchFamily="34" charset="-122"/>
                 <a:cs typeface="游ゴシック" pitchFamily="34" charset="-120"/>
               </a:rPr>
-              <a:t>28,293,034</a:t>
+              <a:t>18,428,718</a:t>
             </a:r>
             <a:endParaRPr lang="en-US" sz="1300" dirty="0"/>
           </a:p>
@@ -7800,13 +8230,13 @@
       </p:sp>
       <p:sp>
         <p:nvSpPr>
-          <p:cNvPr id="76" name="Text 74"/>
-          <p:cNvSpPr/>
-          <p:nvPr/>
-        </p:nvSpPr>
-        <p:spPr>
-          <a:xfrm>
-            <a:off x="10698480" y="4814316"/>
+          <p:cNvPr id="88" name="Text 86"/>
+          <p:cNvSpPr/>
+          <p:nvPr/>
+        </p:nvSpPr>
+        <p:spPr>
+          <a:xfrm>
+            <a:off x="10698480" y="5481828"/>
             <a:ext cx="941832" cy="333756"/>
           </a:xfrm>
           <a:prstGeom prst="rect">
@@ -7825,13 +8255,13 @@
             <a:r>
               <a:rPr lang="en-US" sz="1300" b="1" dirty="0">
                 <a:solidFill>
-                  <a:srgbClr val="16A34A"/>
-                </a:solidFill>
-                <a:latin typeface="游ゴシック" pitchFamily="34" charset="0"/>
-                <a:ea typeface="游ゴシック" pitchFamily="34" charset="-122"/>
-                <a:cs typeface="游ゴシック" pitchFamily="34" charset="-120"/>
-              </a:rPr>
-              <a:t>26.1%</a:t>
+                  <a:srgbClr val="DC2626"/>
+                </a:solidFill>
+                <a:latin typeface="游ゴシック" pitchFamily="34" charset="0"/>
+                <a:ea typeface="游ゴシック" pitchFamily="34" charset="-122"/>
+                <a:cs typeface="游ゴシック" pitchFamily="34" charset="-120"/>
+              </a:rPr>
+              <a:t>▲36.3%</a:t>
             </a:r>
             <a:endParaRPr lang="en-US" sz="1300" dirty="0"/>
           </a:p>
@@ -7839,13 +8269,13 @@
       </p:sp>
       <p:sp>
         <p:nvSpPr>
-          <p:cNvPr id="77" name="Shape 75"/>
-          <p:cNvSpPr/>
-          <p:nvPr/>
-        </p:nvSpPr>
-        <p:spPr>
-          <a:xfrm>
-            <a:off x="548640" y="5148072"/>
+          <p:cNvPr id="89" name="Shape 87"/>
+          <p:cNvSpPr/>
+          <p:nvPr/>
+        </p:nvSpPr>
+        <p:spPr>
+          <a:xfrm>
+            <a:off x="548640" y="5815584"/>
             <a:ext cx="11091672" cy="333756"/>
           </a:xfrm>
           <a:prstGeom prst="rect">
@@ -7859,13 +8289,13 @@
       </p:sp>
       <p:sp>
         <p:nvSpPr>
-          <p:cNvPr id="78" name="Text 76"/>
-          <p:cNvSpPr/>
-          <p:nvPr/>
-        </p:nvSpPr>
-        <p:spPr>
-          <a:xfrm>
-            <a:off x="548640" y="5148072"/>
+          <p:cNvPr id="90" name="Text 88"/>
+          <p:cNvSpPr/>
+          <p:nvPr/>
+        </p:nvSpPr>
+        <p:spPr>
+          <a:xfrm>
+            <a:off x="548640" y="5815584"/>
             <a:ext cx="594360" cy="333756"/>
           </a:xfrm>
           <a:prstGeom prst="rect">
@@ -7890,7 +8320,7 @@
                 <a:ea typeface="游ゴシック" pitchFamily="34" charset="-122"/>
                 <a:cs typeface="游ゴシック" pitchFamily="34" charset="-120"/>
               </a:rPr>
-              <a:t>12</a:t>
+              <a:t>14</a:t>
             </a:r>
             <a:endParaRPr lang="en-US" sz="1200" dirty="0"/>
           </a:p>
@@ -7898,13 +8328,13 @@
       </p:sp>
       <p:sp>
         <p:nvSpPr>
-          <p:cNvPr id="79" name="Text 77"/>
-          <p:cNvSpPr/>
-          <p:nvPr/>
-        </p:nvSpPr>
-        <p:spPr>
-          <a:xfrm>
-            <a:off x="1143000" y="5148072"/>
+          <p:cNvPr id="91" name="Text 89"/>
+          <p:cNvSpPr/>
+          <p:nvPr/>
+        </p:nvSpPr>
+        <p:spPr>
+          <a:xfrm>
+            <a:off x="1143000" y="5815584"/>
             <a:ext cx="594360" cy="333756"/>
           </a:xfrm>
           <a:prstGeom prst="rect">
@@ -7929,7 +8359,7 @@
                 <a:ea typeface="游ゴシック" pitchFamily="34" charset="-122"/>
                 <a:cs typeface="游ゴシック" pitchFamily="34" charset="-120"/>
               </a:rPr>
-              <a:t>85</a:t>
+              <a:t>204</a:t>
             </a:r>
             <a:endParaRPr lang="en-US" sz="1100" dirty="0"/>
           </a:p>
@@ -7937,13 +8367,13 @@
       </p:sp>
       <p:sp>
         <p:nvSpPr>
-          <p:cNvPr id="80" name="Text 78"/>
-          <p:cNvSpPr/>
-          <p:nvPr/>
-        </p:nvSpPr>
-        <p:spPr>
-          <a:xfrm>
-            <a:off x="1828800" y="5148072"/>
+          <p:cNvPr id="92" name="Text 90"/>
+          <p:cNvSpPr/>
+          <p:nvPr/>
+        </p:nvSpPr>
+        <p:spPr>
+          <a:xfrm>
+            <a:off x="1828800" y="5815584"/>
             <a:ext cx="7040880" cy="333756"/>
           </a:xfrm>
           <a:prstGeom prst="rect">
@@ -7968,7 +8398,7 @@
                 <a:ea typeface="游ゴシック" pitchFamily="34" charset="-122"/>
                 <a:cs typeface="游ゴシック" pitchFamily="34" charset="-120"/>
               </a:rPr>
-              <a:t>姫路イベントセンター</a:t>
+              <a:t>広島イベントセンター</a:t>
             </a:r>
             <a:endParaRPr lang="en-US" sz="1300" dirty="0"/>
           </a:p>
@@ -7976,13 +8406,13 @@
       </p:sp>
       <p:sp>
         <p:nvSpPr>
-          <p:cNvPr id="81" name="Text 79"/>
-          <p:cNvSpPr/>
-          <p:nvPr/>
-        </p:nvSpPr>
-        <p:spPr>
-          <a:xfrm>
-            <a:off x="8778240" y="5148072"/>
+          <p:cNvPr id="93" name="Text 91"/>
+          <p:cNvSpPr/>
+          <p:nvPr/>
+        </p:nvSpPr>
+        <p:spPr>
+          <a:xfrm>
+            <a:off x="8778240" y="5815584"/>
             <a:ext cx="1920240" cy="333756"/>
           </a:xfrm>
           <a:prstGeom prst="rect">
@@ -8007,7 +8437,7 @@
                 <a:ea typeface="游ゴシック" pitchFamily="34" charset="-122"/>
                 <a:cs typeface="游ゴシック" pitchFamily="34" charset="-120"/>
               </a:rPr>
-              <a:t>26,936,903</a:t>
+              <a:t>16,097,450</a:t>
             </a:r>
             <a:endParaRPr lang="en-US" sz="1300" dirty="0"/>
           </a:p>
@@ -8015,13 +8445,13 @@
       </p:sp>
       <p:sp>
         <p:nvSpPr>
-          <p:cNvPr id="82" name="Text 80"/>
-          <p:cNvSpPr/>
-          <p:nvPr/>
-        </p:nvSpPr>
-        <p:spPr>
-          <a:xfrm>
-            <a:off x="10698480" y="5148072"/>
+          <p:cNvPr id="94" name="Text 92"/>
+          <p:cNvSpPr/>
+          <p:nvPr/>
+        </p:nvSpPr>
+        <p:spPr>
+          <a:xfrm>
+            <a:off x="10698480" y="5815584"/>
             <a:ext cx="941832" cy="333756"/>
           </a:xfrm>
           <a:prstGeom prst="rect">
@@ -8040,13 +8470,13 @@
             <a:r>
               <a:rPr lang="en-US" sz="1300" b="1" dirty="0">
                 <a:solidFill>
-                  <a:srgbClr val="16A34A"/>
-                </a:solidFill>
-                <a:latin typeface="游ゴシック" pitchFamily="34" charset="0"/>
-                <a:ea typeface="游ゴシック" pitchFamily="34" charset="-122"/>
-                <a:cs typeface="游ゴシック" pitchFamily="34" charset="-120"/>
-              </a:rPr>
-              <a:t>103.9%</a:t>
+                  <a:srgbClr val="DC2626"/>
+                </a:solidFill>
+                <a:latin typeface="游ゴシック" pitchFamily="34" charset="0"/>
+                <a:ea typeface="游ゴシック" pitchFamily="34" charset="-122"/>
+                <a:cs typeface="游ゴシック" pitchFamily="34" charset="-120"/>
+              </a:rPr>
+              <a:t>▲20.7%</a:t>
             </a:r>
             <a:endParaRPr lang="en-US" sz="1300" dirty="0"/>
           </a:p>
@@ -8054,13 +8484,13 @@
       </p:sp>
       <p:sp>
         <p:nvSpPr>
-          <p:cNvPr id="83" name="Shape 81"/>
-          <p:cNvSpPr/>
-          <p:nvPr/>
-        </p:nvSpPr>
-        <p:spPr>
-          <a:xfrm>
-            <a:off x="548640" y="5481828"/>
+          <p:cNvPr id="95" name="Shape 93"/>
+          <p:cNvSpPr/>
+          <p:nvPr/>
+        </p:nvSpPr>
+        <p:spPr>
+          <a:xfrm>
+            <a:off x="548640" y="6149340"/>
             <a:ext cx="11091672" cy="333756"/>
           </a:xfrm>
           <a:prstGeom prst="rect">
@@ -8074,436 +8504,6 @@
       </p:sp>
       <p:sp>
         <p:nvSpPr>
-          <p:cNvPr id="84" name="Text 82"/>
-          <p:cNvSpPr/>
-          <p:nvPr/>
-        </p:nvSpPr>
-        <p:spPr>
-          <a:xfrm>
-            <a:off x="548640" y="5481828"/>
-            <a:ext cx="594360" cy="333756"/>
-          </a:xfrm>
-          <a:prstGeom prst="rect">
-            <a:avLst/>
-          </a:prstGeom>
-          <a:noFill/>
-          <a:ln/>
-        </p:spPr>
-        <p:txBody>
-          <a:bodyPr wrap="square" rtlCol="0" anchor="ctr"/>
-          <a:lstStyle/>
-          <a:p>
-            <a:pPr algn="ctr" indent="0" marL="0">
-              <a:buNone/>
-            </a:pPr>
-            <a:r>
-              <a:rPr lang="en-US" sz="1200" dirty="0">
-                <a:solidFill>
-                  <a:srgbClr val="1A1A2E"/>
-                </a:solidFill>
-                <a:latin typeface="游ゴシック" pitchFamily="34" charset="0"/>
-                <a:ea typeface="游ゴシック" pitchFamily="34" charset="-122"/>
-                <a:cs typeface="游ゴシック" pitchFamily="34" charset="-120"/>
-              </a:rPr>
-              <a:t>13</a:t>
-            </a:r>
-            <a:endParaRPr lang="en-US" sz="1200" dirty="0"/>
-          </a:p>
-        </p:txBody>
-      </p:sp>
-      <p:sp>
-        <p:nvSpPr>
-          <p:cNvPr id="85" name="Text 83"/>
-          <p:cNvSpPr/>
-          <p:nvPr/>
-        </p:nvSpPr>
-        <p:spPr>
-          <a:xfrm>
-            <a:off x="1143000" y="5481828"/>
-            <a:ext cx="594360" cy="333756"/>
-          </a:xfrm>
-          <a:prstGeom prst="rect">
-            <a:avLst/>
-          </a:prstGeom>
-          <a:noFill/>
-          <a:ln/>
-        </p:spPr>
-        <p:txBody>
-          <a:bodyPr wrap="square" rtlCol="0" anchor="ctr"/>
-          <a:lstStyle/>
-          <a:p>
-            <a:pPr algn="ctr" indent="0" marL="0">
-              <a:buNone/>
-            </a:pPr>
-            <a:r>
-              <a:rPr lang="en-US" sz="1100" dirty="0">
-                <a:solidFill>
-                  <a:srgbClr val="6B7280"/>
-                </a:solidFill>
-                <a:latin typeface="游ゴシック" pitchFamily="34" charset="0"/>
-                <a:ea typeface="游ゴシック" pitchFamily="34" charset="-122"/>
-                <a:cs typeface="游ゴシック" pitchFamily="34" charset="-120"/>
-              </a:rPr>
-              <a:t>186</a:t>
-            </a:r>
-            <a:endParaRPr lang="en-US" sz="1100" dirty="0"/>
-          </a:p>
-        </p:txBody>
-      </p:sp>
-      <p:sp>
-        <p:nvSpPr>
-          <p:cNvPr id="86" name="Text 84"/>
-          <p:cNvSpPr/>
-          <p:nvPr/>
-        </p:nvSpPr>
-        <p:spPr>
-          <a:xfrm>
-            <a:off x="1828800" y="5481828"/>
-            <a:ext cx="7040880" cy="333756"/>
-          </a:xfrm>
-          <a:prstGeom prst="rect">
-            <a:avLst/>
-          </a:prstGeom>
-          <a:noFill/>
-          <a:ln/>
-        </p:spPr>
-        <p:txBody>
-          <a:bodyPr wrap="square" rtlCol="0" anchor="ctr"/>
-          <a:lstStyle/>
-          <a:p>
-            <a:pPr algn="l" indent="0" marL="0">
-              <a:buNone/>
-            </a:pPr>
-            <a:r>
-              <a:rPr lang="en-US" sz="1300" dirty="0">
-                <a:solidFill>
-                  <a:srgbClr val="1A1A2E"/>
-                </a:solidFill>
-                <a:latin typeface="游ゴシック" pitchFamily="34" charset="0"/>
-                <a:ea typeface="游ゴシック" pitchFamily="34" charset="-122"/>
-                <a:cs typeface="游ゴシック" pitchFamily="34" charset="-120"/>
-              </a:rPr>
-              <a:t>大阪南港イベントセンター</a:t>
-            </a:r>
-            <a:endParaRPr lang="en-US" sz="1300" dirty="0"/>
-          </a:p>
-        </p:txBody>
-      </p:sp>
-      <p:sp>
-        <p:nvSpPr>
-          <p:cNvPr id="87" name="Text 85"/>
-          <p:cNvSpPr/>
-          <p:nvPr/>
-        </p:nvSpPr>
-        <p:spPr>
-          <a:xfrm>
-            <a:off x="8778240" y="5481828"/>
-            <a:ext cx="1920240" cy="333756"/>
-          </a:xfrm>
-          <a:prstGeom prst="rect">
-            <a:avLst/>
-          </a:prstGeom>
-          <a:noFill/>
-          <a:ln/>
-        </p:spPr>
-        <p:txBody>
-          <a:bodyPr wrap="square" rtlCol="0" anchor="ctr"/>
-          <a:lstStyle/>
-          <a:p>
-            <a:pPr algn="r" indent="0" marL="0">
-              <a:buNone/>
-            </a:pPr>
-            <a:r>
-              <a:rPr lang="en-US" sz="1300" b="1" dirty="0">
-                <a:solidFill>
-                  <a:srgbClr val="1A1A2E"/>
-                </a:solidFill>
-                <a:latin typeface="游ゴシック" pitchFamily="34" charset="0"/>
-                <a:ea typeface="游ゴシック" pitchFamily="34" charset="-122"/>
-                <a:cs typeface="游ゴシック" pitchFamily="34" charset="-120"/>
-              </a:rPr>
-              <a:t>26,245,836</a:t>
-            </a:r>
-            <a:endParaRPr lang="en-US" sz="1300" dirty="0"/>
-          </a:p>
-        </p:txBody>
-      </p:sp>
-      <p:sp>
-        <p:nvSpPr>
-          <p:cNvPr id="88" name="Text 86"/>
-          <p:cNvSpPr/>
-          <p:nvPr/>
-        </p:nvSpPr>
-        <p:spPr>
-          <a:xfrm>
-            <a:off x="10698480" y="5481828"/>
-            <a:ext cx="941832" cy="333756"/>
-          </a:xfrm>
-          <a:prstGeom prst="rect">
-            <a:avLst/>
-          </a:prstGeom>
-          <a:noFill/>
-          <a:ln/>
-        </p:spPr>
-        <p:txBody>
-          <a:bodyPr wrap="square" rtlCol="0" anchor="ctr"/>
-          <a:lstStyle/>
-          <a:p>
-            <a:pPr algn="r" indent="0" marL="0">
-              <a:buNone/>
-            </a:pPr>
-            <a:r>
-              <a:rPr lang="en-US" sz="1300" b="1" dirty="0">
-                <a:solidFill>
-                  <a:srgbClr val="16A34A"/>
-                </a:solidFill>
-                <a:latin typeface="游ゴシック" pitchFamily="34" charset="0"/>
-                <a:ea typeface="游ゴシック" pitchFamily="34" charset="-122"/>
-                <a:cs typeface="游ゴシック" pitchFamily="34" charset="-120"/>
-              </a:rPr>
-              <a:t>88.4%</a:t>
-            </a:r>
-            <a:endParaRPr lang="en-US" sz="1300" dirty="0"/>
-          </a:p>
-        </p:txBody>
-      </p:sp>
-      <p:sp>
-        <p:nvSpPr>
-          <p:cNvPr id="89" name="Shape 87"/>
-          <p:cNvSpPr/>
-          <p:nvPr/>
-        </p:nvSpPr>
-        <p:spPr>
-          <a:xfrm>
-            <a:off x="548640" y="5815584"/>
-            <a:ext cx="11091672" cy="333756"/>
-          </a:xfrm>
-          <a:prstGeom prst="rect">
-            <a:avLst/>
-          </a:prstGeom>
-          <a:solidFill>
-            <a:srgbClr val="F5F7FA"/>
-          </a:solidFill>
-          <a:ln/>
-        </p:spPr>
-      </p:sp>
-      <p:sp>
-        <p:nvSpPr>
-          <p:cNvPr id="90" name="Text 88"/>
-          <p:cNvSpPr/>
-          <p:nvPr/>
-        </p:nvSpPr>
-        <p:spPr>
-          <a:xfrm>
-            <a:off x="548640" y="5815584"/>
-            <a:ext cx="594360" cy="333756"/>
-          </a:xfrm>
-          <a:prstGeom prst="rect">
-            <a:avLst/>
-          </a:prstGeom>
-          <a:noFill/>
-          <a:ln/>
-        </p:spPr>
-        <p:txBody>
-          <a:bodyPr wrap="square" rtlCol="0" anchor="ctr"/>
-          <a:lstStyle/>
-          <a:p>
-            <a:pPr algn="ctr" indent="0" marL="0">
-              <a:buNone/>
-            </a:pPr>
-            <a:r>
-              <a:rPr lang="en-US" sz="1200" dirty="0">
-                <a:solidFill>
-                  <a:srgbClr val="1A1A2E"/>
-                </a:solidFill>
-                <a:latin typeface="游ゴシック" pitchFamily="34" charset="0"/>
-                <a:ea typeface="游ゴシック" pitchFamily="34" charset="-122"/>
-                <a:cs typeface="游ゴシック" pitchFamily="34" charset="-120"/>
-              </a:rPr>
-              <a:t>14</a:t>
-            </a:r>
-            <a:endParaRPr lang="en-US" sz="1200" dirty="0"/>
-          </a:p>
-        </p:txBody>
-      </p:sp>
-      <p:sp>
-        <p:nvSpPr>
-          <p:cNvPr id="91" name="Text 89"/>
-          <p:cNvSpPr/>
-          <p:nvPr/>
-        </p:nvSpPr>
-        <p:spPr>
-          <a:xfrm>
-            <a:off x="1143000" y="5815584"/>
-            <a:ext cx="594360" cy="333756"/>
-          </a:xfrm>
-          <a:prstGeom prst="rect">
-            <a:avLst/>
-          </a:prstGeom>
-          <a:noFill/>
-          <a:ln/>
-        </p:spPr>
-        <p:txBody>
-          <a:bodyPr wrap="square" rtlCol="0" anchor="ctr"/>
-          <a:lstStyle/>
-          <a:p>
-            <a:pPr algn="ctr" indent="0" marL="0">
-              <a:buNone/>
-            </a:pPr>
-            <a:r>
-              <a:rPr lang="en-US" sz="1100" dirty="0">
-                <a:solidFill>
-                  <a:srgbClr val="6B7280"/>
-                </a:solidFill>
-                <a:latin typeface="游ゴシック" pitchFamily="34" charset="0"/>
-                <a:ea typeface="游ゴシック" pitchFamily="34" charset="-122"/>
-                <a:cs typeface="游ゴシック" pitchFamily="34" charset="-120"/>
-              </a:rPr>
-              <a:t>78</a:t>
-            </a:r>
-            <a:endParaRPr lang="en-US" sz="1100" dirty="0"/>
-          </a:p>
-        </p:txBody>
-      </p:sp>
-      <p:sp>
-        <p:nvSpPr>
-          <p:cNvPr id="92" name="Text 90"/>
-          <p:cNvSpPr/>
-          <p:nvPr/>
-        </p:nvSpPr>
-        <p:spPr>
-          <a:xfrm>
-            <a:off x="1828800" y="5815584"/>
-            <a:ext cx="7040880" cy="333756"/>
-          </a:xfrm>
-          <a:prstGeom prst="rect">
-            <a:avLst/>
-          </a:prstGeom>
-          <a:noFill/>
-          <a:ln/>
-        </p:spPr>
-        <p:txBody>
-          <a:bodyPr wrap="square" rtlCol="0" anchor="ctr"/>
-          <a:lstStyle/>
-          <a:p>
-            <a:pPr algn="l" indent="0" marL="0">
-              <a:buNone/>
-            </a:pPr>
-            <a:r>
-              <a:rPr lang="en-US" sz="1300" dirty="0">
-                <a:solidFill>
-                  <a:srgbClr val="1A1A2E"/>
-                </a:solidFill>
-                <a:latin typeface="游ゴシック" pitchFamily="34" charset="0"/>
-                <a:ea typeface="游ゴシック" pitchFamily="34" charset="-122"/>
-                <a:cs typeface="游ゴシック" pitchFamily="34" charset="-120"/>
-              </a:rPr>
-              <a:t>所沢イベントセンター</a:t>
-            </a:r>
-            <a:endParaRPr lang="en-US" sz="1300" dirty="0"/>
-          </a:p>
-        </p:txBody>
-      </p:sp>
-      <p:sp>
-        <p:nvSpPr>
-          <p:cNvPr id="93" name="Text 91"/>
-          <p:cNvSpPr/>
-          <p:nvPr/>
-        </p:nvSpPr>
-        <p:spPr>
-          <a:xfrm>
-            <a:off x="8778240" y="5815584"/>
-            <a:ext cx="1920240" cy="333756"/>
-          </a:xfrm>
-          <a:prstGeom prst="rect">
-            <a:avLst/>
-          </a:prstGeom>
-          <a:noFill/>
-          <a:ln/>
-        </p:spPr>
-        <p:txBody>
-          <a:bodyPr wrap="square" rtlCol="0" anchor="ctr"/>
-          <a:lstStyle/>
-          <a:p>
-            <a:pPr algn="r" indent="0" marL="0">
-              <a:buNone/>
-            </a:pPr>
-            <a:r>
-              <a:rPr lang="en-US" sz="1300" b="1" dirty="0">
-                <a:solidFill>
-                  <a:srgbClr val="1A1A2E"/>
-                </a:solidFill>
-                <a:latin typeface="游ゴシック" pitchFamily="34" charset="0"/>
-                <a:ea typeface="游ゴシック" pitchFamily="34" charset="-122"/>
-                <a:cs typeface="游ゴシック" pitchFamily="34" charset="-120"/>
-              </a:rPr>
-              <a:t>24,939,640</a:t>
-            </a:r>
-            <a:endParaRPr lang="en-US" sz="1300" dirty="0"/>
-          </a:p>
-        </p:txBody>
-      </p:sp>
-      <p:sp>
-        <p:nvSpPr>
-          <p:cNvPr id="94" name="Text 92"/>
-          <p:cNvSpPr/>
-          <p:nvPr/>
-        </p:nvSpPr>
-        <p:spPr>
-          <a:xfrm>
-            <a:off x="10698480" y="5815584"/>
-            <a:ext cx="941832" cy="333756"/>
-          </a:xfrm>
-          <a:prstGeom prst="rect">
-            <a:avLst/>
-          </a:prstGeom>
-          <a:noFill/>
-          <a:ln/>
-        </p:spPr>
-        <p:txBody>
-          <a:bodyPr wrap="square" rtlCol="0" anchor="ctr"/>
-          <a:lstStyle/>
-          <a:p>
-            <a:pPr algn="r" indent="0" marL="0">
-              <a:buNone/>
-            </a:pPr>
-            <a:r>
-              <a:rPr lang="en-US" sz="1300" b="1" dirty="0">
-                <a:solidFill>
-                  <a:srgbClr val="DC2626"/>
-                </a:solidFill>
-                <a:latin typeface="游ゴシック" pitchFamily="34" charset="0"/>
-                <a:ea typeface="游ゴシック" pitchFamily="34" charset="-122"/>
-                <a:cs typeface="游ゴシック" pitchFamily="34" charset="-120"/>
-              </a:rPr>
-              <a:t>▲9.2%</a:t>
-            </a:r>
-            <a:endParaRPr lang="en-US" sz="1300" dirty="0"/>
-          </a:p>
-        </p:txBody>
-      </p:sp>
-      <p:sp>
-        <p:nvSpPr>
-          <p:cNvPr id="95" name="Shape 93"/>
-          <p:cNvSpPr/>
-          <p:nvPr/>
-        </p:nvSpPr>
-        <p:spPr>
-          <a:xfrm>
-            <a:off x="548640" y="6149340"/>
-            <a:ext cx="11091672" cy="333756"/>
-          </a:xfrm>
-          <a:prstGeom prst="rect">
-            <a:avLst/>
-          </a:prstGeom>
-          <a:solidFill>
-            <a:srgbClr val="FFFFFF"/>
-          </a:solidFill>
-          <a:ln/>
-        </p:spPr>
-      </p:sp>
-      <p:sp>
-        <p:nvSpPr>
           <p:cNvPr id="96" name="Text 94"/>
           <p:cNvSpPr/>
           <p:nvPr/>
@@ -8574,7 +8574,7 @@
                 <a:ea typeface="游ゴシック" pitchFamily="34" charset="-122"/>
                 <a:cs typeface="游ゴシック" pitchFamily="34" charset="-120"/>
               </a:rPr>
-              <a:t>179</a:t>
+              <a:t>380</a:t>
             </a:r>
             <a:endParaRPr lang="en-US" sz="1100" dirty="0"/>
           </a:p>
@@ -8613,7 +8613,7 @@
                 <a:ea typeface="游ゴシック" pitchFamily="34" charset="-122"/>
                 <a:cs typeface="游ゴシック" pitchFamily="34" charset="-120"/>
               </a:rPr>
-              <a:t>東京足立イベントセンター</a:t>
+              <a:t>南風原ステーション</a:t>
             </a:r>
             <a:endParaRPr lang="en-US" sz="1300" dirty="0"/>
           </a:p>
@@ -8652,7 +8652,7 @@
                 <a:ea typeface="游ゴシック" pitchFamily="34" charset="-122"/>
                 <a:cs typeface="游ゴシック" pitchFamily="34" charset="-120"/>
               </a:rPr>
-              <a:t>24,777,113</a:t>
+              <a:t>16,019,460</a:t>
             </a:r>
             <a:endParaRPr lang="en-US" sz="1300" dirty="0"/>
           </a:p>
@@ -8691,7 +8691,7 @@
                 <a:ea typeface="游ゴシック" pitchFamily="34" charset="-122"/>
                 <a:cs typeface="游ゴシック" pitchFamily="34" charset="-120"/>
               </a:rPr>
-              <a:t>8.4%</a:t>
+              <a:t>370.0%</a:t>
             </a:r>
             <a:endParaRPr lang="en-US" sz="1300" dirty="0"/>
           </a:p>

</xml_diff>

<commit_message>
refactor: slim down to title + ranking only (May edition)
- Remove slides 2-5 (placeholder data)
- Update to 5月度, date 2026.05.27

https://claude.ai/code/session_013LUtg8kZ6SCk9upzYYqLj7
</commit_message>
<xml_diff>
--- a/slides/exports/sales-meeting.pptx
+++ b/slides/exports/sales-meeting.pptx
@@ -7,13 +7,9 @@
   <p:sldIdLst>
     <p:sldId id="256" r:id="rId2"/>
     <p:sldId id="257" r:id="rId3"/>
-    <p:sldId id="258" r:id="rId4"/>
-    <p:sldId id="259" r:id="rId5"/>
-    <p:sldId id="260" r:id="rId6"/>
-    <p:sldId id="261" r:id="rId7"/>
   </p:sldIdLst>
   <p:notesMasterIdLst>
-    <p:notesMasterId r:id="rId8"/>
+    <p:notesMasterId r:id="rId4"/>
   </p:notesMasterIdLst>
   <p:sldSz cx="12192000" cy="6858000"/>
   <p:notesSz cx="6858000" cy="12192000"/>
@@ -619,358 +615,6 @@
             <a:fld id="{F7021451-1387-4CA6-816F-3879F97B5CBC}" type="slidenum">
               <a:rPr lang="en-US"/>
               <a:t>2</a:t>
-            </a:fld>
-            <a:endParaRPr lang="en-US"/>
-          </a:p>
-        </p:txBody>
-      </p:sp>
-    </p:spTree>
-    <p:extLst>
-      <p:ext uri="{BB962C8B-B14F-4D97-AF65-F5344CB8AC3E}">
-        <p14:creationId xmlns:p14="http://schemas.microsoft.com/office/powerpoint/2010/main" val="1024086991"/>
-      </p:ext>
-    </p:extLst>
-  </p:cSld>
-  <p:clrMapOvr>
-    <a:masterClrMapping/>
-  </p:clrMapOvr>
-</p:notes>
-</file>
-
-<file path=ppt/notesSlides/notesSlide3.xml><?xml version="1.0" encoding="utf-8"?>
-<p:notes xmlns:a="http://schemas.openxmlformats.org/drawingml/2006/main" xmlns:r="http://schemas.openxmlformats.org/officeDocument/2006/relationships" xmlns:p="http://schemas.openxmlformats.org/presentationml/2006/main">
-  <p:cSld>
-    <p:spTree>
-      <p:nvGrpSpPr>
-        <p:cNvPr id="1" name=""/>
-        <p:cNvGrpSpPr/>
-        <p:nvPr/>
-      </p:nvGrpSpPr>
-      <p:grpSpPr>
-        <a:xfrm>
-          <a:off x="0" y="0"/>
-          <a:ext cx="0" cy="0"/>
-          <a:chOff x="0" y="0"/>
-          <a:chExt cx="0" cy="0"/>
-        </a:xfrm>
-      </p:grpSpPr>
-      <p:sp>
-        <p:nvSpPr>
-          <p:cNvPr id="2" name="Slide Image Placeholder 1"/>
-          <p:cNvSpPr>
-            <a:spLocks noGrp="1" noRot="1" noChangeAspect="1"/>
-          </p:cNvSpPr>
-          <p:nvPr>
-            <p:ph type="sldImg"/>
-          </p:nvPr>
-        </p:nvSpPr>
-        <p:spPr/>
-      </p:sp>
-      <p:sp>
-        <p:nvSpPr>
-          <p:cNvPr id="3" name="Notes Placeholder 2"/>
-          <p:cNvSpPr>
-            <a:spLocks noGrp="1"/>
-          </p:cNvSpPr>
-          <p:nvPr>
-            <p:ph type="body" idx="1"/>
-          </p:nvPr>
-        </p:nvSpPr>
-        <p:spPr/>
-        <p:txBody>
-          <a:bodyPr/>
-          <a:lstStyle/>
-          <a:p>
-            <a:r>
-              <a:rPr lang="en-US" dirty="0"/>
-              <a:t/>
-            </a:r>
-            <a:endParaRPr lang="en-US" dirty="0"/>
-          </a:p>
-        </p:txBody>
-      </p:sp>
-      <p:sp>
-        <p:nvSpPr>
-          <p:cNvPr id="4" name="Slide Number Placeholder 3"/>
-          <p:cNvSpPr>
-            <a:spLocks noGrp="1"/>
-          </p:cNvSpPr>
-          <p:nvPr>
-            <p:ph type="sldNum" sz="quarter" idx="10"/>
-          </p:nvPr>
-        </p:nvSpPr>
-        <p:spPr/>
-        <p:txBody>
-          <a:bodyPr/>
-          <a:lstStyle/>
-          <a:p>
-            <a:fld id="{F7021451-1387-4CA6-816F-3879F97B5CBC}" type="slidenum">
-              <a:rPr lang="en-US"/>
-              <a:t>3</a:t>
-            </a:fld>
-            <a:endParaRPr lang="en-US"/>
-          </a:p>
-        </p:txBody>
-      </p:sp>
-    </p:spTree>
-    <p:extLst>
-      <p:ext uri="{BB962C8B-B14F-4D97-AF65-F5344CB8AC3E}">
-        <p14:creationId xmlns:p14="http://schemas.microsoft.com/office/powerpoint/2010/main" val="1024086991"/>
-      </p:ext>
-    </p:extLst>
-  </p:cSld>
-  <p:clrMapOvr>
-    <a:masterClrMapping/>
-  </p:clrMapOvr>
-</p:notes>
-</file>
-
-<file path=ppt/notesSlides/notesSlide4.xml><?xml version="1.0" encoding="utf-8"?>
-<p:notes xmlns:a="http://schemas.openxmlformats.org/drawingml/2006/main" xmlns:r="http://schemas.openxmlformats.org/officeDocument/2006/relationships" xmlns:p="http://schemas.openxmlformats.org/presentationml/2006/main">
-  <p:cSld>
-    <p:spTree>
-      <p:nvGrpSpPr>
-        <p:cNvPr id="1" name=""/>
-        <p:cNvGrpSpPr/>
-        <p:nvPr/>
-      </p:nvGrpSpPr>
-      <p:grpSpPr>
-        <a:xfrm>
-          <a:off x="0" y="0"/>
-          <a:ext cx="0" cy="0"/>
-          <a:chOff x="0" y="0"/>
-          <a:chExt cx="0" cy="0"/>
-        </a:xfrm>
-      </p:grpSpPr>
-      <p:sp>
-        <p:nvSpPr>
-          <p:cNvPr id="2" name="Slide Image Placeholder 1"/>
-          <p:cNvSpPr>
-            <a:spLocks noGrp="1" noRot="1" noChangeAspect="1"/>
-          </p:cNvSpPr>
-          <p:nvPr>
-            <p:ph type="sldImg"/>
-          </p:nvPr>
-        </p:nvSpPr>
-        <p:spPr/>
-      </p:sp>
-      <p:sp>
-        <p:nvSpPr>
-          <p:cNvPr id="3" name="Notes Placeholder 2"/>
-          <p:cNvSpPr>
-            <a:spLocks noGrp="1"/>
-          </p:cNvSpPr>
-          <p:nvPr>
-            <p:ph type="body" idx="1"/>
-          </p:nvPr>
-        </p:nvSpPr>
-        <p:spPr/>
-        <p:txBody>
-          <a:bodyPr/>
-          <a:lstStyle/>
-          <a:p>
-            <a:r>
-              <a:rPr lang="en-US" dirty="0"/>
-              <a:t/>
-            </a:r>
-            <a:endParaRPr lang="en-US" dirty="0"/>
-          </a:p>
-        </p:txBody>
-      </p:sp>
-      <p:sp>
-        <p:nvSpPr>
-          <p:cNvPr id="4" name="Slide Number Placeholder 3"/>
-          <p:cNvSpPr>
-            <a:spLocks noGrp="1"/>
-          </p:cNvSpPr>
-          <p:nvPr>
-            <p:ph type="sldNum" sz="quarter" idx="10"/>
-          </p:nvPr>
-        </p:nvSpPr>
-        <p:spPr/>
-        <p:txBody>
-          <a:bodyPr/>
-          <a:lstStyle/>
-          <a:p>
-            <a:fld id="{F7021451-1387-4CA6-816F-3879F97B5CBC}" type="slidenum">
-              <a:rPr lang="en-US"/>
-              <a:t>4</a:t>
-            </a:fld>
-            <a:endParaRPr lang="en-US"/>
-          </a:p>
-        </p:txBody>
-      </p:sp>
-    </p:spTree>
-    <p:extLst>
-      <p:ext uri="{BB962C8B-B14F-4D97-AF65-F5344CB8AC3E}">
-        <p14:creationId xmlns:p14="http://schemas.microsoft.com/office/powerpoint/2010/main" val="1024086991"/>
-      </p:ext>
-    </p:extLst>
-  </p:cSld>
-  <p:clrMapOvr>
-    <a:masterClrMapping/>
-  </p:clrMapOvr>
-</p:notes>
-</file>
-
-<file path=ppt/notesSlides/notesSlide5.xml><?xml version="1.0" encoding="utf-8"?>
-<p:notes xmlns:a="http://schemas.openxmlformats.org/drawingml/2006/main" xmlns:r="http://schemas.openxmlformats.org/officeDocument/2006/relationships" xmlns:p="http://schemas.openxmlformats.org/presentationml/2006/main">
-  <p:cSld>
-    <p:spTree>
-      <p:nvGrpSpPr>
-        <p:cNvPr id="1" name=""/>
-        <p:cNvGrpSpPr/>
-        <p:nvPr/>
-      </p:nvGrpSpPr>
-      <p:grpSpPr>
-        <a:xfrm>
-          <a:off x="0" y="0"/>
-          <a:ext cx="0" cy="0"/>
-          <a:chOff x="0" y="0"/>
-          <a:chExt cx="0" cy="0"/>
-        </a:xfrm>
-      </p:grpSpPr>
-      <p:sp>
-        <p:nvSpPr>
-          <p:cNvPr id="2" name="Slide Image Placeholder 1"/>
-          <p:cNvSpPr>
-            <a:spLocks noGrp="1" noRot="1" noChangeAspect="1"/>
-          </p:cNvSpPr>
-          <p:nvPr>
-            <p:ph type="sldImg"/>
-          </p:nvPr>
-        </p:nvSpPr>
-        <p:spPr/>
-      </p:sp>
-      <p:sp>
-        <p:nvSpPr>
-          <p:cNvPr id="3" name="Notes Placeholder 2"/>
-          <p:cNvSpPr>
-            <a:spLocks noGrp="1"/>
-          </p:cNvSpPr>
-          <p:nvPr>
-            <p:ph type="body" idx="1"/>
-          </p:nvPr>
-        </p:nvSpPr>
-        <p:spPr/>
-        <p:txBody>
-          <a:bodyPr/>
-          <a:lstStyle/>
-          <a:p>
-            <a:r>
-              <a:rPr lang="en-US" dirty="0"/>
-              <a:t/>
-            </a:r>
-            <a:endParaRPr lang="en-US" dirty="0"/>
-          </a:p>
-        </p:txBody>
-      </p:sp>
-      <p:sp>
-        <p:nvSpPr>
-          <p:cNvPr id="4" name="Slide Number Placeholder 3"/>
-          <p:cNvSpPr>
-            <a:spLocks noGrp="1"/>
-          </p:cNvSpPr>
-          <p:nvPr>
-            <p:ph type="sldNum" sz="quarter" idx="10"/>
-          </p:nvPr>
-        </p:nvSpPr>
-        <p:spPr/>
-        <p:txBody>
-          <a:bodyPr/>
-          <a:lstStyle/>
-          <a:p>
-            <a:fld id="{F7021451-1387-4CA6-816F-3879F97B5CBC}" type="slidenum">
-              <a:rPr lang="en-US"/>
-              <a:t>5</a:t>
-            </a:fld>
-            <a:endParaRPr lang="en-US"/>
-          </a:p>
-        </p:txBody>
-      </p:sp>
-    </p:spTree>
-    <p:extLst>
-      <p:ext uri="{BB962C8B-B14F-4D97-AF65-F5344CB8AC3E}">
-        <p14:creationId xmlns:p14="http://schemas.microsoft.com/office/powerpoint/2010/main" val="1024086991"/>
-      </p:ext>
-    </p:extLst>
-  </p:cSld>
-  <p:clrMapOvr>
-    <a:masterClrMapping/>
-  </p:clrMapOvr>
-</p:notes>
-</file>
-
-<file path=ppt/notesSlides/notesSlide6.xml><?xml version="1.0" encoding="utf-8"?>
-<p:notes xmlns:a="http://schemas.openxmlformats.org/drawingml/2006/main" xmlns:r="http://schemas.openxmlformats.org/officeDocument/2006/relationships" xmlns:p="http://schemas.openxmlformats.org/presentationml/2006/main">
-  <p:cSld>
-    <p:spTree>
-      <p:nvGrpSpPr>
-        <p:cNvPr id="1" name=""/>
-        <p:cNvGrpSpPr/>
-        <p:nvPr/>
-      </p:nvGrpSpPr>
-      <p:grpSpPr>
-        <a:xfrm>
-          <a:off x="0" y="0"/>
-          <a:ext cx="0" cy="0"/>
-          <a:chOff x="0" y="0"/>
-          <a:chExt cx="0" cy="0"/>
-        </a:xfrm>
-      </p:grpSpPr>
-      <p:sp>
-        <p:nvSpPr>
-          <p:cNvPr id="2" name="Slide Image Placeholder 1"/>
-          <p:cNvSpPr>
-            <a:spLocks noGrp="1" noRot="1" noChangeAspect="1"/>
-          </p:cNvSpPr>
-          <p:nvPr>
-            <p:ph type="sldImg"/>
-          </p:nvPr>
-        </p:nvSpPr>
-        <p:spPr/>
-      </p:sp>
-      <p:sp>
-        <p:nvSpPr>
-          <p:cNvPr id="3" name="Notes Placeholder 2"/>
-          <p:cNvSpPr>
-            <a:spLocks noGrp="1"/>
-          </p:cNvSpPr>
-          <p:nvPr>
-            <p:ph type="body" idx="1"/>
-          </p:nvPr>
-        </p:nvSpPr>
-        <p:spPr/>
-        <p:txBody>
-          <a:bodyPr/>
-          <a:lstStyle/>
-          <a:p>
-            <a:r>
-              <a:rPr lang="en-US" dirty="0"/>
-              <a:t/>
-            </a:r>
-            <a:endParaRPr lang="en-US" dirty="0"/>
-          </a:p>
-        </p:txBody>
-      </p:sp>
-      <p:sp>
-        <p:nvSpPr>
-          <p:cNvPr id="4" name="Slide Number Placeholder 3"/>
-          <p:cNvSpPr>
-            <a:spLocks noGrp="1"/>
-          </p:cNvSpPr>
-          <p:nvPr>
-            <p:ph type="sldNum" sz="quarter" idx="10"/>
-          </p:nvPr>
-        </p:nvSpPr>
-        <p:spPr/>
-        <p:txBody>
-          <a:bodyPr/>
-          <a:lstStyle/>
-          <a:p>
-            <a:fld id="{F7021451-1387-4CA6-816F-3879F97B5CBC}" type="slidenum">
-              <a:rPr lang="en-US"/>
-              <a:t>6</a:t>
             </a:fld>
             <a:endParaRPr lang="en-US"/>
           </a:p>
@@ -1491,7 +1135,7 @@
                 <a:ea typeface="游ゴシック" pitchFamily="34" charset="-122"/>
                 <a:cs typeface="游ゴシック" pitchFamily="34" charset="-120"/>
               </a:rPr>
-              <a:t>2026年3月度　実績報告・進捗確認</a:t>
+              <a:t>2026年5月度　月度売上ランキング</a:t>
             </a:r>
             <a:endParaRPr lang="en-US" sz="2000" dirty="0"/>
           </a:p>
@@ -1530,7 +1174,7 @@
                 <a:ea typeface="游ゴシック" pitchFamily="34" charset="-122"/>
                 <a:cs typeface="游ゴシック" pitchFamily="34" charset="-120"/>
               </a:rPr>
-              <a:t>2026.04.24</a:t>
+              <a:t>2026.05.27</a:t>
             </a:r>
             <a:endParaRPr lang="en-US" sz="1400" dirty="0"/>
           </a:p>
@@ -1547,3616 +1191,6 @@
 <file path=ppt/slides/slide2.xml><?xml version="1.0" encoding="utf-8"?>
 <p:sld xmlns:a="http://schemas.openxmlformats.org/drawingml/2006/main" xmlns:r="http://schemas.openxmlformats.org/officeDocument/2006/relationships" xmlns:p="http://schemas.openxmlformats.org/presentationml/2006/main">
   <p:cSld name="Slide 2">
-    <p:bg>
-      <p:bgPr>
-        <a:solidFill>
-          <a:srgbClr val="FFFFFF"/>
-        </a:solidFill>
-      </p:bgPr>
-    </p:bg>
-    <p:spTree>
-      <p:nvGrpSpPr>
-        <p:cNvPr id="1" name=""/>
-        <p:cNvGrpSpPr/>
-        <p:nvPr/>
-      </p:nvGrpSpPr>
-      <p:grpSpPr>
-        <a:xfrm>
-          <a:off x="0" y="0"/>
-          <a:ext cx="0" cy="0"/>
-          <a:chOff x="0" y="0"/>
-          <a:chExt cx="0" cy="0"/>
-        </a:xfrm>
-      </p:grpSpPr>
-      <p:sp>
-        <p:nvSpPr>
-          <p:cNvPr id="2" name="Text 0"/>
-          <p:cNvSpPr/>
-          <p:nvPr/>
-        </p:nvSpPr>
-        <p:spPr>
-          <a:xfrm>
-            <a:off x="548640" y="274320"/>
-            <a:ext cx="11091672" cy="594360"/>
-          </a:xfrm>
-          <a:prstGeom prst="rect">
-            <a:avLst/>
-          </a:prstGeom>
-          <a:noFill/>
-          <a:ln/>
-        </p:spPr>
-        <p:txBody>
-          <a:bodyPr wrap="square" rtlCol="0" anchor="t"/>
-          <a:lstStyle/>
-          <a:p>
-            <a:pPr algn="l" indent="0" marL="0">
-              <a:buNone/>
-            </a:pPr>
-            <a:r>
-              <a:rPr lang="en-US" sz="2600" b="1" dirty="0">
-                <a:solidFill>
-                  <a:srgbClr val="1A1A2E"/>
-                </a:solidFill>
-                <a:latin typeface="游ゴシック" pitchFamily="34" charset="0"/>
-                <a:ea typeface="游ゴシック" pitchFamily="34" charset="-122"/>
-                <a:cs typeface="游ゴシック" pitchFamily="34" charset="-120"/>
-              </a:rPr>
-              <a:t>3月度 売上サマリー</a:t>
-            </a:r>
-            <a:endParaRPr lang="en-US" sz="2600" dirty="0"/>
-          </a:p>
-        </p:txBody>
-      </p:sp>
-      <p:sp>
-        <p:nvSpPr>
-          <p:cNvPr id="3" name="Shape 1"/>
-          <p:cNvSpPr/>
-          <p:nvPr/>
-        </p:nvSpPr>
-        <p:spPr>
-          <a:xfrm>
-            <a:off x="548640" y="960120"/>
-            <a:ext cx="11091672" cy="36576"/>
-          </a:xfrm>
-          <a:prstGeom prst="rect">
-            <a:avLst/>
-          </a:prstGeom>
-          <a:solidFill>
-            <a:srgbClr val="2563EB"/>
-          </a:solidFill>
-          <a:ln/>
-        </p:spPr>
-      </p:sp>
-      <p:sp>
-        <p:nvSpPr>
-          <p:cNvPr id="4" name="Shape 2"/>
-          <p:cNvSpPr/>
-          <p:nvPr/>
-        </p:nvSpPr>
-        <p:spPr>
-          <a:xfrm>
-            <a:off x="548640" y="1143000"/>
-            <a:ext cx="3544824" cy="3840480"/>
-          </a:xfrm>
-          <a:prstGeom prst="rect">
-            <a:avLst/>
-          </a:prstGeom>
-          <a:solidFill>
-            <a:srgbClr val="F5F7FA"/>
-          </a:solidFill>
-          <a:ln/>
-        </p:spPr>
-      </p:sp>
-      <p:sp>
-        <p:nvSpPr>
-          <p:cNvPr id="5" name="Text 3"/>
-          <p:cNvSpPr/>
-          <p:nvPr/>
-        </p:nvSpPr>
-        <p:spPr>
-          <a:xfrm>
-            <a:off x="731520" y="1737360"/>
-            <a:ext cx="3179064" cy="365760"/>
-          </a:xfrm>
-          <a:prstGeom prst="rect">
-            <a:avLst/>
-          </a:prstGeom>
-          <a:noFill/>
-          <a:ln/>
-        </p:spPr>
-        <p:txBody>
-          <a:bodyPr wrap="square" rtlCol="0" anchor="ctr"/>
-          <a:lstStyle/>
-          <a:p>
-            <a:pPr algn="ctr" indent="0" marL="0">
-              <a:buNone/>
-            </a:pPr>
-            <a:r>
-              <a:rPr lang="en-US" sz="1300" dirty="0">
-                <a:solidFill>
-                  <a:srgbClr val="6B7280"/>
-                </a:solidFill>
-                <a:latin typeface="游ゴシック" pitchFamily="34" charset="0"/>
-                <a:ea typeface="游ゴシック" pitchFamily="34" charset="-122"/>
-                <a:cs typeface="游ゴシック" pitchFamily="34" charset="-120"/>
-              </a:rPr>
-              <a:t>売上高</a:t>
-            </a:r>
-            <a:endParaRPr lang="en-US" sz="1300" dirty="0"/>
-          </a:p>
-        </p:txBody>
-      </p:sp>
-      <p:sp>
-        <p:nvSpPr>
-          <p:cNvPr id="6" name="Text 4"/>
-          <p:cNvSpPr/>
-          <p:nvPr/>
-        </p:nvSpPr>
-        <p:spPr>
-          <a:xfrm>
-            <a:off x="731520" y="2331720"/>
-            <a:ext cx="3179064" cy="914400"/>
-          </a:xfrm>
-          <a:prstGeom prst="rect">
-            <a:avLst/>
-          </a:prstGeom>
-          <a:noFill/>
-          <a:ln/>
-        </p:spPr>
-        <p:txBody>
-          <a:bodyPr wrap="square" rtlCol="0" anchor="ctr"/>
-          <a:lstStyle/>
-          <a:p>
-            <a:pPr algn="ctr" indent="0" marL="0">
-              <a:buNone/>
-            </a:pPr>
-            <a:r>
-              <a:rPr lang="en-US" sz="4000" b="1" dirty="0">
-                <a:solidFill>
-                  <a:srgbClr val="2563EB"/>
-                </a:solidFill>
-                <a:latin typeface="游ゴシック" pitchFamily="34" charset="0"/>
-                <a:ea typeface="游ゴシック" pitchFamily="34" charset="-122"/>
-                <a:cs typeface="游ゴシック" pitchFamily="34" charset="-120"/>
-              </a:rPr>
-              <a:t>¥48.5M</a:t>
-            </a:r>
-            <a:endParaRPr lang="en-US" sz="4000" dirty="0"/>
-          </a:p>
-        </p:txBody>
-      </p:sp>
-      <p:sp>
-        <p:nvSpPr>
-          <p:cNvPr id="7" name="Text 5"/>
-          <p:cNvSpPr/>
-          <p:nvPr/>
-        </p:nvSpPr>
-        <p:spPr>
-          <a:xfrm>
-            <a:off x="731520" y="3429000"/>
-            <a:ext cx="3179064" cy="365760"/>
-          </a:xfrm>
-          <a:prstGeom prst="rect">
-            <a:avLst/>
-          </a:prstGeom>
-          <a:noFill/>
-          <a:ln/>
-        </p:spPr>
-        <p:txBody>
-          <a:bodyPr wrap="square" rtlCol="0" anchor="ctr"/>
-          <a:lstStyle/>
-          <a:p>
-            <a:pPr algn="ctr" indent="0" marL="0">
-              <a:buNone/>
-            </a:pPr>
-            <a:r>
-              <a:rPr lang="en-US" sz="1400" b="1" dirty="0">
-                <a:solidFill>
-                  <a:srgbClr val="16A34A"/>
-                </a:solidFill>
-                <a:latin typeface="游ゴシック" pitchFamily="34" charset="0"/>
-                <a:ea typeface="游ゴシック" pitchFamily="34" charset="-122"/>
-                <a:cs typeface="游ゴシック" pitchFamily="34" charset="-120"/>
-              </a:rPr>
-              <a:t>▲ 12.3% 前月比</a:t>
-            </a:r>
-            <a:endParaRPr lang="en-US" sz="1400" dirty="0"/>
-          </a:p>
-        </p:txBody>
-      </p:sp>
-      <p:sp>
-        <p:nvSpPr>
-          <p:cNvPr id="8" name="Text 6"/>
-          <p:cNvSpPr/>
-          <p:nvPr/>
-        </p:nvSpPr>
-        <p:spPr>
-          <a:xfrm>
-            <a:off x="731520" y="3931920"/>
-            <a:ext cx="3179064" cy="457200"/>
-          </a:xfrm>
-          <a:prstGeom prst="rect">
-            <a:avLst/>
-          </a:prstGeom>
-          <a:noFill/>
-          <a:ln/>
-        </p:spPr>
-        <p:txBody>
-          <a:bodyPr wrap="square" rtlCol="0" anchor="t"/>
-          <a:lstStyle/>
-          <a:p>
-            <a:pPr algn="ctr" indent="0" marL="0">
-              <a:buNone/>
-            </a:pPr>
-            <a:r>
-              <a:rPr lang="en-US" sz="1100" dirty="0">
-                <a:solidFill>
-                  <a:srgbClr val="6B7280"/>
-                </a:solidFill>
-                <a:latin typeface="游ゴシック" pitchFamily="34" charset="0"/>
-                <a:ea typeface="游ゴシック" pitchFamily="34" charset="-122"/>
-                <a:cs typeface="游ゴシック" pitchFamily="34" charset="-120"/>
-              </a:rPr>
-              <a:t>目標 ¥45M（達成率 107.8%）</a:t>
-            </a:r>
-            <a:endParaRPr lang="en-US" sz="1100" dirty="0"/>
-          </a:p>
-        </p:txBody>
-      </p:sp>
-      <p:sp>
-        <p:nvSpPr>
-          <p:cNvPr id="9" name="Shape 7"/>
-          <p:cNvSpPr/>
-          <p:nvPr/>
-        </p:nvSpPr>
-        <p:spPr>
-          <a:xfrm>
-            <a:off x="4322064" y="1143000"/>
-            <a:ext cx="3544824" cy="3840480"/>
-          </a:xfrm>
-          <a:prstGeom prst="rect">
-            <a:avLst/>
-          </a:prstGeom>
-          <a:solidFill>
-            <a:srgbClr val="F5F7FA"/>
-          </a:solidFill>
-          <a:ln/>
-        </p:spPr>
-      </p:sp>
-      <p:sp>
-        <p:nvSpPr>
-          <p:cNvPr id="10" name="Text 8"/>
-          <p:cNvSpPr/>
-          <p:nvPr/>
-        </p:nvSpPr>
-        <p:spPr>
-          <a:xfrm>
-            <a:off x="4504944" y="1737360"/>
-            <a:ext cx="3179064" cy="365760"/>
-          </a:xfrm>
-          <a:prstGeom prst="rect">
-            <a:avLst/>
-          </a:prstGeom>
-          <a:noFill/>
-          <a:ln/>
-        </p:spPr>
-        <p:txBody>
-          <a:bodyPr wrap="square" rtlCol="0" anchor="ctr"/>
-          <a:lstStyle/>
-          <a:p>
-            <a:pPr algn="ctr" indent="0" marL="0">
-              <a:buNone/>
-            </a:pPr>
-            <a:r>
-              <a:rPr lang="en-US" sz="1300" dirty="0">
-                <a:solidFill>
-                  <a:srgbClr val="6B7280"/>
-                </a:solidFill>
-                <a:latin typeface="游ゴシック" pitchFamily="34" charset="0"/>
-                <a:ea typeface="游ゴシック" pitchFamily="34" charset="-122"/>
-                <a:cs typeface="游ゴシック" pitchFamily="34" charset="-120"/>
-              </a:rPr>
-              <a:t>新規受注件数</a:t>
-            </a:r>
-            <a:endParaRPr lang="en-US" sz="1300" dirty="0"/>
-          </a:p>
-        </p:txBody>
-      </p:sp>
-      <p:sp>
-        <p:nvSpPr>
-          <p:cNvPr id="11" name="Text 9"/>
-          <p:cNvSpPr/>
-          <p:nvPr/>
-        </p:nvSpPr>
-        <p:spPr>
-          <a:xfrm>
-            <a:off x="4504944" y="2331720"/>
-            <a:ext cx="3179064" cy="914400"/>
-          </a:xfrm>
-          <a:prstGeom prst="rect">
-            <a:avLst/>
-          </a:prstGeom>
-          <a:noFill/>
-          <a:ln/>
-        </p:spPr>
-        <p:txBody>
-          <a:bodyPr wrap="square" rtlCol="0" anchor="ctr"/>
-          <a:lstStyle/>
-          <a:p>
-            <a:pPr algn="ctr" indent="0" marL="0">
-              <a:buNone/>
-            </a:pPr>
-            <a:r>
-              <a:rPr lang="en-US" sz="4000" b="1" dirty="0">
-                <a:solidFill>
-                  <a:srgbClr val="2563EB"/>
-                </a:solidFill>
-                <a:latin typeface="游ゴシック" pitchFamily="34" charset="0"/>
-                <a:ea typeface="游ゴシック" pitchFamily="34" charset="-122"/>
-                <a:cs typeface="游ゴシック" pitchFamily="34" charset="-120"/>
-              </a:rPr>
-              <a:t>23件</a:t>
-            </a:r>
-            <a:endParaRPr lang="en-US" sz="4000" dirty="0"/>
-          </a:p>
-        </p:txBody>
-      </p:sp>
-      <p:sp>
-        <p:nvSpPr>
-          <p:cNvPr id="12" name="Text 10"/>
-          <p:cNvSpPr/>
-          <p:nvPr/>
-        </p:nvSpPr>
-        <p:spPr>
-          <a:xfrm>
-            <a:off x="4504944" y="3429000"/>
-            <a:ext cx="3179064" cy="365760"/>
-          </a:xfrm>
-          <a:prstGeom prst="rect">
-            <a:avLst/>
-          </a:prstGeom>
-          <a:noFill/>
-          <a:ln/>
-        </p:spPr>
-        <p:txBody>
-          <a:bodyPr wrap="square" rtlCol="0" anchor="ctr"/>
-          <a:lstStyle/>
-          <a:p>
-            <a:pPr algn="ctr" indent="0" marL="0">
-              <a:buNone/>
-            </a:pPr>
-            <a:r>
-              <a:rPr lang="en-US" sz="1400" b="1" dirty="0">
-                <a:solidFill>
-                  <a:srgbClr val="16A34A"/>
-                </a:solidFill>
-                <a:latin typeface="游ゴシック" pitchFamily="34" charset="0"/>
-                <a:ea typeface="游ゴシック" pitchFamily="34" charset="-122"/>
-                <a:cs typeface="游ゴシック" pitchFamily="34" charset="-120"/>
-              </a:rPr>
-              <a:t>▲ 5件 前月比</a:t>
-            </a:r>
-            <a:endParaRPr lang="en-US" sz="1400" dirty="0"/>
-          </a:p>
-        </p:txBody>
-      </p:sp>
-      <p:sp>
-        <p:nvSpPr>
-          <p:cNvPr id="13" name="Text 11"/>
-          <p:cNvSpPr/>
-          <p:nvPr/>
-        </p:nvSpPr>
-        <p:spPr>
-          <a:xfrm>
-            <a:off x="4504944" y="3931920"/>
-            <a:ext cx="3179064" cy="457200"/>
-          </a:xfrm>
-          <a:prstGeom prst="rect">
-            <a:avLst/>
-          </a:prstGeom>
-          <a:noFill/>
-          <a:ln/>
-        </p:spPr>
-        <p:txBody>
-          <a:bodyPr wrap="square" rtlCol="0" anchor="t"/>
-          <a:lstStyle/>
-          <a:p>
-            <a:pPr algn="ctr" indent="0" marL="0">
-              <a:buNone/>
-            </a:pPr>
-            <a:r>
-              <a:rPr lang="en-US" sz="1100" dirty="0">
-                <a:solidFill>
-                  <a:srgbClr val="6B7280"/>
-                </a:solidFill>
-                <a:latin typeface="游ゴシック" pitchFamily="34" charset="0"/>
-                <a:ea typeface="游ゴシック" pitchFamily="34" charset="-122"/>
-                <a:cs typeface="游ゴシック" pitchFamily="34" charset="-120"/>
-              </a:rPr>
-              <a:t>目標 20件（達成率 115%）</a:t>
-            </a:r>
-            <a:endParaRPr lang="en-US" sz="1100" dirty="0"/>
-          </a:p>
-        </p:txBody>
-      </p:sp>
-      <p:sp>
-        <p:nvSpPr>
-          <p:cNvPr id="14" name="Shape 12"/>
-          <p:cNvSpPr/>
-          <p:nvPr/>
-        </p:nvSpPr>
-        <p:spPr>
-          <a:xfrm>
-            <a:off x="8095488" y="1143000"/>
-            <a:ext cx="3544824" cy="3840480"/>
-          </a:xfrm>
-          <a:prstGeom prst="rect">
-            <a:avLst/>
-          </a:prstGeom>
-          <a:solidFill>
-            <a:srgbClr val="F5F7FA"/>
-          </a:solidFill>
-          <a:ln/>
-        </p:spPr>
-      </p:sp>
-      <p:sp>
-        <p:nvSpPr>
-          <p:cNvPr id="15" name="Text 13"/>
-          <p:cNvSpPr/>
-          <p:nvPr/>
-        </p:nvSpPr>
-        <p:spPr>
-          <a:xfrm>
-            <a:off x="8278368" y="1737360"/>
-            <a:ext cx="3179064" cy="365760"/>
-          </a:xfrm>
-          <a:prstGeom prst="rect">
-            <a:avLst/>
-          </a:prstGeom>
-          <a:noFill/>
-          <a:ln/>
-        </p:spPr>
-        <p:txBody>
-          <a:bodyPr wrap="square" rtlCol="0" anchor="ctr"/>
-          <a:lstStyle/>
-          <a:p>
-            <a:pPr algn="ctr" indent="0" marL="0">
-              <a:buNone/>
-            </a:pPr>
-            <a:r>
-              <a:rPr lang="en-US" sz="1300" dirty="0">
-                <a:solidFill>
-                  <a:srgbClr val="6B7280"/>
-                </a:solidFill>
-                <a:latin typeface="游ゴシック" pitchFamily="34" charset="0"/>
-                <a:ea typeface="游ゴシック" pitchFamily="34" charset="-122"/>
-                <a:cs typeface="游ゴシック" pitchFamily="34" charset="-120"/>
-              </a:rPr>
-              <a:t>受注単価（平均）</a:t>
-            </a:r>
-            <a:endParaRPr lang="en-US" sz="1300" dirty="0"/>
-          </a:p>
-        </p:txBody>
-      </p:sp>
-      <p:sp>
-        <p:nvSpPr>
-          <p:cNvPr id="16" name="Text 14"/>
-          <p:cNvSpPr/>
-          <p:nvPr/>
-        </p:nvSpPr>
-        <p:spPr>
-          <a:xfrm>
-            <a:off x="8278368" y="2331720"/>
-            <a:ext cx="3179064" cy="914400"/>
-          </a:xfrm>
-          <a:prstGeom prst="rect">
-            <a:avLst/>
-          </a:prstGeom>
-          <a:noFill/>
-          <a:ln/>
-        </p:spPr>
-        <p:txBody>
-          <a:bodyPr wrap="square" rtlCol="0" anchor="ctr"/>
-          <a:lstStyle/>
-          <a:p>
-            <a:pPr algn="ctr" indent="0" marL="0">
-              <a:buNone/>
-            </a:pPr>
-            <a:r>
-              <a:rPr lang="en-US" sz="4000" b="1" dirty="0">
-                <a:solidFill>
-                  <a:srgbClr val="2563EB"/>
-                </a:solidFill>
-                <a:latin typeface="游ゴシック" pitchFamily="34" charset="0"/>
-                <a:ea typeface="游ゴシック" pitchFamily="34" charset="-122"/>
-                <a:cs typeface="游ゴシック" pitchFamily="34" charset="-120"/>
-              </a:rPr>
-              <a:t>¥2.1M</a:t>
-            </a:r>
-            <a:endParaRPr lang="en-US" sz="4000" dirty="0"/>
-          </a:p>
-        </p:txBody>
-      </p:sp>
-      <p:sp>
-        <p:nvSpPr>
-          <p:cNvPr id="17" name="Text 15"/>
-          <p:cNvSpPr/>
-          <p:nvPr/>
-        </p:nvSpPr>
-        <p:spPr>
-          <a:xfrm>
-            <a:off x="8278368" y="3429000"/>
-            <a:ext cx="3179064" cy="365760"/>
-          </a:xfrm>
-          <a:prstGeom prst="rect">
-            <a:avLst/>
-          </a:prstGeom>
-          <a:noFill/>
-          <a:ln/>
-        </p:spPr>
-        <p:txBody>
-          <a:bodyPr wrap="square" rtlCol="0" anchor="ctr"/>
-          <a:lstStyle/>
-          <a:p>
-            <a:pPr algn="ctr" indent="0" marL="0">
-              <a:buNone/>
-            </a:pPr>
-            <a:r>
-              <a:rPr lang="en-US" sz="1400" b="1" dirty="0">
-                <a:solidFill>
-                  <a:srgbClr val="DC2626"/>
-                </a:solidFill>
-                <a:latin typeface="游ゴシック" pitchFamily="34" charset="0"/>
-                <a:ea typeface="游ゴシック" pitchFamily="34" charset="-122"/>
-                <a:cs typeface="游ゴシック" pitchFamily="34" charset="-120"/>
-              </a:rPr>
-              <a:t>▼ 3.2% 前月比</a:t>
-            </a:r>
-            <a:endParaRPr lang="en-US" sz="1400" dirty="0"/>
-          </a:p>
-        </p:txBody>
-      </p:sp>
-      <p:sp>
-        <p:nvSpPr>
-          <p:cNvPr id="18" name="Text 16"/>
-          <p:cNvSpPr/>
-          <p:nvPr/>
-        </p:nvSpPr>
-        <p:spPr>
-          <a:xfrm>
-            <a:off x="8278368" y="3931920"/>
-            <a:ext cx="3179064" cy="457200"/>
-          </a:xfrm>
-          <a:prstGeom prst="rect">
-            <a:avLst/>
-          </a:prstGeom>
-          <a:noFill/>
-          <a:ln/>
-        </p:spPr>
-        <p:txBody>
-          <a:bodyPr wrap="square" rtlCol="0" anchor="t"/>
-          <a:lstStyle/>
-          <a:p>
-            <a:pPr algn="ctr" indent="0" marL="0">
-              <a:buNone/>
-            </a:pPr>
-            <a:r>
-              <a:rPr lang="en-US" sz="1100" dirty="0">
-                <a:solidFill>
-                  <a:srgbClr val="6B7280"/>
-                </a:solidFill>
-                <a:latin typeface="游ゴシック" pitchFamily="34" charset="0"/>
-                <a:ea typeface="游ゴシック" pitchFamily="34" charset="-122"/>
-                <a:cs typeface="游ゴシック" pitchFamily="34" charset="-120"/>
-              </a:rPr>
-              <a:t>前月 ¥2.17M</a:t>
-            </a:r>
-            <a:endParaRPr lang="en-US" sz="1100" dirty="0"/>
-          </a:p>
-        </p:txBody>
-      </p:sp>
-      <p:sp>
-        <p:nvSpPr>
-          <p:cNvPr id="19" name="Shape 17"/>
-          <p:cNvSpPr/>
-          <p:nvPr/>
-        </p:nvSpPr>
-        <p:spPr>
-          <a:xfrm>
-            <a:off x="548640" y="5166360"/>
-            <a:ext cx="11091672" cy="566928"/>
-          </a:xfrm>
-          <a:prstGeom prst="rect">
-            <a:avLst/>
-          </a:prstGeom>
-          <a:solidFill>
-            <a:srgbClr val="EEF2F7"/>
-          </a:solidFill>
-          <a:ln/>
-        </p:spPr>
-      </p:sp>
-      <p:sp>
-        <p:nvSpPr>
-          <p:cNvPr id="20" name="Shape 18"/>
-          <p:cNvSpPr/>
-          <p:nvPr/>
-        </p:nvSpPr>
-        <p:spPr>
-          <a:xfrm>
-            <a:off x="548640" y="5166360"/>
-            <a:ext cx="11091672" cy="13716"/>
-          </a:xfrm>
-          <a:prstGeom prst="rect">
-            <a:avLst/>
-          </a:prstGeom>
-          <a:solidFill>
-            <a:srgbClr val="2563EB"/>
-          </a:solidFill>
-          <a:ln/>
-        </p:spPr>
-      </p:sp>
-      <p:sp>
-        <p:nvSpPr>
-          <p:cNvPr id="21" name="Text 19"/>
-          <p:cNvSpPr/>
-          <p:nvPr/>
-        </p:nvSpPr>
-        <p:spPr>
-          <a:xfrm>
-            <a:off x="822960" y="5166360"/>
-            <a:ext cx="10543032" cy="566928"/>
-          </a:xfrm>
-          <a:prstGeom prst="rect">
-            <a:avLst/>
-          </a:prstGeom>
-          <a:noFill/>
-          <a:ln/>
-        </p:spPr>
-        <p:txBody>
-          <a:bodyPr wrap="square" rtlCol="0" anchor="ctr"/>
-          <a:lstStyle/>
-          <a:p>
-            <a:pPr algn="ctr" indent="0" marL="0">
-              <a:buNone/>
-            </a:pPr>
-            <a:r>
-              <a:rPr lang="en-US" sz="1400" dirty="0">
-                <a:solidFill>
-                  <a:srgbClr val="1A1A2E"/>
-                </a:solidFill>
-                <a:latin typeface="游ゴシック" pitchFamily="34" charset="0"/>
-                <a:ea typeface="游ゴシック" pitchFamily="34" charset="-122"/>
-                <a:cs typeface="游ゴシック" pitchFamily="34" charset="-120"/>
-              </a:rPr>
-              <a:t>売上・件数ともに月間目標を達成。単価は小型案件の増加により微減。</a:t>
-            </a:r>
-            <a:endParaRPr lang="en-US" sz="1400" dirty="0"/>
-          </a:p>
-        </p:txBody>
-      </p:sp>
-    </p:spTree>
-  </p:cSld>
-  <p:clrMapOvr>
-    <a:masterClrMapping/>
-  </p:clrMapOvr>
-</p:sld>
-</file>
-
-<file path=ppt/slides/slide3.xml><?xml version="1.0" encoding="utf-8"?>
-<p:sld xmlns:a="http://schemas.openxmlformats.org/drawingml/2006/main" xmlns:r="http://schemas.openxmlformats.org/officeDocument/2006/relationships" xmlns:p="http://schemas.openxmlformats.org/presentationml/2006/main">
-  <p:cSld name="Slide 3">
-    <p:bg>
-      <p:bgPr>
-        <a:solidFill>
-          <a:srgbClr val="FFFFFF"/>
-        </a:solidFill>
-      </p:bgPr>
-    </p:bg>
-    <p:spTree>
-      <p:nvGrpSpPr>
-        <p:cNvPr id="1" name=""/>
-        <p:cNvGrpSpPr/>
-        <p:nvPr/>
-      </p:nvGrpSpPr>
-      <p:grpSpPr>
-        <a:xfrm>
-          <a:off x="0" y="0"/>
-          <a:ext cx="0" cy="0"/>
-          <a:chOff x="0" y="0"/>
-          <a:chExt cx="0" cy="0"/>
-        </a:xfrm>
-      </p:grpSpPr>
-      <p:sp>
-        <p:nvSpPr>
-          <p:cNvPr id="2" name="Text 0"/>
-          <p:cNvSpPr/>
-          <p:nvPr/>
-        </p:nvSpPr>
-        <p:spPr>
-          <a:xfrm>
-            <a:off x="548640" y="274320"/>
-            <a:ext cx="11091672" cy="594360"/>
-          </a:xfrm>
-          <a:prstGeom prst="rect">
-            <a:avLst/>
-          </a:prstGeom>
-          <a:noFill/>
-          <a:ln/>
-        </p:spPr>
-        <p:txBody>
-          <a:bodyPr wrap="square" rtlCol="0" anchor="t"/>
-          <a:lstStyle/>
-          <a:p>
-            <a:pPr algn="l" indent="0" marL="0">
-              <a:buNone/>
-            </a:pPr>
-            <a:r>
-              <a:rPr lang="en-US" sz="2600" b="1" dirty="0">
-                <a:solidFill>
-                  <a:srgbClr val="1A1A2E"/>
-                </a:solidFill>
-                <a:latin typeface="游ゴシック" pitchFamily="34" charset="0"/>
-                <a:ea typeface="游ゴシック" pitchFamily="34" charset="-122"/>
-                <a:cs typeface="游ゴシック" pitchFamily="34" charset="-120"/>
-              </a:rPr>
-              <a:t>売上内訳</a:t>
-            </a:r>
-            <a:endParaRPr lang="en-US" sz="2600" dirty="0"/>
-          </a:p>
-        </p:txBody>
-      </p:sp>
-      <p:sp>
-        <p:nvSpPr>
-          <p:cNvPr id="3" name="Shape 1"/>
-          <p:cNvSpPr/>
-          <p:nvPr/>
-        </p:nvSpPr>
-        <p:spPr>
-          <a:xfrm>
-            <a:off x="548640" y="960120"/>
-            <a:ext cx="11091672" cy="36576"/>
-          </a:xfrm>
-          <a:prstGeom prst="rect">
-            <a:avLst/>
-          </a:prstGeom>
-          <a:solidFill>
-            <a:srgbClr val="2563EB"/>
-          </a:solidFill>
-          <a:ln/>
-        </p:spPr>
-      </p:sp>
-      <p:sp>
-        <p:nvSpPr>
-          <p:cNvPr id="4" name="Text 2"/>
-          <p:cNvSpPr/>
-          <p:nvPr/>
-        </p:nvSpPr>
-        <p:spPr>
-          <a:xfrm>
-            <a:off x="548640" y="1143000"/>
-            <a:ext cx="5362956" cy="365760"/>
-          </a:xfrm>
-          <a:prstGeom prst="rect">
-            <a:avLst/>
-          </a:prstGeom>
-          <a:noFill/>
-          <a:ln/>
-        </p:spPr>
-        <p:txBody>
-          <a:bodyPr wrap="square" rtlCol="0" anchor="t"/>
-          <a:lstStyle/>
-          <a:p>
-            <a:pPr algn="l" indent="0" marL="0">
-              <a:buNone/>
-            </a:pPr>
-            <a:r>
-              <a:rPr lang="en-US" sz="1500" b="1" dirty="0">
-                <a:solidFill>
-                  <a:srgbClr val="1A1A2E"/>
-                </a:solidFill>
-                <a:latin typeface="游ゴシック" pitchFamily="34" charset="0"/>
-                <a:ea typeface="游ゴシック" pitchFamily="34" charset="-122"/>
-                <a:cs typeface="游ゴシック" pitchFamily="34" charset="-120"/>
-              </a:rPr>
-              <a:t>カテゴリ別</a:t>
-            </a:r>
-            <a:endParaRPr lang="en-US" sz="1500" dirty="0"/>
-          </a:p>
-        </p:txBody>
-      </p:sp>
-      <p:sp>
-        <p:nvSpPr>
-          <p:cNvPr id="5" name="Shape 3"/>
-          <p:cNvSpPr/>
-          <p:nvPr/>
-        </p:nvSpPr>
-        <p:spPr>
-          <a:xfrm>
-            <a:off x="548640" y="1536192"/>
-            <a:ext cx="5362956" cy="10973"/>
-          </a:xfrm>
-          <a:prstGeom prst="rect">
-            <a:avLst/>
-          </a:prstGeom>
-          <a:solidFill>
-            <a:srgbClr val="E0E4EA"/>
-          </a:solidFill>
-          <a:ln/>
-        </p:spPr>
-      </p:sp>
-      <p:sp>
-        <p:nvSpPr>
-          <p:cNvPr id="6" name="Text 4"/>
-          <p:cNvSpPr/>
-          <p:nvPr/>
-        </p:nvSpPr>
-        <p:spPr>
-          <a:xfrm>
-            <a:off x="548640" y="1737360"/>
-            <a:ext cx="1234440" cy="438912"/>
-          </a:xfrm>
-          <a:prstGeom prst="rect">
-            <a:avLst/>
-          </a:prstGeom>
-          <a:noFill/>
-          <a:ln/>
-        </p:spPr>
-        <p:txBody>
-          <a:bodyPr wrap="square" rtlCol="0" anchor="ctr"/>
-          <a:lstStyle/>
-          <a:p>
-            <a:pPr algn="l" indent="0" marL="0">
-              <a:buNone/>
-            </a:pPr>
-            <a:r>
-              <a:rPr lang="en-US" sz="1300" dirty="0">
-                <a:solidFill>
-                  <a:srgbClr val="6B7280"/>
-                </a:solidFill>
-                <a:latin typeface="游ゴシック" pitchFamily="34" charset="0"/>
-                <a:ea typeface="游ゴシック" pitchFamily="34" charset="-122"/>
-                <a:cs typeface="游ゴシック" pitchFamily="34" charset="-120"/>
-              </a:rPr>
-              <a:t>SaaS</a:t>
-            </a:r>
-            <a:endParaRPr lang="en-US" sz="1300" dirty="0"/>
-          </a:p>
-        </p:txBody>
-      </p:sp>
-      <p:sp>
-        <p:nvSpPr>
-          <p:cNvPr id="7" name="Shape 5"/>
-          <p:cNvSpPr/>
-          <p:nvPr/>
-        </p:nvSpPr>
-        <p:spPr>
-          <a:xfrm>
-            <a:off x="1828800" y="1737360"/>
-            <a:ext cx="3991356" cy="438912"/>
-          </a:xfrm>
-          <a:prstGeom prst="rect">
-            <a:avLst/>
-          </a:prstGeom>
-          <a:solidFill>
-            <a:srgbClr val="E0E4EA"/>
-          </a:solidFill>
-          <a:ln/>
-        </p:spPr>
-      </p:sp>
-      <p:sp>
-        <p:nvSpPr>
-          <p:cNvPr id="8" name="Shape 6"/>
-          <p:cNvSpPr/>
-          <p:nvPr/>
-        </p:nvSpPr>
-        <p:spPr>
-          <a:xfrm>
-            <a:off x="1828800" y="1737360"/>
-            <a:ext cx="2195246" cy="438912"/>
-          </a:xfrm>
-          <a:prstGeom prst="rect">
-            <a:avLst/>
-          </a:prstGeom>
-          <a:solidFill>
-            <a:srgbClr val="2563EB"/>
-          </a:solidFill>
-          <a:ln/>
-        </p:spPr>
-      </p:sp>
-      <p:sp>
-        <p:nvSpPr>
-          <p:cNvPr id="9" name="Text 7"/>
-          <p:cNvSpPr/>
-          <p:nvPr/>
-        </p:nvSpPr>
-        <p:spPr>
-          <a:xfrm>
-            <a:off x="1965960" y="1737360"/>
-            <a:ext cx="2058086" cy="438912"/>
-          </a:xfrm>
-          <a:prstGeom prst="rect">
-            <a:avLst/>
-          </a:prstGeom>
-          <a:noFill/>
-          <a:ln/>
-        </p:spPr>
-        <p:txBody>
-          <a:bodyPr wrap="square" rtlCol="0" anchor="ctr"/>
-          <a:lstStyle/>
-          <a:p>
-            <a:pPr algn="l" indent="0" marL="0">
-              <a:buNone/>
-            </a:pPr>
-            <a:r>
-              <a:rPr lang="en-US" sz="1300" b="1" dirty="0">
-                <a:solidFill>
-                  <a:srgbClr val="FFFFFF"/>
-                </a:solidFill>
-                <a:latin typeface="游ゴシック" pitchFamily="34" charset="0"/>
-                <a:ea typeface="游ゴシック" pitchFamily="34" charset="-122"/>
-                <a:cs typeface="游ゴシック" pitchFamily="34" charset="-120"/>
-              </a:rPr>
-              <a:t>¥26.7M</a:t>
-            </a:r>
-            <a:endParaRPr lang="en-US" sz="1300" dirty="0"/>
-          </a:p>
-        </p:txBody>
-      </p:sp>
-      <p:sp>
-        <p:nvSpPr>
-          <p:cNvPr id="10" name="Text 8"/>
-          <p:cNvSpPr/>
-          <p:nvPr/>
-        </p:nvSpPr>
-        <p:spPr>
-          <a:xfrm>
-            <a:off x="548640" y="2414016"/>
-            <a:ext cx="1234440" cy="438912"/>
-          </a:xfrm>
-          <a:prstGeom prst="rect">
-            <a:avLst/>
-          </a:prstGeom>
-          <a:noFill/>
-          <a:ln/>
-        </p:spPr>
-        <p:txBody>
-          <a:bodyPr wrap="square" rtlCol="0" anchor="ctr"/>
-          <a:lstStyle/>
-          <a:p>
-            <a:pPr algn="l" indent="0" marL="0">
-              <a:buNone/>
-            </a:pPr>
-            <a:r>
-              <a:rPr lang="en-US" sz="1300" dirty="0">
-                <a:solidFill>
-                  <a:srgbClr val="6B7280"/>
-                </a:solidFill>
-                <a:latin typeface="游ゴシック" pitchFamily="34" charset="0"/>
-                <a:ea typeface="游ゴシック" pitchFamily="34" charset="-122"/>
-                <a:cs typeface="游ゴシック" pitchFamily="34" charset="-120"/>
-              </a:rPr>
-              <a:t>受託開発</a:t>
-            </a:r>
-            <a:endParaRPr lang="en-US" sz="1300" dirty="0"/>
-          </a:p>
-        </p:txBody>
-      </p:sp>
-      <p:sp>
-        <p:nvSpPr>
-          <p:cNvPr id="11" name="Shape 9"/>
-          <p:cNvSpPr/>
-          <p:nvPr/>
-        </p:nvSpPr>
-        <p:spPr>
-          <a:xfrm>
-            <a:off x="1828800" y="2414016"/>
-            <a:ext cx="3991356" cy="438912"/>
-          </a:xfrm>
-          <a:prstGeom prst="rect">
-            <a:avLst/>
-          </a:prstGeom>
-          <a:solidFill>
-            <a:srgbClr val="E0E4EA"/>
-          </a:solidFill>
-          <a:ln/>
-        </p:spPr>
-      </p:sp>
-      <p:sp>
-        <p:nvSpPr>
-          <p:cNvPr id="12" name="Shape 10"/>
-          <p:cNvSpPr/>
-          <p:nvPr/>
-        </p:nvSpPr>
-        <p:spPr>
-          <a:xfrm>
-            <a:off x="1828800" y="2414016"/>
-            <a:ext cx="1197407" cy="438912"/>
-          </a:xfrm>
-          <a:prstGeom prst="rect">
-            <a:avLst/>
-          </a:prstGeom>
-          <a:solidFill>
-            <a:srgbClr val="8B5CF6"/>
-          </a:solidFill>
-          <a:ln/>
-        </p:spPr>
-      </p:sp>
-      <p:sp>
-        <p:nvSpPr>
-          <p:cNvPr id="13" name="Text 11"/>
-          <p:cNvSpPr/>
-          <p:nvPr/>
-        </p:nvSpPr>
-        <p:spPr>
-          <a:xfrm>
-            <a:off x="1965960" y="2414016"/>
-            <a:ext cx="1060247" cy="438912"/>
-          </a:xfrm>
-          <a:prstGeom prst="rect">
-            <a:avLst/>
-          </a:prstGeom>
-          <a:noFill/>
-          <a:ln/>
-        </p:spPr>
-        <p:txBody>
-          <a:bodyPr wrap="square" rtlCol="0" anchor="ctr"/>
-          <a:lstStyle/>
-          <a:p>
-            <a:pPr algn="l" indent="0" marL="0">
-              <a:buNone/>
-            </a:pPr>
-            <a:r>
-              <a:rPr lang="en-US" sz="1300" b="1" dirty="0">
-                <a:solidFill>
-                  <a:srgbClr val="FFFFFF"/>
-                </a:solidFill>
-                <a:latin typeface="游ゴシック" pitchFamily="34" charset="0"/>
-                <a:ea typeface="游ゴシック" pitchFamily="34" charset="-122"/>
-                <a:cs typeface="游ゴシック" pitchFamily="34" charset="-120"/>
-              </a:rPr>
-              <a:t>¥14.6M</a:t>
-            </a:r>
-            <a:endParaRPr lang="en-US" sz="1300" dirty="0"/>
-          </a:p>
-        </p:txBody>
-      </p:sp>
-      <p:sp>
-        <p:nvSpPr>
-          <p:cNvPr id="14" name="Text 12"/>
-          <p:cNvSpPr/>
-          <p:nvPr/>
-        </p:nvSpPr>
-        <p:spPr>
-          <a:xfrm>
-            <a:off x="548640" y="3090672"/>
-            <a:ext cx="1234440" cy="438912"/>
-          </a:xfrm>
-          <a:prstGeom prst="rect">
-            <a:avLst/>
-          </a:prstGeom>
-          <a:noFill/>
-          <a:ln/>
-        </p:spPr>
-        <p:txBody>
-          <a:bodyPr wrap="square" rtlCol="0" anchor="ctr"/>
-          <a:lstStyle/>
-          <a:p>
-            <a:pPr algn="l" indent="0" marL="0">
-              <a:buNone/>
-            </a:pPr>
-            <a:r>
-              <a:rPr lang="en-US" sz="1300" dirty="0">
-                <a:solidFill>
-                  <a:srgbClr val="6B7280"/>
-                </a:solidFill>
-                <a:latin typeface="游ゴシック" pitchFamily="34" charset="0"/>
-                <a:ea typeface="游ゴシック" pitchFamily="34" charset="-122"/>
-                <a:cs typeface="游ゴシック" pitchFamily="34" charset="-120"/>
-              </a:rPr>
-              <a:t>コンサル</a:t>
-            </a:r>
-            <a:endParaRPr lang="en-US" sz="1300" dirty="0"/>
-          </a:p>
-        </p:txBody>
-      </p:sp>
-      <p:sp>
-        <p:nvSpPr>
-          <p:cNvPr id="15" name="Shape 13"/>
-          <p:cNvSpPr/>
-          <p:nvPr/>
-        </p:nvSpPr>
-        <p:spPr>
-          <a:xfrm>
-            <a:off x="1828800" y="3090672"/>
-            <a:ext cx="3991356" cy="438912"/>
-          </a:xfrm>
-          <a:prstGeom prst="rect">
-            <a:avLst/>
-          </a:prstGeom>
-          <a:solidFill>
-            <a:srgbClr val="E0E4EA"/>
-          </a:solidFill>
-          <a:ln/>
-        </p:spPr>
-      </p:sp>
-      <p:sp>
-        <p:nvSpPr>
-          <p:cNvPr id="16" name="Shape 14"/>
-          <p:cNvSpPr/>
-          <p:nvPr/>
-        </p:nvSpPr>
-        <p:spPr>
-          <a:xfrm>
-            <a:off x="1828800" y="3090672"/>
-            <a:ext cx="598703" cy="438912"/>
-          </a:xfrm>
-          <a:prstGeom prst="rect">
-            <a:avLst/>
-          </a:prstGeom>
-          <a:solidFill>
-            <a:srgbClr val="06B6D4"/>
-          </a:solidFill>
-          <a:ln/>
-        </p:spPr>
-      </p:sp>
-      <p:sp>
-        <p:nvSpPr>
-          <p:cNvPr id="17" name="Text 15"/>
-          <p:cNvSpPr/>
-          <p:nvPr/>
-        </p:nvSpPr>
-        <p:spPr>
-          <a:xfrm>
-            <a:off x="1965960" y="3090672"/>
-            <a:ext cx="461543" cy="438912"/>
-          </a:xfrm>
-          <a:prstGeom prst="rect">
-            <a:avLst/>
-          </a:prstGeom>
-          <a:noFill/>
-          <a:ln/>
-        </p:spPr>
-        <p:txBody>
-          <a:bodyPr wrap="square" rtlCol="0" anchor="ctr"/>
-          <a:lstStyle/>
-          <a:p>
-            <a:pPr algn="l" indent="0" marL="0">
-              <a:buNone/>
-            </a:pPr>
-            <a:r>
-              <a:rPr lang="en-US" sz="1300" b="1" dirty="0">
-                <a:solidFill>
-                  <a:srgbClr val="FFFFFF"/>
-                </a:solidFill>
-                <a:latin typeface="游ゴシック" pitchFamily="34" charset="0"/>
-                <a:ea typeface="游ゴシック" pitchFamily="34" charset="-122"/>
-                <a:cs typeface="游ゴシック" pitchFamily="34" charset="-120"/>
-              </a:rPr>
-              <a:t>¥7.2M</a:t>
-            </a:r>
-            <a:endParaRPr lang="en-US" sz="1300" dirty="0"/>
-          </a:p>
-        </p:txBody>
-      </p:sp>
-      <p:sp>
-        <p:nvSpPr>
-          <p:cNvPr id="18" name="Text 16"/>
-          <p:cNvSpPr/>
-          <p:nvPr/>
-        </p:nvSpPr>
-        <p:spPr>
-          <a:xfrm>
-            <a:off x="6277356" y="1143000"/>
-            <a:ext cx="5362956" cy="365760"/>
-          </a:xfrm>
-          <a:prstGeom prst="rect">
-            <a:avLst/>
-          </a:prstGeom>
-          <a:noFill/>
-          <a:ln/>
-        </p:spPr>
-        <p:txBody>
-          <a:bodyPr wrap="square" rtlCol="0" anchor="t"/>
-          <a:lstStyle/>
-          <a:p>
-            <a:pPr algn="l" indent="0" marL="0">
-              <a:buNone/>
-            </a:pPr>
-            <a:r>
-              <a:rPr lang="en-US" sz="1500" b="1" dirty="0">
-                <a:solidFill>
-                  <a:srgbClr val="1A1A2E"/>
-                </a:solidFill>
-                <a:latin typeface="游ゴシック" pitchFamily="34" charset="0"/>
-                <a:ea typeface="游ゴシック" pitchFamily="34" charset="-122"/>
-                <a:cs typeface="游ゴシック" pitchFamily="34" charset="-120"/>
-              </a:rPr>
-              <a:t>チーム別実績</a:t>
-            </a:r>
-            <a:endParaRPr lang="en-US" sz="1500" dirty="0"/>
-          </a:p>
-        </p:txBody>
-      </p:sp>
-      <p:sp>
-        <p:nvSpPr>
-          <p:cNvPr id="19" name="Shape 17"/>
-          <p:cNvSpPr/>
-          <p:nvPr/>
-        </p:nvSpPr>
-        <p:spPr>
-          <a:xfrm>
-            <a:off x="6277356" y="1536192"/>
-            <a:ext cx="5362956" cy="10973"/>
-          </a:xfrm>
-          <a:prstGeom prst="rect">
-            <a:avLst/>
-          </a:prstGeom>
-          <a:solidFill>
-            <a:srgbClr val="E0E4EA"/>
-          </a:solidFill>
-          <a:ln/>
-        </p:spPr>
-      </p:sp>
-      <p:sp>
-        <p:nvSpPr>
-          <p:cNvPr id="20" name="Shape 18"/>
-          <p:cNvSpPr/>
-          <p:nvPr/>
-        </p:nvSpPr>
-        <p:spPr>
-          <a:xfrm>
-            <a:off x="6277356" y="1737360"/>
-            <a:ext cx="5362956" cy="1188720"/>
-          </a:xfrm>
-          <a:prstGeom prst="rect">
-            <a:avLst/>
-          </a:prstGeom>
-          <a:solidFill>
-            <a:srgbClr val="F5F7FA"/>
-          </a:solidFill>
-          <a:ln/>
-        </p:spPr>
-      </p:sp>
-      <p:sp>
-        <p:nvSpPr>
-          <p:cNvPr id="21" name="Text 19"/>
-          <p:cNvSpPr/>
-          <p:nvPr/>
-        </p:nvSpPr>
-        <p:spPr>
-          <a:xfrm>
-            <a:off x="6551676" y="1901952"/>
-            <a:ext cx="3351276" cy="411480"/>
-          </a:xfrm>
-          <a:prstGeom prst="rect">
-            <a:avLst/>
-          </a:prstGeom>
-          <a:noFill/>
-          <a:ln/>
-        </p:spPr>
-        <p:txBody>
-          <a:bodyPr wrap="square" rtlCol="0" anchor="ctr"/>
-          <a:lstStyle/>
-          <a:p>
-            <a:pPr algn="l" indent="0" marL="0">
-              <a:buNone/>
-            </a:pPr>
-            <a:r>
-              <a:rPr lang="en-US" sz="1700" b="1" dirty="0">
-                <a:solidFill>
-                  <a:srgbClr val="1A1A2E"/>
-                </a:solidFill>
-                <a:latin typeface="游ゴシック" pitchFamily="34" charset="0"/>
-                <a:ea typeface="游ゴシック" pitchFamily="34" charset="-122"/>
-                <a:cs typeface="游ゴシック" pitchFamily="34" charset="-120"/>
-              </a:rPr>
-              <a:t>第1営業部</a:t>
-            </a:r>
-            <a:endParaRPr lang="en-US" sz="1700" dirty="0"/>
-          </a:p>
-        </p:txBody>
-      </p:sp>
-      <p:sp>
-        <p:nvSpPr>
-          <p:cNvPr id="22" name="Text 20"/>
-          <p:cNvSpPr/>
-          <p:nvPr/>
-        </p:nvSpPr>
-        <p:spPr>
-          <a:xfrm>
-            <a:off x="6551676" y="2359152"/>
-            <a:ext cx="3351276" cy="320040"/>
-          </a:xfrm>
-          <a:prstGeom prst="rect">
-            <a:avLst/>
-          </a:prstGeom>
-          <a:noFill/>
-          <a:ln/>
-        </p:spPr>
-        <p:txBody>
-          <a:bodyPr wrap="square" rtlCol="0" anchor="ctr"/>
-          <a:lstStyle/>
-          <a:p>
-            <a:pPr algn="l" indent="0" marL="0">
-              <a:buNone/>
-            </a:pPr>
-            <a:r>
-              <a:rPr lang="en-US" sz="1100" dirty="0">
-                <a:solidFill>
-                  <a:srgbClr val="6B7280"/>
-                </a:solidFill>
-                <a:latin typeface="游ゴシック" pitchFamily="34" charset="0"/>
-                <a:ea typeface="游ゴシック" pitchFamily="34" charset="-122"/>
-                <a:cs typeface="游ゴシック" pitchFamily="34" charset="-120"/>
-              </a:rPr>
-              <a:t>田中チーム</a:t>
-            </a:r>
-            <a:endParaRPr lang="en-US" sz="1100" dirty="0"/>
-          </a:p>
-        </p:txBody>
-      </p:sp>
-      <p:sp>
-        <p:nvSpPr>
-          <p:cNvPr id="23" name="Text 21"/>
-          <p:cNvSpPr/>
-          <p:nvPr/>
-        </p:nvSpPr>
-        <p:spPr>
-          <a:xfrm>
-            <a:off x="6551676" y="1847088"/>
-            <a:ext cx="4905756" cy="530352"/>
-          </a:xfrm>
-          <a:prstGeom prst="rect">
-            <a:avLst/>
-          </a:prstGeom>
-          <a:noFill/>
-          <a:ln/>
-        </p:spPr>
-        <p:txBody>
-          <a:bodyPr wrap="square" rtlCol="0" anchor="ctr"/>
-          <a:lstStyle/>
-          <a:p>
-            <a:pPr algn="r" indent="0" marL="0">
-              <a:buNone/>
-            </a:pPr>
-            <a:r>
-              <a:rPr lang="en-US" sz="2400" b="1" dirty="0">
-                <a:solidFill>
-                  <a:srgbClr val="2563EB"/>
-                </a:solidFill>
-                <a:latin typeface="游ゴシック" pitchFamily="34" charset="0"/>
-                <a:ea typeface="游ゴシック" pitchFamily="34" charset="-122"/>
-                <a:cs typeface="游ゴシック" pitchFamily="34" charset="-120"/>
-              </a:rPr>
-              <a:t>¥22.1M</a:t>
-            </a:r>
-            <a:endParaRPr lang="en-US" sz="2400" dirty="0"/>
-          </a:p>
-        </p:txBody>
-      </p:sp>
-      <p:sp>
-        <p:nvSpPr>
-          <p:cNvPr id="24" name="Text 22"/>
-          <p:cNvSpPr/>
-          <p:nvPr/>
-        </p:nvSpPr>
-        <p:spPr>
-          <a:xfrm>
-            <a:off x="6551676" y="2423160"/>
-            <a:ext cx="4905756" cy="320040"/>
-          </a:xfrm>
-          <a:prstGeom prst="rect">
-            <a:avLst/>
-          </a:prstGeom>
-          <a:noFill/>
-          <a:ln/>
-        </p:spPr>
-        <p:txBody>
-          <a:bodyPr wrap="square" rtlCol="0" anchor="ctr"/>
-          <a:lstStyle/>
-          <a:p>
-            <a:pPr algn="r" indent="0" marL="0">
-              <a:buNone/>
-            </a:pPr>
-            <a:r>
-              <a:rPr lang="en-US" sz="1200" b="1" dirty="0">
-                <a:solidFill>
-                  <a:srgbClr val="16A34A"/>
-                </a:solidFill>
-                <a:latin typeface="游ゴシック" pitchFamily="34" charset="0"/>
-                <a:ea typeface="游ゴシック" pitchFamily="34" charset="-122"/>
-                <a:cs typeface="游ゴシック" pitchFamily="34" charset="-120"/>
-              </a:rPr>
-              <a:t>達成率 112%</a:t>
-            </a:r>
-            <a:endParaRPr lang="en-US" sz="1200" dirty="0"/>
-          </a:p>
-        </p:txBody>
-      </p:sp>
-      <p:sp>
-        <p:nvSpPr>
-          <p:cNvPr id="25" name="Shape 23"/>
-          <p:cNvSpPr/>
-          <p:nvPr/>
-        </p:nvSpPr>
-        <p:spPr>
-          <a:xfrm>
-            <a:off x="6277356" y="3108960"/>
-            <a:ext cx="5362956" cy="1188720"/>
-          </a:xfrm>
-          <a:prstGeom prst="rect">
-            <a:avLst/>
-          </a:prstGeom>
-          <a:solidFill>
-            <a:srgbClr val="F5F7FA"/>
-          </a:solidFill>
-          <a:ln/>
-        </p:spPr>
-      </p:sp>
-      <p:sp>
-        <p:nvSpPr>
-          <p:cNvPr id="26" name="Text 24"/>
-          <p:cNvSpPr/>
-          <p:nvPr/>
-        </p:nvSpPr>
-        <p:spPr>
-          <a:xfrm>
-            <a:off x="6551676" y="3273552"/>
-            <a:ext cx="3351276" cy="411480"/>
-          </a:xfrm>
-          <a:prstGeom prst="rect">
-            <a:avLst/>
-          </a:prstGeom>
-          <a:noFill/>
-          <a:ln/>
-        </p:spPr>
-        <p:txBody>
-          <a:bodyPr wrap="square" rtlCol="0" anchor="ctr"/>
-          <a:lstStyle/>
-          <a:p>
-            <a:pPr algn="l" indent="0" marL="0">
-              <a:buNone/>
-            </a:pPr>
-            <a:r>
-              <a:rPr lang="en-US" sz="1700" b="1" dirty="0">
-                <a:solidFill>
-                  <a:srgbClr val="1A1A2E"/>
-                </a:solidFill>
-                <a:latin typeface="游ゴシック" pitchFamily="34" charset="0"/>
-                <a:ea typeface="游ゴシック" pitchFamily="34" charset="-122"/>
-                <a:cs typeface="游ゴシック" pitchFamily="34" charset="-120"/>
-              </a:rPr>
-              <a:t>第2営業部</a:t>
-            </a:r>
-            <a:endParaRPr lang="en-US" sz="1700" dirty="0"/>
-          </a:p>
-        </p:txBody>
-      </p:sp>
-      <p:sp>
-        <p:nvSpPr>
-          <p:cNvPr id="27" name="Text 25"/>
-          <p:cNvSpPr/>
-          <p:nvPr/>
-        </p:nvSpPr>
-        <p:spPr>
-          <a:xfrm>
-            <a:off x="6551676" y="3730752"/>
-            <a:ext cx="3351276" cy="320040"/>
-          </a:xfrm>
-          <a:prstGeom prst="rect">
-            <a:avLst/>
-          </a:prstGeom>
-          <a:noFill/>
-          <a:ln/>
-        </p:spPr>
-        <p:txBody>
-          <a:bodyPr wrap="square" rtlCol="0" anchor="ctr"/>
-          <a:lstStyle/>
-          <a:p>
-            <a:pPr algn="l" indent="0" marL="0">
-              <a:buNone/>
-            </a:pPr>
-            <a:r>
-              <a:rPr lang="en-US" sz="1100" dirty="0">
-                <a:solidFill>
-                  <a:srgbClr val="6B7280"/>
-                </a:solidFill>
-                <a:latin typeface="游ゴシック" pitchFamily="34" charset="0"/>
-                <a:ea typeface="游ゴシック" pitchFamily="34" charset="-122"/>
-                <a:cs typeface="游ゴシック" pitchFamily="34" charset="-120"/>
-              </a:rPr>
-              <a:t>鈴木チーム</a:t>
-            </a:r>
-            <a:endParaRPr lang="en-US" sz="1100" dirty="0"/>
-          </a:p>
-        </p:txBody>
-      </p:sp>
-      <p:sp>
-        <p:nvSpPr>
-          <p:cNvPr id="28" name="Text 26"/>
-          <p:cNvSpPr/>
-          <p:nvPr/>
-        </p:nvSpPr>
-        <p:spPr>
-          <a:xfrm>
-            <a:off x="6551676" y="3218688"/>
-            <a:ext cx="4905756" cy="530352"/>
-          </a:xfrm>
-          <a:prstGeom prst="rect">
-            <a:avLst/>
-          </a:prstGeom>
-          <a:noFill/>
-          <a:ln/>
-        </p:spPr>
-        <p:txBody>
-          <a:bodyPr wrap="square" rtlCol="0" anchor="ctr"/>
-          <a:lstStyle/>
-          <a:p>
-            <a:pPr algn="r" indent="0" marL="0">
-              <a:buNone/>
-            </a:pPr>
-            <a:r>
-              <a:rPr lang="en-US" sz="2400" b="1" dirty="0">
-                <a:solidFill>
-                  <a:srgbClr val="2563EB"/>
-                </a:solidFill>
-                <a:latin typeface="游ゴシック" pitchFamily="34" charset="0"/>
-                <a:ea typeface="游ゴシック" pitchFamily="34" charset="-122"/>
-                <a:cs typeface="游ゴシック" pitchFamily="34" charset="-120"/>
-              </a:rPr>
-              <a:t>¥16.2M</a:t>
-            </a:r>
-            <a:endParaRPr lang="en-US" sz="2400" dirty="0"/>
-          </a:p>
-        </p:txBody>
-      </p:sp>
-      <p:sp>
-        <p:nvSpPr>
-          <p:cNvPr id="29" name="Text 27"/>
-          <p:cNvSpPr/>
-          <p:nvPr/>
-        </p:nvSpPr>
-        <p:spPr>
-          <a:xfrm>
-            <a:off x="6551676" y="3794760"/>
-            <a:ext cx="4905756" cy="320040"/>
-          </a:xfrm>
-          <a:prstGeom prst="rect">
-            <a:avLst/>
-          </a:prstGeom>
-          <a:noFill/>
-          <a:ln/>
-        </p:spPr>
-        <p:txBody>
-          <a:bodyPr wrap="square" rtlCol="0" anchor="ctr"/>
-          <a:lstStyle/>
-          <a:p>
-            <a:pPr algn="r" indent="0" marL="0">
-              <a:buNone/>
-            </a:pPr>
-            <a:r>
-              <a:rPr lang="en-US" sz="1200" b="1" dirty="0">
-                <a:solidFill>
-                  <a:srgbClr val="16A34A"/>
-                </a:solidFill>
-                <a:latin typeface="游ゴシック" pitchFamily="34" charset="0"/>
-                <a:ea typeface="游ゴシック" pitchFamily="34" charset="-122"/>
-                <a:cs typeface="游ゴシック" pitchFamily="34" charset="-120"/>
-              </a:rPr>
-              <a:t>達成率 105%</a:t>
-            </a:r>
-            <a:endParaRPr lang="en-US" sz="1200" dirty="0"/>
-          </a:p>
-        </p:txBody>
-      </p:sp>
-      <p:sp>
-        <p:nvSpPr>
-          <p:cNvPr id="30" name="Shape 28"/>
-          <p:cNvSpPr/>
-          <p:nvPr/>
-        </p:nvSpPr>
-        <p:spPr>
-          <a:xfrm>
-            <a:off x="6277356" y="4480560"/>
-            <a:ext cx="5362956" cy="1188720"/>
-          </a:xfrm>
-          <a:prstGeom prst="rect">
-            <a:avLst/>
-          </a:prstGeom>
-          <a:solidFill>
-            <a:srgbClr val="F5F7FA"/>
-          </a:solidFill>
-          <a:ln/>
-        </p:spPr>
-      </p:sp>
-      <p:sp>
-        <p:nvSpPr>
-          <p:cNvPr id="31" name="Text 29"/>
-          <p:cNvSpPr/>
-          <p:nvPr/>
-        </p:nvSpPr>
-        <p:spPr>
-          <a:xfrm>
-            <a:off x="6551676" y="4645152"/>
-            <a:ext cx="3351276" cy="411480"/>
-          </a:xfrm>
-          <a:prstGeom prst="rect">
-            <a:avLst/>
-          </a:prstGeom>
-          <a:noFill/>
-          <a:ln/>
-        </p:spPr>
-        <p:txBody>
-          <a:bodyPr wrap="square" rtlCol="0" anchor="ctr"/>
-          <a:lstStyle/>
-          <a:p>
-            <a:pPr algn="l" indent="0" marL="0">
-              <a:buNone/>
-            </a:pPr>
-            <a:r>
-              <a:rPr lang="en-US" sz="1700" b="1" dirty="0">
-                <a:solidFill>
-                  <a:srgbClr val="1A1A2E"/>
-                </a:solidFill>
-                <a:latin typeface="游ゴシック" pitchFamily="34" charset="0"/>
-                <a:ea typeface="游ゴシック" pitchFamily="34" charset="-122"/>
-                <a:cs typeface="游ゴシック" pitchFamily="34" charset="-120"/>
-              </a:rPr>
-              <a:t>第3営業部</a:t>
-            </a:r>
-            <a:endParaRPr lang="en-US" sz="1700" dirty="0"/>
-          </a:p>
-        </p:txBody>
-      </p:sp>
-      <p:sp>
-        <p:nvSpPr>
-          <p:cNvPr id="32" name="Text 30"/>
-          <p:cNvSpPr/>
-          <p:nvPr/>
-        </p:nvSpPr>
-        <p:spPr>
-          <a:xfrm>
-            <a:off x="6551676" y="5102352"/>
-            <a:ext cx="3351276" cy="320040"/>
-          </a:xfrm>
-          <a:prstGeom prst="rect">
-            <a:avLst/>
-          </a:prstGeom>
-          <a:noFill/>
-          <a:ln/>
-        </p:spPr>
-        <p:txBody>
-          <a:bodyPr wrap="square" rtlCol="0" anchor="ctr"/>
-          <a:lstStyle/>
-          <a:p>
-            <a:pPr algn="l" indent="0" marL="0">
-              <a:buNone/>
-            </a:pPr>
-            <a:r>
-              <a:rPr lang="en-US" sz="1100" dirty="0">
-                <a:solidFill>
-                  <a:srgbClr val="6B7280"/>
-                </a:solidFill>
-                <a:latin typeface="游ゴシック" pitchFamily="34" charset="0"/>
-                <a:ea typeface="游ゴシック" pitchFamily="34" charset="-122"/>
-                <a:cs typeface="游ゴシック" pitchFamily="34" charset="-120"/>
-              </a:rPr>
-              <a:t>佐藤チーム</a:t>
-            </a:r>
-            <a:endParaRPr lang="en-US" sz="1100" dirty="0"/>
-          </a:p>
-        </p:txBody>
-      </p:sp>
-      <p:sp>
-        <p:nvSpPr>
-          <p:cNvPr id="33" name="Text 31"/>
-          <p:cNvSpPr/>
-          <p:nvPr/>
-        </p:nvSpPr>
-        <p:spPr>
-          <a:xfrm>
-            <a:off x="6551676" y="4590288"/>
-            <a:ext cx="4905756" cy="530352"/>
-          </a:xfrm>
-          <a:prstGeom prst="rect">
-            <a:avLst/>
-          </a:prstGeom>
-          <a:noFill/>
-          <a:ln/>
-        </p:spPr>
-        <p:txBody>
-          <a:bodyPr wrap="square" rtlCol="0" anchor="ctr"/>
-          <a:lstStyle/>
-          <a:p>
-            <a:pPr algn="r" indent="0" marL="0">
-              <a:buNone/>
-            </a:pPr>
-            <a:r>
-              <a:rPr lang="en-US" sz="2400" b="1" dirty="0">
-                <a:solidFill>
-                  <a:srgbClr val="2563EB"/>
-                </a:solidFill>
-                <a:latin typeface="游ゴシック" pitchFamily="34" charset="0"/>
-                <a:ea typeface="游ゴシック" pitchFamily="34" charset="-122"/>
-                <a:cs typeface="游ゴシック" pitchFamily="34" charset="-120"/>
-              </a:rPr>
-              <a:t>¥10.2M</a:t>
-            </a:r>
-            <a:endParaRPr lang="en-US" sz="2400" dirty="0"/>
-          </a:p>
-        </p:txBody>
-      </p:sp>
-      <p:sp>
-        <p:nvSpPr>
-          <p:cNvPr id="34" name="Text 32"/>
-          <p:cNvSpPr/>
-          <p:nvPr/>
-        </p:nvSpPr>
-        <p:spPr>
-          <a:xfrm>
-            <a:off x="6551676" y="5166360"/>
-            <a:ext cx="4905756" cy="320040"/>
-          </a:xfrm>
-          <a:prstGeom prst="rect">
-            <a:avLst/>
-          </a:prstGeom>
-          <a:noFill/>
-          <a:ln/>
-        </p:spPr>
-        <p:txBody>
-          <a:bodyPr wrap="square" rtlCol="0" anchor="ctr"/>
-          <a:lstStyle/>
-          <a:p>
-            <a:pPr algn="r" indent="0" marL="0">
-              <a:buNone/>
-            </a:pPr>
-            <a:r>
-              <a:rPr lang="en-US" sz="1200" b="1" dirty="0">
-                <a:solidFill>
-                  <a:srgbClr val="DC2626"/>
-                </a:solidFill>
-                <a:latin typeface="游ゴシック" pitchFamily="34" charset="0"/>
-                <a:ea typeface="游ゴシック" pitchFamily="34" charset="-122"/>
-                <a:cs typeface="游ゴシック" pitchFamily="34" charset="-120"/>
-              </a:rPr>
-              <a:t>達成率 92%</a:t>
-            </a:r>
-            <a:endParaRPr lang="en-US" sz="1200" dirty="0"/>
-          </a:p>
-        </p:txBody>
-      </p:sp>
-    </p:spTree>
-  </p:cSld>
-  <p:clrMapOvr>
-    <a:masterClrMapping/>
-  </p:clrMapOvr>
-</p:sld>
-</file>
-
-<file path=ppt/slides/slide4.xml><?xml version="1.0" encoding="utf-8"?>
-<p:sld xmlns:a="http://schemas.openxmlformats.org/drawingml/2006/main" xmlns:r="http://schemas.openxmlformats.org/officeDocument/2006/relationships" xmlns:p="http://schemas.openxmlformats.org/presentationml/2006/main">
-  <p:cSld name="Slide 4">
-    <p:bg>
-      <p:bgPr>
-        <a:solidFill>
-          <a:srgbClr val="FFFFFF"/>
-        </a:solidFill>
-      </p:bgPr>
-    </p:bg>
-    <p:spTree>
-      <p:nvGrpSpPr>
-        <p:cNvPr id="1" name=""/>
-        <p:cNvGrpSpPr/>
-        <p:nvPr/>
-      </p:nvGrpSpPr>
-      <p:grpSpPr>
-        <a:xfrm>
-          <a:off x="0" y="0"/>
-          <a:ext cx="0" cy="0"/>
-          <a:chOff x="0" y="0"/>
-          <a:chExt cx="0" cy="0"/>
-        </a:xfrm>
-      </p:grpSpPr>
-      <p:sp>
-        <p:nvSpPr>
-          <p:cNvPr id="2" name="Text 0"/>
-          <p:cNvSpPr/>
-          <p:nvPr/>
-        </p:nvSpPr>
-        <p:spPr>
-          <a:xfrm>
-            <a:off x="548640" y="274320"/>
-            <a:ext cx="11091672" cy="594360"/>
-          </a:xfrm>
-          <a:prstGeom prst="rect">
-            <a:avLst/>
-          </a:prstGeom>
-          <a:noFill/>
-          <a:ln/>
-        </p:spPr>
-        <p:txBody>
-          <a:bodyPr wrap="square" rtlCol="0" anchor="t"/>
-          <a:lstStyle/>
-          <a:p>
-            <a:pPr algn="l" indent="0" marL="0">
-              <a:buNone/>
-            </a:pPr>
-            <a:r>
-              <a:rPr lang="en-US" sz="2600" b="1" dirty="0">
-                <a:solidFill>
-                  <a:srgbClr val="1A1A2E"/>
-                </a:solidFill>
-                <a:latin typeface="游ゴシック" pitchFamily="34" charset="0"/>
-                <a:ea typeface="游ゴシック" pitchFamily="34" charset="-122"/>
-                <a:cs typeface="游ゴシック" pitchFamily="34" charset="-120"/>
-              </a:rPr>
-              <a:t>営業進捗 — パイプライン</a:t>
-            </a:r>
-            <a:endParaRPr lang="en-US" sz="2600" dirty="0"/>
-          </a:p>
-        </p:txBody>
-      </p:sp>
-      <p:sp>
-        <p:nvSpPr>
-          <p:cNvPr id="3" name="Shape 1"/>
-          <p:cNvSpPr/>
-          <p:nvPr/>
-        </p:nvSpPr>
-        <p:spPr>
-          <a:xfrm>
-            <a:off x="548640" y="960120"/>
-            <a:ext cx="11091672" cy="36576"/>
-          </a:xfrm>
-          <a:prstGeom prst="rect">
-            <a:avLst/>
-          </a:prstGeom>
-          <a:solidFill>
-            <a:srgbClr val="2563EB"/>
-          </a:solidFill>
-          <a:ln/>
-        </p:spPr>
-      </p:sp>
-      <p:sp>
-        <p:nvSpPr>
-          <p:cNvPr id="4" name="Text 2"/>
-          <p:cNvSpPr/>
-          <p:nvPr/>
-        </p:nvSpPr>
-        <p:spPr>
-          <a:xfrm>
-            <a:off x="548640" y="1234440"/>
-            <a:ext cx="1463040" cy="594360"/>
-          </a:xfrm>
-          <a:prstGeom prst="rect">
-            <a:avLst/>
-          </a:prstGeom>
-          <a:noFill/>
-          <a:ln/>
-        </p:spPr>
-        <p:txBody>
-          <a:bodyPr wrap="square" rtlCol="0" anchor="ctr"/>
-          <a:lstStyle/>
-          <a:p>
-            <a:pPr algn="r" indent="0" marL="0">
-              <a:buNone/>
-            </a:pPr>
-            <a:r>
-              <a:rPr lang="en-US" sz="1400" dirty="0">
-                <a:solidFill>
-                  <a:srgbClr val="6B7280"/>
-                </a:solidFill>
-                <a:latin typeface="游ゴシック" pitchFamily="34" charset="0"/>
-                <a:ea typeface="游ゴシック" pitchFamily="34" charset="-122"/>
-                <a:cs typeface="游ゴシック" pitchFamily="34" charset="-120"/>
-              </a:rPr>
-              <a:t>リード</a:t>
-            </a:r>
-            <a:endParaRPr lang="en-US" sz="1400" dirty="0"/>
-          </a:p>
-        </p:txBody>
-      </p:sp>
-      <p:sp>
-        <p:nvSpPr>
-          <p:cNvPr id="5" name="Shape 3"/>
-          <p:cNvSpPr/>
-          <p:nvPr/>
-        </p:nvSpPr>
-        <p:spPr>
-          <a:xfrm>
-            <a:off x="2103120" y="1234440"/>
-            <a:ext cx="9537192" cy="594360"/>
-          </a:xfrm>
-          <a:prstGeom prst="rect">
-            <a:avLst/>
-          </a:prstGeom>
-          <a:solidFill>
-            <a:srgbClr val="E0E4EA"/>
-          </a:solidFill>
-          <a:ln/>
-        </p:spPr>
-      </p:sp>
-      <p:sp>
-        <p:nvSpPr>
-          <p:cNvPr id="6" name="Shape 4"/>
-          <p:cNvSpPr/>
-          <p:nvPr/>
-        </p:nvSpPr>
-        <p:spPr>
-          <a:xfrm>
-            <a:off x="2103120" y="1234440"/>
-            <a:ext cx="9537192" cy="594360"/>
-          </a:xfrm>
-          <a:prstGeom prst="rect">
-            <a:avLst/>
-          </a:prstGeom>
-          <a:solidFill>
-            <a:srgbClr val="DBEAFE"/>
-          </a:solidFill>
-          <a:ln/>
-        </p:spPr>
-      </p:sp>
-      <p:sp>
-        <p:nvSpPr>
-          <p:cNvPr id="7" name="Text 5"/>
-          <p:cNvSpPr/>
-          <p:nvPr/>
-        </p:nvSpPr>
-        <p:spPr>
-          <a:xfrm>
-            <a:off x="2286000" y="1234440"/>
-            <a:ext cx="9354312" cy="594360"/>
-          </a:xfrm>
-          <a:prstGeom prst="rect">
-            <a:avLst/>
-          </a:prstGeom>
-          <a:noFill/>
-          <a:ln/>
-        </p:spPr>
-        <p:txBody>
-          <a:bodyPr wrap="square" rtlCol="0" anchor="ctr"/>
-          <a:lstStyle/>
-          <a:p>
-            <a:pPr algn="l" indent="0" marL="0">
-              <a:buNone/>
-            </a:pPr>
-            <a:r>
-              <a:rPr lang="en-US" sz="1500" b="1" dirty="0">
-                <a:solidFill>
-                  <a:srgbClr val="1A1A2E"/>
-                </a:solidFill>
-                <a:latin typeface="游ゴシック" pitchFamily="34" charset="0"/>
-                <a:ea typeface="游ゴシック" pitchFamily="34" charset="-122"/>
-                <a:cs typeface="游ゴシック" pitchFamily="34" charset="-120"/>
-              </a:rPr>
-              <a:t>142件  </a:t>
-            </a:r>
-            <a:pPr algn="l" indent="0" marL="0">
-              <a:buNone/>
-            </a:pPr>
-            <a:r>
-              <a:rPr lang="en-US" sz="1200" b="1" dirty="0">
-                <a:solidFill>
-                  <a:srgbClr val="6B7280"/>
-                </a:solidFill>
-                <a:latin typeface="游ゴシック" pitchFamily="34" charset="0"/>
-                <a:ea typeface="游ゴシック" pitchFamily="34" charset="-122"/>
-                <a:cs typeface="游ゴシック" pitchFamily="34" charset="-120"/>
-              </a:rPr>
-              <a:t>前月 +18件</a:t>
-            </a:r>
-            <a:endParaRPr lang="en-US" sz="1500" dirty="0"/>
-          </a:p>
-        </p:txBody>
-      </p:sp>
-      <p:sp>
-        <p:nvSpPr>
-          <p:cNvPr id="8" name="Text 6"/>
-          <p:cNvSpPr/>
-          <p:nvPr/>
-        </p:nvSpPr>
-        <p:spPr>
-          <a:xfrm>
-            <a:off x="548640" y="2029968"/>
-            <a:ext cx="1463040" cy="594360"/>
-          </a:xfrm>
-          <a:prstGeom prst="rect">
-            <a:avLst/>
-          </a:prstGeom>
-          <a:noFill/>
-          <a:ln/>
-        </p:spPr>
-        <p:txBody>
-          <a:bodyPr wrap="square" rtlCol="0" anchor="ctr"/>
-          <a:lstStyle/>
-          <a:p>
-            <a:pPr algn="r" indent="0" marL="0">
-              <a:buNone/>
-            </a:pPr>
-            <a:r>
-              <a:rPr lang="en-US" sz="1400" dirty="0">
-                <a:solidFill>
-                  <a:srgbClr val="6B7280"/>
-                </a:solidFill>
-                <a:latin typeface="游ゴシック" pitchFamily="34" charset="0"/>
-                <a:ea typeface="游ゴシック" pitchFamily="34" charset="-122"/>
-                <a:cs typeface="游ゴシック" pitchFamily="34" charset="-120"/>
-              </a:rPr>
-              <a:t>商談中</a:t>
-            </a:r>
-            <a:endParaRPr lang="en-US" sz="1400" dirty="0"/>
-          </a:p>
-        </p:txBody>
-      </p:sp>
-      <p:sp>
-        <p:nvSpPr>
-          <p:cNvPr id="9" name="Shape 7"/>
-          <p:cNvSpPr/>
-          <p:nvPr/>
-        </p:nvSpPr>
-        <p:spPr>
-          <a:xfrm>
-            <a:off x="2103120" y="2029968"/>
-            <a:ext cx="9537192" cy="594360"/>
-          </a:xfrm>
-          <a:prstGeom prst="rect">
-            <a:avLst/>
-          </a:prstGeom>
-          <a:solidFill>
-            <a:srgbClr val="E0E4EA"/>
-          </a:solidFill>
-          <a:ln/>
-        </p:spPr>
-      </p:sp>
-      <p:sp>
-        <p:nvSpPr>
-          <p:cNvPr id="10" name="Shape 8"/>
-          <p:cNvSpPr/>
-          <p:nvPr/>
-        </p:nvSpPr>
-        <p:spPr>
-          <a:xfrm>
-            <a:off x="2103120" y="2029968"/>
-            <a:ext cx="7152894" cy="594360"/>
-          </a:xfrm>
-          <a:prstGeom prst="rect">
-            <a:avLst/>
-          </a:prstGeom>
-          <a:solidFill>
-            <a:srgbClr val="BFDBFE"/>
-          </a:solidFill>
-          <a:ln/>
-        </p:spPr>
-      </p:sp>
-      <p:sp>
-        <p:nvSpPr>
-          <p:cNvPr id="11" name="Text 9"/>
-          <p:cNvSpPr/>
-          <p:nvPr/>
-        </p:nvSpPr>
-        <p:spPr>
-          <a:xfrm>
-            <a:off x="2286000" y="2029968"/>
-            <a:ext cx="6970014" cy="594360"/>
-          </a:xfrm>
-          <a:prstGeom prst="rect">
-            <a:avLst/>
-          </a:prstGeom>
-          <a:noFill/>
-          <a:ln/>
-        </p:spPr>
-        <p:txBody>
-          <a:bodyPr wrap="square" rtlCol="0" anchor="ctr"/>
-          <a:lstStyle/>
-          <a:p>
-            <a:pPr algn="l" indent="0" marL="0">
-              <a:buNone/>
-            </a:pPr>
-            <a:r>
-              <a:rPr lang="en-US" sz="1500" b="1" dirty="0">
-                <a:solidFill>
-                  <a:srgbClr val="1A1A2E"/>
-                </a:solidFill>
-                <a:latin typeface="游ゴシック" pitchFamily="34" charset="0"/>
-                <a:ea typeface="游ゴシック" pitchFamily="34" charset="-122"/>
-                <a:cs typeface="游ゴシック" pitchFamily="34" charset="-120"/>
-              </a:rPr>
-              <a:t>68件  </a:t>
-            </a:r>
-            <a:pPr algn="l" indent="0" marL="0">
-              <a:buNone/>
-            </a:pPr>
-            <a:r>
-              <a:rPr lang="en-US" sz="1200" b="1" dirty="0">
-                <a:solidFill>
-                  <a:srgbClr val="6B7280"/>
-                </a:solidFill>
-                <a:latin typeface="游ゴシック" pitchFamily="34" charset="0"/>
-                <a:ea typeface="游ゴシック" pitchFamily="34" charset="-122"/>
-                <a:cs typeface="游ゴシック" pitchFamily="34" charset="-120"/>
-              </a:rPr>
-              <a:t>見込額 ¥156M</a:t>
-            </a:r>
-            <a:endParaRPr lang="en-US" sz="1500" dirty="0"/>
-          </a:p>
-        </p:txBody>
-      </p:sp>
-      <p:sp>
-        <p:nvSpPr>
-          <p:cNvPr id="12" name="Text 10"/>
-          <p:cNvSpPr/>
-          <p:nvPr/>
-        </p:nvSpPr>
-        <p:spPr>
-          <a:xfrm>
-            <a:off x="548640" y="2825496"/>
-            <a:ext cx="1463040" cy="594360"/>
-          </a:xfrm>
-          <a:prstGeom prst="rect">
-            <a:avLst/>
-          </a:prstGeom>
-          <a:noFill/>
-          <a:ln/>
-        </p:spPr>
-        <p:txBody>
-          <a:bodyPr wrap="square" rtlCol="0" anchor="ctr"/>
-          <a:lstStyle/>
-          <a:p>
-            <a:pPr algn="r" indent="0" marL="0">
-              <a:buNone/>
-            </a:pPr>
-            <a:r>
-              <a:rPr lang="en-US" sz="1400" dirty="0">
-                <a:solidFill>
-                  <a:srgbClr val="6B7280"/>
-                </a:solidFill>
-                <a:latin typeface="游ゴシック" pitchFamily="34" charset="0"/>
-                <a:ea typeface="游ゴシック" pitchFamily="34" charset="-122"/>
-                <a:cs typeface="游ゴシック" pitchFamily="34" charset="-120"/>
-              </a:rPr>
-              <a:t>提案済</a:t>
-            </a:r>
-            <a:endParaRPr lang="en-US" sz="1400" dirty="0"/>
-          </a:p>
-        </p:txBody>
-      </p:sp>
-      <p:sp>
-        <p:nvSpPr>
-          <p:cNvPr id="13" name="Shape 11"/>
-          <p:cNvSpPr/>
-          <p:nvPr/>
-        </p:nvSpPr>
-        <p:spPr>
-          <a:xfrm>
-            <a:off x="2103120" y="2825496"/>
-            <a:ext cx="9537192" cy="594360"/>
-          </a:xfrm>
-          <a:prstGeom prst="rect">
-            <a:avLst/>
-          </a:prstGeom>
-          <a:solidFill>
-            <a:srgbClr val="E0E4EA"/>
-          </a:solidFill>
-          <a:ln/>
-        </p:spPr>
-      </p:sp>
-      <p:sp>
-        <p:nvSpPr>
-          <p:cNvPr id="14" name="Shape 12"/>
-          <p:cNvSpPr/>
-          <p:nvPr/>
-        </p:nvSpPr>
-        <p:spPr>
-          <a:xfrm>
-            <a:off x="2103120" y="2825496"/>
-            <a:ext cx="4768596" cy="594360"/>
-          </a:xfrm>
-          <a:prstGeom prst="rect">
-            <a:avLst/>
-          </a:prstGeom>
-          <a:solidFill>
-            <a:srgbClr val="93C5FD"/>
-          </a:solidFill>
-          <a:ln/>
-        </p:spPr>
-      </p:sp>
-      <p:sp>
-        <p:nvSpPr>
-          <p:cNvPr id="15" name="Text 13"/>
-          <p:cNvSpPr/>
-          <p:nvPr/>
-        </p:nvSpPr>
-        <p:spPr>
-          <a:xfrm>
-            <a:off x="2286000" y="2825496"/>
-            <a:ext cx="4585716" cy="594360"/>
-          </a:xfrm>
-          <a:prstGeom prst="rect">
-            <a:avLst/>
-          </a:prstGeom>
-          <a:noFill/>
-          <a:ln/>
-        </p:spPr>
-        <p:txBody>
-          <a:bodyPr wrap="square" rtlCol="0" anchor="ctr"/>
-          <a:lstStyle/>
-          <a:p>
-            <a:pPr algn="l" indent="0" marL="0">
-              <a:buNone/>
-            </a:pPr>
-            <a:r>
-              <a:rPr lang="en-US" sz="1500" b="1" dirty="0">
-                <a:solidFill>
-                  <a:srgbClr val="1A1A2E"/>
-                </a:solidFill>
-                <a:latin typeface="游ゴシック" pitchFamily="34" charset="0"/>
-                <a:ea typeface="游ゴシック" pitchFamily="34" charset="-122"/>
-                <a:cs typeface="游ゴシック" pitchFamily="34" charset="-120"/>
-              </a:rPr>
-              <a:t>31件  </a:t>
-            </a:r>
-            <a:pPr algn="l" indent="0" marL="0">
-              <a:buNone/>
-            </a:pPr>
-            <a:r>
-              <a:rPr lang="en-US" sz="1200" b="1" dirty="0">
-                <a:solidFill>
-                  <a:srgbClr val="6B7280"/>
-                </a:solidFill>
-                <a:latin typeface="游ゴシック" pitchFamily="34" charset="0"/>
-                <a:ea typeface="游ゴシック" pitchFamily="34" charset="-122"/>
-                <a:cs typeface="游ゴシック" pitchFamily="34" charset="-120"/>
-              </a:rPr>
-              <a:t>見込額 ¥82M</a:t>
-            </a:r>
-            <a:endParaRPr lang="en-US" sz="1500" dirty="0"/>
-          </a:p>
-        </p:txBody>
-      </p:sp>
-      <p:sp>
-        <p:nvSpPr>
-          <p:cNvPr id="16" name="Text 14"/>
-          <p:cNvSpPr/>
-          <p:nvPr/>
-        </p:nvSpPr>
-        <p:spPr>
-          <a:xfrm>
-            <a:off x="548640" y="3621024"/>
-            <a:ext cx="1463040" cy="594360"/>
-          </a:xfrm>
-          <a:prstGeom prst="rect">
-            <a:avLst/>
-          </a:prstGeom>
-          <a:noFill/>
-          <a:ln/>
-        </p:spPr>
-        <p:txBody>
-          <a:bodyPr wrap="square" rtlCol="0" anchor="ctr"/>
-          <a:lstStyle/>
-          <a:p>
-            <a:pPr algn="r" indent="0" marL="0">
-              <a:buNone/>
-            </a:pPr>
-            <a:r>
-              <a:rPr lang="en-US" sz="1400" dirty="0">
-                <a:solidFill>
-                  <a:srgbClr val="6B7280"/>
-                </a:solidFill>
-                <a:latin typeface="游ゴシック" pitchFamily="34" charset="0"/>
-                <a:ea typeface="游ゴシック" pitchFamily="34" charset="-122"/>
-                <a:cs typeface="游ゴシック" pitchFamily="34" charset="-120"/>
-              </a:rPr>
-              <a:t>最終交渉</a:t>
-            </a:r>
-            <a:endParaRPr lang="en-US" sz="1400" dirty="0"/>
-          </a:p>
-        </p:txBody>
-      </p:sp>
-      <p:sp>
-        <p:nvSpPr>
-          <p:cNvPr id="17" name="Shape 15"/>
-          <p:cNvSpPr/>
-          <p:nvPr/>
-        </p:nvSpPr>
-        <p:spPr>
-          <a:xfrm>
-            <a:off x="2103120" y="3621024"/>
-            <a:ext cx="9537192" cy="594360"/>
-          </a:xfrm>
-          <a:prstGeom prst="rect">
-            <a:avLst/>
-          </a:prstGeom>
-          <a:solidFill>
-            <a:srgbClr val="E0E4EA"/>
-          </a:solidFill>
-          <a:ln/>
-        </p:spPr>
-      </p:sp>
-      <p:sp>
-        <p:nvSpPr>
-          <p:cNvPr id="18" name="Shape 16"/>
-          <p:cNvSpPr/>
-          <p:nvPr/>
-        </p:nvSpPr>
-        <p:spPr>
-          <a:xfrm>
-            <a:off x="2103120" y="3621024"/>
-            <a:ext cx="2861158" cy="594360"/>
-          </a:xfrm>
-          <a:prstGeom prst="rect">
-            <a:avLst/>
-          </a:prstGeom>
-          <a:solidFill>
-            <a:srgbClr val="2563EB"/>
-          </a:solidFill>
-          <a:ln/>
-        </p:spPr>
-      </p:sp>
-      <p:sp>
-        <p:nvSpPr>
-          <p:cNvPr id="19" name="Text 17"/>
-          <p:cNvSpPr/>
-          <p:nvPr/>
-        </p:nvSpPr>
-        <p:spPr>
-          <a:xfrm>
-            <a:off x="2286000" y="3621024"/>
-            <a:ext cx="2678278" cy="594360"/>
-          </a:xfrm>
-          <a:prstGeom prst="rect">
-            <a:avLst/>
-          </a:prstGeom>
-          <a:noFill/>
-          <a:ln/>
-        </p:spPr>
-        <p:txBody>
-          <a:bodyPr wrap="square" rtlCol="0" anchor="ctr"/>
-          <a:lstStyle/>
-          <a:p>
-            <a:pPr algn="l" indent="0" marL="0">
-              <a:buNone/>
-            </a:pPr>
-            <a:r>
-              <a:rPr lang="en-US" sz="1500" b="1" dirty="0">
-                <a:solidFill>
-                  <a:srgbClr val="1A1A2E"/>
-                </a:solidFill>
-                <a:latin typeface="游ゴシック" pitchFamily="34" charset="0"/>
-                <a:ea typeface="游ゴシック" pitchFamily="34" charset="-122"/>
-                <a:cs typeface="游ゴシック" pitchFamily="34" charset="-120"/>
-              </a:rPr>
-              <a:t>12件  </a:t>
-            </a:r>
-            <a:pPr algn="l" indent="0" marL="0">
-              <a:buNone/>
-            </a:pPr>
-            <a:r>
-              <a:rPr lang="en-US" sz="1200" b="1" dirty="0">
-                <a:solidFill>
-                  <a:srgbClr val="6B7280"/>
-                </a:solidFill>
-                <a:latin typeface="游ゴシック" pitchFamily="34" charset="0"/>
-                <a:ea typeface="游ゴシック" pitchFamily="34" charset="-122"/>
-                <a:cs typeface="游ゴシック" pitchFamily="34" charset="-120"/>
-              </a:rPr>
-              <a:t>¥38M</a:t>
-            </a:r>
-            <a:endParaRPr lang="en-US" sz="1500" dirty="0"/>
-          </a:p>
-        </p:txBody>
-      </p:sp>
-      <p:sp>
-        <p:nvSpPr>
-          <p:cNvPr id="20" name="Text 18"/>
-          <p:cNvSpPr/>
-          <p:nvPr/>
-        </p:nvSpPr>
-        <p:spPr>
-          <a:xfrm>
-            <a:off x="548640" y="4690872"/>
-            <a:ext cx="3697224" cy="566928"/>
-          </a:xfrm>
-          <a:prstGeom prst="rect">
-            <a:avLst/>
-          </a:prstGeom>
-          <a:noFill/>
-          <a:ln/>
-        </p:spPr>
-        <p:txBody>
-          <a:bodyPr wrap="square" rtlCol="0" anchor="ctr"/>
-          <a:lstStyle/>
-          <a:p>
-            <a:pPr algn="ctr" indent="0" marL="0">
-              <a:buNone/>
-            </a:pPr>
-            <a:r>
-              <a:rPr lang="en-US" sz="3200" b="1" dirty="0">
-                <a:solidFill>
-                  <a:srgbClr val="2563EB"/>
-                </a:solidFill>
-                <a:latin typeface="游ゴシック" pitchFamily="34" charset="0"/>
-                <a:ea typeface="游ゴシック" pitchFamily="34" charset="-122"/>
-                <a:cs typeface="游ゴシック" pitchFamily="34" charset="-120"/>
-              </a:rPr>
-              <a:t>47.9%</a:t>
-            </a:r>
-            <a:endParaRPr lang="en-US" sz="3200" dirty="0"/>
-          </a:p>
-        </p:txBody>
-      </p:sp>
-      <p:sp>
-        <p:nvSpPr>
-          <p:cNvPr id="21" name="Text 19"/>
-          <p:cNvSpPr/>
-          <p:nvPr/>
-        </p:nvSpPr>
-        <p:spPr>
-          <a:xfrm>
-            <a:off x="548640" y="5257800"/>
-            <a:ext cx="3697224" cy="320040"/>
-          </a:xfrm>
-          <a:prstGeom prst="rect">
-            <a:avLst/>
-          </a:prstGeom>
-          <a:noFill/>
-          <a:ln/>
-        </p:spPr>
-        <p:txBody>
-          <a:bodyPr wrap="square" rtlCol="0" anchor="t"/>
-          <a:lstStyle/>
-          <a:p>
-            <a:pPr algn="ctr" indent="0" marL="0">
-              <a:buNone/>
-            </a:pPr>
-            <a:r>
-              <a:rPr lang="en-US" sz="1200" dirty="0">
-                <a:solidFill>
-                  <a:srgbClr val="6B7280"/>
-                </a:solidFill>
-                <a:latin typeface="游ゴシック" pitchFamily="34" charset="0"/>
-                <a:ea typeface="游ゴシック" pitchFamily="34" charset="-122"/>
-                <a:cs typeface="游ゴシック" pitchFamily="34" charset="-120"/>
-              </a:rPr>
-              <a:t>リード→商談 転換率</a:t>
-            </a:r>
-            <a:endParaRPr lang="en-US" sz="1200" dirty="0"/>
-          </a:p>
-        </p:txBody>
-      </p:sp>
-      <p:sp>
-        <p:nvSpPr>
-          <p:cNvPr id="22" name="Text 20"/>
-          <p:cNvSpPr/>
-          <p:nvPr/>
-        </p:nvSpPr>
-        <p:spPr>
-          <a:xfrm>
-            <a:off x="4245864" y="4690872"/>
-            <a:ext cx="3697224" cy="566928"/>
-          </a:xfrm>
-          <a:prstGeom prst="rect">
-            <a:avLst/>
-          </a:prstGeom>
-          <a:noFill/>
-          <a:ln/>
-        </p:spPr>
-        <p:txBody>
-          <a:bodyPr wrap="square" rtlCol="0" anchor="ctr"/>
-          <a:lstStyle/>
-          <a:p>
-            <a:pPr algn="ctr" indent="0" marL="0">
-              <a:buNone/>
-            </a:pPr>
-            <a:r>
-              <a:rPr lang="en-US" sz="3200" b="1" dirty="0">
-                <a:solidFill>
-                  <a:srgbClr val="2563EB"/>
-                </a:solidFill>
-                <a:latin typeface="游ゴシック" pitchFamily="34" charset="0"/>
-                <a:ea typeface="游ゴシック" pitchFamily="34" charset="-122"/>
-                <a:cs typeface="游ゴシック" pitchFamily="34" charset="-120"/>
-              </a:rPr>
-              <a:t>33.8%</a:t>
-            </a:r>
-            <a:endParaRPr lang="en-US" sz="3200" dirty="0"/>
-          </a:p>
-        </p:txBody>
-      </p:sp>
-      <p:sp>
-        <p:nvSpPr>
-          <p:cNvPr id="23" name="Text 21"/>
-          <p:cNvSpPr/>
-          <p:nvPr/>
-        </p:nvSpPr>
-        <p:spPr>
-          <a:xfrm>
-            <a:off x="4245864" y="5257800"/>
-            <a:ext cx="3697224" cy="320040"/>
-          </a:xfrm>
-          <a:prstGeom prst="rect">
-            <a:avLst/>
-          </a:prstGeom>
-          <a:noFill/>
-          <a:ln/>
-        </p:spPr>
-        <p:txBody>
-          <a:bodyPr wrap="square" rtlCol="0" anchor="t"/>
-          <a:lstStyle/>
-          <a:p>
-            <a:pPr algn="ctr" indent="0" marL="0">
-              <a:buNone/>
-            </a:pPr>
-            <a:r>
-              <a:rPr lang="en-US" sz="1200" dirty="0">
-                <a:solidFill>
-                  <a:srgbClr val="6B7280"/>
-                </a:solidFill>
-                <a:latin typeface="游ゴシック" pitchFamily="34" charset="0"/>
-                <a:ea typeface="游ゴシック" pitchFamily="34" charset="-122"/>
-                <a:cs typeface="游ゴシック" pitchFamily="34" charset="-120"/>
-              </a:rPr>
-              <a:t>商談→受注 成約率</a:t>
-            </a:r>
-            <a:endParaRPr lang="en-US" sz="1200" dirty="0"/>
-          </a:p>
-        </p:txBody>
-      </p:sp>
-      <p:sp>
-        <p:nvSpPr>
-          <p:cNvPr id="24" name="Text 22"/>
-          <p:cNvSpPr/>
-          <p:nvPr/>
-        </p:nvSpPr>
-        <p:spPr>
-          <a:xfrm>
-            <a:off x="7943088" y="4690872"/>
-            <a:ext cx="3697224" cy="566928"/>
-          </a:xfrm>
-          <a:prstGeom prst="rect">
-            <a:avLst/>
-          </a:prstGeom>
-          <a:noFill/>
-          <a:ln/>
-        </p:spPr>
-        <p:txBody>
-          <a:bodyPr wrap="square" rtlCol="0" anchor="ctr"/>
-          <a:lstStyle/>
-          <a:p>
-            <a:pPr algn="ctr" indent="0" marL="0">
-              <a:buNone/>
-            </a:pPr>
-            <a:r>
-              <a:rPr lang="en-US" sz="3200" b="1" dirty="0">
-                <a:solidFill>
-                  <a:srgbClr val="2563EB"/>
-                </a:solidFill>
-                <a:latin typeface="游ゴシック" pitchFamily="34" charset="0"/>
-                <a:ea typeface="游ゴシック" pitchFamily="34" charset="-122"/>
-                <a:cs typeface="游ゴシック" pitchFamily="34" charset="-120"/>
-              </a:rPr>
-              <a:t>42日</a:t>
-            </a:r>
-            <a:endParaRPr lang="en-US" sz="3200" dirty="0"/>
-          </a:p>
-        </p:txBody>
-      </p:sp>
-      <p:sp>
-        <p:nvSpPr>
-          <p:cNvPr id="25" name="Text 23"/>
-          <p:cNvSpPr/>
-          <p:nvPr/>
-        </p:nvSpPr>
-        <p:spPr>
-          <a:xfrm>
-            <a:off x="7943088" y="5257800"/>
-            <a:ext cx="3697224" cy="320040"/>
-          </a:xfrm>
-          <a:prstGeom prst="rect">
-            <a:avLst/>
-          </a:prstGeom>
-          <a:noFill/>
-          <a:ln/>
-        </p:spPr>
-        <p:txBody>
-          <a:bodyPr wrap="square" rtlCol="0" anchor="t"/>
-          <a:lstStyle/>
-          <a:p>
-            <a:pPr algn="ctr" indent="0" marL="0">
-              <a:buNone/>
-            </a:pPr>
-            <a:r>
-              <a:rPr lang="en-US" sz="1200" dirty="0">
-                <a:solidFill>
-                  <a:srgbClr val="6B7280"/>
-                </a:solidFill>
-                <a:latin typeface="游ゴシック" pitchFamily="34" charset="0"/>
-                <a:ea typeface="游ゴシック" pitchFamily="34" charset="-122"/>
-                <a:cs typeface="游ゴシック" pitchFamily="34" charset="-120"/>
-              </a:rPr>
-              <a:t>平均リードタイム</a:t>
-            </a:r>
-            <a:endParaRPr lang="en-US" sz="1200" dirty="0"/>
-          </a:p>
-        </p:txBody>
-      </p:sp>
-    </p:spTree>
-  </p:cSld>
-  <p:clrMapOvr>
-    <a:masterClrMapping/>
-  </p:clrMapOvr>
-</p:sld>
-</file>
-
-<file path=ppt/slides/slide5.xml><?xml version="1.0" encoding="utf-8"?>
-<p:sld xmlns:a="http://schemas.openxmlformats.org/drawingml/2006/main" xmlns:r="http://schemas.openxmlformats.org/officeDocument/2006/relationships" xmlns:p="http://schemas.openxmlformats.org/presentationml/2006/main">
-  <p:cSld name="Slide 5">
-    <p:bg>
-      <p:bgPr>
-        <a:solidFill>
-          <a:srgbClr val="FFFFFF"/>
-        </a:solidFill>
-      </p:bgPr>
-    </p:bg>
-    <p:spTree>
-      <p:nvGrpSpPr>
-        <p:cNvPr id="1" name=""/>
-        <p:cNvGrpSpPr/>
-        <p:nvPr/>
-      </p:nvGrpSpPr>
-      <p:grpSpPr>
-        <a:xfrm>
-          <a:off x="0" y="0"/>
-          <a:ext cx="0" cy="0"/>
-          <a:chOff x="0" y="0"/>
-          <a:chExt cx="0" cy="0"/>
-        </a:xfrm>
-      </p:grpSpPr>
-      <p:sp>
-        <p:nvSpPr>
-          <p:cNvPr id="2" name="Text 0"/>
-          <p:cNvSpPr/>
-          <p:nvPr/>
-        </p:nvSpPr>
-        <p:spPr>
-          <a:xfrm>
-            <a:off x="548640" y="274320"/>
-            <a:ext cx="11091672" cy="594360"/>
-          </a:xfrm>
-          <a:prstGeom prst="rect">
-            <a:avLst/>
-          </a:prstGeom>
-          <a:noFill/>
-          <a:ln/>
-        </p:spPr>
-        <p:txBody>
-          <a:bodyPr wrap="square" rtlCol="0" anchor="t"/>
-          <a:lstStyle/>
-          <a:p>
-            <a:pPr algn="l" indent="0" marL="0">
-              <a:buNone/>
-            </a:pPr>
-            <a:r>
-              <a:rPr lang="en-US" sz="2600" b="1" dirty="0">
-                <a:solidFill>
-                  <a:srgbClr val="1A1A2E"/>
-                </a:solidFill>
-                <a:latin typeface="游ゴシック" pitchFamily="34" charset="0"/>
-                <a:ea typeface="游ゴシック" pitchFamily="34" charset="-122"/>
-                <a:cs typeface="游ゴシック" pitchFamily="34" charset="-120"/>
-              </a:rPr>
-              <a:t>4月度 アクションプラン</a:t>
-            </a:r>
-            <a:endParaRPr lang="en-US" sz="2600" dirty="0"/>
-          </a:p>
-        </p:txBody>
-      </p:sp>
-      <p:sp>
-        <p:nvSpPr>
-          <p:cNvPr id="3" name="Shape 1"/>
-          <p:cNvSpPr/>
-          <p:nvPr/>
-        </p:nvSpPr>
-        <p:spPr>
-          <a:xfrm>
-            <a:off x="548640" y="960120"/>
-            <a:ext cx="11091672" cy="36576"/>
-          </a:xfrm>
-          <a:prstGeom prst="rect">
-            <a:avLst/>
-          </a:prstGeom>
-          <a:solidFill>
-            <a:srgbClr val="2563EB"/>
-          </a:solidFill>
-          <a:ln/>
-        </p:spPr>
-      </p:sp>
-      <p:sp>
-        <p:nvSpPr>
-          <p:cNvPr id="4" name="Text 2"/>
-          <p:cNvSpPr/>
-          <p:nvPr/>
-        </p:nvSpPr>
-        <p:spPr>
-          <a:xfrm>
-            <a:off x="548640" y="1143000"/>
-            <a:ext cx="5362956" cy="365760"/>
-          </a:xfrm>
-          <a:prstGeom prst="rect">
-            <a:avLst/>
-          </a:prstGeom>
-          <a:noFill/>
-          <a:ln/>
-        </p:spPr>
-        <p:txBody>
-          <a:bodyPr wrap="square" rtlCol="0" anchor="t"/>
-          <a:lstStyle/>
-          <a:p>
-            <a:pPr algn="l" indent="0" marL="0">
-              <a:buNone/>
-            </a:pPr>
-            <a:r>
-              <a:rPr lang="en-US" sz="1500" b="1" dirty="0">
-                <a:solidFill>
-                  <a:srgbClr val="2563EB"/>
-                </a:solidFill>
-                <a:latin typeface="游ゴシック" pitchFamily="34" charset="0"/>
-                <a:ea typeface="游ゴシック" pitchFamily="34" charset="-122"/>
-                <a:cs typeface="游ゴシック" pitchFamily="34" charset="-120"/>
-              </a:rPr>
-              <a:t>重点施策</a:t>
-            </a:r>
-            <a:endParaRPr lang="en-US" sz="1500" dirty="0"/>
-          </a:p>
-        </p:txBody>
-      </p:sp>
-      <p:sp>
-        <p:nvSpPr>
-          <p:cNvPr id="5" name="Shape 3"/>
-          <p:cNvSpPr/>
-          <p:nvPr/>
-        </p:nvSpPr>
-        <p:spPr>
-          <a:xfrm>
-            <a:off x="548640" y="1947672"/>
-            <a:ext cx="237744" cy="237744"/>
-          </a:xfrm>
-          <a:prstGeom prst="rect">
-            <a:avLst/>
-          </a:prstGeom>
-          <a:solidFill>
-            <a:srgbClr val="2563EB"/>
-          </a:solidFill>
-          <a:ln/>
-        </p:spPr>
-      </p:sp>
-      <p:sp>
-        <p:nvSpPr>
-          <p:cNvPr id="6" name="Text 4"/>
-          <p:cNvSpPr/>
-          <p:nvPr/>
-        </p:nvSpPr>
-        <p:spPr>
-          <a:xfrm>
-            <a:off x="548640" y="1901952"/>
-            <a:ext cx="237744" cy="329184"/>
-          </a:xfrm>
-          <a:prstGeom prst="rect">
-            <a:avLst/>
-          </a:prstGeom>
-          <a:noFill/>
-          <a:ln/>
-        </p:spPr>
-        <p:txBody>
-          <a:bodyPr wrap="square" rtlCol="0" anchor="ctr"/>
-          <a:lstStyle/>
-          <a:p>
-            <a:pPr algn="ctr" indent="0" marL="0">
-              <a:buNone/>
-            </a:pPr>
-            <a:r>
-              <a:rPr lang="en-US" sz="1200" b="1" dirty="0">
-                <a:solidFill>
-                  <a:srgbClr val="FFFFFF"/>
-                </a:solidFill>
-                <a:latin typeface="游ゴシック" pitchFamily="34" charset="0"/>
-                <a:ea typeface="游ゴシック" pitchFamily="34" charset="-122"/>
-                <a:cs typeface="游ゴシック" pitchFamily="34" charset="-120"/>
-              </a:rPr>
-              <a:t>✓</a:t>
-            </a:r>
-            <a:endParaRPr lang="en-US" sz="1200" dirty="0"/>
-          </a:p>
-        </p:txBody>
-      </p:sp>
-      <p:sp>
-        <p:nvSpPr>
-          <p:cNvPr id="7" name="Text 5"/>
-          <p:cNvSpPr/>
-          <p:nvPr/>
-        </p:nvSpPr>
-        <p:spPr>
-          <a:xfrm>
-            <a:off x="914400" y="1645920"/>
-            <a:ext cx="4997196" cy="1234440"/>
-          </a:xfrm>
-          <a:prstGeom prst="rect">
-            <a:avLst/>
-          </a:prstGeom>
-          <a:noFill/>
-          <a:ln/>
-        </p:spPr>
-        <p:txBody>
-          <a:bodyPr wrap="square" rtlCol="0" anchor="ctr"/>
-          <a:lstStyle/>
-          <a:p>
-            <a:pPr algn="l" indent="0" marL="0">
-              <a:lnSpc>
-                <a:spcPct val="140000"/>
-              </a:lnSpc>
-              <a:buNone/>
-            </a:pPr>
-            <a:r>
-              <a:rPr lang="en-US" sz="1500" b="1" dirty="0">
-                <a:solidFill>
-                  <a:srgbClr val="1A1A2E"/>
-                </a:solidFill>
-                <a:latin typeface="游ゴシック" pitchFamily="34" charset="0"/>
-                <a:ea typeface="游ゴシック" pitchFamily="34" charset="-122"/>
-                <a:cs typeface="游ゴシック" pitchFamily="34" charset="-120"/>
-              </a:rPr>
-              <a:t>最終交渉中の12件を月内クロージング
-</a:t>
-            </a:r>
-            <a:endParaRPr lang="en-US" sz="1500" dirty="0"/>
-          </a:p>
-          <a:p>
-            <a:pPr algn="l" indent="0" marL="0">
-              <a:lnSpc>
-                <a:spcPct val="140000"/>
-              </a:lnSpc>
-              <a:buNone/>
-            </a:pPr>
-            <a:r>
-              <a:rPr lang="en-US" sz="1100" b="1" dirty="0">
-                <a:solidFill>
-                  <a:srgbClr val="6B7280"/>
-                </a:solidFill>
-                <a:latin typeface="游ゴシック" pitchFamily="34" charset="0"/>
-                <a:ea typeface="游ゴシック" pitchFamily="34" charset="-122"/>
-                <a:cs typeface="游ゴシック" pitchFamily="34" charset="-120"/>
-              </a:rPr>
-              <a:t>担当: 各チームリーダー / 期限: 4/25</a:t>
-            </a:r>
-            <a:endParaRPr lang="en-US" sz="1500" dirty="0"/>
-          </a:p>
-        </p:txBody>
-      </p:sp>
-      <p:sp>
-        <p:nvSpPr>
-          <p:cNvPr id="8" name="Shape 6"/>
-          <p:cNvSpPr/>
-          <p:nvPr/>
-        </p:nvSpPr>
-        <p:spPr>
-          <a:xfrm>
-            <a:off x="548640" y="2935224"/>
-            <a:ext cx="5362956" cy="10973"/>
-          </a:xfrm>
-          <a:prstGeom prst="rect">
-            <a:avLst/>
-          </a:prstGeom>
-          <a:solidFill>
-            <a:srgbClr val="E0E4EA"/>
-          </a:solidFill>
-          <a:ln/>
-        </p:spPr>
-      </p:sp>
-      <p:sp>
-        <p:nvSpPr>
-          <p:cNvPr id="9" name="Shape 7"/>
-          <p:cNvSpPr/>
-          <p:nvPr/>
-        </p:nvSpPr>
-        <p:spPr>
-          <a:xfrm>
-            <a:off x="548640" y="3291840"/>
-            <a:ext cx="237744" cy="237744"/>
-          </a:xfrm>
-          <a:prstGeom prst="rect">
-            <a:avLst/>
-          </a:prstGeom>
-          <a:solidFill>
-            <a:srgbClr val="2563EB"/>
-          </a:solidFill>
-          <a:ln/>
-        </p:spPr>
-      </p:sp>
-      <p:sp>
-        <p:nvSpPr>
-          <p:cNvPr id="10" name="Text 8"/>
-          <p:cNvSpPr/>
-          <p:nvPr/>
-        </p:nvSpPr>
-        <p:spPr>
-          <a:xfrm>
-            <a:off x="548640" y="3246120"/>
-            <a:ext cx="237744" cy="329184"/>
-          </a:xfrm>
-          <a:prstGeom prst="rect">
-            <a:avLst/>
-          </a:prstGeom>
-          <a:noFill/>
-          <a:ln/>
-        </p:spPr>
-        <p:txBody>
-          <a:bodyPr wrap="square" rtlCol="0" anchor="ctr"/>
-          <a:lstStyle/>
-          <a:p>
-            <a:pPr algn="ctr" indent="0" marL="0">
-              <a:buNone/>
-            </a:pPr>
-            <a:r>
-              <a:rPr lang="en-US" sz="1200" b="1" dirty="0">
-                <a:solidFill>
-                  <a:srgbClr val="FFFFFF"/>
-                </a:solidFill>
-                <a:latin typeface="游ゴシック" pitchFamily="34" charset="0"/>
-                <a:ea typeface="游ゴシック" pitchFamily="34" charset="-122"/>
-                <a:cs typeface="游ゴシック" pitchFamily="34" charset="-120"/>
-              </a:rPr>
-              <a:t>✓</a:t>
-            </a:r>
-            <a:endParaRPr lang="en-US" sz="1200" dirty="0"/>
-          </a:p>
-        </p:txBody>
-      </p:sp>
-      <p:sp>
-        <p:nvSpPr>
-          <p:cNvPr id="11" name="Text 9"/>
-          <p:cNvSpPr/>
-          <p:nvPr/>
-        </p:nvSpPr>
-        <p:spPr>
-          <a:xfrm>
-            <a:off x="914400" y="2990088"/>
-            <a:ext cx="4997196" cy="1234440"/>
-          </a:xfrm>
-          <a:prstGeom prst="rect">
-            <a:avLst/>
-          </a:prstGeom>
-          <a:noFill/>
-          <a:ln/>
-        </p:spPr>
-        <p:txBody>
-          <a:bodyPr wrap="square" rtlCol="0" anchor="ctr"/>
-          <a:lstStyle/>
-          <a:p>
-            <a:pPr algn="l" indent="0" marL="0">
-              <a:lnSpc>
-                <a:spcPct val="140000"/>
-              </a:lnSpc>
-              <a:buNone/>
-            </a:pPr>
-            <a:r>
-              <a:rPr lang="en-US" sz="1500" b="1" dirty="0">
-                <a:solidFill>
-                  <a:srgbClr val="1A1A2E"/>
-                </a:solidFill>
-                <a:latin typeface="游ゴシック" pitchFamily="34" charset="0"/>
-                <a:ea typeface="游ゴシック" pitchFamily="34" charset="-122"/>
-                <a:cs typeface="游ゴシック" pitchFamily="34" charset="-120"/>
-              </a:rPr>
-              <a:t>新規リード獲得キャンペーン実施
-</a:t>
-            </a:r>
-            <a:endParaRPr lang="en-US" sz="1500" dirty="0"/>
-          </a:p>
-          <a:p>
-            <a:pPr algn="l" indent="0" marL="0">
-              <a:lnSpc>
-                <a:spcPct val="140000"/>
-              </a:lnSpc>
-              <a:buNone/>
-            </a:pPr>
-            <a:r>
-              <a:rPr lang="en-US" sz="1100" b="1" dirty="0">
-                <a:solidFill>
-                  <a:srgbClr val="6B7280"/>
-                </a:solidFill>
-                <a:latin typeface="游ゴシック" pitchFamily="34" charset="0"/>
-                <a:ea typeface="游ゴシック" pitchFamily="34" charset="-122"/>
-                <a:cs typeface="游ゴシック" pitchFamily="34" charset="-120"/>
-              </a:rPr>
-              <a:t>担当: マーケ連携 / 期限: 4/15開始</a:t>
-            </a:r>
-            <a:endParaRPr lang="en-US" sz="1500" dirty="0"/>
-          </a:p>
-        </p:txBody>
-      </p:sp>
-      <p:sp>
-        <p:nvSpPr>
-          <p:cNvPr id="12" name="Shape 10"/>
-          <p:cNvSpPr/>
-          <p:nvPr/>
-        </p:nvSpPr>
-        <p:spPr>
-          <a:xfrm>
-            <a:off x="548640" y="4279392"/>
-            <a:ext cx="5362956" cy="10973"/>
-          </a:xfrm>
-          <a:prstGeom prst="rect">
-            <a:avLst/>
-          </a:prstGeom>
-          <a:solidFill>
-            <a:srgbClr val="E0E4EA"/>
-          </a:solidFill>
-          <a:ln/>
-        </p:spPr>
-      </p:sp>
-      <p:sp>
-        <p:nvSpPr>
-          <p:cNvPr id="13" name="Shape 11"/>
-          <p:cNvSpPr/>
-          <p:nvPr/>
-        </p:nvSpPr>
-        <p:spPr>
-          <a:xfrm>
-            <a:off x="548640" y="4636008"/>
-            <a:ext cx="237744" cy="237744"/>
-          </a:xfrm>
-          <a:prstGeom prst="rect">
-            <a:avLst/>
-          </a:prstGeom>
-          <a:solidFill>
-            <a:srgbClr val="2563EB"/>
-          </a:solidFill>
-          <a:ln/>
-        </p:spPr>
-      </p:sp>
-      <p:sp>
-        <p:nvSpPr>
-          <p:cNvPr id="14" name="Text 12"/>
-          <p:cNvSpPr/>
-          <p:nvPr/>
-        </p:nvSpPr>
-        <p:spPr>
-          <a:xfrm>
-            <a:off x="548640" y="4590288"/>
-            <a:ext cx="237744" cy="329184"/>
-          </a:xfrm>
-          <a:prstGeom prst="rect">
-            <a:avLst/>
-          </a:prstGeom>
-          <a:noFill/>
-          <a:ln/>
-        </p:spPr>
-        <p:txBody>
-          <a:bodyPr wrap="square" rtlCol="0" anchor="ctr"/>
-          <a:lstStyle/>
-          <a:p>
-            <a:pPr algn="ctr" indent="0" marL="0">
-              <a:buNone/>
-            </a:pPr>
-            <a:r>
-              <a:rPr lang="en-US" sz="1200" b="1" dirty="0">
-                <a:solidFill>
-                  <a:srgbClr val="FFFFFF"/>
-                </a:solidFill>
-                <a:latin typeface="游ゴシック" pitchFamily="34" charset="0"/>
-                <a:ea typeface="游ゴシック" pitchFamily="34" charset="-122"/>
-                <a:cs typeface="游ゴシック" pitchFamily="34" charset="-120"/>
-              </a:rPr>
-              <a:t>✓</a:t>
-            </a:r>
-            <a:endParaRPr lang="en-US" sz="1200" dirty="0"/>
-          </a:p>
-        </p:txBody>
-      </p:sp>
-      <p:sp>
-        <p:nvSpPr>
-          <p:cNvPr id="15" name="Text 13"/>
-          <p:cNvSpPr/>
-          <p:nvPr/>
-        </p:nvSpPr>
-        <p:spPr>
-          <a:xfrm>
-            <a:off x="914400" y="4334256"/>
-            <a:ext cx="4997196" cy="1234440"/>
-          </a:xfrm>
-          <a:prstGeom prst="rect">
-            <a:avLst/>
-          </a:prstGeom>
-          <a:noFill/>
-          <a:ln/>
-        </p:spPr>
-        <p:txBody>
-          <a:bodyPr wrap="square" rtlCol="0" anchor="ctr"/>
-          <a:lstStyle/>
-          <a:p>
-            <a:pPr algn="l" indent="0" marL="0">
-              <a:lnSpc>
-                <a:spcPct val="140000"/>
-              </a:lnSpc>
-              <a:buNone/>
-            </a:pPr>
-            <a:r>
-              <a:rPr lang="en-US" sz="1500" b="1" dirty="0">
-                <a:solidFill>
-                  <a:srgbClr val="1A1A2E"/>
-                </a:solidFill>
-                <a:latin typeface="游ゴシック" pitchFamily="34" charset="0"/>
-                <a:ea typeface="游ゴシック" pitchFamily="34" charset="-122"/>
-                <a:cs typeface="游ゴシック" pitchFamily="34" charset="-120"/>
-              </a:rPr>
-              <a:t>第3営業部の底上げ施策
-</a:t>
-            </a:r>
-            <a:endParaRPr lang="en-US" sz="1500" dirty="0"/>
-          </a:p>
-          <a:p>
-            <a:pPr algn="l" indent="0" marL="0">
-              <a:lnSpc>
-                <a:spcPct val="140000"/>
-              </a:lnSpc>
-              <a:buNone/>
-            </a:pPr>
-            <a:r>
-              <a:rPr lang="en-US" sz="1100" b="1" dirty="0">
-                <a:solidFill>
-                  <a:srgbClr val="6B7280"/>
-                </a:solidFill>
-                <a:latin typeface="游ゴシック" pitchFamily="34" charset="0"/>
-                <a:ea typeface="游ゴシック" pitchFamily="34" charset="-122"/>
-                <a:cs typeface="游ゴシック" pitchFamily="34" charset="-120"/>
-              </a:rPr>
-              <a:t>担当: 佐藤 / 週次1on1で進捗管理</a:t>
-            </a:r>
-            <a:endParaRPr lang="en-US" sz="1500" dirty="0"/>
-          </a:p>
-        </p:txBody>
-      </p:sp>
-      <p:sp>
-        <p:nvSpPr>
-          <p:cNvPr id="16" name="Shape 14"/>
-          <p:cNvSpPr/>
-          <p:nvPr/>
-        </p:nvSpPr>
-        <p:spPr>
-          <a:xfrm>
-            <a:off x="548640" y="5623560"/>
-            <a:ext cx="5362956" cy="10973"/>
-          </a:xfrm>
-          <a:prstGeom prst="rect">
-            <a:avLst/>
-          </a:prstGeom>
-          <a:solidFill>
-            <a:srgbClr val="E0E4EA"/>
-          </a:solidFill>
-          <a:ln/>
-        </p:spPr>
-      </p:sp>
-      <p:sp>
-        <p:nvSpPr>
-          <p:cNvPr id="17" name="Text 15"/>
-          <p:cNvSpPr/>
-          <p:nvPr/>
-        </p:nvSpPr>
-        <p:spPr>
-          <a:xfrm>
-            <a:off x="6277356" y="1143000"/>
-            <a:ext cx="5362956" cy="365760"/>
-          </a:xfrm>
-          <a:prstGeom prst="rect">
-            <a:avLst/>
-          </a:prstGeom>
-          <a:noFill/>
-          <a:ln/>
-        </p:spPr>
-        <p:txBody>
-          <a:bodyPr wrap="square" rtlCol="0" anchor="t"/>
-          <a:lstStyle/>
-          <a:p>
-            <a:pPr algn="l" indent="0" marL="0">
-              <a:buNone/>
-            </a:pPr>
-            <a:r>
-              <a:rPr lang="en-US" sz="1500" b="1" dirty="0">
-                <a:solidFill>
-                  <a:srgbClr val="2563EB"/>
-                </a:solidFill>
-                <a:latin typeface="游ゴシック" pitchFamily="34" charset="0"/>
-                <a:ea typeface="游ゴシック" pitchFamily="34" charset="-122"/>
-                <a:cs typeface="游ゴシック" pitchFamily="34" charset="-120"/>
-              </a:rPr>
-              <a:t>4月度 目標</a:t>
-            </a:r>
-            <a:endParaRPr lang="en-US" sz="1500" dirty="0"/>
-          </a:p>
-        </p:txBody>
-      </p:sp>
-      <p:sp>
-        <p:nvSpPr>
-          <p:cNvPr id="18" name="Shape 16"/>
-          <p:cNvSpPr/>
-          <p:nvPr/>
-        </p:nvSpPr>
-        <p:spPr>
-          <a:xfrm>
-            <a:off x="6277356" y="1645920"/>
-            <a:ext cx="5362956" cy="822960"/>
-          </a:xfrm>
-          <a:prstGeom prst="rect">
-            <a:avLst/>
-          </a:prstGeom>
-          <a:solidFill>
-            <a:srgbClr val="F5F7FA"/>
-          </a:solidFill>
-          <a:ln/>
-        </p:spPr>
-      </p:sp>
-      <p:sp>
-        <p:nvSpPr>
-          <p:cNvPr id="19" name="Text 17"/>
-          <p:cNvSpPr/>
-          <p:nvPr/>
-        </p:nvSpPr>
-        <p:spPr>
-          <a:xfrm>
-            <a:off x="6551676" y="1645920"/>
-            <a:ext cx="2949626" cy="822960"/>
-          </a:xfrm>
-          <a:prstGeom prst="rect">
-            <a:avLst/>
-          </a:prstGeom>
-          <a:noFill/>
-          <a:ln/>
-        </p:spPr>
-        <p:txBody>
-          <a:bodyPr wrap="square" rtlCol="0" anchor="ctr"/>
-          <a:lstStyle/>
-          <a:p>
-            <a:pPr algn="l" indent="0" marL="0">
-              <a:buNone/>
-            </a:pPr>
-            <a:r>
-              <a:rPr lang="en-US" sz="1600" b="1" dirty="0">
-                <a:solidFill>
-                  <a:srgbClr val="1A1A2E"/>
-                </a:solidFill>
-                <a:latin typeface="游ゴシック" pitchFamily="34" charset="0"/>
-                <a:ea typeface="游ゴシック" pitchFamily="34" charset="-122"/>
-                <a:cs typeface="游ゴシック" pitchFamily="34" charset="-120"/>
-              </a:rPr>
-              <a:t>売上目標</a:t>
-            </a:r>
-            <a:endParaRPr lang="en-US" sz="1600" dirty="0"/>
-          </a:p>
-        </p:txBody>
-      </p:sp>
-      <p:sp>
-        <p:nvSpPr>
-          <p:cNvPr id="20" name="Text 18"/>
-          <p:cNvSpPr/>
-          <p:nvPr/>
-        </p:nvSpPr>
-        <p:spPr>
-          <a:xfrm>
-            <a:off x="6551676" y="1645920"/>
-            <a:ext cx="4997196" cy="822960"/>
-          </a:xfrm>
-          <a:prstGeom prst="rect">
-            <a:avLst/>
-          </a:prstGeom>
-          <a:noFill/>
-          <a:ln/>
-        </p:spPr>
-        <p:txBody>
-          <a:bodyPr wrap="square" rtlCol="0" anchor="ctr"/>
-          <a:lstStyle/>
-          <a:p>
-            <a:pPr algn="r" indent="0" marL="0">
-              <a:buNone/>
-            </a:pPr>
-            <a:r>
-              <a:rPr lang="en-US" sz="2600" b="1" dirty="0">
-                <a:solidFill>
-                  <a:srgbClr val="2563EB"/>
-                </a:solidFill>
-                <a:latin typeface="游ゴシック" pitchFamily="34" charset="0"/>
-                <a:ea typeface="游ゴシック" pitchFamily="34" charset="-122"/>
-                <a:cs typeface="游ゴシック" pitchFamily="34" charset="-120"/>
-              </a:rPr>
-              <a:t>¥52M</a:t>
-            </a:r>
-            <a:endParaRPr lang="en-US" sz="2600" dirty="0"/>
-          </a:p>
-        </p:txBody>
-      </p:sp>
-      <p:sp>
-        <p:nvSpPr>
-          <p:cNvPr id="21" name="Shape 19"/>
-          <p:cNvSpPr/>
-          <p:nvPr/>
-        </p:nvSpPr>
-        <p:spPr>
-          <a:xfrm>
-            <a:off x="6277356" y="2633472"/>
-            <a:ext cx="5362956" cy="822960"/>
-          </a:xfrm>
-          <a:prstGeom prst="rect">
-            <a:avLst/>
-          </a:prstGeom>
-          <a:solidFill>
-            <a:srgbClr val="F5F7FA"/>
-          </a:solidFill>
-          <a:ln/>
-        </p:spPr>
-      </p:sp>
-      <p:sp>
-        <p:nvSpPr>
-          <p:cNvPr id="22" name="Text 20"/>
-          <p:cNvSpPr/>
-          <p:nvPr/>
-        </p:nvSpPr>
-        <p:spPr>
-          <a:xfrm>
-            <a:off x="6551676" y="2633472"/>
-            <a:ext cx="2949626" cy="822960"/>
-          </a:xfrm>
-          <a:prstGeom prst="rect">
-            <a:avLst/>
-          </a:prstGeom>
-          <a:noFill/>
-          <a:ln/>
-        </p:spPr>
-        <p:txBody>
-          <a:bodyPr wrap="square" rtlCol="0" anchor="ctr"/>
-          <a:lstStyle/>
-          <a:p>
-            <a:pPr algn="l" indent="0" marL="0">
-              <a:buNone/>
-            </a:pPr>
-            <a:r>
-              <a:rPr lang="en-US" sz="1600" b="1" dirty="0">
-                <a:solidFill>
-                  <a:srgbClr val="1A1A2E"/>
-                </a:solidFill>
-                <a:latin typeface="游ゴシック" pitchFamily="34" charset="0"/>
-                <a:ea typeface="游ゴシック" pitchFamily="34" charset="-122"/>
-                <a:cs typeface="游ゴシック" pitchFamily="34" charset="-120"/>
-              </a:rPr>
-              <a:t>新規受注</a:t>
-            </a:r>
-            <a:endParaRPr lang="en-US" sz="1600" dirty="0"/>
-          </a:p>
-        </p:txBody>
-      </p:sp>
-      <p:sp>
-        <p:nvSpPr>
-          <p:cNvPr id="23" name="Text 21"/>
-          <p:cNvSpPr/>
-          <p:nvPr/>
-        </p:nvSpPr>
-        <p:spPr>
-          <a:xfrm>
-            <a:off x="6551676" y="2633472"/>
-            <a:ext cx="4997196" cy="822960"/>
-          </a:xfrm>
-          <a:prstGeom prst="rect">
-            <a:avLst/>
-          </a:prstGeom>
-          <a:noFill/>
-          <a:ln/>
-        </p:spPr>
-        <p:txBody>
-          <a:bodyPr wrap="square" rtlCol="0" anchor="ctr"/>
-          <a:lstStyle/>
-          <a:p>
-            <a:pPr algn="r" indent="0" marL="0">
-              <a:buNone/>
-            </a:pPr>
-            <a:r>
-              <a:rPr lang="en-US" sz="2600" b="1" dirty="0">
-                <a:solidFill>
-                  <a:srgbClr val="2563EB"/>
-                </a:solidFill>
-                <a:latin typeface="游ゴシック" pitchFamily="34" charset="0"/>
-                <a:ea typeface="游ゴシック" pitchFamily="34" charset="-122"/>
-                <a:cs typeface="游ゴシック" pitchFamily="34" charset="-120"/>
-              </a:rPr>
-              <a:t>25件</a:t>
-            </a:r>
-            <a:endParaRPr lang="en-US" sz="2600" dirty="0"/>
-          </a:p>
-        </p:txBody>
-      </p:sp>
-      <p:sp>
-        <p:nvSpPr>
-          <p:cNvPr id="24" name="Shape 22"/>
-          <p:cNvSpPr/>
-          <p:nvPr/>
-        </p:nvSpPr>
-        <p:spPr>
-          <a:xfrm>
-            <a:off x="6277356" y="3621024"/>
-            <a:ext cx="5362956" cy="822960"/>
-          </a:xfrm>
-          <a:prstGeom prst="rect">
-            <a:avLst/>
-          </a:prstGeom>
-          <a:solidFill>
-            <a:srgbClr val="F5F7FA"/>
-          </a:solidFill>
-          <a:ln/>
-        </p:spPr>
-      </p:sp>
-      <p:sp>
-        <p:nvSpPr>
-          <p:cNvPr id="25" name="Text 23"/>
-          <p:cNvSpPr/>
-          <p:nvPr/>
-        </p:nvSpPr>
-        <p:spPr>
-          <a:xfrm>
-            <a:off x="6551676" y="3621024"/>
-            <a:ext cx="2949626" cy="822960"/>
-          </a:xfrm>
-          <a:prstGeom prst="rect">
-            <a:avLst/>
-          </a:prstGeom>
-          <a:noFill/>
-          <a:ln/>
-        </p:spPr>
-        <p:txBody>
-          <a:bodyPr wrap="square" rtlCol="0" anchor="ctr"/>
-          <a:lstStyle/>
-          <a:p>
-            <a:pPr algn="l" indent="0" marL="0">
-              <a:buNone/>
-            </a:pPr>
-            <a:r>
-              <a:rPr lang="en-US" sz="1600" b="1" dirty="0">
-                <a:solidFill>
-                  <a:srgbClr val="1A1A2E"/>
-                </a:solidFill>
-                <a:latin typeface="游ゴシック" pitchFamily="34" charset="0"/>
-                <a:ea typeface="游ゴシック" pitchFamily="34" charset="-122"/>
-                <a:cs typeface="游ゴシック" pitchFamily="34" charset="-120"/>
-              </a:rPr>
-              <a:t>成約率</a:t>
-            </a:r>
-            <a:endParaRPr lang="en-US" sz="1600" dirty="0"/>
-          </a:p>
-        </p:txBody>
-      </p:sp>
-      <p:sp>
-        <p:nvSpPr>
-          <p:cNvPr id="26" name="Text 24"/>
-          <p:cNvSpPr/>
-          <p:nvPr/>
-        </p:nvSpPr>
-        <p:spPr>
-          <a:xfrm>
-            <a:off x="6551676" y="3621024"/>
-            <a:ext cx="4997196" cy="822960"/>
-          </a:xfrm>
-          <a:prstGeom prst="rect">
-            <a:avLst/>
-          </a:prstGeom>
-          <a:noFill/>
-          <a:ln/>
-        </p:spPr>
-        <p:txBody>
-          <a:bodyPr wrap="square" rtlCol="0" anchor="ctr"/>
-          <a:lstStyle/>
-          <a:p>
-            <a:pPr algn="r" indent="0" marL="0">
-              <a:buNone/>
-            </a:pPr>
-            <a:r>
-              <a:rPr lang="en-US" sz="2600" b="1" dirty="0">
-                <a:solidFill>
-                  <a:srgbClr val="2563EB"/>
-                </a:solidFill>
-                <a:latin typeface="游ゴシック" pitchFamily="34" charset="0"/>
-                <a:ea typeface="游ゴシック" pitchFamily="34" charset="-122"/>
-                <a:cs typeface="游ゴシック" pitchFamily="34" charset="-120"/>
-              </a:rPr>
-              <a:t>35%↑</a:t>
-            </a:r>
-            <a:endParaRPr lang="en-US" sz="2600" dirty="0"/>
-          </a:p>
-        </p:txBody>
-      </p:sp>
-      <p:sp>
-        <p:nvSpPr>
-          <p:cNvPr id="27" name="Shape 25"/>
-          <p:cNvSpPr/>
-          <p:nvPr/>
-        </p:nvSpPr>
-        <p:spPr>
-          <a:xfrm>
-            <a:off x="6277356" y="4700016"/>
-            <a:ext cx="5362956" cy="658368"/>
-          </a:xfrm>
-          <a:prstGeom prst="rect">
-            <a:avLst/>
-          </a:prstGeom>
-          <a:solidFill>
-            <a:srgbClr val="EEF2F7"/>
-          </a:solidFill>
-          <a:ln/>
-        </p:spPr>
-      </p:sp>
-      <p:sp>
-        <p:nvSpPr>
-          <p:cNvPr id="28" name="Shape 26"/>
-          <p:cNvSpPr/>
-          <p:nvPr/>
-        </p:nvSpPr>
-        <p:spPr>
-          <a:xfrm>
-            <a:off x="6277356" y="4700016"/>
-            <a:ext cx="5362956" cy="13716"/>
-          </a:xfrm>
-          <a:prstGeom prst="rect">
-            <a:avLst/>
-          </a:prstGeom>
-          <a:solidFill>
-            <a:srgbClr val="2563EB"/>
-          </a:solidFill>
-          <a:ln/>
-        </p:spPr>
-      </p:sp>
-      <p:sp>
-        <p:nvSpPr>
-          <p:cNvPr id="29" name="Text 27"/>
-          <p:cNvSpPr/>
-          <p:nvPr/>
-        </p:nvSpPr>
-        <p:spPr>
-          <a:xfrm>
-            <a:off x="6460236" y="4700016"/>
-            <a:ext cx="5088636" cy="658368"/>
-          </a:xfrm>
-          <a:prstGeom prst="rect">
-            <a:avLst/>
-          </a:prstGeom>
-          <a:noFill/>
-          <a:ln/>
-        </p:spPr>
-        <p:txBody>
-          <a:bodyPr wrap="square" rtlCol="0" anchor="ctr"/>
-          <a:lstStyle/>
-          <a:p>
-            <a:pPr algn="ctr" indent="0" marL="0">
-              <a:buNone/>
-            </a:pPr>
-            <a:r>
-              <a:rPr lang="en-US" sz="1400" dirty="0">
-                <a:solidFill>
-                  <a:srgbClr val="1A1A2E"/>
-                </a:solidFill>
-                <a:latin typeface="游ゴシック" pitchFamily="34" charset="0"/>
-                <a:ea typeface="游ゴシック" pitchFamily="34" charset="-122"/>
-                <a:cs typeface="游ゴシック" pitchFamily="34" charset="-120"/>
-              </a:rPr>
-              <a:t>Q1累計  ¥138.2M　（通期目標進捗 69.1%）</a:t>
-            </a:r>
-            <a:endParaRPr lang="en-US" sz="1400" dirty="0"/>
-          </a:p>
-        </p:txBody>
-      </p:sp>
-    </p:spTree>
-  </p:cSld>
-  <p:clrMapOvr>
-    <a:masterClrMapping/>
-  </p:clrMapOvr>
-</p:sld>
-</file>
-
-<file path=ppt/slides/slide6.xml><?xml version="1.0" encoding="utf-8"?>
-<p:sld xmlns:a="http://schemas.openxmlformats.org/drawingml/2006/main" xmlns:r="http://schemas.openxmlformats.org/officeDocument/2006/relationships" xmlns:p="http://schemas.openxmlformats.org/presentationml/2006/main">
-  <p:cSld name="Slide 6">
     <p:bg>
       <p:bgPr>
         <a:solidFill>

</xml_diff>

<commit_message>
Add TOC and section placeholder slides (8 slides total)
Slide 2: agenda with ①–⑤ items, ① highlighted in accent blue
Slides 4–8: placeholder section dividers for each agenda item
(content to be filled in later per user instructions)

https://claude.ai/code/session_013LUtg8kZ6SCk9upzYYqLj7
</commit_message>
<xml_diff>
--- a/slides/exports/sales-meeting.pptx
+++ b/slides/exports/sales-meeting.pptx
@@ -7,9 +7,15 @@
   <p:sldIdLst>
     <p:sldId id="256" r:id="rId2"/>
     <p:sldId id="257" r:id="rId3"/>
+    <p:sldId id="258" r:id="rId4"/>
+    <p:sldId id="259" r:id="rId5"/>
+    <p:sldId id="260" r:id="rId6"/>
+    <p:sldId id="261" r:id="rId7"/>
+    <p:sldId id="262" r:id="rId8"/>
+    <p:sldId id="263" r:id="rId9"/>
   </p:sldIdLst>
   <p:notesMasterIdLst>
-    <p:notesMasterId r:id="rId4"/>
+    <p:notesMasterId r:id="rId10"/>
   </p:notesMasterIdLst>
   <p:sldSz cx="12192000" cy="6858000"/>
   <p:notesSz cx="6858000" cy="12192000"/>
@@ -615,6 +621,534 @@
             <a:fld id="{F7021451-1387-4CA6-816F-3879F97B5CBC}" type="slidenum">
               <a:rPr lang="en-US"/>
               <a:t>2</a:t>
+            </a:fld>
+            <a:endParaRPr lang="en-US"/>
+          </a:p>
+        </p:txBody>
+      </p:sp>
+    </p:spTree>
+    <p:extLst>
+      <p:ext uri="{BB962C8B-B14F-4D97-AF65-F5344CB8AC3E}">
+        <p14:creationId xmlns:p14="http://schemas.microsoft.com/office/powerpoint/2010/main" val="1024086991"/>
+      </p:ext>
+    </p:extLst>
+  </p:cSld>
+  <p:clrMapOvr>
+    <a:masterClrMapping/>
+  </p:clrMapOvr>
+</p:notes>
+</file>
+
+<file path=ppt/notesSlides/notesSlide3.xml><?xml version="1.0" encoding="utf-8"?>
+<p:notes xmlns:a="http://schemas.openxmlformats.org/drawingml/2006/main" xmlns:r="http://schemas.openxmlformats.org/officeDocument/2006/relationships" xmlns:p="http://schemas.openxmlformats.org/presentationml/2006/main">
+  <p:cSld>
+    <p:spTree>
+      <p:nvGrpSpPr>
+        <p:cNvPr id="1" name=""/>
+        <p:cNvGrpSpPr/>
+        <p:nvPr/>
+      </p:nvGrpSpPr>
+      <p:grpSpPr>
+        <a:xfrm>
+          <a:off x="0" y="0"/>
+          <a:ext cx="0" cy="0"/>
+          <a:chOff x="0" y="0"/>
+          <a:chExt cx="0" cy="0"/>
+        </a:xfrm>
+      </p:grpSpPr>
+      <p:sp>
+        <p:nvSpPr>
+          <p:cNvPr id="2" name="Slide Image Placeholder 1"/>
+          <p:cNvSpPr>
+            <a:spLocks noGrp="1" noRot="1" noChangeAspect="1"/>
+          </p:cNvSpPr>
+          <p:nvPr>
+            <p:ph type="sldImg"/>
+          </p:nvPr>
+        </p:nvSpPr>
+        <p:spPr/>
+      </p:sp>
+      <p:sp>
+        <p:nvSpPr>
+          <p:cNvPr id="3" name="Notes Placeholder 2"/>
+          <p:cNvSpPr>
+            <a:spLocks noGrp="1"/>
+          </p:cNvSpPr>
+          <p:nvPr>
+            <p:ph type="body" idx="1"/>
+          </p:nvPr>
+        </p:nvSpPr>
+        <p:spPr/>
+        <p:txBody>
+          <a:bodyPr/>
+          <a:lstStyle/>
+          <a:p>
+            <a:r>
+              <a:rPr lang="en-US" dirty="0"/>
+              <a:t/>
+            </a:r>
+            <a:endParaRPr lang="en-US" dirty="0"/>
+          </a:p>
+        </p:txBody>
+      </p:sp>
+      <p:sp>
+        <p:nvSpPr>
+          <p:cNvPr id="4" name="Slide Number Placeholder 3"/>
+          <p:cNvSpPr>
+            <a:spLocks noGrp="1"/>
+          </p:cNvSpPr>
+          <p:nvPr>
+            <p:ph type="sldNum" sz="quarter" idx="10"/>
+          </p:nvPr>
+        </p:nvSpPr>
+        <p:spPr/>
+        <p:txBody>
+          <a:bodyPr/>
+          <a:lstStyle/>
+          <a:p>
+            <a:fld id="{F7021451-1387-4CA6-816F-3879F97B5CBC}" type="slidenum">
+              <a:rPr lang="en-US"/>
+              <a:t>3</a:t>
+            </a:fld>
+            <a:endParaRPr lang="en-US"/>
+          </a:p>
+        </p:txBody>
+      </p:sp>
+    </p:spTree>
+    <p:extLst>
+      <p:ext uri="{BB962C8B-B14F-4D97-AF65-F5344CB8AC3E}">
+        <p14:creationId xmlns:p14="http://schemas.microsoft.com/office/powerpoint/2010/main" val="1024086991"/>
+      </p:ext>
+    </p:extLst>
+  </p:cSld>
+  <p:clrMapOvr>
+    <a:masterClrMapping/>
+  </p:clrMapOvr>
+</p:notes>
+</file>
+
+<file path=ppt/notesSlides/notesSlide4.xml><?xml version="1.0" encoding="utf-8"?>
+<p:notes xmlns:a="http://schemas.openxmlformats.org/drawingml/2006/main" xmlns:r="http://schemas.openxmlformats.org/officeDocument/2006/relationships" xmlns:p="http://schemas.openxmlformats.org/presentationml/2006/main">
+  <p:cSld>
+    <p:spTree>
+      <p:nvGrpSpPr>
+        <p:cNvPr id="1" name=""/>
+        <p:cNvGrpSpPr/>
+        <p:nvPr/>
+      </p:nvGrpSpPr>
+      <p:grpSpPr>
+        <a:xfrm>
+          <a:off x="0" y="0"/>
+          <a:ext cx="0" cy="0"/>
+          <a:chOff x="0" y="0"/>
+          <a:chExt cx="0" cy="0"/>
+        </a:xfrm>
+      </p:grpSpPr>
+      <p:sp>
+        <p:nvSpPr>
+          <p:cNvPr id="2" name="Slide Image Placeholder 1"/>
+          <p:cNvSpPr>
+            <a:spLocks noGrp="1" noRot="1" noChangeAspect="1"/>
+          </p:cNvSpPr>
+          <p:nvPr>
+            <p:ph type="sldImg"/>
+          </p:nvPr>
+        </p:nvSpPr>
+        <p:spPr/>
+      </p:sp>
+      <p:sp>
+        <p:nvSpPr>
+          <p:cNvPr id="3" name="Notes Placeholder 2"/>
+          <p:cNvSpPr>
+            <a:spLocks noGrp="1"/>
+          </p:cNvSpPr>
+          <p:nvPr>
+            <p:ph type="body" idx="1"/>
+          </p:nvPr>
+        </p:nvSpPr>
+        <p:spPr/>
+        <p:txBody>
+          <a:bodyPr/>
+          <a:lstStyle/>
+          <a:p>
+            <a:r>
+              <a:rPr lang="en-US" dirty="0"/>
+              <a:t/>
+            </a:r>
+            <a:endParaRPr lang="en-US" dirty="0"/>
+          </a:p>
+        </p:txBody>
+      </p:sp>
+      <p:sp>
+        <p:nvSpPr>
+          <p:cNvPr id="4" name="Slide Number Placeholder 3"/>
+          <p:cNvSpPr>
+            <a:spLocks noGrp="1"/>
+          </p:cNvSpPr>
+          <p:nvPr>
+            <p:ph type="sldNum" sz="quarter" idx="10"/>
+          </p:nvPr>
+        </p:nvSpPr>
+        <p:spPr/>
+        <p:txBody>
+          <a:bodyPr/>
+          <a:lstStyle/>
+          <a:p>
+            <a:fld id="{F7021451-1387-4CA6-816F-3879F97B5CBC}" type="slidenum">
+              <a:rPr lang="en-US"/>
+              <a:t>4</a:t>
+            </a:fld>
+            <a:endParaRPr lang="en-US"/>
+          </a:p>
+        </p:txBody>
+      </p:sp>
+    </p:spTree>
+    <p:extLst>
+      <p:ext uri="{BB962C8B-B14F-4D97-AF65-F5344CB8AC3E}">
+        <p14:creationId xmlns:p14="http://schemas.microsoft.com/office/powerpoint/2010/main" val="1024086991"/>
+      </p:ext>
+    </p:extLst>
+  </p:cSld>
+  <p:clrMapOvr>
+    <a:masterClrMapping/>
+  </p:clrMapOvr>
+</p:notes>
+</file>
+
+<file path=ppt/notesSlides/notesSlide5.xml><?xml version="1.0" encoding="utf-8"?>
+<p:notes xmlns:a="http://schemas.openxmlformats.org/drawingml/2006/main" xmlns:r="http://schemas.openxmlformats.org/officeDocument/2006/relationships" xmlns:p="http://schemas.openxmlformats.org/presentationml/2006/main">
+  <p:cSld>
+    <p:spTree>
+      <p:nvGrpSpPr>
+        <p:cNvPr id="1" name=""/>
+        <p:cNvGrpSpPr/>
+        <p:nvPr/>
+      </p:nvGrpSpPr>
+      <p:grpSpPr>
+        <a:xfrm>
+          <a:off x="0" y="0"/>
+          <a:ext cx="0" cy="0"/>
+          <a:chOff x="0" y="0"/>
+          <a:chExt cx="0" cy="0"/>
+        </a:xfrm>
+      </p:grpSpPr>
+      <p:sp>
+        <p:nvSpPr>
+          <p:cNvPr id="2" name="Slide Image Placeholder 1"/>
+          <p:cNvSpPr>
+            <a:spLocks noGrp="1" noRot="1" noChangeAspect="1"/>
+          </p:cNvSpPr>
+          <p:nvPr>
+            <p:ph type="sldImg"/>
+          </p:nvPr>
+        </p:nvSpPr>
+        <p:spPr/>
+      </p:sp>
+      <p:sp>
+        <p:nvSpPr>
+          <p:cNvPr id="3" name="Notes Placeholder 2"/>
+          <p:cNvSpPr>
+            <a:spLocks noGrp="1"/>
+          </p:cNvSpPr>
+          <p:nvPr>
+            <p:ph type="body" idx="1"/>
+          </p:nvPr>
+        </p:nvSpPr>
+        <p:spPr/>
+        <p:txBody>
+          <a:bodyPr/>
+          <a:lstStyle/>
+          <a:p>
+            <a:r>
+              <a:rPr lang="en-US" dirty="0"/>
+              <a:t/>
+            </a:r>
+            <a:endParaRPr lang="en-US" dirty="0"/>
+          </a:p>
+        </p:txBody>
+      </p:sp>
+      <p:sp>
+        <p:nvSpPr>
+          <p:cNvPr id="4" name="Slide Number Placeholder 3"/>
+          <p:cNvSpPr>
+            <a:spLocks noGrp="1"/>
+          </p:cNvSpPr>
+          <p:nvPr>
+            <p:ph type="sldNum" sz="quarter" idx="10"/>
+          </p:nvPr>
+        </p:nvSpPr>
+        <p:spPr/>
+        <p:txBody>
+          <a:bodyPr/>
+          <a:lstStyle/>
+          <a:p>
+            <a:fld id="{F7021451-1387-4CA6-816F-3879F97B5CBC}" type="slidenum">
+              <a:rPr lang="en-US"/>
+              <a:t>5</a:t>
+            </a:fld>
+            <a:endParaRPr lang="en-US"/>
+          </a:p>
+        </p:txBody>
+      </p:sp>
+    </p:spTree>
+    <p:extLst>
+      <p:ext uri="{BB962C8B-B14F-4D97-AF65-F5344CB8AC3E}">
+        <p14:creationId xmlns:p14="http://schemas.microsoft.com/office/powerpoint/2010/main" val="1024086991"/>
+      </p:ext>
+    </p:extLst>
+  </p:cSld>
+  <p:clrMapOvr>
+    <a:masterClrMapping/>
+  </p:clrMapOvr>
+</p:notes>
+</file>
+
+<file path=ppt/notesSlides/notesSlide6.xml><?xml version="1.0" encoding="utf-8"?>
+<p:notes xmlns:a="http://schemas.openxmlformats.org/drawingml/2006/main" xmlns:r="http://schemas.openxmlformats.org/officeDocument/2006/relationships" xmlns:p="http://schemas.openxmlformats.org/presentationml/2006/main">
+  <p:cSld>
+    <p:spTree>
+      <p:nvGrpSpPr>
+        <p:cNvPr id="1" name=""/>
+        <p:cNvGrpSpPr/>
+        <p:nvPr/>
+      </p:nvGrpSpPr>
+      <p:grpSpPr>
+        <a:xfrm>
+          <a:off x="0" y="0"/>
+          <a:ext cx="0" cy="0"/>
+          <a:chOff x="0" y="0"/>
+          <a:chExt cx="0" cy="0"/>
+        </a:xfrm>
+      </p:grpSpPr>
+      <p:sp>
+        <p:nvSpPr>
+          <p:cNvPr id="2" name="Slide Image Placeholder 1"/>
+          <p:cNvSpPr>
+            <a:spLocks noGrp="1" noRot="1" noChangeAspect="1"/>
+          </p:cNvSpPr>
+          <p:nvPr>
+            <p:ph type="sldImg"/>
+          </p:nvPr>
+        </p:nvSpPr>
+        <p:spPr/>
+      </p:sp>
+      <p:sp>
+        <p:nvSpPr>
+          <p:cNvPr id="3" name="Notes Placeholder 2"/>
+          <p:cNvSpPr>
+            <a:spLocks noGrp="1"/>
+          </p:cNvSpPr>
+          <p:nvPr>
+            <p:ph type="body" idx="1"/>
+          </p:nvPr>
+        </p:nvSpPr>
+        <p:spPr/>
+        <p:txBody>
+          <a:bodyPr/>
+          <a:lstStyle/>
+          <a:p>
+            <a:r>
+              <a:rPr lang="en-US" dirty="0"/>
+              <a:t/>
+            </a:r>
+            <a:endParaRPr lang="en-US" dirty="0"/>
+          </a:p>
+        </p:txBody>
+      </p:sp>
+      <p:sp>
+        <p:nvSpPr>
+          <p:cNvPr id="4" name="Slide Number Placeholder 3"/>
+          <p:cNvSpPr>
+            <a:spLocks noGrp="1"/>
+          </p:cNvSpPr>
+          <p:nvPr>
+            <p:ph type="sldNum" sz="quarter" idx="10"/>
+          </p:nvPr>
+        </p:nvSpPr>
+        <p:spPr/>
+        <p:txBody>
+          <a:bodyPr/>
+          <a:lstStyle/>
+          <a:p>
+            <a:fld id="{F7021451-1387-4CA6-816F-3879F97B5CBC}" type="slidenum">
+              <a:rPr lang="en-US"/>
+              <a:t>6</a:t>
+            </a:fld>
+            <a:endParaRPr lang="en-US"/>
+          </a:p>
+        </p:txBody>
+      </p:sp>
+    </p:spTree>
+    <p:extLst>
+      <p:ext uri="{BB962C8B-B14F-4D97-AF65-F5344CB8AC3E}">
+        <p14:creationId xmlns:p14="http://schemas.microsoft.com/office/powerpoint/2010/main" val="1024086991"/>
+      </p:ext>
+    </p:extLst>
+  </p:cSld>
+  <p:clrMapOvr>
+    <a:masterClrMapping/>
+  </p:clrMapOvr>
+</p:notes>
+</file>
+
+<file path=ppt/notesSlides/notesSlide7.xml><?xml version="1.0" encoding="utf-8"?>
+<p:notes xmlns:a="http://schemas.openxmlformats.org/drawingml/2006/main" xmlns:r="http://schemas.openxmlformats.org/officeDocument/2006/relationships" xmlns:p="http://schemas.openxmlformats.org/presentationml/2006/main">
+  <p:cSld>
+    <p:spTree>
+      <p:nvGrpSpPr>
+        <p:cNvPr id="1" name=""/>
+        <p:cNvGrpSpPr/>
+        <p:nvPr/>
+      </p:nvGrpSpPr>
+      <p:grpSpPr>
+        <a:xfrm>
+          <a:off x="0" y="0"/>
+          <a:ext cx="0" cy="0"/>
+          <a:chOff x="0" y="0"/>
+          <a:chExt cx="0" cy="0"/>
+        </a:xfrm>
+      </p:grpSpPr>
+      <p:sp>
+        <p:nvSpPr>
+          <p:cNvPr id="2" name="Slide Image Placeholder 1"/>
+          <p:cNvSpPr>
+            <a:spLocks noGrp="1" noRot="1" noChangeAspect="1"/>
+          </p:cNvSpPr>
+          <p:nvPr>
+            <p:ph type="sldImg"/>
+          </p:nvPr>
+        </p:nvSpPr>
+        <p:spPr/>
+      </p:sp>
+      <p:sp>
+        <p:nvSpPr>
+          <p:cNvPr id="3" name="Notes Placeholder 2"/>
+          <p:cNvSpPr>
+            <a:spLocks noGrp="1"/>
+          </p:cNvSpPr>
+          <p:nvPr>
+            <p:ph type="body" idx="1"/>
+          </p:nvPr>
+        </p:nvSpPr>
+        <p:spPr/>
+        <p:txBody>
+          <a:bodyPr/>
+          <a:lstStyle/>
+          <a:p>
+            <a:r>
+              <a:rPr lang="en-US" dirty="0"/>
+              <a:t/>
+            </a:r>
+            <a:endParaRPr lang="en-US" dirty="0"/>
+          </a:p>
+        </p:txBody>
+      </p:sp>
+      <p:sp>
+        <p:nvSpPr>
+          <p:cNvPr id="4" name="Slide Number Placeholder 3"/>
+          <p:cNvSpPr>
+            <a:spLocks noGrp="1"/>
+          </p:cNvSpPr>
+          <p:nvPr>
+            <p:ph type="sldNum" sz="quarter" idx="10"/>
+          </p:nvPr>
+        </p:nvSpPr>
+        <p:spPr/>
+        <p:txBody>
+          <a:bodyPr/>
+          <a:lstStyle/>
+          <a:p>
+            <a:fld id="{F7021451-1387-4CA6-816F-3879F97B5CBC}" type="slidenum">
+              <a:rPr lang="en-US"/>
+              <a:t>7</a:t>
+            </a:fld>
+            <a:endParaRPr lang="en-US"/>
+          </a:p>
+        </p:txBody>
+      </p:sp>
+    </p:spTree>
+    <p:extLst>
+      <p:ext uri="{BB962C8B-B14F-4D97-AF65-F5344CB8AC3E}">
+        <p14:creationId xmlns:p14="http://schemas.microsoft.com/office/powerpoint/2010/main" val="1024086991"/>
+      </p:ext>
+    </p:extLst>
+  </p:cSld>
+  <p:clrMapOvr>
+    <a:masterClrMapping/>
+  </p:clrMapOvr>
+</p:notes>
+</file>
+
+<file path=ppt/notesSlides/notesSlide8.xml><?xml version="1.0" encoding="utf-8"?>
+<p:notes xmlns:a="http://schemas.openxmlformats.org/drawingml/2006/main" xmlns:r="http://schemas.openxmlformats.org/officeDocument/2006/relationships" xmlns:p="http://schemas.openxmlformats.org/presentationml/2006/main">
+  <p:cSld>
+    <p:spTree>
+      <p:nvGrpSpPr>
+        <p:cNvPr id="1" name=""/>
+        <p:cNvGrpSpPr/>
+        <p:nvPr/>
+      </p:nvGrpSpPr>
+      <p:grpSpPr>
+        <a:xfrm>
+          <a:off x="0" y="0"/>
+          <a:ext cx="0" cy="0"/>
+          <a:chOff x="0" y="0"/>
+          <a:chExt cx="0" cy="0"/>
+        </a:xfrm>
+      </p:grpSpPr>
+      <p:sp>
+        <p:nvSpPr>
+          <p:cNvPr id="2" name="Slide Image Placeholder 1"/>
+          <p:cNvSpPr>
+            <a:spLocks noGrp="1" noRot="1" noChangeAspect="1"/>
+          </p:cNvSpPr>
+          <p:nvPr>
+            <p:ph type="sldImg"/>
+          </p:nvPr>
+        </p:nvSpPr>
+        <p:spPr/>
+      </p:sp>
+      <p:sp>
+        <p:nvSpPr>
+          <p:cNvPr id="3" name="Notes Placeholder 2"/>
+          <p:cNvSpPr>
+            <a:spLocks noGrp="1"/>
+          </p:cNvSpPr>
+          <p:nvPr>
+            <p:ph type="body" idx="1"/>
+          </p:nvPr>
+        </p:nvSpPr>
+        <p:spPr/>
+        <p:txBody>
+          <a:bodyPr/>
+          <a:lstStyle/>
+          <a:p>
+            <a:r>
+              <a:rPr lang="en-US" dirty="0"/>
+              <a:t/>
+            </a:r>
+            <a:endParaRPr lang="en-US" dirty="0"/>
+          </a:p>
+        </p:txBody>
+      </p:sp>
+      <p:sp>
+        <p:nvSpPr>
+          <p:cNvPr id="4" name="Slide Number Placeholder 3"/>
+          <p:cNvSpPr>
+            <a:spLocks noGrp="1"/>
+          </p:cNvSpPr>
+          <p:nvPr>
+            <p:ph type="sldNum" sz="quarter" idx="10"/>
+          </p:nvPr>
+        </p:nvSpPr>
+        <p:spPr/>
+        <p:txBody>
+          <a:bodyPr/>
+          <a:lstStyle/>
+          <a:p>
+            <a:fld id="{F7021451-1387-4CA6-816F-3879F97B5CBC}" type="slidenum">
+              <a:rPr lang="en-US"/>
+              <a:t>8</a:t>
             </a:fld>
             <a:endParaRPr lang="en-US"/>
           </a:p>
@@ -1245,7 +1779,7 @@
                 <a:ea typeface="游ゴシック" pitchFamily="34" charset="-122"/>
                 <a:cs typeface="游ゴシック" pitchFamily="34" charset="-120"/>
               </a:rPr>
-              <a:t>4月度 売上ランキング　（単位：円）</a:t>
+              <a:t>アジェンダ</a:t>
             </a:r>
             <a:endParaRPr lang="en-US" sz="2600" dirty="0"/>
           </a:p>
@@ -1279,6 +1813,687 @@
         </p:nvSpPr>
         <p:spPr>
           <a:xfrm>
+            <a:off x="548640" y="1280160"/>
+            <a:ext cx="11091672" cy="530352"/>
+          </a:xfrm>
+          <a:prstGeom prst="rect">
+            <a:avLst/>
+          </a:prstGeom>
+          <a:solidFill>
+            <a:srgbClr val="DBEAFE"/>
+          </a:solidFill>
+          <a:ln/>
+        </p:spPr>
+      </p:sp>
+      <p:sp>
+        <p:nvSpPr>
+          <p:cNvPr id="5" name="Shape 3"/>
+          <p:cNvSpPr/>
+          <p:nvPr/>
+        </p:nvSpPr>
+        <p:spPr>
+          <a:xfrm>
+            <a:off x="548640" y="1280160"/>
+            <a:ext cx="41148" cy="530352"/>
+          </a:xfrm>
+          <a:prstGeom prst="rect">
+            <a:avLst/>
+          </a:prstGeom>
+          <a:solidFill>
+            <a:srgbClr val="2563EB"/>
+          </a:solidFill>
+          <a:ln/>
+        </p:spPr>
+      </p:sp>
+      <p:sp>
+        <p:nvSpPr>
+          <p:cNvPr id="6" name="Text 4"/>
+          <p:cNvSpPr/>
+          <p:nvPr/>
+        </p:nvSpPr>
+        <p:spPr>
+          <a:xfrm>
+            <a:off x="658368" y="1280160"/>
+            <a:ext cx="502920" cy="530352"/>
+          </a:xfrm>
+          <a:prstGeom prst="rect">
+            <a:avLst/>
+          </a:prstGeom>
+          <a:noFill/>
+          <a:ln/>
+        </p:spPr>
+        <p:txBody>
+          <a:bodyPr wrap="square" rtlCol="0" anchor="ctr"/>
+          <a:lstStyle/>
+          <a:p>
+            <a:pPr algn="ctr" indent="0" marL="0">
+              <a:buNone/>
+            </a:pPr>
+            <a:r>
+              <a:rPr lang="en-US" sz="1800" b="1" dirty="0">
+                <a:solidFill>
+                  <a:srgbClr val="2563EB"/>
+                </a:solidFill>
+                <a:latin typeface="游ゴシック" pitchFamily="34" charset="0"/>
+                <a:ea typeface="游ゴシック" pitchFamily="34" charset="-122"/>
+                <a:cs typeface="游ゴシック" pitchFamily="34" charset="-120"/>
+              </a:rPr>
+              <a:t>①</a:t>
+            </a:r>
+            <a:endParaRPr lang="en-US" sz="1800" dirty="0"/>
+          </a:p>
+        </p:txBody>
+      </p:sp>
+      <p:sp>
+        <p:nvSpPr>
+          <p:cNvPr id="7" name="Text 5"/>
+          <p:cNvSpPr/>
+          <p:nvPr/>
+        </p:nvSpPr>
+        <p:spPr>
+          <a:xfrm>
+            <a:off x="1207008" y="1280160"/>
+            <a:ext cx="10341864" cy="530352"/>
+          </a:xfrm>
+          <a:prstGeom prst="rect">
+            <a:avLst/>
+          </a:prstGeom>
+          <a:noFill/>
+          <a:ln/>
+        </p:spPr>
+        <p:txBody>
+          <a:bodyPr wrap="square" rtlCol="0" anchor="ctr"/>
+          <a:lstStyle/>
+          <a:p>
+            <a:pPr algn="l" indent="0" marL="0">
+              <a:buNone/>
+            </a:pPr>
+            <a:r>
+              <a:rPr lang="en-US" sz="1600" b="1" dirty="0">
+                <a:solidFill>
+                  <a:srgbClr val="1A1A2E"/>
+                </a:solidFill>
+                <a:latin typeface="游ゴシック" pitchFamily="34" charset="0"/>
+                <a:ea typeface="游ゴシック" pitchFamily="34" charset="-122"/>
+                <a:cs typeface="游ゴシック" pitchFamily="34" charset="-120"/>
+              </a:rPr>
+              <a:t>4月分 売上　／　営業活動進捗</a:t>
+            </a:r>
+            <a:endParaRPr lang="en-US" sz="1600" dirty="0"/>
+          </a:p>
+        </p:txBody>
+      </p:sp>
+      <p:sp>
+        <p:nvSpPr>
+          <p:cNvPr id="8" name="Shape 6"/>
+          <p:cNvSpPr/>
+          <p:nvPr/>
+        </p:nvSpPr>
+        <p:spPr>
+          <a:xfrm>
+            <a:off x="548640" y="1920240"/>
+            <a:ext cx="11091672" cy="530352"/>
+          </a:xfrm>
+          <a:prstGeom prst="rect">
+            <a:avLst/>
+          </a:prstGeom>
+          <a:solidFill>
+            <a:srgbClr val="F5F7FA"/>
+          </a:solidFill>
+          <a:ln/>
+        </p:spPr>
+      </p:sp>
+      <p:sp>
+        <p:nvSpPr>
+          <p:cNvPr id="9" name="Shape 7"/>
+          <p:cNvSpPr/>
+          <p:nvPr/>
+        </p:nvSpPr>
+        <p:spPr>
+          <a:xfrm>
+            <a:off x="548640" y="1920240"/>
+            <a:ext cx="41148" cy="530352"/>
+          </a:xfrm>
+          <a:prstGeom prst="rect">
+            <a:avLst/>
+          </a:prstGeom>
+          <a:solidFill>
+            <a:srgbClr val="E0E4EA"/>
+          </a:solidFill>
+          <a:ln/>
+        </p:spPr>
+      </p:sp>
+      <p:sp>
+        <p:nvSpPr>
+          <p:cNvPr id="10" name="Text 8"/>
+          <p:cNvSpPr/>
+          <p:nvPr/>
+        </p:nvSpPr>
+        <p:spPr>
+          <a:xfrm>
+            <a:off x="658368" y="1920240"/>
+            <a:ext cx="502920" cy="530352"/>
+          </a:xfrm>
+          <a:prstGeom prst="rect">
+            <a:avLst/>
+          </a:prstGeom>
+          <a:noFill/>
+          <a:ln/>
+        </p:spPr>
+        <p:txBody>
+          <a:bodyPr wrap="square" rtlCol="0" anchor="ctr"/>
+          <a:lstStyle/>
+          <a:p>
+            <a:pPr algn="ctr" indent="0" marL="0">
+              <a:buNone/>
+            </a:pPr>
+            <a:r>
+              <a:rPr lang="en-US" sz="1800" b="1" dirty="0">
+                <a:solidFill>
+                  <a:srgbClr val="6B7280"/>
+                </a:solidFill>
+                <a:latin typeface="游ゴシック" pitchFamily="34" charset="0"/>
+                <a:ea typeface="游ゴシック" pitchFamily="34" charset="-122"/>
+                <a:cs typeface="游ゴシック" pitchFamily="34" charset="-120"/>
+              </a:rPr>
+              <a:t>②</a:t>
+            </a:r>
+            <a:endParaRPr lang="en-US" sz="1800" dirty="0"/>
+          </a:p>
+        </p:txBody>
+      </p:sp>
+      <p:sp>
+        <p:nvSpPr>
+          <p:cNvPr id="11" name="Text 9"/>
+          <p:cNvSpPr/>
+          <p:nvPr/>
+        </p:nvSpPr>
+        <p:spPr>
+          <a:xfrm>
+            <a:off x="1207008" y="1920240"/>
+            <a:ext cx="10341864" cy="530352"/>
+          </a:xfrm>
+          <a:prstGeom prst="rect">
+            <a:avLst/>
+          </a:prstGeom>
+          <a:noFill/>
+          <a:ln/>
+        </p:spPr>
+        <p:txBody>
+          <a:bodyPr wrap="square" rtlCol="0" anchor="ctr"/>
+          <a:lstStyle/>
+          <a:p>
+            <a:pPr algn="l" indent="0" marL="0">
+              <a:buNone/>
+            </a:pPr>
+            <a:r>
+              <a:rPr lang="en-US" sz="1600" dirty="0">
+                <a:solidFill>
+                  <a:srgbClr val="1A1A2E"/>
+                </a:solidFill>
+                <a:latin typeface="游ゴシック" pitchFamily="34" charset="0"/>
+                <a:ea typeface="游ゴシック" pitchFamily="34" charset="-122"/>
+                <a:cs typeface="游ゴシック" pitchFamily="34" charset="-120"/>
+              </a:rPr>
+              <a:t>店長・副店長から</a:t>
+            </a:r>
+            <a:endParaRPr lang="en-US" sz="1600" dirty="0"/>
+          </a:p>
+        </p:txBody>
+      </p:sp>
+      <p:sp>
+        <p:nvSpPr>
+          <p:cNvPr id="12" name="Shape 10"/>
+          <p:cNvSpPr/>
+          <p:nvPr/>
+        </p:nvSpPr>
+        <p:spPr>
+          <a:xfrm>
+            <a:off x="548640" y="2560320"/>
+            <a:ext cx="11091672" cy="530352"/>
+          </a:xfrm>
+          <a:prstGeom prst="rect">
+            <a:avLst/>
+          </a:prstGeom>
+          <a:solidFill>
+            <a:srgbClr val="F5F7FA"/>
+          </a:solidFill>
+          <a:ln/>
+        </p:spPr>
+      </p:sp>
+      <p:sp>
+        <p:nvSpPr>
+          <p:cNvPr id="13" name="Shape 11"/>
+          <p:cNvSpPr/>
+          <p:nvPr/>
+        </p:nvSpPr>
+        <p:spPr>
+          <a:xfrm>
+            <a:off x="548640" y="2560320"/>
+            <a:ext cx="41148" cy="530352"/>
+          </a:xfrm>
+          <a:prstGeom prst="rect">
+            <a:avLst/>
+          </a:prstGeom>
+          <a:solidFill>
+            <a:srgbClr val="E0E4EA"/>
+          </a:solidFill>
+          <a:ln/>
+        </p:spPr>
+      </p:sp>
+      <p:sp>
+        <p:nvSpPr>
+          <p:cNvPr id="14" name="Text 12"/>
+          <p:cNvSpPr/>
+          <p:nvPr/>
+        </p:nvSpPr>
+        <p:spPr>
+          <a:xfrm>
+            <a:off x="658368" y="2560320"/>
+            <a:ext cx="502920" cy="530352"/>
+          </a:xfrm>
+          <a:prstGeom prst="rect">
+            <a:avLst/>
+          </a:prstGeom>
+          <a:noFill/>
+          <a:ln/>
+        </p:spPr>
+        <p:txBody>
+          <a:bodyPr wrap="square" rtlCol="0" anchor="ctr"/>
+          <a:lstStyle/>
+          <a:p>
+            <a:pPr algn="ctr" indent="0" marL="0">
+              <a:buNone/>
+            </a:pPr>
+            <a:r>
+              <a:rPr lang="en-US" sz="1800" b="1" dirty="0">
+                <a:solidFill>
+                  <a:srgbClr val="6B7280"/>
+                </a:solidFill>
+                <a:latin typeface="游ゴシック" pitchFamily="34" charset="0"/>
+                <a:ea typeface="游ゴシック" pitchFamily="34" charset="-122"/>
+                <a:cs typeface="游ゴシック" pitchFamily="34" charset="-120"/>
+              </a:rPr>
+              <a:t>③</a:t>
+            </a:r>
+            <a:endParaRPr lang="en-US" sz="1800" dirty="0"/>
+          </a:p>
+        </p:txBody>
+      </p:sp>
+      <p:sp>
+        <p:nvSpPr>
+          <p:cNvPr id="15" name="Text 13"/>
+          <p:cNvSpPr/>
+          <p:nvPr/>
+        </p:nvSpPr>
+        <p:spPr>
+          <a:xfrm>
+            <a:off x="1207008" y="2560320"/>
+            <a:ext cx="10341864" cy="530352"/>
+          </a:xfrm>
+          <a:prstGeom prst="rect">
+            <a:avLst/>
+          </a:prstGeom>
+          <a:noFill/>
+          <a:ln/>
+        </p:spPr>
+        <p:txBody>
+          <a:bodyPr wrap="square" rtlCol="0" anchor="ctr"/>
+          <a:lstStyle/>
+          <a:p>
+            <a:pPr algn="l" indent="0" marL="0">
+              <a:buNone/>
+            </a:pPr>
+            <a:r>
+              <a:rPr lang="en-US" sz="1600" dirty="0">
+                <a:solidFill>
+                  <a:srgbClr val="1A1A2E"/>
+                </a:solidFill>
+                <a:latin typeface="游ゴシック" pitchFamily="34" charset="0"/>
+                <a:ea typeface="游ゴシック" pitchFamily="34" charset="-122"/>
+                <a:cs typeface="游ゴシック" pitchFamily="34" charset="-120"/>
+              </a:rPr>
+              <a:t>吉川さん（PJ関連）</a:t>
+            </a:r>
+            <a:endParaRPr lang="en-US" sz="1600" dirty="0"/>
+          </a:p>
+        </p:txBody>
+      </p:sp>
+      <p:sp>
+        <p:nvSpPr>
+          <p:cNvPr id="16" name="Shape 14"/>
+          <p:cNvSpPr/>
+          <p:nvPr/>
+        </p:nvSpPr>
+        <p:spPr>
+          <a:xfrm>
+            <a:off x="548640" y="3200400"/>
+            <a:ext cx="11091672" cy="530352"/>
+          </a:xfrm>
+          <a:prstGeom prst="rect">
+            <a:avLst/>
+          </a:prstGeom>
+          <a:solidFill>
+            <a:srgbClr val="F5F7FA"/>
+          </a:solidFill>
+          <a:ln/>
+        </p:spPr>
+      </p:sp>
+      <p:sp>
+        <p:nvSpPr>
+          <p:cNvPr id="17" name="Shape 15"/>
+          <p:cNvSpPr/>
+          <p:nvPr/>
+        </p:nvSpPr>
+        <p:spPr>
+          <a:xfrm>
+            <a:off x="548640" y="3200400"/>
+            <a:ext cx="41148" cy="530352"/>
+          </a:xfrm>
+          <a:prstGeom prst="rect">
+            <a:avLst/>
+          </a:prstGeom>
+          <a:solidFill>
+            <a:srgbClr val="E0E4EA"/>
+          </a:solidFill>
+          <a:ln/>
+        </p:spPr>
+      </p:sp>
+      <p:sp>
+        <p:nvSpPr>
+          <p:cNvPr id="18" name="Text 16"/>
+          <p:cNvSpPr/>
+          <p:nvPr/>
+        </p:nvSpPr>
+        <p:spPr>
+          <a:xfrm>
+            <a:off x="658368" y="3200400"/>
+            <a:ext cx="502920" cy="530352"/>
+          </a:xfrm>
+          <a:prstGeom prst="rect">
+            <a:avLst/>
+          </a:prstGeom>
+          <a:noFill/>
+          <a:ln/>
+        </p:spPr>
+        <p:txBody>
+          <a:bodyPr wrap="square" rtlCol="0" anchor="ctr"/>
+          <a:lstStyle/>
+          <a:p>
+            <a:pPr algn="ctr" indent="0" marL="0">
+              <a:buNone/>
+            </a:pPr>
+            <a:r>
+              <a:rPr lang="en-US" sz="1800" b="1" dirty="0">
+                <a:solidFill>
+                  <a:srgbClr val="6B7280"/>
+                </a:solidFill>
+                <a:latin typeface="游ゴシック" pitchFamily="34" charset="0"/>
+                <a:ea typeface="游ゴシック" pitchFamily="34" charset="-122"/>
+                <a:cs typeface="游ゴシック" pitchFamily="34" charset="-120"/>
+              </a:rPr>
+              <a:t>④</a:t>
+            </a:r>
+            <a:endParaRPr lang="en-US" sz="1800" dirty="0"/>
+          </a:p>
+        </p:txBody>
+      </p:sp>
+      <p:sp>
+        <p:nvSpPr>
+          <p:cNvPr id="19" name="Text 17"/>
+          <p:cNvSpPr/>
+          <p:nvPr/>
+        </p:nvSpPr>
+        <p:spPr>
+          <a:xfrm>
+            <a:off x="1207008" y="3200400"/>
+            <a:ext cx="10341864" cy="530352"/>
+          </a:xfrm>
+          <a:prstGeom prst="rect">
+            <a:avLst/>
+          </a:prstGeom>
+          <a:noFill/>
+          <a:ln/>
+        </p:spPr>
+        <p:txBody>
+          <a:bodyPr wrap="square" rtlCol="0" anchor="ctr"/>
+          <a:lstStyle/>
+          <a:p>
+            <a:pPr algn="l" indent="0" marL="0">
+              <a:buNone/>
+            </a:pPr>
+            <a:r>
+              <a:rPr lang="en-US" sz="1600" dirty="0">
+                <a:solidFill>
+                  <a:srgbClr val="1A1A2E"/>
+                </a:solidFill>
+                <a:latin typeface="游ゴシック" pitchFamily="34" charset="0"/>
+                <a:ea typeface="游ゴシック" pitchFamily="34" charset="-122"/>
+                <a:cs typeface="游ゴシック" pitchFamily="34" charset="-120"/>
+              </a:rPr>
+              <a:t>関さん（防災関連）</a:t>
+            </a:r>
+            <a:endParaRPr lang="en-US" sz="1600" dirty="0"/>
+          </a:p>
+        </p:txBody>
+      </p:sp>
+      <p:sp>
+        <p:nvSpPr>
+          <p:cNvPr id="20" name="Shape 18"/>
+          <p:cNvSpPr/>
+          <p:nvPr/>
+        </p:nvSpPr>
+        <p:spPr>
+          <a:xfrm>
+            <a:off x="548640" y="3840480"/>
+            <a:ext cx="11091672" cy="530352"/>
+          </a:xfrm>
+          <a:prstGeom prst="rect">
+            <a:avLst/>
+          </a:prstGeom>
+          <a:solidFill>
+            <a:srgbClr val="F5F7FA"/>
+          </a:solidFill>
+          <a:ln/>
+        </p:spPr>
+      </p:sp>
+      <p:sp>
+        <p:nvSpPr>
+          <p:cNvPr id="21" name="Shape 19"/>
+          <p:cNvSpPr/>
+          <p:nvPr/>
+        </p:nvSpPr>
+        <p:spPr>
+          <a:xfrm>
+            <a:off x="548640" y="3840480"/>
+            <a:ext cx="41148" cy="530352"/>
+          </a:xfrm>
+          <a:prstGeom prst="rect">
+            <a:avLst/>
+          </a:prstGeom>
+          <a:solidFill>
+            <a:srgbClr val="E0E4EA"/>
+          </a:solidFill>
+          <a:ln/>
+        </p:spPr>
+      </p:sp>
+      <p:sp>
+        <p:nvSpPr>
+          <p:cNvPr id="22" name="Text 20"/>
+          <p:cNvSpPr/>
+          <p:nvPr/>
+        </p:nvSpPr>
+        <p:spPr>
+          <a:xfrm>
+            <a:off x="658368" y="3840480"/>
+            <a:ext cx="502920" cy="530352"/>
+          </a:xfrm>
+          <a:prstGeom prst="rect">
+            <a:avLst/>
+          </a:prstGeom>
+          <a:noFill/>
+          <a:ln/>
+        </p:spPr>
+        <p:txBody>
+          <a:bodyPr wrap="square" rtlCol="0" anchor="ctr"/>
+          <a:lstStyle/>
+          <a:p>
+            <a:pPr algn="ctr" indent="0" marL="0">
+              <a:buNone/>
+            </a:pPr>
+            <a:r>
+              <a:rPr lang="en-US" sz="1800" b="1" dirty="0">
+                <a:solidFill>
+                  <a:srgbClr val="6B7280"/>
+                </a:solidFill>
+                <a:latin typeface="游ゴシック" pitchFamily="34" charset="0"/>
+                <a:ea typeface="游ゴシック" pitchFamily="34" charset="-122"/>
+                <a:cs typeface="游ゴシック" pitchFamily="34" charset="-120"/>
+              </a:rPr>
+              <a:t>⑤</a:t>
+            </a:r>
+            <a:endParaRPr lang="en-US" sz="1800" dirty="0"/>
+          </a:p>
+        </p:txBody>
+      </p:sp>
+      <p:sp>
+        <p:nvSpPr>
+          <p:cNvPr id="23" name="Text 21"/>
+          <p:cNvSpPr/>
+          <p:nvPr/>
+        </p:nvSpPr>
+        <p:spPr>
+          <a:xfrm>
+            <a:off x="1207008" y="3840480"/>
+            <a:ext cx="10341864" cy="530352"/>
+          </a:xfrm>
+          <a:prstGeom prst="rect">
+            <a:avLst/>
+          </a:prstGeom>
+          <a:noFill/>
+          <a:ln/>
+        </p:spPr>
+        <p:txBody>
+          <a:bodyPr wrap="square" rtlCol="0" anchor="ctr"/>
+          <a:lstStyle/>
+          <a:p>
+            <a:pPr algn="l" indent="0" marL="0">
+              <a:buNone/>
+            </a:pPr>
+            <a:r>
+              <a:rPr lang="en-US" sz="1600" dirty="0">
+                <a:solidFill>
+                  <a:srgbClr val="1A1A2E"/>
+                </a:solidFill>
+                <a:latin typeface="游ゴシック" pitchFamily="34" charset="0"/>
+                <a:ea typeface="游ゴシック" pitchFamily="34" charset="-122"/>
+                <a:cs typeface="游ゴシック" pitchFamily="34" charset="-120"/>
+              </a:rPr>
+              <a:t>業務アイデアコンテスト</a:t>
+            </a:r>
+            <a:endParaRPr lang="en-US" sz="1600" dirty="0"/>
+          </a:p>
+        </p:txBody>
+      </p:sp>
+    </p:spTree>
+  </p:cSld>
+  <p:clrMapOvr>
+    <a:masterClrMapping/>
+  </p:clrMapOvr>
+</p:sld>
+</file>
+
+<file path=ppt/slides/slide3.xml><?xml version="1.0" encoding="utf-8"?>
+<p:sld xmlns:a="http://schemas.openxmlformats.org/drawingml/2006/main" xmlns:r="http://schemas.openxmlformats.org/officeDocument/2006/relationships" xmlns:p="http://schemas.openxmlformats.org/presentationml/2006/main">
+  <p:cSld name="Slide 3">
+    <p:bg>
+      <p:bgPr>
+        <a:solidFill>
+          <a:srgbClr val="FFFFFF"/>
+        </a:solidFill>
+      </p:bgPr>
+    </p:bg>
+    <p:spTree>
+      <p:nvGrpSpPr>
+        <p:cNvPr id="1" name=""/>
+        <p:cNvGrpSpPr/>
+        <p:nvPr/>
+      </p:nvGrpSpPr>
+      <p:grpSpPr>
+        <a:xfrm>
+          <a:off x="0" y="0"/>
+          <a:ext cx="0" cy="0"/>
+          <a:chOff x="0" y="0"/>
+          <a:chExt cx="0" cy="0"/>
+        </a:xfrm>
+      </p:grpSpPr>
+      <p:sp>
+        <p:nvSpPr>
+          <p:cNvPr id="2" name="Text 0"/>
+          <p:cNvSpPr/>
+          <p:nvPr/>
+        </p:nvSpPr>
+        <p:spPr>
+          <a:xfrm>
+            <a:off x="548640" y="274320"/>
+            <a:ext cx="11091672" cy="594360"/>
+          </a:xfrm>
+          <a:prstGeom prst="rect">
+            <a:avLst/>
+          </a:prstGeom>
+          <a:noFill/>
+          <a:ln/>
+        </p:spPr>
+        <p:txBody>
+          <a:bodyPr wrap="square" rtlCol="0" anchor="t"/>
+          <a:lstStyle/>
+          <a:p>
+            <a:pPr algn="l" indent="0" marL="0">
+              <a:buNone/>
+            </a:pPr>
+            <a:r>
+              <a:rPr lang="en-US" sz="2600" b="1" dirty="0">
+                <a:solidFill>
+                  <a:srgbClr val="1A1A2E"/>
+                </a:solidFill>
+                <a:latin typeface="游ゴシック" pitchFamily="34" charset="0"/>
+                <a:ea typeface="游ゴシック" pitchFamily="34" charset="-122"/>
+                <a:cs typeface="游ゴシック" pitchFamily="34" charset="-120"/>
+              </a:rPr>
+              <a:t>4月度 売上ランキング　（単位：円）</a:t>
+            </a:r>
+            <a:endParaRPr lang="en-US" sz="2600" dirty="0"/>
+          </a:p>
+        </p:txBody>
+      </p:sp>
+      <p:sp>
+        <p:nvSpPr>
+          <p:cNvPr id="3" name="Shape 1"/>
+          <p:cNvSpPr/>
+          <p:nvPr/>
+        </p:nvSpPr>
+        <p:spPr>
+          <a:xfrm>
+            <a:off x="548640" y="960120"/>
+            <a:ext cx="11091672" cy="36576"/>
+          </a:xfrm>
+          <a:prstGeom prst="rect">
+            <a:avLst/>
+          </a:prstGeom>
+          <a:solidFill>
+            <a:srgbClr val="2563EB"/>
+          </a:solidFill>
+          <a:ln/>
+        </p:spPr>
+      </p:sp>
+      <p:sp>
+        <p:nvSpPr>
+          <p:cNvPr id="4" name="Shape 2"/>
+          <p:cNvSpPr/>
+          <p:nvPr/>
+        </p:nvSpPr>
+        <p:spPr>
+          <a:xfrm>
             <a:off x="548640" y="1143000"/>
             <a:ext cx="11091672" cy="333756"/>
           </a:xfrm>
@@ -4728,6 +5943,851 @@
               <a:t>370.0%</a:t>
             </a:r>
             <a:endParaRPr lang="en-US" sz="1300" dirty="0"/>
+          </a:p>
+        </p:txBody>
+      </p:sp>
+    </p:spTree>
+  </p:cSld>
+  <p:clrMapOvr>
+    <a:masterClrMapping/>
+  </p:clrMapOvr>
+</p:sld>
+</file>
+
+<file path=ppt/slides/slide4.xml><?xml version="1.0" encoding="utf-8"?>
+<p:sld xmlns:a="http://schemas.openxmlformats.org/drawingml/2006/main" xmlns:r="http://schemas.openxmlformats.org/officeDocument/2006/relationships" xmlns:p="http://schemas.openxmlformats.org/presentationml/2006/main">
+  <p:cSld name="Slide 4">
+    <p:bg>
+      <p:bgPr>
+        <a:solidFill>
+          <a:srgbClr val="FFFFFF"/>
+        </a:solidFill>
+      </p:bgPr>
+    </p:bg>
+    <p:spTree>
+      <p:nvGrpSpPr>
+        <p:cNvPr id="1" name=""/>
+        <p:cNvGrpSpPr/>
+        <p:nvPr/>
+      </p:nvGrpSpPr>
+      <p:grpSpPr>
+        <a:xfrm>
+          <a:off x="0" y="0"/>
+          <a:ext cx="0" cy="0"/>
+          <a:chOff x="0" y="0"/>
+          <a:chExt cx="0" cy="0"/>
+        </a:xfrm>
+      </p:grpSpPr>
+      <p:sp>
+        <p:nvSpPr>
+          <p:cNvPr id="2" name="Shape 0"/>
+          <p:cNvSpPr/>
+          <p:nvPr/>
+        </p:nvSpPr>
+        <p:spPr>
+          <a:xfrm>
+            <a:off x="5362956" y="2377440"/>
+            <a:ext cx="1463040" cy="347472"/>
+          </a:xfrm>
+          <a:prstGeom prst="rect">
+            <a:avLst/>
+          </a:prstGeom>
+          <a:solidFill>
+            <a:srgbClr val="DBEAFE"/>
+          </a:solidFill>
+          <a:ln/>
+        </p:spPr>
+      </p:sp>
+      <p:sp>
+        <p:nvSpPr>
+          <p:cNvPr id="3" name="Text 1"/>
+          <p:cNvSpPr/>
+          <p:nvPr/>
+        </p:nvSpPr>
+        <p:spPr>
+          <a:xfrm>
+            <a:off x="5362956" y="2377440"/>
+            <a:ext cx="1463040" cy="347472"/>
+          </a:xfrm>
+          <a:prstGeom prst="rect">
+            <a:avLst/>
+          </a:prstGeom>
+          <a:noFill/>
+          <a:ln/>
+        </p:spPr>
+        <p:txBody>
+          <a:bodyPr wrap="square" rtlCol="0" anchor="ctr"/>
+          <a:lstStyle/>
+          <a:p>
+            <a:pPr algn="ctr" indent="0" marL="0">
+              <a:buNone/>
+            </a:pPr>
+            <a:r>
+              <a:rPr lang="en-US" sz="1100" b="1" dirty="0">
+                <a:solidFill>
+                  <a:srgbClr val="2563EB"/>
+                </a:solidFill>
+                <a:latin typeface="游ゴシック" pitchFamily="34" charset="0"/>
+                <a:ea typeface="游ゴシック" pitchFamily="34" charset="-122"/>
+                <a:cs typeface="游ゴシック" pitchFamily="34" charset="-120"/>
+              </a:rPr>
+              <a:t>① 売上</a:t>
+            </a:r>
+            <a:endParaRPr lang="en-US" sz="1100" dirty="0"/>
+          </a:p>
+        </p:txBody>
+      </p:sp>
+      <p:sp>
+        <p:nvSpPr>
+          <p:cNvPr id="4" name="Text 2"/>
+          <p:cNvSpPr/>
+          <p:nvPr/>
+        </p:nvSpPr>
+        <p:spPr>
+          <a:xfrm>
+            <a:off x="548640" y="2880360"/>
+            <a:ext cx="11091672" cy="822960"/>
+          </a:xfrm>
+          <a:prstGeom prst="rect">
+            <a:avLst/>
+          </a:prstGeom>
+          <a:noFill/>
+          <a:ln/>
+        </p:spPr>
+        <p:txBody>
+          <a:bodyPr wrap="square" rtlCol="0" anchor="ctr"/>
+          <a:lstStyle/>
+          <a:p>
+            <a:pPr algn="ctr" indent="0" marL="0">
+              <a:buNone/>
+            </a:pPr>
+            <a:r>
+              <a:rPr lang="en-US" sz="3000" b="1" dirty="0">
+                <a:solidFill>
+                  <a:srgbClr val="1A1A2E"/>
+                </a:solidFill>
+                <a:latin typeface="游ゴシック" pitchFamily="34" charset="0"/>
+                <a:ea typeface="游ゴシック" pitchFamily="34" charset="-122"/>
+                <a:cs typeface="游ゴシック" pitchFamily="34" charset="-120"/>
+              </a:rPr>
+              <a:t>営業活動進捗</a:t>
+            </a:r>
+            <a:endParaRPr lang="en-US" sz="3000" dirty="0"/>
+          </a:p>
+        </p:txBody>
+      </p:sp>
+      <p:sp>
+        <p:nvSpPr>
+          <p:cNvPr id="5" name="Text 3"/>
+          <p:cNvSpPr/>
+          <p:nvPr/>
+        </p:nvSpPr>
+        <p:spPr>
+          <a:xfrm>
+            <a:off x="548640" y="3794760"/>
+            <a:ext cx="11091672" cy="365760"/>
+          </a:xfrm>
+          <a:prstGeom prst="rect">
+            <a:avLst/>
+          </a:prstGeom>
+          <a:noFill/>
+          <a:ln/>
+        </p:spPr>
+        <p:txBody>
+          <a:bodyPr wrap="square" rtlCol="0" anchor="ctr"/>
+          <a:lstStyle/>
+          <a:p>
+            <a:pPr algn="ctr" indent="0" marL="0">
+              <a:buNone/>
+            </a:pPr>
+            <a:r>
+              <a:rPr lang="en-US" sz="1400" b="1" dirty="0">
+                <a:solidFill>
+                  <a:srgbClr val="6B7280"/>
+                </a:solidFill>
+                <a:latin typeface="游ゴシック" pitchFamily="34" charset="0"/>
+                <a:ea typeface="游ゴシック" pitchFamily="34" charset="-122"/>
+                <a:cs typeface="游ゴシック" pitchFamily="34" charset="-120"/>
+              </a:rPr>
+              <a:t>内容を準備中</a:t>
+            </a:r>
+            <a:endParaRPr lang="en-US" sz="1400" dirty="0"/>
+          </a:p>
+        </p:txBody>
+      </p:sp>
+    </p:spTree>
+  </p:cSld>
+  <p:clrMapOvr>
+    <a:masterClrMapping/>
+  </p:clrMapOvr>
+</p:sld>
+</file>
+
+<file path=ppt/slides/slide5.xml><?xml version="1.0" encoding="utf-8"?>
+<p:sld xmlns:a="http://schemas.openxmlformats.org/drawingml/2006/main" xmlns:r="http://schemas.openxmlformats.org/officeDocument/2006/relationships" xmlns:p="http://schemas.openxmlformats.org/presentationml/2006/main">
+  <p:cSld name="Slide 5">
+    <p:bg>
+      <p:bgPr>
+        <a:solidFill>
+          <a:srgbClr val="FFFFFF"/>
+        </a:solidFill>
+      </p:bgPr>
+    </p:bg>
+    <p:spTree>
+      <p:nvGrpSpPr>
+        <p:cNvPr id="1" name=""/>
+        <p:cNvGrpSpPr/>
+        <p:nvPr/>
+      </p:nvGrpSpPr>
+      <p:grpSpPr>
+        <a:xfrm>
+          <a:off x="0" y="0"/>
+          <a:ext cx="0" cy="0"/>
+          <a:chOff x="0" y="0"/>
+          <a:chExt cx="0" cy="0"/>
+        </a:xfrm>
+      </p:grpSpPr>
+      <p:sp>
+        <p:nvSpPr>
+          <p:cNvPr id="2" name="Shape 0"/>
+          <p:cNvSpPr/>
+          <p:nvPr/>
+        </p:nvSpPr>
+        <p:spPr>
+          <a:xfrm>
+            <a:off x="5820156" y="2377440"/>
+            <a:ext cx="548640" cy="347472"/>
+          </a:xfrm>
+          <a:prstGeom prst="rect">
+            <a:avLst/>
+          </a:prstGeom>
+          <a:solidFill>
+            <a:srgbClr val="DBEAFE"/>
+          </a:solidFill>
+          <a:ln/>
+        </p:spPr>
+      </p:sp>
+      <p:sp>
+        <p:nvSpPr>
+          <p:cNvPr id="3" name="Text 1"/>
+          <p:cNvSpPr/>
+          <p:nvPr/>
+        </p:nvSpPr>
+        <p:spPr>
+          <a:xfrm>
+            <a:off x="5820156" y="2377440"/>
+            <a:ext cx="548640" cy="347472"/>
+          </a:xfrm>
+          <a:prstGeom prst="rect">
+            <a:avLst/>
+          </a:prstGeom>
+          <a:noFill/>
+          <a:ln/>
+        </p:spPr>
+        <p:txBody>
+          <a:bodyPr wrap="square" rtlCol="0" anchor="ctr"/>
+          <a:lstStyle/>
+          <a:p>
+            <a:pPr algn="ctr" indent="0" marL="0">
+              <a:buNone/>
+            </a:pPr>
+            <a:r>
+              <a:rPr lang="en-US" sz="1100" b="1" dirty="0">
+                <a:solidFill>
+                  <a:srgbClr val="2563EB"/>
+                </a:solidFill>
+                <a:latin typeface="游ゴシック" pitchFamily="34" charset="0"/>
+                <a:ea typeface="游ゴシック" pitchFamily="34" charset="-122"/>
+                <a:cs typeface="游ゴシック" pitchFamily="34" charset="-120"/>
+              </a:rPr>
+              <a:t>②</a:t>
+            </a:r>
+            <a:endParaRPr lang="en-US" sz="1100" dirty="0"/>
+          </a:p>
+        </p:txBody>
+      </p:sp>
+      <p:sp>
+        <p:nvSpPr>
+          <p:cNvPr id="4" name="Text 2"/>
+          <p:cNvSpPr/>
+          <p:nvPr/>
+        </p:nvSpPr>
+        <p:spPr>
+          <a:xfrm>
+            <a:off x="548640" y="2880360"/>
+            <a:ext cx="11091672" cy="822960"/>
+          </a:xfrm>
+          <a:prstGeom prst="rect">
+            <a:avLst/>
+          </a:prstGeom>
+          <a:noFill/>
+          <a:ln/>
+        </p:spPr>
+        <p:txBody>
+          <a:bodyPr wrap="square" rtlCol="0" anchor="ctr"/>
+          <a:lstStyle/>
+          <a:p>
+            <a:pPr algn="ctr" indent="0" marL="0">
+              <a:buNone/>
+            </a:pPr>
+            <a:r>
+              <a:rPr lang="en-US" sz="3000" b="1" dirty="0">
+                <a:solidFill>
+                  <a:srgbClr val="1A1A2E"/>
+                </a:solidFill>
+                <a:latin typeface="游ゴシック" pitchFamily="34" charset="0"/>
+                <a:ea typeface="游ゴシック" pitchFamily="34" charset="-122"/>
+                <a:cs typeface="游ゴシック" pitchFamily="34" charset="-120"/>
+              </a:rPr>
+              <a:t>店長・副店長から</a:t>
+            </a:r>
+            <a:endParaRPr lang="en-US" sz="3000" dirty="0"/>
+          </a:p>
+        </p:txBody>
+      </p:sp>
+      <p:sp>
+        <p:nvSpPr>
+          <p:cNvPr id="5" name="Text 3"/>
+          <p:cNvSpPr/>
+          <p:nvPr/>
+        </p:nvSpPr>
+        <p:spPr>
+          <a:xfrm>
+            <a:off x="548640" y="3794760"/>
+            <a:ext cx="11091672" cy="365760"/>
+          </a:xfrm>
+          <a:prstGeom prst="rect">
+            <a:avLst/>
+          </a:prstGeom>
+          <a:noFill/>
+          <a:ln/>
+        </p:spPr>
+        <p:txBody>
+          <a:bodyPr wrap="square" rtlCol="0" anchor="ctr"/>
+          <a:lstStyle/>
+          <a:p>
+            <a:pPr algn="ctr" indent="0" marL="0">
+              <a:buNone/>
+            </a:pPr>
+            <a:r>
+              <a:rPr lang="en-US" sz="1400" b="1" dirty="0">
+                <a:solidFill>
+                  <a:srgbClr val="6B7280"/>
+                </a:solidFill>
+                <a:latin typeface="游ゴシック" pitchFamily="34" charset="0"/>
+                <a:ea typeface="游ゴシック" pitchFamily="34" charset="-122"/>
+                <a:cs typeface="游ゴシック" pitchFamily="34" charset="-120"/>
+              </a:rPr>
+              <a:t>内容を準備中</a:t>
+            </a:r>
+            <a:endParaRPr lang="en-US" sz="1400" dirty="0"/>
+          </a:p>
+        </p:txBody>
+      </p:sp>
+    </p:spTree>
+  </p:cSld>
+  <p:clrMapOvr>
+    <a:masterClrMapping/>
+  </p:clrMapOvr>
+</p:sld>
+</file>
+
+<file path=ppt/slides/slide6.xml><?xml version="1.0" encoding="utf-8"?>
+<p:sld xmlns:a="http://schemas.openxmlformats.org/drawingml/2006/main" xmlns:r="http://schemas.openxmlformats.org/officeDocument/2006/relationships" xmlns:p="http://schemas.openxmlformats.org/presentationml/2006/main">
+  <p:cSld name="Slide 6">
+    <p:bg>
+      <p:bgPr>
+        <a:solidFill>
+          <a:srgbClr val="FFFFFF"/>
+        </a:solidFill>
+      </p:bgPr>
+    </p:bg>
+    <p:spTree>
+      <p:nvGrpSpPr>
+        <p:cNvPr id="1" name=""/>
+        <p:cNvGrpSpPr/>
+        <p:nvPr/>
+      </p:nvGrpSpPr>
+      <p:grpSpPr>
+        <a:xfrm>
+          <a:off x="0" y="0"/>
+          <a:ext cx="0" cy="0"/>
+          <a:chOff x="0" y="0"/>
+          <a:chExt cx="0" cy="0"/>
+        </a:xfrm>
+      </p:grpSpPr>
+      <p:sp>
+        <p:nvSpPr>
+          <p:cNvPr id="2" name="Shape 0"/>
+          <p:cNvSpPr/>
+          <p:nvPr/>
+        </p:nvSpPr>
+        <p:spPr>
+          <a:xfrm>
+            <a:off x="5820156" y="2377440"/>
+            <a:ext cx="548640" cy="347472"/>
+          </a:xfrm>
+          <a:prstGeom prst="rect">
+            <a:avLst/>
+          </a:prstGeom>
+          <a:solidFill>
+            <a:srgbClr val="DBEAFE"/>
+          </a:solidFill>
+          <a:ln/>
+        </p:spPr>
+      </p:sp>
+      <p:sp>
+        <p:nvSpPr>
+          <p:cNvPr id="3" name="Text 1"/>
+          <p:cNvSpPr/>
+          <p:nvPr/>
+        </p:nvSpPr>
+        <p:spPr>
+          <a:xfrm>
+            <a:off x="5820156" y="2377440"/>
+            <a:ext cx="548640" cy="347472"/>
+          </a:xfrm>
+          <a:prstGeom prst="rect">
+            <a:avLst/>
+          </a:prstGeom>
+          <a:noFill/>
+          <a:ln/>
+        </p:spPr>
+        <p:txBody>
+          <a:bodyPr wrap="square" rtlCol="0" anchor="ctr"/>
+          <a:lstStyle/>
+          <a:p>
+            <a:pPr algn="ctr" indent="0" marL="0">
+              <a:buNone/>
+            </a:pPr>
+            <a:r>
+              <a:rPr lang="en-US" sz="1100" b="1" dirty="0">
+                <a:solidFill>
+                  <a:srgbClr val="2563EB"/>
+                </a:solidFill>
+                <a:latin typeface="游ゴシック" pitchFamily="34" charset="0"/>
+                <a:ea typeface="游ゴシック" pitchFamily="34" charset="-122"/>
+                <a:cs typeface="游ゴシック" pitchFamily="34" charset="-120"/>
+              </a:rPr>
+              <a:t>③</a:t>
+            </a:r>
+            <a:endParaRPr lang="en-US" sz="1100" dirty="0"/>
+          </a:p>
+        </p:txBody>
+      </p:sp>
+      <p:sp>
+        <p:nvSpPr>
+          <p:cNvPr id="4" name="Text 2"/>
+          <p:cNvSpPr/>
+          <p:nvPr/>
+        </p:nvSpPr>
+        <p:spPr>
+          <a:xfrm>
+            <a:off x="548640" y="2880360"/>
+            <a:ext cx="11091672" cy="822960"/>
+          </a:xfrm>
+          <a:prstGeom prst="rect">
+            <a:avLst/>
+          </a:prstGeom>
+          <a:noFill/>
+          <a:ln/>
+        </p:spPr>
+        <p:txBody>
+          <a:bodyPr wrap="square" rtlCol="0" anchor="ctr"/>
+          <a:lstStyle/>
+          <a:p>
+            <a:pPr algn="ctr" indent="0" marL="0">
+              <a:buNone/>
+            </a:pPr>
+            <a:r>
+              <a:rPr lang="en-US" sz="3000" b="1" dirty="0">
+                <a:solidFill>
+                  <a:srgbClr val="1A1A2E"/>
+                </a:solidFill>
+                <a:latin typeface="游ゴシック" pitchFamily="34" charset="0"/>
+                <a:ea typeface="游ゴシック" pitchFamily="34" charset="-122"/>
+                <a:cs typeface="游ゴシック" pitchFamily="34" charset="-120"/>
+              </a:rPr>
+              <a:t>吉川さん（PJ関連）</a:t>
+            </a:r>
+            <a:endParaRPr lang="en-US" sz="3000" dirty="0"/>
+          </a:p>
+        </p:txBody>
+      </p:sp>
+      <p:sp>
+        <p:nvSpPr>
+          <p:cNvPr id="5" name="Text 3"/>
+          <p:cNvSpPr/>
+          <p:nvPr/>
+        </p:nvSpPr>
+        <p:spPr>
+          <a:xfrm>
+            <a:off x="548640" y="3794760"/>
+            <a:ext cx="11091672" cy="365760"/>
+          </a:xfrm>
+          <a:prstGeom prst="rect">
+            <a:avLst/>
+          </a:prstGeom>
+          <a:noFill/>
+          <a:ln/>
+        </p:spPr>
+        <p:txBody>
+          <a:bodyPr wrap="square" rtlCol="0" anchor="ctr"/>
+          <a:lstStyle/>
+          <a:p>
+            <a:pPr algn="ctr" indent="0" marL="0">
+              <a:buNone/>
+            </a:pPr>
+            <a:r>
+              <a:rPr lang="en-US" sz="1400" b="1" dirty="0">
+                <a:solidFill>
+                  <a:srgbClr val="6B7280"/>
+                </a:solidFill>
+                <a:latin typeface="游ゴシック" pitchFamily="34" charset="0"/>
+                <a:ea typeface="游ゴシック" pitchFamily="34" charset="-122"/>
+                <a:cs typeface="游ゴシック" pitchFamily="34" charset="-120"/>
+              </a:rPr>
+              <a:t>内容を準備中</a:t>
+            </a:r>
+            <a:endParaRPr lang="en-US" sz="1400" dirty="0"/>
+          </a:p>
+        </p:txBody>
+      </p:sp>
+    </p:spTree>
+  </p:cSld>
+  <p:clrMapOvr>
+    <a:masterClrMapping/>
+  </p:clrMapOvr>
+</p:sld>
+</file>
+
+<file path=ppt/slides/slide7.xml><?xml version="1.0" encoding="utf-8"?>
+<p:sld xmlns:a="http://schemas.openxmlformats.org/drawingml/2006/main" xmlns:r="http://schemas.openxmlformats.org/officeDocument/2006/relationships" xmlns:p="http://schemas.openxmlformats.org/presentationml/2006/main">
+  <p:cSld name="Slide 7">
+    <p:bg>
+      <p:bgPr>
+        <a:solidFill>
+          <a:srgbClr val="FFFFFF"/>
+        </a:solidFill>
+      </p:bgPr>
+    </p:bg>
+    <p:spTree>
+      <p:nvGrpSpPr>
+        <p:cNvPr id="1" name=""/>
+        <p:cNvGrpSpPr/>
+        <p:nvPr/>
+      </p:nvGrpSpPr>
+      <p:grpSpPr>
+        <a:xfrm>
+          <a:off x="0" y="0"/>
+          <a:ext cx="0" cy="0"/>
+          <a:chOff x="0" y="0"/>
+          <a:chExt cx="0" cy="0"/>
+        </a:xfrm>
+      </p:grpSpPr>
+      <p:sp>
+        <p:nvSpPr>
+          <p:cNvPr id="2" name="Shape 0"/>
+          <p:cNvSpPr/>
+          <p:nvPr/>
+        </p:nvSpPr>
+        <p:spPr>
+          <a:xfrm>
+            <a:off x="5820156" y="2377440"/>
+            <a:ext cx="548640" cy="347472"/>
+          </a:xfrm>
+          <a:prstGeom prst="rect">
+            <a:avLst/>
+          </a:prstGeom>
+          <a:solidFill>
+            <a:srgbClr val="DBEAFE"/>
+          </a:solidFill>
+          <a:ln/>
+        </p:spPr>
+      </p:sp>
+      <p:sp>
+        <p:nvSpPr>
+          <p:cNvPr id="3" name="Text 1"/>
+          <p:cNvSpPr/>
+          <p:nvPr/>
+        </p:nvSpPr>
+        <p:spPr>
+          <a:xfrm>
+            <a:off x="5820156" y="2377440"/>
+            <a:ext cx="548640" cy="347472"/>
+          </a:xfrm>
+          <a:prstGeom prst="rect">
+            <a:avLst/>
+          </a:prstGeom>
+          <a:noFill/>
+          <a:ln/>
+        </p:spPr>
+        <p:txBody>
+          <a:bodyPr wrap="square" rtlCol="0" anchor="ctr"/>
+          <a:lstStyle/>
+          <a:p>
+            <a:pPr algn="ctr" indent="0" marL="0">
+              <a:buNone/>
+            </a:pPr>
+            <a:r>
+              <a:rPr lang="en-US" sz="1100" b="1" dirty="0">
+                <a:solidFill>
+                  <a:srgbClr val="2563EB"/>
+                </a:solidFill>
+                <a:latin typeface="游ゴシック" pitchFamily="34" charset="0"/>
+                <a:ea typeface="游ゴシック" pitchFamily="34" charset="-122"/>
+                <a:cs typeface="游ゴシック" pitchFamily="34" charset="-120"/>
+              </a:rPr>
+              <a:t>④</a:t>
+            </a:r>
+            <a:endParaRPr lang="en-US" sz="1100" dirty="0"/>
+          </a:p>
+        </p:txBody>
+      </p:sp>
+      <p:sp>
+        <p:nvSpPr>
+          <p:cNvPr id="4" name="Text 2"/>
+          <p:cNvSpPr/>
+          <p:nvPr/>
+        </p:nvSpPr>
+        <p:spPr>
+          <a:xfrm>
+            <a:off x="548640" y="2880360"/>
+            <a:ext cx="11091672" cy="822960"/>
+          </a:xfrm>
+          <a:prstGeom prst="rect">
+            <a:avLst/>
+          </a:prstGeom>
+          <a:noFill/>
+          <a:ln/>
+        </p:spPr>
+        <p:txBody>
+          <a:bodyPr wrap="square" rtlCol="0" anchor="ctr"/>
+          <a:lstStyle/>
+          <a:p>
+            <a:pPr algn="ctr" indent="0" marL="0">
+              <a:buNone/>
+            </a:pPr>
+            <a:r>
+              <a:rPr lang="en-US" sz="3000" b="1" dirty="0">
+                <a:solidFill>
+                  <a:srgbClr val="1A1A2E"/>
+                </a:solidFill>
+                <a:latin typeface="游ゴシック" pitchFamily="34" charset="0"/>
+                <a:ea typeface="游ゴシック" pitchFamily="34" charset="-122"/>
+                <a:cs typeface="游ゴシック" pitchFamily="34" charset="-120"/>
+              </a:rPr>
+              <a:t>関さん（防災関連）</a:t>
+            </a:r>
+            <a:endParaRPr lang="en-US" sz="3000" dirty="0"/>
+          </a:p>
+        </p:txBody>
+      </p:sp>
+      <p:sp>
+        <p:nvSpPr>
+          <p:cNvPr id="5" name="Text 3"/>
+          <p:cNvSpPr/>
+          <p:nvPr/>
+        </p:nvSpPr>
+        <p:spPr>
+          <a:xfrm>
+            <a:off x="548640" y="3794760"/>
+            <a:ext cx="11091672" cy="365760"/>
+          </a:xfrm>
+          <a:prstGeom prst="rect">
+            <a:avLst/>
+          </a:prstGeom>
+          <a:noFill/>
+          <a:ln/>
+        </p:spPr>
+        <p:txBody>
+          <a:bodyPr wrap="square" rtlCol="0" anchor="ctr"/>
+          <a:lstStyle/>
+          <a:p>
+            <a:pPr algn="ctr" indent="0" marL="0">
+              <a:buNone/>
+            </a:pPr>
+            <a:r>
+              <a:rPr lang="en-US" sz="1400" b="1" dirty="0">
+                <a:solidFill>
+                  <a:srgbClr val="6B7280"/>
+                </a:solidFill>
+                <a:latin typeface="游ゴシック" pitchFamily="34" charset="0"/>
+                <a:ea typeface="游ゴシック" pitchFamily="34" charset="-122"/>
+                <a:cs typeface="游ゴシック" pitchFamily="34" charset="-120"/>
+              </a:rPr>
+              <a:t>内容を準備中</a:t>
+            </a:r>
+            <a:endParaRPr lang="en-US" sz="1400" dirty="0"/>
+          </a:p>
+        </p:txBody>
+      </p:sp>
+    </p:spTree>
+  </p:cSld>
+  <p:clrMapOvr>
+    <a:masterClrMapping/>
+  </p:clrMapOvr>
+</p:sld>
+</file>
+
+<file path=ppt/slides/slide8.xml><?xml version="1.0" encoding="utf-8"?>
+<p:sld xmlns:a="http://schemas.openxmlformats.org/drawingml/2006/main" xmlns:r="http://schemas.openxmlformats.org/officeDocument/2006/relationships" xmlns:p="http://schemas.openxmlformats.org/presentationml/2006/main">
+  <p:cSld name="Slide 8">
+    <p:bg>
+      <p:bgPr>
+        <a:solidFill>
+          <a:srgbClr val="FFFFFF"/>
+        </a:solidFill>
+      </p:bgPr>
+    </p:bg>
+    <p:spTree>
+      <p:nvGrpSpPr>
+        <p:cNvPr id="1" name=""/>
+        <p:cNvGrpSpPr/>
+        <p:nvPr/>
+      </p:nvGrpSpPr>
+      <p:grpSpPr>
+        <a:xfrm>
+          <a:off x="0" y="0"/>
+          <a:ext cx="0" cy="0"/>
+          <a:chOff x="0" y="0"/>
+          <a:chExt cx="0" cy="0"/>
+        </a:xfrm>
+      </p:grpSpPr>
+      <p:sp>
+        <p:nvSpPr>
+          <p:cNvPr id="2" name="Shape 0"/>
+          <p:cNvSpPr/>
+          <p:nvPr/>
+        </p:nvSpPr>
+        <p:spPr>
+          <a:xfrm>
+            <a:off x="5820156" y="2377440"/>
+            <a:ext cx="548640" cy="347472"/>
+          </a:xfrm>
+          <a:prstGeom prst="rect">
+            <a:avLst/>
+          </a:prstGeom>
+          <a:solidFill>
+            <a:srgbClr val="DBEAFE"/>
+          </a:solidFill>
+          <a:ln/>
+        </p:spPr>
+      </p:sp>
+      <p:sp>
+        <p:nvSpPr>
+          <p:cNvPr id="3" name="Text 1"/>
+          <p:cNvSpPr/>
+          <p:nvPr/>
+        </p:nvSpPr>
+        <p:spPr>
+          <a:xfrm>
+            <a:off x="5820156" y="2377440"/>
+            <a:ext cx="548640" cy="347472"/>
+          </a:xfrm>
+          <a:prstGeom prst="rect">
+            <a:avLst/>
+          </a:prstGeom>
+          <a:noFill/>
+          <a:ln/>
+        </p:spPr>
+        <p:txBody>
+          <a:bodyPr wrap="square" rtlCol="0" anchor="ctr"/>
+          <a:lstStyle/>
+          <a:p>
+            <a:pPr algn="ctr" indent="0" marL="0">
+              <a:buNone/>
+            </a:pPr>
+            <a:r>
+              <a:rPr lang="en-US" sz="1100" b="1" dirty="0">
+                <a:solidFill>
+                  <a:srgbClr val="2563EB"/>
+                </a:solidFill>
+                <a:latin typeface="游ゴシック" pitchFamily="34" charset="0"/>
+                <a:ea typeface="游ゴシック" pitchFamily="34" charset="-122"/>
+                <a:cs typeface="游ゴシック" pitchFamily="34" charset="-120"/>
+              </a:rPr>
+              <a:t>⑤</a:t>
+            </a:r>
+            <a:endParaRPr lang="en-US" sz="1100" dirty="0"/>
+          </a:p>
+        </p:txBody>
+      </p:sp>
+      <p:sp>
+        <p:nvSpPr>
+          <p:cNvPr id="4" name="Text 2"/>
+          <p:cNvSpPr/>
+          <p:nvPr/>
+        </p:nvSpPr>
+        <p:spPr>
+          <a:xfrm>
+            <a:off x="548640" y="2880360"/>
+            <a:ext cx="11091672" cy="822960"/>
+          </a:xfrm>
+          <a:prstGeom prst="rect">
+            <a:avLst/>
+          </a:prstGeom>
+          <a:noFill/>
+          <a:ln/>
+        </p:spPr>
+        <p:txBody>
+          <a:bodyPr wrap="square" rtlCol="0" anchor="ctr"/>
+          <a:lstStyle/>
+          <a:p>
+            <a:pPr algn="ctr" indent="0" marL="0">
+              <a:buNone/>
+            </a:pPr>
+            <a:r>
+              <a:rPr lang="en-US" sz="3000" b="1" dirty="0">
+                <a:solidFill>
+                  <a:srgbClr val="1A1A2E"/>
+                </a:solidFill>
+                <a:latin typeface="游ゴシック" pitchFamily="34" charset="0"/>
+                <a:ea typeface="游ゴシック" pitchFamily="34" charset="-122"/>
+                <a:cs typeface="游ゴシック" pitchFamily="34" charset="-120"/>
+              </a:rPr>
+              <a:t>業務アイデアコンテスト</a:t>
+            </a:r>
+            <a:endParaRPr lang="en-US" sz="3000" dirty="0"/>
+          </a:p>
+        </p:txBody>
+      </p:sp>
+      <p:sp>
+        <p:nvSpPr>
+          <p:cNvPr id="5" name="Text 3"/>
+          <p:cNvSpPr/>
+          <p:nvPr/>
+        </p:nvSpPr>
+        <p:spPr>
+          <a:xfrm>
+            <a:off x="548640" y="3794760"/>
+            <a:ext cx="11091672" cy="365760"/>
+          </a:xfrm>
+          <a:prstGeom prst="rect">
+            <a:avLst/>
+          </a:prstGeom>
+          <a:noFill/>
+          <a:ln/>
+        </p:spPr>
+        <p:txBody>
+          <a:bodyPr wrap="square" rtlCol="0" anchor="ctr"/>
+          <a:lstStyle/>
+          <a:p>
+            <a:pPr algn="ctr" indent="0" marL="0">
+              <a:buNone/>
+            </a:pPr>
+            <a:r>
+              <a:rPr lang="en-US" sz="1400" b="1" dirty="0">
+                <a:solidFill>
+                  <a:srgbClr val="6B7280"/>
+                </a:solidFill>
+                <a:latin typeface="游ゴシック" pitchFamily="34" charset="0"/>
+                <a:ea typeface="游ゴシック" pitchFamily="34" charset="-122"/>
+                <a:cs typeface="游ゴシック" pitchFamily="34" charset="-120"/>
+              </a:rPr>
+              <a:t>内容を準備中</a:t>
+            </a:r>
+            <a:endParaRPr lang="en-US" sz="1400" dirty="0"/>
           </a:p>
         </p:txBody>
       </p:sp>

</xml_diff>

<commit_message>
Remove slides 5-8, keep only slide 4 (営業活動進捗) as placeholder
Slides now: title / TOC / ranking / 営業活動進捗(pending)

https://claude.ai/code/session_013LUtg8kZ6SCk9upzYYqLj7
</commit_message>
<xml_diff>
--- a/slides/exports/sales-meeting.pptx
+++ b/slides/exports/sales-meeting.pptx
@@ -9,13 +9,9 @@
     <p:sldId id="257" r:id="rId3"/>
     <p:sldId id="258" r:id="rId4"/>
     <p:sldId id="259" r:id="rId5"/>
-    <p:sldId id="260" r:id="rId6"/>
-    <p:sldId id="261" r:id="rId7"/>
-    <p:sldId id="262" r:id="rId8"/>
-    <p:sldId id="263" r:id="rId9"/>
   </p:sldIdLst>
   <p:notesMasterIdLst>
-    <p:notesMasterId r:id="rId10"/>
+    <p:notesMasterId r:id="rId6"/>
   </p:notesMasterIdLst>
   <p:sldSz cx="12192000" cy="6858000"/>
   <p:notesSz cx="6858000" cy="12192000"/>
@@ -797,358 +793,6 @@
             <a:fld id="{F7021451-1387-4CA6-816F-3879F97B5CBC}" type="slidenum">
               <a:rPr lang="en-US"/>
               <a:t>4</a:t>
-            </a:fld>
-            <a:endParaRPr lang="en-US"/>
-          </a:p>
-        </p:txBody>
-      </p:sp>
-    </p:spTree>
-    <p:extLst>
-      <p:ext uri="{BB962C8B-B14F-4D97-AF65-F5344CB8AC3E}">
-        <p14:creationId xmlns:p14="http://schemas.microsoft.com/office/powerpoint/2010/main" val="1024086991"/>
-      </p:ext>
-    </p:extLst>
-  </p:cSld>
-  <p:clrMapOvr>
-    <a:masterClrMapping/>
-  </p:clrMapOvr>
-</p:notes>
-</file>
-
-<file path=ppt/notesSlides/notesSlide5.xml><?xml version="1.0" encoding="utf-8"?>
-<p:notes xmlns:a="http://schemas.openxmlformats.org/drawingml/2006/main" xmlns:r="http://schemas.openxmlformats.org/officeDocument/2006/relationships" xmlns:p="http://schemas.openxmlformats.org/presentationml/2006/main">
-  <p:cSld>
-    <p:spTree>
-      <p:nvGrpSpPr>
-        <p:cNvPr id="1" name=""/>
-        <p:cNvGrpSpPr/>
-        <p:nvPr/>
-      </p:nvGrpSpPr>
-      <p:grpSpPr>
-        <a:xfrm>
-          <a:off x="0" y="0"/>
-          <a:ext cx="0" cy="0"/>
-          <a:chOff x="0" y="0"/>
-          <a:chExt cx="0" cy="0"/>
-        </a:xfrm>
-      </p:grpSpPr>
-      <p:sp>
-        <p:nvSpPr>
-          <p:cNvPr id="2" name="Slide Image Placeholder 1"/>
-          <p:cNvSpPr>
-            <a:spLocks noGrp="1" noRot="1" noChangeAspect="1"/>
-          </p:cNvSpPr>
-          <p:nvPr>
-            <p:ph type="sldImg"/>
-          </p:nvPr>
-        </p:nvSpPr>
-        <p:spPr/>
-      </p:sp>
-      <p:sp>
-        <p:nvSpPr>
-          <p:cNvPr id="3" name="Notes Placeholder 2"/>
-          <p:cNvSpPr>
-            <a:spLocks noGrp="1"/>
-          </p:cNvSpPr>
-          <p:nvPr>
-            <p:ph type="body" idx="1"/>
-          </p:nvPr>
-        </p:nvSpPr>
-        <p:spPr/>
-        <p:txBody>
-          <a:bodyPr/>
-          <a:lstStyle/>
-          <a:p>
-            <a:r>
-              <a:rPr lang="en-US" dirty="0"/>
-              <a:t/>
-            </a:r>
-            <a:endParaRPr lang="en-US" dirty="0"/>
-          </a:p>
-        </p:txBody>
-      </p:sp>
-      <p:sp>
-        <p:nvSpPr>
-          <p:cNvPr id="4" name="Slide Number Placeholder 3"/>
-          <p:cNvSpPr>
-            <a:spLocks noGrp="1"/>
-          </p:cNvSpPr>
-          <p:nvPr>
-            <p:ph type="sldNum" sz="quarter" idx="10"/>
-          </p:nvPr>
-        </p:nvSpPr>
-        <p:spPr/>
-        <p:txBody>
-          <a:bodyPr/>
-          <a:lstStyle/>
-          <a:p>
-            <a:fld id="{F7021451-1387-4CA6-816F-3879F97B5CBC}" type="slidenum">
-              <a:rPr lang="en-US"/>
-              <a:t>5</a:t>
-            </a:fld>
-            <a:endParaRPr lang="en-US"/>
-          </a:p>
-        </p:txBody>
-      </p:sp>
-    </p:spTree>
-    <p:extLst>
-      <p:ext uri="{BB962C8B-B14F-4D97-AF65-F5344CB8AC3E}">
-        <p14:creationId xmlns:p14="http://schemas.microsoft.com/office/powerpoint/2010/main" val="1024086991"/>
-      </p:ext>
-    </p:extLst>
-  </p:cSld>
-  <p:clrMapOvr>
-    <a:masterClrMapping/>
-  </p:clrMapOvr>
-</p:notes>
-</file>
-
-<file path=ppt/notesSlides/notesSlide6.xml><?xml version="1.0" encoding="utf-8"?>
-<p:notes xmlns:a="http://schemas.openxmlformats.org/drawingml/2006/main" xmlns:r="http://schemas.openxmlformats.org/officeDocument/2006/relationships" xmlns:p="http://schemas.openxmlformats.org/presentationml/2006/main">
-  <p:cSld>
-    <p:spTree>
-      <p:nvGrpSpPr>
-        <p:cNvPr id="1" name=""/>
-        <p:cNvGrpSpPr/>
-        <p:nvPr/>
-      </p:nvGrpSpPr>
-      <p:grpSpPr>
-        <a:xfrm>
-          <a:off x="0" y="0"/>
-          <a:ext cx="0" cy="0"/>
-          <a:chOff x="0" y="0"/>
-          <a:chExt cx="0" cy="0"/>
-        </a:xfrm>
-      </p:grpSpPr>
-      <p:sp>
-        <p:nvSpPr>
-          <p:cNvPr id="2" name="Slide Image Placeholder 1"/>
-          <p:cNvSpPr>
-            <a:spLocks noGrp="1" noRot="1" noChangeAspect="1"/>
-          </p:cNvSpPr>
-          <p:nvPr>
-            <p:ph type="sldImg"/>
-          </p:nvPr>
-        </p:nvSpPr>
-        <p:spPr/>
-      </p:sp>
-      <p:sp>
-        <p:nvSpPr>
-          <p:cNvPr id="3" name="Notes Placeholder 2"/>
-          <p:cNvSpPr>
-            <a:spLocks noGrp="1"/>
-          </p:cNvSpPr>
-          <p:nvPr>
-            <p:ph type="body" idx="1"/>
-          </p:nvPr>
-        </p:nvSpPr>
-        <p:spPr/>
-        <p:txBody>
-          <a:bodyPr/>
-          <a:lstStyle/>
-          <a:p>
-            <a:r>
-              <a:rPr lang="en-US" dirty="0"/>
-              <a:t/>
-            </a:r>
-            <a:endParaRPr lang="en-US" dirty="0"/>
-          </a:p>
-        </p:txBody>
-      </p:sp>
-      <p:sp>
-        <p:nvSpPr>
-          <p:cNvPr id="4" name="Slide Number Placeholder 3"/>
-          <p:cNvSpPr>
-            <a:spLocks noGrp="1"/>
-          </p:cNvSpPr>
-          <p:nvPr>
-            <p:ph type="sldNum" sz="quarter" idx="10"/>
-          </p:nvPr>
-        </p:nvSpPr>
-        <p:spPr/>
-        <p:txBody>
-          <a:bodyPr/>
-          <a:lstStyle/>
-          <a:p>
-            <a:fld id="{F7021451-1387-4CA6-816F-3879F97B5CBC}" type="slidenum">
-              <a:rPr lang="en-US"/>
-              <a:t>6</a:t>
-            </a:fld>
-            <a:endParaRPr lang="en-US"/>
-          </a:p>
-        </p:txBody>
-      </p:sp>
-    </p:spTree>
-    <p:extLst>
-      <p:ext uri="{BB962C8B-B14F-4D97-AF65-F5344CB8AC3E}">
-        <p14:creationId xmlns:p14="http://schemas.microsoft.com/office/powerpoint/2010/main" val="1024086991"/>
-      </p:ext>
-    </p:extLst>
-  </p:cSld>
-  <p:clrMapOvr>
-    <a:masterClrMapping/>
-  </p:clrMapOvr>
-</p:notes>
-</file>
-
-<file path=ppt/notesSlides/notesSlide7.xml><?xml version="1.0" encoding="utf-8"?>
-<p:notes xmlns:a="http://schemas.openxmlformats.org/drawingml/2006/main" xmlns:r="http://schemas.openxmlformats.org/officeDocument/2006/relationships" xmlns:p="http://schemas.openxmlformats.org/presentationml/2006/main">
-  <p:cSld>
-    <p:spTree>
-      <p:nvGrpSpPr>
-        <p:cNvPr id="1" name=""/>
-        <p:cNvGrpSpPr/>
-        <p:nvPr/>
-      </p:nvGrpSpPr>
-      <p:grpSpPr>
-        <a:xfrm>
-          <a:off x="0" y="0"/>
-          <a:ext cx="0" cy="0"/>
-          <a:chOff x="0" y="0"/>
-          <a:chExt cx="0" cy="0"/>
-        </a:xfrm>
-      </p:grpSpPr>
-      <p:sp>
-        <p:nvSpPr>
-          <p:cNvPr id="2" name="Slide Image Placeholder 1"/>
-          <p:cNvSpPr>
-            <a:spLocks noGrp="1" noRot="1" noChangeAspect="1"/>
-          </p:cNvSpPr>
-          <p:nvPr>
-            <p:ph type="sldImg"/>
-          </p:nvPr>
-        </p:nvSpPr>
-        <p:spPr/>
-      </p:sp>
-      <p:sp>
-        <p:nvSpPr>
-          <p:cNvPr id="3" name="Notes Placeholder 2"/>
-          <p:cNvSpPr>
-            <a:spLocks noGrp="1"/>
-          </p:cNvSpPr>
-          <p:nvPr>
-            <p:ph type="body" idx="1"/>
-          </p:nvPr>
-        </p:nvSpPr>
-        <p:spPr/>
-        <p:txBody>
-          <a:bodyPr/>
-          <a:lstStyle/>
-          <a:p>
-            <a:r>
-              <a:rPr lang="en-US" dirty="0"/>
-              <a:t/>
-            </a:r>
-            <a:endParaRPr lang="en-US" dirty="0"/>
-          </a:p>
-        </p:txBody>
-      </p:sp>
-      <p:sp>
-        <p:nvSpPr>
-          <p:cNvPr id="4" name="Slide Number Placeholder 3"/>
-          <p:cNvSpPr>
-            <a:spLocks noGrp="1"/>
-          </p:cNvSpPr>
-          <p:nvPr>
-            <p:ph type="sldNum" sz="quarter" idx="10"/>
-          </p:nvPr>
-        </p:nvSpPr>
-        <p:spPr/>
-        <p:txBody>
-          <a:bodyPr/>
-          <a:lstStyle/>
-          <a:p>
-            <a:fld id="{F7021451-1387-4CA6-816F-3879F97B5CBC}" type="slidenum">
-              <a:rPr lang="en-US"/>
-              <a:t>7</a:t>
-            </a:fld>
-            <a:endParaRPr lang="en-US"/>
-          </a:p>
-        </p:txBody>
-      </p:sp>
-    </p:spTree>
-    <p:extLst>
-      <p:ext uri="{BB962C8B-B14F-4D97-AF65-F5344CB8AC3E}">
-        <p14:creationId xmlns:p14="http://schemas.microsoft.com/office/powerpoint/2010/main" val="1024086991"/>
-      </p:ext>
-    </p:extLst>
-  </p:cSld>
-  <p:clrMapOvr>
-    <a:masterClrMapping/>
-  </p:clrMapOvr>
-</p:notes>
-</file>
-
-<file path=ppt/notesSlides/notesSlide8.xml><?xml version="1.0" encoding="utf-8"?>
-<p:notes xmlns:a="http://schemas.openxmlformats.org/drawingml/2006/main" xmlns:r="http://schemas.openxmlformats.org/officeDocument/2006/relationships" xmlns:p="http://schemas.openxmlformats.org/presentationml/2006/main">
-  <p:cSld>
-    <p:spTree>
-      <p:nvGrpSpPr>
-        <p:cNvPr id="1" name=""/>
-        <p:cNvGrpSpPr/>
-        <p:nvPr/>
-      </p:nvGrpSpPr>
-      <p:grpSpPr>
-        <a:xfrm>
-          <a:off x="0" y="0"/>
-          <a:ext cx="0" cy="0"/>
-          <a:chOff x="0" y="0"/>
-          <a:chExt cx="0" cy="0"/>
-        </a:xfrm>
-      </p:grpSpPr>
-      <p:sp>
-        <p:nvSpPr>
-          <p:cNvPr id="2" name="Slide Image Placeholder 1"/>
-          <p:cNvSpPr>
-            <a:spLocks noGrp="1" noRot="1" noChangeAspect="1"/>
-          </p:cNvSpPr>
-          <p:nvPr>
-            <p:ph type="sldImg"/>
-          </p:nvPr>
-        </p:nvSpPr>
-        <p:spPr/>
-      </p:sp>
-      <p:sp>
-        <p:nvSpPr>
-          <p:cNvPr id="3" name="Notes Placeholder 2"/>
-          <p:cNvSpPr>
-            <a:spLocks noGrp="1"/>
-          </p:cNvSpPr>
-          <p:nvPr>
-            <p:ph type="body" idx="1"/>
-          </p:nvPr>
-        </p:nvSpPr>
-        <p:spPr/>
-        <p:txBody>
-          <a:bodyPr/>
-          <a:lstStyle/>
-          <a:p>
-            <a:r>
-              <a:rPr lang="en-US" dirty="0"/>
-              <a:t/>
-            </a:r>
-            <a:endParaRPr lang="en-US" dirty="0"/>
-          </a:p>
-        </p:txBody>
-      </p:sp>
-      <p:sp>
-        <p:nvSpPr>
-          <p:cNvPr id="4" name="Slide Number Placeholder 3"/>
-          <p:cNvSpPr>
-            <a:spLocks noGrp="1"/>
-          </p:cNvSpPr>
-          <p:nvPr>
-            <p:ph type="sldNum" sz="quarter" idx="10"/>
-          </p:nvPr>
-        </p:nvSpPr>
-        <p:spPr/>
-        <p:txBody>
-          <a:bodyPr/>
-          <a:lstStyle/>
-          <a:p>
-            <a:fld id="{F7021451-1387-4CA6-816F-3879F97B5CBC}" type="slidenum">
-              <a:rPr lang="en-US"/>
-              <a:t>8</a:t>
             </a:fld>
             <a:endParaRPr lang="en-US"/>
           </a:p>
@@ -6123,682 +5767,6 @@
 </p:sld>
 </file>
 
-<file path=ppt/slides/slide5.xml><?xml version="1.0" encoding="utf-8"?>
-<p:sld xmlns:a="http://schemas.openxmlformats.org/drawingml/2006/main" xmlns:r="http://schemas.openxmlformats.org/officeDocument/2006/relationships" xmlns:p="http://schemas.openxmlformats.org/presentationml/2006/main">
-  <p:cSld name="Slide 5">
-    <p:bg>
-      <p:bgPr>
-        <a:solidFill>
-          <a:srgbClr val="FFFFFF"/>
-        </a:solidFill>
-      </p:bgPr>
-    </p:bg>
-    <p:spTree>
-      <p:nvGrpSpPr>
-        <p:cNvPr id="1" name=""/>
-        <p:cNvGrpSpPr/>
-        <p:nvPr/>
-      </p:nvGrpSpPr>
-      <p:grpSpPr>
-        <a:xfrm>
-          <a:off x="0" y="0"/>
-          <a:ext cx="0" cy="0"/>
-          <a:chOff x="0" y="0"/>
-          <a:chExt cx="0" cy="0"/>
-        </a:xfrm>
-      </p:grpSpPr>
-      <p:sp>
-        <p:nvSpPr>
-          <p:cNvPr id="2" name="Shape 0"/>
-          <p:cNvSpPr/>
-          <p:nvPr/>
-        </p:nvSpPr>
-        <p:spPr>
-          <a:xfrm>
-            <a:off x="5820156" y="2377440"/>
-            <a:ext cx="548640" cy="347472"/>
-          </a:xfrm>
-          <a:prstGeom prst="rect">
-            <a:avLst/>
-          </a:prstGeom>
-          <a:solidFill>
-            <a:srgbClr val="DBEAFE"/>
-          </a:solidFill>
-          <a:ln/>
-        </p:spPr>
-      </p:sp>
-      <p:sp>
-        <p:nvSpPr>
-          <p:cNvPr id="3" name="Text 1"/>
-          <p:cNvSpPr/>
-          <p:nvPr/>
-        </p:nvSpPr>
-        <p:spPr>
-          <a:xfrm>
-            <a:off x="5820156" y="2377440"/>
-            <a:ext cx="548640" cy="347472"/>
-          </a:xfrm>
-          <a:prstGeom prst="rect">
-            <a:avLst/>
-          </a:prstGeom>
-          <a:noFill/>
-          <a:ln/>
-        </p:spPr>
-        <p:txBody>
-          <a:bodyPr wrap="square" rtlCol="0" anchor="ctr"/>
-          <a:lstStyle/>
-          <a:p>
-            <a:pPr algn="ctr" indent="0" marL="0">
-              <a:buNone/>
-            </a:pPr>
-            <a:r>
-              <a:rPr lang="en-US" sz="1100" b="1" dirty="0">
-                <a:solidFill>
-                  <a:srgbClr val="2563EB"/>
-                </a:solidFill>
-                <a:latin typeface="游ゴシック" pitchFamily="34" charset="0"/>
-                <a:ea typeface="游ゴシック" pitchFamily="34" charset="-122"/>
-                <a:cs typeface="游ゴシック" pitchFamily="34" charset="-120"/>
-              </a:rPr>
-              <a:t>②</a:t>
-            </a:r>
-            <a:endParaRPr lang="en-US" sz="1100" dirty="0"/>
-          </a:p>
-        </p:txBody>
-      </p:sp>
-      <p:sp>
-        <p:nvSpPr>
-          <p:cNvPr id="4" name="Text 2"/>
-          <p:cNvSpPr/>
-          <p:nvPr/>
-        </p:nvSpPr>
-        <p:spPr>
-          <a:xfrm>
-            <a:off x="548640" y="2880360"/>
-            <a:ext cx="11091672" cy="822960"/>
-          </a:xfrm>
-          <a:prstGeom prst="rect">
-            <a:avLst/>
-          </a:prstGeom>
-          <a:noFill/>
-          <a:ln/>
-        </p:spPr>
-        <p:txBody>
-          <a:bodyPr wrap="square" rtlCol="0" anchor="ctr"/>
-          <a:lstStyle/>
-          <a:p>
-            <a:pPr algn="ctr" indent="0" marL="0">
-              <a:buNone/>
-            </a:pPr>
-            <a:r>
-              <a:rPr lang="en-US" sz="3000" b="1" dirty="0">
-                <a:solidFill>
-                  <a:srgbClr val="1A1A2E"/>
-                </a:solidFill>
-                <a:latin typeface="游ゴシック" pitchFamily="34" charset="0"/>
-                <a:ea typeface="游ゴシック" pitchFamily="34" charset="-122"/>
-                <a:cs typeface="游ゴシック" pitchFamily="34" charset="-120"/>
-              </a:rPr>
-              <a:t>店長・副店長から</a:t>
-            </a:r>
-            <a:endParaRPr lang="en-US" sz="3000" dirty="0"/>
-          </a:p>
-        </p:txBody>
-      </p:sp>
-      <p:sp>
-        <p:nvSpPr>
-          <p:cNvPr id="5" name="Text 3"/>
-          <p:cNvSpPr/>
-          <p:nvPr/>
-        </p:nvSpPr>
-        <p:spPr>
-          <a:xfrm>
-            <a:off x="548640" y="3794760"/>
-            <a:ext cx="11091672" cy="365760"/>
-          </a:xfrm>
-          <a:prstGeom prst="rect">
-            <a:avLst/>
-          </a:prstGeom>
-          <a:noFill/>
-          <a:ln/>
-        </p:spPr>
-        <p:txBody>
-          <a:bodyPr wrap="square" rtlCol="0" anchor="ctr"/>
-          <a:lstStyle/>
-          <a:p>
-            <a:pPr algn="ctr" indent="0" marL="0">
-              <a:buNone/>
-            </a:pPr>
-            <a:r>
-              <a:rPr lang="en-US" sz="1400" b="1" dirty="0">
-                <a:solidFill>
-                  <a:srgbClr val="6B7280"/>
-                </a:solidFill>
-                <a:latin typeface="游ゴシック" pitchFamily="34" charset="0"/>
-                <a:ea typeface="游ゴシック" pitchFamily="34" charset="-122"/>
-                <a:cs typeface="游ゴシック" pitchFamily="34" charset="-120"/>
-              </a:rPr>
-              <a:t>内容を準備中</a:t>
-            </a:r>
-            <a:endParaRPr lang="en-US" sz="1400" dirty="0"/>
-          </a:p>
-        </p:txBody>
-      </p:sp>
-    </p:spTree>
-  </p:cSld>
-  <p:clrMapOvr>
-    <a:masterClrMapping/>
-  </p:clrMapOvr>
-</p:sld>
-</file>
-
-<file path=ppt/slides/slide6.xml><?xml version="1.0" encoding="utf-8"?>
-<p:sld xmlns:a="http://schemas.openxmlformats.org/drawingml/2006/main" xmlns:r="http://schemas.openxmlformats.org/officeDocument/2006/relationships" xmlns:p="http://schemas.openxmlformats.org/presentationml/2006/main">
-  <p:cSld name="Slide 6">
-    <p:bg>
-      <p:bgPr>
-        <a:solidFill>
-          <a:srgbClr val="FFFFFF"/>
-        </a:solidFill>
-      </p:bgPr>
-    </p:bg>
-    <p:spTree>
-      <p:nvGrpSpPr>
-        <p:cNvPr id="1" name=""/>
-        <p:cNvGrpSpPr/>
-        <p:nvPr/>
-      </p:nvGrpSpPr>
-      <p:grpSpPr>
-        <a:xfrm>
-          <a:off x="0" y="0"/>
-          <a:ext cx="0" cy="0"/>
-          <a:chOff x="0" y="0"/>
-          <a:chExt cx="0" cy="0"/>
-        </a:xfrm>
-      </p:grpSpPr>
-      <p:sp>
-        <p:nvSpPr>
-          <p:cNvPr id="2" name="Shape 0"/>
-          <p:cNvSpPr/>
-          <p:nvPr/>
-        </p:nvSpPr>
-        <p:spPr>
-          <a:xfrm>
-            <a:off x="5820156" y="2377440"/>
-            <a:ext cx="548640" cy="347472"/>
-          </a:xfrm>
-          <a:prstGeom prst="rect">
-            <a:avLst/>
-          </a:prstGeom>
-          <a:solidFill>
-            <a:srgbClr val="DBEAFE"/>
-          </a:solidFill>
-          <a:ln/>
-        </p:spPr>
-      </p:sp>
-      <p:sp>
-        <p:nvSpPr>
-          <p:cNvPr id="3" name="Text 1"/>
-          <p:cNvSpPr/>
-          <p:nvPr/>
-        </p:nvSpPr>
-        <p:spPr>
-          <a:xfrm>
-            <a:off x="5820156" y="2377440"/>
-            <a:ext cx="548640" cy="347472"/>
-          </a:xfrm>
-          <a:prstGeom prst="rect">
-            <a:avLst/>
-          </a:prstGeom>
-          <a:noFill/>
-          <a:ln/>
-        </p:spPr>
-        <p:txBody>
-          <a:bodyPr wrap="square" rtlCol="0" anchor="ctr"/>
-          <a:lstStyle/>
-          <a:p>
-            <a:pPr algn="ctr" indent="0" marL="0">
-              <a:buNone/>
-            </a:pPr>
-            <a:r>
-              <a:rPr lang="en-US" sz="1100" b="1" dirty="0">
-                <a:solidFill>
-                  <a:srgbClr val="2563EB"/>
-                </a:solidFill>
-                <a:latin typeface="游ゴシック" pitchFamily="34" charset="0"/>
-                <a:ea typeface="游ゴシック" pitchFamily="34" charset="-122"/>
-                <a:cs typeface="游ゴシック" pitchFamily="34" charset="-120"/>
-              </a:rPr>
-              <a:t>③</a:t>
-            </a:r>
-            <a:endParaRPr lang="en-US" sz="1100" dirty="0"/>
-          </a:p>
-        </p:txBody>
-      </p:sp>
-      <p:sp>
-        <p:nvSpPr>
-          <p:cNvPr id="4" name="Text 2"/>
-          <p:cNvSpPr/>
-          <p:nvPr/>
-        </p:nvSpPr>
-        <p:spPr>
-          <a:xfrm>
-            <a:off x="548640" y="2880360"/>
-            <a:ext cx="11091672" cy="822960"/>
-          </a:xfrm>
-          <a:prstGeom prst="rect">
-            <a:avLst/>
-          </a:prstGeom>
-          <a:noFill/>
-          <a:ln/>
-        </p:spPr>
-        <p:txBody>
-          <a:bodyPr wrap="square" rtlCol="0" anchor="ctr"/>
-          <a:lstStyle/>
-          <a:p>
-            <a:pPr algn="ctr" indent="0" marL="0">
-              <a:buNone/>
-            </a:pPr>
-            <a:r>
-              <a:rPr lang="en-US" sz="3000" b="1" dirty="0">
-                <a:solidFill>
-                  <a:srgbClr val="1A1A2E"/>
-                </a:solidFill>
-                <a:latin typeface="游ゴシック" pitchFamily="34" charset="0"/>
-                <a:ea typeface="游ゴシック" pitchFamily="34" charset="-122"/>
-                <a:cs typeface="游ゴシック" pitchFamily="34" charset="-120"/>
-              </a:rPr>
-              <a:t>吉川さん（PJ関連）</a:t>
-            </a:r>
-            <a:endParaRPr lang="en-US" sz="3000" dirty="0"/>
-          </a:p>
-        </p:txBody>
-      </p:sp>
-      <p:sp>
-        <p:nvSpPr>
-          <p:cNvPr id="5" name="Text 3"/>
-          <p:cNvSpPr/>
-          <p:nvPr/>
-        </p:nvSpPr>
-        <p:spPr>
-          <a:xfrm>
-            <a:off x="548640" y="3794760"/>
-            <a:ext cx="11091672" cy="365760"/>
-          </a:xfrm>
-          <a:prstGeom prst="rect">
-            <a:avLst/>
-          </a:prstGeom>
-          <a:noFill/>
-          <a:ln/>
-        </p:spPr>
-        <p:txBody>
-          <a:bodyPr wrap="square" rtlCol="0" anchor="ctr"/>
-          <a:lstStyle/>
-          <a:p>
-            <a:pPr algn="ctr" indent="0" marL="0">
-              <a:buNone/>
-            </a:pPr>
-            <a:r>
-              <a:rPr lang="en-US" sz="1400" b="1" dirty="0">
-                <a:solidFill>
-                  <a:srgbClr val="6B7280"/>
-                </a:solidFill>
-                <a:latin typeface="游ゴシック" pitchFamily="34" charset="0"/>
-                <a:ea typeface="游ゴシック" pitchFamily="34" charset="-122"/>
-                <a:cs typeface="游ゴシック" pitchFamily="34" charset="-120"/>
-              </a:rPr>
-              <a:t>内容を準備中</a:t>
-            </a:r>
-            <a:endParaRPr lang="en-US" sz="1400" dirty="0"/>
-          </a:p>
-        </p:txBody>
-      </p:sp>
-    </p:spTree>
-  </p:cSld>
-  <p:clrMapOvr>
-    <a:masterClrMapping/>
-  </p:clrMapOvr>
-</p:sld>
-</file>
-
-<file path=ppt/slides/slide7.xml><?xml version="1.0" encoding="utf-8"?>
-<p:sld xmlns:a="http://schemas.openxmlformats.org/drawingml/2006/main" xmlns:r="http://schemas.openxmlformats.org/officeDocument/2006/relationships" xmlns:p="http://schemas.openxmlformats.org/presentationml/2006/main">
-  <p:cSld name="Slide 7">
-    <p:bg>
-      <p:bgPr>
-        <a:solidFill>
-          <a:srgbClr val="FFFFFF"/>
-        </a:solidFill>
-      </p:bgPr>
-    </p:bg>
-    <p:spTree>
-      <p:nvGrpSpPr>
-        <p:cNvPr id="1" name=""/>
-        <p:cNvGrpSpPr/>
-        <p:nvPr/>
-      </p:nvGrpSpPr>
-      <p:grpSpPr>
-        <a:xfrm>
-          <a:off x="0" y="0"/>
-          <a:ext cx="0" cy="0"/>
-          <a:chOff x="0" y="0"/>
-          <a:chExt cx="0" cy="0"/>
-        </a:xfrm>
-      </p:grpSpPr>
-      <p:sp>
-        <p:nvSpPr>
-          <p:cNvPr id="2" name="Shape 0"/>
-          <p:cNvSpPr/>
-          <p:nvPr/>
-        </p:nvSpPr>
-        <p:spPr>
-          <a:xfrm>
-            <a:off x="5820156" y="2377440"/>
-            <a:ext cx="548640" cy="347472"/>
-          </a:xfrm>
-          <a:prstGeom prst="rect">
-            <a:avLst/>
-          </a:prstGeom>
-          <a:solidFill>
-            <a:srgbClr val="DBEAFE"/>
-          </a:solidFill>
-          <a:ln/>
-        </p:spPr>
-      </p:sp>
-      <p:sp>
-        <p:nvSpPr>
-          <p:cNvPr id="3" name="Text 1"/>
-          <p:cNvSpPr/>
-          <p:nvPr/>
-        </p:nvSpPr>
-        <p:spPr>
-          <a:xfrm>
-            <a:off x="5820156" y="2377440"/>
-            <a:ext cx="548640" cy="347472"/>
-          </a:xfrm>
-          <a:prstGeom prst="rect">
-            <a:avLst/>
-          </a:prstGeom>
-          <a:noFill/>
-          <a:ln/>
-        </p:spPr>
-        <p:txBody>
-          <a:bodyPr wrap="square" rtlCol="0" anchor="ctr"/>
-          <a:lstStyle/>
-          <a:p>
-            <a:pPr algn="ctr" indent="0" marL="0">
-              <a:buNone/>
-            </a:pPr>
-            <a:r>
-              <a:rPr lang="en-US" sz="1100" b="1" dirty="0">
-                <a:solidFill>
-                  <a:srgbClr val="2563EB"/>
-                </a:solidFill>
-                <a:latin typeface="游ゴシック" pitchFamily="34" charset="0"/>
-                <a:ea typeface="游ゴシック" pitchFamily="34" charset="-122"/>
-                <a:cs typeface="游ゴシック" pitchFamily="34" charset="-120"/>
-              </a:rPr>
-              <a:t>④</a:t>
-            </a:r>
-            <a:endParaRPr lang="en-US" sz="1100" dirty="0"/>
-          </a:p>
-        </p:txBody>
-      </p:sp>
-      <p:sp>
-        <p:nvSpPr>
-          <p:cNvPr id="4" name="Text 2"/>
-          <p:cNvSpPr/>
-          <p:nvPr/>
-        </p:nvSpPr>
-        <p:spPr>
-          <a:xfrm>
-            <a:off x="548640" y="2880360"/>
-            <a:ext cx="11091672" cy="822960"/>
-          </a:xfrm>
-          <a:prstGeom prst="rect">
-            <a:avLst/>
-          </a:prstGeom>
-          <a:noFill/>
-          <a:ln/>
-        </p:spPr>
-        <p:txBody>
-          <a:bodyPr wrap="square" rtlCol="0" anchor="ctr"/>
-          <a:lstStyle/>
-          <a:p>
-            <a:pPr algn="ctr" indent="0" marL="0">
-              <a:buNone/>
-            </a:pPr>
-            <a:r>
-              <a:rPr lang="en-US" sz="3000" b="1" dirty="0">
-                <a:solidFill>
-                  <a:srgbClr val="1A1A2E"/>
-                </a:solidFill>
-                <a:latin typeface="游ゴシック" pitchFamily="34" charset="0"/>
-                <a:ea typeface="游ゴシック" pitchFamily="34" charset="-122"/>
-                <a:cs typeface="游ゴシック" pitchFamily="34" charset="-120"/>
-              </a:rPr>
-              <a:t>関さん（防災関連）</a:t>
-            </a:r>
-            <a:endParaRPr lang="en-US" sz="3000" dirty="0"/>
-          </a:p>
-        </p:txBody>
-      </p:sp>
-      <p:sp>
-        <p:nvSpPr>
-          <p:cNvPr id="5" name="Text 3"/>
-          <p:cNvSpPr/>
-          <p:nvPr/>
-        </p:nvSpPr>
-        <p:spPr>
-          <a:xfrm>
-            <a:off x="548640" y="3794760"/>
-            <a:ext cx="11091672" cy="365760"/>
-          </a:xfrm>
-          <a:prstGeom prst="rect">
-            <a:avLst/>
-          </a:prstGeom>
-          <a:noFill/>
-          <a:ln/>
-        </p:spPr>
-        <p:txBody>
-          <a:bodyPr wrap="square" rtlCol="0" anchor="ctr"/>
-          <a:lstStyle/>
-          <a:p>
-            <a:pPr algn="ctr" indent="0" marL="0">
-              <a:buNone/>
-            </a:pPr>
-            <a:r>
-              <a:rPr lang="en-US" sz="1400" b="1" dirty="0">
-                <a:solidFill>
-                  <a:srgbClr val="6B7280"/>
-                </a:solidFill>
-                <a:latin typeface="游ゴシック" pitchFamily="34" charset="0"/>
-                <a:ea typeface="游ゴシック" pitchFamily="34" charset="-122"/>
-                <a:cs typeface="游ゴシック" pitchFamily="34" charset="-120"/>
-              </a:rPr>
-              <a:t>内容を準備中</a:t>
-            </a:r>
-            <a:endParaRPr lang="en-US" sz="1400" dirty="0"/>
-          </a:p>
-        </p:txBody>
-      </p:sp>
-    </p:spTree>
-  </p:cSld>
-  <p:clrMapOvr>
-    <a:masterClrMapping/>
-  </p:clrMapOvr>
-</p:sld>
-</file>
-
-<file path=ppt/slides/slide8.xml><?xml version="1.0" encoding="utf-8"?>
-<p:sld xmlns:a="http://schemas.openxmlformats.org/drawingml/2006/main" xmlns:r="http://schemas.openxmlformats.org/officeDocument/2006/relationships" xmlns:p="http://schemas.openxmlformats.org/presentationml/2006/main">
-  <p:cSld name="Slide 8">
-    <p:bg>
-      <p:bgPr>
-        <a:solidFill>
-          <a:srgbClr val="FFFFFF"/>
-        </a:solidFill>
-      </p:bgPr>
-    </p:bg>
-    <p:spTree>
-      <p:nvGrpSpPr>
-        <p:cNvPr id="1" name=""/>
-        <p:cNvGrpSpPr/>
-        <p:nvPr/>
-      </p:nvGrpSpPr>
-      <p:grpSpPr>
-        <a:xfrm>
-          <a:off x="0" y="0"/>
-          <a:ext cx="0" cy="0"/>
-          <a:chOff x="0" y="0"/>
-          <a:chExt cx="0" cy="0"/>
-        </a:xfrm>
-      </p:grpSpPr>
-      <p:sp>
-        <p:nvSpPr>
-          <p:cNvPr id="2" name="Shape 0"/>
-          <p:cNvSpPr/>
-          <p:nvPr/>
-        </p:nvSpPr>
-        <p:spPr>
-          <a:xfrm>
-            <a:off x="5820156" y="2377440"/>
-            <a:ext cx="548640" cy="347472"/>
-          </a:xfrm>
-          <a:prstGeom prst="rect">
-            <a:avLst/>
-          </a:prstGeom>
-          <a:solidFill>
-            <a:srgbClr val="DBEAFE"/>
-          </a:solidFill>
-          <a:ln/>
-        </p:spPr>
-      </p:sp>
-      <p:sp>
-        <p:nvSpPr>
-          <p:cNvPr id="3" name="Text 1"/>
-          <p:cNvSpPr/>
-          <p:nvPr/>
-        </p:nvSpPr>
-        <p:spPr>
-          <a:xfrm>
-            <a:off x="5820156" y="2377440"/>
-            <a:ext cx="548640" cy="347472"/>
-          </a:xfrm>
-          <a:prstGeom prst="rect">
-            <a:avLst/>
-          </a:prstGeom>
-          <a:noFill/>
-          <a:ln/>
-        </p:spPr>
-        <p:txBody>
-          <a:bodyPr wrap="square" rtlCol="0" anchor="ctr"/>
-          <a:lstStyle/>
-          <a:p>
-            <a:pPr algn="ctr" indent="0" marL="0">
-              <a:buNone/>
-            </a:pPr>
-            <a:r>
-              <a:rPr lang="en-US" sz="1100" b="1" dirty="0">
-                <a:solidFill>
-                  <a:srgbClr val="2563EB"/>
-                </a:solidFill>
-                <a:latin typeface="游ゴシック" pitchFamily="34" charset="0"/>
-                <a:ea typeface="游ゴシック" pitchFamily="34" charset="-122"/>
-                <a:cs typeface="游ゴシック" pitchFamily="34" charset="-120"/>
-              </a:rPr>
-              <a:t>⑤</a:t>
-            </a:r>
-            <a:endParaRPr lang="en-US" sz="1100" dirty="0"/>
-          </a:p>
-        </p:txBody>
-      </p:sp>
-      <p:sp>
-        <p:nvSpPr>
-          <p:cNvPr id="4" name="Text 2"/>
-          <p:cNvSpPr/>
-          <p:nvPr/>
-        </p:nvSpPr>
-        <p:spPr>
-          <a:xfrm>
-            <a:off x="548640" y="2880360"/>
-            <a:ext cx="11091672" cy="822960"/>
-          </a:xfrm>
-          <a:prstGeom prst="rect">
-            <a:avLst/>
-          </a:prstGeom>
-          <a:noFill/>
-          <a:ln/>
-        </p:spPr>
-        <p:txBody>
-          <a:bodyPr wrap="square" rtlCol="0" anchor="ctr"/>
-          <a:lstStyle/>
-          <a:p>
-            <a:pPr algn="ctr" indent="0" marL="0">
-              <a:buNone/>
-            </a:pPr>
-            <a:r>
-              <a:rPr lang="en-US" sz="3000" b="1" dirty="0">
-                <a:solidFill>
-                  <a:srgbClr val="1A1A2E"/>
-                </a:solidFill>
-                <a:latin typeface="游ゴシック" pitchFamily="34" charset="0"/>
-                <a:ea typeface="游ゴシック" pitchFamily="34" charset="-122"/>
-                <a:cs typeface="游ゴシック" pitchFamily="34" charset="-120"/>
-              </a:rPr>
-              <a:t>業務アイデアコンテスト</a:t>
-            </a:r>
-            <a:endParaRPr lang="en-US" sz="3000" dirty="0"/>
-          </a:p>
-        </p:txBody>
-      </p:sp>
-      <p:sp>
-        <p:nvSpPr>
-          <p:cNvPr id="5" name="Text 3"/>
-          <p:cNvSpPr/>
-          <p:nvPr/>
-        </p:nvSpPr>
-        <p:spPr>
-          <a:xfrm>
-            <a:off x="548640" y="3794760"/>
-            <a:ext cx="11091672" cy="365760"/>
-          </a:xfrm>
-          <a:prstGeom prst="rect">
-            <a:avLst/>
-          </a:prstGeom>
-          <a:noFill/>
-          <a:ln/>
-        </p:spPr>
-        <p:txBody>
-          <a:bodyPr wrap="square" rtlCol="0" anchor="ctr"/>
-          <a:lstStyle/>
-          <a:p>
-            <a:pPr algn="ctr" indent="0" marL="0">
-              <a:buNone/>
-            </a:pPr>
-            <a:r>
-              <a:rPr lang="en-US" sz="1400" b="1" dirty="0">
-                <a:solidFill>
-                  <a:srgbClr val="6B7280"/>
-                </a:solidFill>
-                <a:latin typeface="游ゴシック" pitchFamily="34" charset="0"/>
-                <a:ea typeface="游ゴシック" pitchFamily="34" charset="-122"/>
-                <a:cs typeface="游ゴシック" pitchFamily="34" charset="-120"/>
-              </a:rPr>
-              <a:t>内容を準備中</a:t>
-            </a:r>
-            <a:endParaRPr lang="en-US" sz="1400" dirty="0"/>
-          </a:p>
-        </p:txBody>
-      </p:sp>
-    </p:spTree>
-  </p:cSld>
-  <p:clrMapOvr>
-    <a:masterClrMapping/>
-  </p:clrMapOvr>
-</p:sld>
-</file>
-
 <file path=ppt/theme/theme1.xml><?xml version="1.0" encoding="utf-8"?>
 <a:theme xmlns:a="http://schemas.openxmlformats.org/drawingml/2006/main" name="Office Theme">
   <a:themeElements>

</xml_diff>

<commit_message>
Add 区民祭り受注管理 table to slide 4
10 districts with date, bid deadline, amount, status (確定/未)
Replaces placeholder slide

https://claude.ai/code/session_013LUtg8kZ6SCk9upzYYqLj7
</commit_message>
<xml_diff>
--- a/slides/exports/sales-meeting.pptx
+++ b/slides/exports/sales-meeting.pptx
@@ -5624,34 +5624,132 @@
       </p:grpSpPr>
       <p:sp>
         <p:nvSpPr>
-          <p:cNvPr id="2" name="Shape 0"/>
-          <p:cNvSpPr/>
-          <p:nvPr/>
-        </p:nvSpPr>
-        <p:spPr>
-          <a:xfrm>
-            <a:off x="5362956" y="2377440"/>
-            <a:ext cx="1463040" cy="347472"/>
+          <p:cNvPr id="2" name="Text 0"/>
+          <p:cNvSpPr/>
+          <p:nvPr/>
+        </p:nvSpPr>
+        <p:spPr>
+          <a:xfrm>
+            <a:off x="548640" y="274320"/>
+            <a:ext cx="11091672" cy="594360"/>
+          </a:xfrm>
+          <a:prstGeom prst="rect">
+            <a:avLst/>
+          </a:prstGeom>
+          <a:noFill/>
+          <a:ln/>
+        </p:spPr>
+        <p:txBody>
+          <a:bodyPr wrap="square" rtlCol="0" anchor="t"/>
+          <a:lstStyle/>
+          <a:p>
+            <a:pPr algn="l" indent="0" marL="0">
+              <a:buNone/>
+            </a:pPr>
+            <a:r>
+              <a:rPr lang="en-US" sz="2600" b="1" dirty="0">
+                <a:solidFill>
+                  <a:srgbClr val="1A1A2E"/>
+                </a:solidFill>
+                <a:latin typeface="游ゴシック" pitchFamily="34" charset="0"/>
+                <a:ea typeface="游ゴシック" pitchFamily="34" charset="-122"/>
+                <a:cs typeface="游ゴシック" pitchFamily="34" charset="-120"/>
+              </a:rPr>
+              <a:t>区民祭り 受注管理（10区）</a:t>
+            </a:r>
+            <a:endParaRPr lang="en-US" sz="2600" dirty="0"/>
+          </a:p>
+        </p:txBody>
+      </p:sp>
+      <p:sp>
+        <p:nvSpPr>
+          <p:cNvPr id="3" name="Shape 1"/>
+          <p:cNvSpPr/>
+          <p:nvPr/>
+        </p:nvSpPr>
+        <p:spPr>
+          <a:xfrm>
+            <a:off x="548640" y="960120"/>
+            <a:ext cx="11091672" cy="36576"/>
           </a:xfrm>
           <a:prstGeom prst="rect">
             <a:avLst/>
           </a:prstGeom>
           <a:solidFill>
-            <a:srgbClr val="DBEAFE"/>
+            <a:srgbClr val="2563EB"/>
           </a:solidFill>
           <a:ln/>
         </p:spPr>
       </p:sp>
       <p:sp>
         <p:nvSpPr>
-          <p:cNvPr id="3" name="Text 1"/>
-          <p:cNvSpPr/>
-          <p:nvPr/>
-        </p:nvSpPr>
-        <p:spPr>
-          <a:xfrm>
-            <a:off x="5362956" y="2377440"/>
-            <a:ext cx="1463040" cy="347472"/>
+          <p:cNvPr id="4" name="Shape 2"/>
+          <p:cNvSpPr/>
+          <p:nvPr/>
+        </p:nvSpPr>
+        <p:spPr>
+          <a:xfrm>
+            <a:off x="548640" y="1143000"/>
+            <a:ext cx="11091672" cy="365760"/>
+          </a:xfrm>
+          <a:prstGeom prst="rect">
+            <a:avLst/>
+          </a:prstGeom>
+          <a:solidFill>
+            <a:srgbClr val="E8EDF5"/>
+          </a:solidFill>
+          <a:ln/>
+        </p:spPr>
+      </p:sp>
+      <p:sp>
+        <p:nvSpPr>
+          <p:cNvPr id="5" name="Text 3"/>
+          <p:cNvSpPr/>
+          <p:nvPr/>
+        </p:nvSpPr>
+        <p:spPr>
+          <a:xfrm>
+            <a:off x="548640" y="1143000"/>
+            <a:ext cx="1097280" cy="365760"/>
+          </a:xfrm>
+          <a:prstGeom prst="rect">
+            <a:avLst/>
+          </a:prstGeom>
+          <a:noFill/>
+          <a:ln/>
+        </p:spPr>
+        <p:txBody>
+          <a:bodyPr wrap="square" rtlCol="0" anchor="ctr"/>
+          <a:lstStyle/>
+          <a:p>
+            <a:pPr algn="l" indent="0" marL="0">
+              <a:buNone/>
+            </a:pPr>
+            <a:r>
+              <a:rPr lang="en-US" sz="1100" b="1" dirty="0">
+                <a:solidFill>
+                  <a:srgbClr val="6B7280"/>
+                </a:solidFill>
+                <a:latin typeface="游ゴシック" pitchFamily="34" charset="0"/>
+                <a:ea typeface="游ゴシック" pitchFamily="34" charset="-122"/>
+                <a:cs typeface="游ゴシック" pitchFamily="34" charset="-120"/>
+              </a:rPr>
+              <a:t>区</a:t>
+            </a:r>
+            <a:endParaRPr lang="en-US" sz="1100" dirty="0"/>
+          </a:p>
+        </p:txBody>
+      </p:sp>
+      <p:sp>
+        <p:nvSpPr>
+          <p:cNvPr id="6" name="Text 4"/>
+          <p:cNvSpPr/>
+          <p:nvPr/>
+        </p:nvSpPr>
+        <p:spPr>
+          <a:xfrm>
+            <a:off x="1645920" y="1143000"/>
+            <a:ext cx="1005840" cy="365760"/>
           </a:xfrm>
           <a:prstGeom prst="rect">
             <a:avLst/>
@@ -5669,13 +5767,13 @@
             <a:r>
               <a:rPr lang="en-US" sz="1100" b="1" dirty="0">
                 <a:solidFill>
-                  <a:srgbClr val="2563EB"/>
-                </a:solidFill>
-                <a:latin typeface="游ゴシック" pitchFamily="34" charset="0"/>
-                <a:ea typeface="游ゴシック" pitchFamily="34" charset="-122"/>
-                <a:cs typeface="游ゴシック" pitchFamily="34" charset="-120"/>
-              </a:rPr>
-              <a:t>① 売上</a:t>
+                  <a:srgbClr val="6B7280"/>
+                </a:solidFill>
+                <a:latin typeface="游ゴシック" pitchFamily="34" charset="0"/>
+                <a:ea typeface="游ゴシック" pitchFamily="34" charset="-122"/>
+                <a:cs typeface="游ゴシック" pitchFamily="34" charset="-120"/>
+              </a:rPr>
+              <a:t>本番日</a:t>
             </a:r>
             <a:endParaRPr lang="en-US" sz="1100" dirty="0"/>
           </a:p>
@@ -5683,14 +5781,14 @@
       </p:sp>
       <p:sp>
         <p:nvSpPr>
-          <p:cNvPr id="4" name="Text 2"/>
-          <p:cNvSpPr/>
-          <p:nvPr/>
-        </p:nvSpPr>
-        <p:spPr>
-          <a:xfrm>
-            <a:off x="548640" y="2880360"/>
-            <a:ext cx="11091672" cy="822960"/>
+          <p:cNvPr id="7" name="Text 5"/>
+          <p:cNvSpPr/>
+          <p:nvPr/>
+        </p:nvSpPr>
+        <p:spPr>
+          <a:xfrm>
+            <a:off x="2651760" y="1143000"/>
+            <a:ext cx="1280160" cy="365760"/>
           </a:xfrm>
           <a:prstGeom prst="rect">
             <a:avLst/>
@@ -5706,34 +5804,171 @@
               <a:buNone/>
             </a:pPr>
             <a:r>
-              <a:rPr lang="en-US" sz="3000" b="1" dirty="0">
-                <a:solidFill>
-                  <a:srgbClr val="1A1A2E"/>
-                </a:solidFill>
-                <a:latin typeface="游ゴシック" pitchFamily="34" charset="0"/>
-                <a:ea typeface="游ゴシック" pitchFamily="34" charset="-122"/>
-                <a:cs typeface="游ゴシック" pitchFamily="34" charset="-120"/>
-              </a:rPr>
-              <a:t>営業活動進捗</a:t>
-            </a:r>
-            <a:endParaRPr lang="en-US" sz="3000" dirty="0"/>
-          </a:p>
-        </p:txBody>
-      </p:sp>
-      <p:sp>
-        <p:nvSpPr>
-          <p:cNvPr id="5" name="Text 3"/>
-          <p:cNvSpPr/>
-          <p:nvPr/>
-        </p:nvSpPr>
-        <p:spPr>
-          <a:xfrm>
-            <a:off x="548640" y="3794760"/>
+              <a:rPr lang="en-US" sz="1100" b="1" dirty="0">
+                <a:solidFill>
+                  <a:srgbClr val="6B7280"/>
+                </a:solidFill>
+                <a:latin typeface="游ゴシック" pitchFamily="34" charset="0"/>
+                <a:ea typeface="游ゴシック" pitchFamily="34" charset="-122"/>
+                <a:cs typeface="游ゴシック" pitchFamily="34" charset="-120"/>
+              </a:rPr>
+              <a:t>入札・見積期限</a:t>
+            </a:r>
+            <a:endParaRPr lang="en-US" sz="1100" dirty="0"/>
+          </a:p>
+        </p:txBody>
+      </p:sp>
+      <p:sp>
+        <p:nvSpPr>
+          <p:cNvPr id="8" name="Text 6"/>
+          <p:cNvSpPr/>
+          <p:nvPr/>
+        </p:nvSpPr>
+        <p:spPr>
+          <a:xfrm>
+            <a:off x="3931920" y="1143000"/>
+            <a:ext cx="4114800" cy="365760"/>
+          </a:xfrm>
+          <a:prstGeom prst="rect">
+            <a:avLst/>
+          </a:prstGeom>
+          <a:noFill/>
+          <a:ln/>
+        </p:spPr>
+        <p:txBody>
+          <a:bodyPr wrap="square" rtlCol="0" anchor="ctr"/>
+          <a:lstStyle/>
+          <a:p>
+            <a:pPr algn="r" indent="0" marL="0">
+              <a:buNone/>
+            </a:pPr>
+            <a:r>
+              <a:rPr lang="en-US" sz="1100" b="1" dirty="0">
+                <a:solidFill>
+                  <a:srgbClr val="6B7280"/>
+                </a:solidFill>
+                <a:latin typeface="游ゴシック" pitchFamily="34" charset="0"/>
+                <a:ea typeface="游ゴシック" pitchFamily="34" charset="-122"/>
+                <a:cs typeface="游ゴシック" pitchFamily="34" charset="-120"/>
+              </a:rPr>
+              <a:t>契約金額（税抜）</a:t>
+            </a:r>
+            <a:endParaRPr lang="en-US" sz="1100" dirty="0"/>
+          </a:p>
+        </p:txBody>
+      </p:sp>
+      <p:sp>
+        <p:nvSpPr>
+          <p:cNvPr id="9" name="Text 7"/>
+          <p:cNvSpPr/>
+          <p:nvPr/>
+        </p:nvSpPr>
+        <p:spPr>
+          <a:xfrm>
+            <a:off x="8046720" y="1143000"/>
+            <a:ext cx="914400" cy="365760"/>
+          </a:xfrm>
+          <a:prstGeom prst="rect">
+            <a:avLst/>
+          </a:prstGeom>
+          <a:noFill/>
+          <a:ln/>
+        </p:spPr>
+        <p:txBody>
+          <a:bodyPr wrap="square" rtlCol="0" anchor="ctr"/>
+          <a:lstStyle/>
+          <a:p>
+            <a:pPr algn="ctr" indent="0" marL="0">
+              <a:buNone/>
+            </a:pPr>
+            <a:r>
+              <a:rPr lang="en-US" sz="1100" b="1" dirty="0">
+                <a:solidFill>
+                  <a:srgbClr val="6B7280"/>
+                </a:solidFill>
+                <a:latin typeface="游ゴシック" pitchFamily="34" charset="0"/>
+                <a:ea typeface="游ゴシック" pitchFamily="34" charset="-122"/>
+                <a:cs typeface="游ゴシック" pitchFamily="34" charset="-120"/>
+              </a:rPr>
+              <a:t>状況</a:t>
+            </a:r>
+            <a:endParaRPr lang="en-US" sz="1100" dirty="0"/>
+          </a:p>
+        </p:txBody>
+      </p:sp>
+      <p:sp>
+        <p:nvSpPr>
+          <p:cNvPr id="10" name="Shape 8"/>
+          <p:cNvSpPr/>
+          <p:nvPr/>
+        </p:nvSpPr>
+        <p:spPr>
+          <a:xfrm>
+            <a:off x="548640" y="1508760"/>
             <a:ext cx="11091672" cy="365760"/>
           </a:xfrm>
           <a:prstGeom prst="rect">
             <a:avLst/>
           </a:prstGeom>
+          <a:solidFill>
+            <a:srgbClr val="FFFFFF"/>
+          </a:solidFill>
+          <a:ln/>
+        </p:spPr>
+      </p:sp>
+      <p:sp>
+        <p:nvSpPr>
+          <p:cNvPr id="11" name="Text 9"/>
+          <p:cNvSpPr/>
+          <p:nvPr/>
+        </p:nvSpPr>
+        <p:spPr>
+          <a:xfrm>
+            <a:off x="548640" y="1508760"/>
+            <a:ext cx="1097280" cy="365760"/>
+          </a:xfrm>
+          <a:prstGeom prst="rect">
+            <a:avLst/>
+          </a:prstGeom>
+          <a:noFill/>
+          <a:ln/>
+        </p:spPr>
+        <p:txBody>
+          <a:bodyPr wrap="square" rtlCol="0" anchor="ctr"/>
+          <a:lstStyle/>
+          <a:p>
+            <a:pPr algn="l" indent="0" marL="0">
+              <a:buNone/>
+            </a:pPr>
+            <a:r>
+              <a:rPr lang="en-US" sz="1300" b="1" dirty="0">
+                <a:solidFill>
+                  <a:srgbClr val="1A1A2E"/>
+                </a:solidFill>
+                <a:latin typeface="游ゴシック" pitchFamily="34" charset="0"/>
+                <a:ea typeface="游ゴシック" pitchFamily="34" charset="-122"/>
+                <a:cs typeface="游ゴシック" pitchFamily="34" charset="-120"/>
+              </a:rPr>
+              <a:t>名東区</a:t>
+            </a:r>
+            <a:endParaRPr lang="en-US" sz="1300" dirty="0"/>
+          </a:p>
+        </p:txBody>
+      </p:sp>
+      <p:sp>
+        <p:nvSpPr>
+          <p:cNvPr id="12" name="Text 10"/>
+          <p:cNvSpPr/>
+          <p:nvPr/>
+        </p:nvSpPr>
+        <p:spPr>
+          <a:xfrm>
+            <a:off x="1645920" y="1508760"/>
+            <a:ext cx="1005840" cy="365760"/>
+          </a:xfrm>
+          <a:prstGeom prst="rect">
+            <a:avLst/>
+          </a:prstGeom>
           <a:noFill/>
           <a:ln/>
         </p:spPr>
@@ -5745,7 +5980,614 @@
               <a:buNone/>
             </a:pPr>
             <a:r>
-              <a:rPr lang="en-US" sz="1400" b="1" dirty="0">
+              <a:rPr lang="en-US" sz="1200" b="1" dirty="0">
+                <a:solidFill>
+                  <a:srgbClr val="1A1A2E"/>
+                </a:solidFill>
+                <a:latin typeface="游ゴシック" pitchFamily="34" charset="0"/>
+                <a:ea typeface="游ゴシック" pitchFamily="34" charset="-122"/>
+                <a:cs typeface="游ゴシック" pitchFamily="34" charset="-120"/>
+              </a:rPr>
+              <a:t>5/10</a:t>
+            </a:r>
+            <a:endParaRPr lang="en-US" sz="1200" dirty="0"/>
+          </a:p>
+        </p:txBody>
+      </p:sp>
+      <p:sp>
+        <p:nvSpPr>
+          <p:cNvPr id="13" name="Text 11"/>
+          <p:cNvSpPr/>
+          <p:nvPr/>
+        </p:nvSpPr>
+        <p:spPr>
+          <a:xfrm>
+            <a:off x="2651760" y="1508760"/>
+            <a:ext cx="1280160" cy="365760"/>
+          </a:xfrm>
+          <a:prstGeom prst="rect">
+            <a:avLst/>
+          </a:prstGeom>
+          <a:noFill/>
+          <a:ln/>
+        </p:spPr>
+        <p:txBody>
+          <a:bodyPr wrap="square" rtlCol="0" anchor="ctr"/>
+          <a:lstStyle/>
+          <a:p>
+            <a:pPr algn="ctr" indent="0" marL="0">
+              <a:buNone/>
+            </a:pPr>
+            <a:r>
+              <a:rPr lang="en-US" sz="1200" b="1" dirty="0">
+                <a:solidFill>
+                  <a:srgbClr val="1A1A2E"/>
+                </a:solidFill>
+                <a:latin typeface="游ゴシック" pitchFamily="34" charset="0"/>
+                <a:ea typeface="游ゴシック" pitchFamily="34" charset="-122"/>
+                <a:cs typeface="游ゴシック" pitchFamily="34" charset="-120"/>
+              </a:rPr>
+              <a:t>3月</a:t>
+            </a:r>
+            <a:endParaRPr lang="en-US" sz="1200" dirty="0"/>
+          </a:p>
+        </p:txBody>
+      </p:sp>
+      <p:sp>
+        <p:nvSpPr>
+          <p:cNvPr id="14" name="Text 12"/>
+          <p:cNvSpPr/>
+          <p:nvPr/>
+        </p:nvSpPr>
+        <p:spPr>
+          <a:xfrm>
+            <a:off x="3931920" y="1508760"/>
+            <a:ext cx="4114800" cy="365760"/>
+          </a:xfrm>
+          <a:prstGeom prst="rect">
+            <a:avLst/>
+          </a:prstGeom>
+          <a:noFill/>
+          <a:ln/>
+        </p:spPr>
+        <p:txBody>
+          <a:bodyPr wrap="square" rtlCol="0" anchor="ctr"/>
+          <a:lstStyle/>
+          <a:p>
+            <a:pPr algn="r" indent="0" marL="0">
+              <a:buNone/>
+            </a:pPr>
+            <a:r>
+              <a:rPr lang="en-US" sz="1300" b="1" dirty="0">
+                <a:solidFill>
+                  <a:srgbClr val="1A1A2E"/>
+                </a:solidFill>
+                <a:latin typeface="游ゴシック" pitchFamily="34" charset="0"/>
+                <a:ea typeface="游ゴシック" pitchFamily="34" charset="-122"/>
+                <a:cs typeface="游ゴシック" pitchFamily="34" charset="-120"/>
+              </a:rPr>
+              <a:t>3,300,000</a:t>
+            </a:r>
+            <a:endParaRPr lang="en-US" sz="1300" dirty="0"/>
+          </a:p>
+        </p:txBody>
+      </p:sp>
+      <p:sp>
+        <p:nvSpPr>
+          <p:cNvPr id="15" name="Shape 13"/>
+          <p:cNvSpPr/>
+          <p:nvPr/>
+        </p:nvSpPr>
+        <p:spPr>
+          <a:xfrm>
+            <a:off x="8206740" y="1581912"/>
+            <a:ext cx="594360" cy="219456"/>
+          </a:xfrm>
+          <a:prstGeom prst="rect">
+            <a:avLst/>
+          </a:prstGeom>
+          <a:solidFill>
+            <a:srgbClr val="16A34A"/>
+          </a:solidFill>
+          <a:ln/>
+        </p:spPr>
+      </p:sp>
+      <p:sp>
+        <p:nvSpPr>
+          <p:cNvPr id="16" name="Text 14"/>
+          <p:cNvSpPr/>
+          <p:nvPr/>
+        </p:nvSpPr>
+        <p:spPr>
+          <a:xfrm>
+            <a:off x="8206740" y="1581912"/>
+            <a:ext cx="594360" cy="219456"/>
+          </a:xfrm>
+          <a:prstGeom prst="rect">
+            <a:avLst/>
+          </a:prstGeom>
+          <a:noFill/>
+          <a:ln/>
+        </p:spPr>
+        <p:txBody>
+          <a:bodyPr wrap="square" rtlCol="0" anchor="ctr"/>
+          <a:lstStyle/>
+          <a:p>
+            <a:pPr algn="ctr" indent="0" marL="0">
+              <a:buNone/>
+            </a:pPr>
+            <a:r>
+              <a:rPr lang="en-US" sz="1000" b="1" dirty="0">
+                <a:solidFill>
+                  <a:srgbClr val="FFFFFF"/>
+                </a:solidFill>
+                <a:latin typeface="游ゴシック" pitchFamily="34" charset="0"/>
+                <a:ea typeface="游ゴシック" pitchFamily="34" charset="-122"/>
+                <a:cs typeface="游ゴシック" pitchFamily="34" charset="-120"/>
+              </a:rPr>
+              <a:t>確定</a:t>
+            </a:r>
+            <a:endParaRPr lang="en-US" sz="1000" dirty="0"/>
+          </a:p>
+        </p:txBody>
+      </p:sp>
+      <p:sp>
+        <p:nvSpPr>
+          <p:cNvPr id="17" name="Shape 15"/>
+          <p:cNvSpPr/>
+          <p:nvPr/>
+        </p:nvSpPr>
+        <p:spPr>
+          <a:xfrm>
+            <a:off x="548640" y="1874520"/>
+            <a:ext cx="11091672" cy="365760"/>
+          </a:xfrm>
+          <a:prstGeom prst="rect">
+            <a:avLst/>
+          </a:prstGeom>
+          <a:solidFill>
+            <a:srgbClr val="F5F7FA"/>
+          </a:solidFill>
+          <a:ln/>
+        </p:spPr>
+      </p:sp>
+      <p:sp>
+        <p:nvSpPr>
+          <p:cNvPr id="18" name="Text 16"/>
+          <p:cNvSpPr/>
+          <p:nvPr/>
+        </p:nvSpPr>
+        <p:spPr>
+          <a:xfrm>
+            <a:off x="548640" y="1874520"/>
+            <a:ext cx="1097280" cy="365760"/>
+          </a:xfrm>
+          <a:prstGeom prst="rect">
+            <a:avLst/>
+          </a:prstGeom>
+          <a:noFill/>
+          <a:ln/>
+        </p:spPr>
+        <p:txBody>
+          <a:bodyPr wrap="square" rtlCol="0" anchor="ctr"/>
+          <a:lstStyle/>
+          <a:p>
+            <a:pPr algn="l" indent="0" marL="0">
+              <a:buNone/>
+            </a:pPr>
+            <a:r>
+              <a:rPr lang="en-US" sz="1300" b="1" dirty="0">
+                <a:solidFill>
+                  <a:srgbClr val="1A1A2E"/>
+                </a:solidFill>
+                <a:latin typeface="游ゴシック" pitchFamily="34" charset="0"/>
+                <a:ea typeface="游ゴシック" pitchFamily="34" charset="-122"/>
+                <a:cs typeface="游ゴシック" pitchFamily="34" charset="-120"/>
+              </a:rPr>
+              <a:t>中村区</a:t>
+            </a:r>
+            <a:endParaRPr lang="en-US" sz="1300" dirty="0"/>
+          </a:p>
+        </p:txBody>
+      </p:sp>
+      <p:sp>
+        <p:nvSpPr>
+          <p:cNvPr id="19" name="Text 17"/>
+          <p:cNvSpPr/>
+          <p:nvPr/>
+        </p:nvSpPr>
+        <p:spPr>
+          <a:xfrm>
+            <a:off x="1645920" y="1874520"/>
+            <a:ext cx="1005840" cy="365760"/>
+          </a:xfrm>
+          <a:prstGeom prst="rect">
+            <a:avLst/>
+          </a:prstGeom>
+          <a:noFill/>
+          <a:ln/>
+        </p:spPr>
+        <p:txBody>
+          <a:bodyPr wrap="square" rtlCol="0" anchor="ctr"/>
+          <a:lstStyle/>
+          <a:p>
+            <a:pPr algn="ctr" indent="0" marL="0">
+              <a:buNone/>
+            </a:pPr>
+            <a:r>
+              <a:rPr lang="en-US" sz="1200" b="1" dirty="0">
+                <a:solidFill>
+                  <a:srgbClr val="1A1A2E"/>
+                </a:solidFill>
+                <a:latin typeface="游ゴシック" pitchFamily="34" charset="0"/>
+                <a:ea typeface="游ゴシック" pitchFamily="34" charset="-122"/>
+                <a:cs typeface="游ゴシック" pitchFamily="34" charset="-120"/>
+              </a:rPr>
+              <a:t>10/31</a:t>
+            </a:r>
+            <a:endParaRPr lang="en-US" sz="1200" dirty="0"/>
+          </a:p>
+        </p:txBody>
+      </p:sp>
+      <p:sp>
+        <p:nvSpPr>
+          <p:cNvPr id="20" name="Text 18"/>
+          <p:cNvSpPr/>
+          <p:nvPr/>
+        </p:nvSpPr>
+        <p:spPr>
+          <a:xfrm>
+            <a:off x="2651760" y="1874520"/>
+            <a:ext cx="1280160" cy="365760"/>
+          </a:xfrm>
+          <a:prstGeom prst="rect">
+            <a:avLst/>
+          </a:prstGeom>
+          <a:noFill/>
+          <a:ln/>
+        </p:spPr>
+        <p:txBody>
+          <a:bodyPr wrap="square" rtlCol="0" anchor="ctr"/>
+          <a:lstStyle/>
+          <a:p>
+            <a:pPr algn="ctr" indent="0" marL="0">
+              <a:buNone/>
+            </a:pPr>
+            <a:r>
+              <a:rPr lang="en-US" sz="1200" b="1" dirty="0">
+                <a:solidFill>
+                  <a:srgbClr val="1A1A2E"/>
+                </a:solidFill>
+                <a:latin typeface="游ゴシック" pitchFamily="34" charset="0"/>
+                <a:ea typeface="游ゴシック" pitchFamily="34" charset="-122"/>
+                <a:cs typeface="游ゴシック" pitchFamily="34" charset="-120"/>
+              </a:rPr>
+              <a:t>5月</a:t>
+            </a:r>
+            <a:endParaRPr lang="en-US" sz="1200" dirty="0"/>
+          </a:p>
+        </p:txBody>
+      </p:sp>
+      <p:sp>
+        <p:nvSpPr>
+          <p:cNvPr id="21" name="Text 19"/>
+          <p:cNvSpPr/>
+          <p:nvPr/>
+        </p:nvSpPr>
+        <p:spPr>
+          <a:xfrm>
+            <a:off x="3931920" y="1874520"/>
+            <a:ext cx="4114800" cy="365760"/>
+          </a:xfrm>
+          <a:prstGeom prst="rect">
+            <a:avLst/>
+          </a:prstGeom>
+          <a:noFill/>
+          <a:ln/>
+        </p:spPr>
+        <p:txBody>
+          <a:bodyPr wrap="square" rtlCol="0" anchor="ctr"/>
+          <a:lstStyle/>
+          <a:p>
+            <a:pPr algn="r" indent="0" marL="0">
+              <a:buNone/>
+            </a:pPr>
+            <a:r>
+              <a:rPr lang="en-US" sz="1300" b="1" dirty="0">
+                <a:solidFill>
+                  <a:srgbClr val="1A1A2E"/>
+                </a:solidFill>
+                <a:latin typeface="游ゴシック" pitchFamily="34" charset="0"/>
+                <a:ea typeface="游ゴシック" pitchFamily="34" charset="-122"/>
+                <a:cs typeface="游ゴシック" pitchFamily="34" charset="-120"/>
+              </a:rPr>
+              <a:t>5,500,000</a:t>
+            </a:r>
+            <a:endParaRPr lang="en-US" sz="1300" dirty="0"/>
+          </a:p>
+        </p:txBody>
+      </p:sp>
+      <p:sp>
+        <p:nvSpPr>
+          <p:cNvPr id="22" name="Shape 20"/>
+          <p:cNvSpPr/>
+          <p:nvPr/>
+        </p:nvSpPr>
+        <p:spPr>
+          <a:xfrm>
+            <a:off x="8206740" y="1947672"/>
+            <a:ext cx="594360" cy="219456"/>
+          </a:xfrm>
+          <a:prstGeom prst="rect">
+            <a:avLst/>
+          </a:prstGeom>
+          <a:solidFill>
+            <a:srgbClr val="16A34A"/>
+          </a:solidFill>
+          <a:ln/>
+        </p:spPr>
+      </p:sp>
+      <p:sp>
+        <p:nvSpPr>
+          <p:cNvPr id="23" name="Text 21"/>
+          <p:cNvSpPr/>
+          <p:nvPr/>
+        </p:nvSpPr>
+        <p:spPr>
+          <a:xfrm>
+            <a:off x="8206740" y="1947672"/>
+            <a:ext cx="594360" cy="219456"/>
+          </a:xfrm>
+          <a:prstGeom prst="rect">
+            <a:avLst/>
+          </a:prstGeom>
+          <a:noFill/>
+          <a:ln/>
+        </p:spPr>
+        <p:txBody>
+          <a:bodyPr wrap="square" rtlCol="0" anchor="ctr"/>
+          <a:lstStyle/>
+          <a:p>
+            <a:pPr algn="ctr" indent="0" marL="0">
+              <a:buNone/>
+            </a:pPr>
+            <a:r>
+              <a:rPr lang="en-US" sz="1000" b="1" dirty="0">
+                <a:solidFill>
+                  <a:srgbClr val="FFFFFF"/>
+                </a:solidFill>
+                <a:latin typeface="游ゴシック" pitchFamily="34" charset="0"/>
+                <a:ea typeface="游ゴシック" pitchFamily="34" charset="-122"/>
+                <a:cs typeface="游ゴシック" pitchFamily="34" charset="-120"/>
+              </a:rPr>
+              <a:t>確定</a:t>
+            </a:r>
+            <a:endParaRPr lang="en-US" sz="1000" dirty="0"/>
+          </a:p>
+        </p:txBody>
+      </p:sp>
+      <p:sp>
+        <p:nvSpPr>
+          <p:cNvPr id="24" name="Shape 22"/>
+          <p:cNvSpPr/>
+          <p:nvPr/>
+        </p:nvSpPr>
+        <p:spPr>
+          <a:xfrm>
+            <a:off x="548640" y="2240280"/>
+            <a:ext cx="11091672" cy="365760"/>
+          </a:xfrm>
+          <a:prstGeom prst="rect">
+            <a:avLst/>
+          </a:prstGeom>
+          <a:solidFill>
+            <a:srgbClr val="FFFFFF"/>
+          </a:solidFill>
+          <a:ln/>
+        </p:spPr>
+      </p:sp>
+      <p:sp>
+        <p:nvSpPr>
+          <p:cNvPr id="25" name="Text 23"/>
+          <p:cNvSpPr/>
+          <p:nvPr/>
+        </p:nvSpPr>
+        <p:spPr>
+          <a:xfrm>
+            <a:off x="548640" y="2240280"/>
+            <a:ext cx="1097280" cy="365760"/>
+          </a:xfrm>
+          <a:prstGeom prst="rect">
+            <a:avLst/>
+          </a:prstGeom>
+          <a:noFill/>
+          <a:ln/>
+        </p:spPr>
+        <p:txBody>
+          <a:bodyPr wrap="square" rtlCol="0" anchor="ctr"/>
+          <a:lstStyle/>
+          <a:p>
+            <a:pPr algn="l" indent="0" marL="0">
+              <a:buNone/>
+            </a:pPr>
+            <a:r>
+              <a:rPr lang="en-US" sz="1300" b="1" dirty="0">
+                <a:solidFill>
+                  <a:srgbClr val="1A1A2E"/>
+                </a:solidFill>
+                <a:latin typeface="游ゴシック" pitchFamily="34" charset="0"/>
+                <a:ea typeface="游ゴシック" pitchFamily="34" charset="-122"/>
+                <a:cs typeface="游ゴシック" pitchFamily="34" charset="-120"/>
+              </a:rPr>
+              <a:t>瑞穂区</a:t>
+            </a:r>
+            <a:endParaRPr lang="en-US" sz="1300" dirty="0"/>
+          </a:p>
+        </p:txBody>
+      </p:sp>
+      <p:sp>
+        <p:nvSpPr>
+          <p:cNvPr id="26" name="Text 24"/>
+          <p:cNvSpPr/>
+          <p:nvPr/>
+        </p:nvSpPr>
+        <p:spPr>
+          <a:xfrm>
+            <a:off x="1645920" y="2240280"/>
+            <a:ext cx="1005840" cy="365760"/>
+          </a:xfrm>
+          <a:prstGeom prst="rect">
+            <a:avLst/>
+          </a:prstGeom>
+          <a:noFill/>
+          <a:ln/>
+        </p:spPr>
+        <p:txBody>
+          <a:bodyPr wrap="square" rtlCol="0" anchor="ctr"/>
+          <a:lstStyle/>
+          <a:p>
+            <a:pPr algn="ctr" indent="0" marL="0">
+              <a:buNone/>
+            </a:pPr>
+            <a:r>
+              <a:rPr lang="en-US" sz="1200" b="1" dirty="0">
+                <a:solidFill>
+                  <a:srgbClr val="1A1A2E"/>
+                </a:solidFill>
+                <a:latin typeface="游ゴシック" pitchFamily="34" charset="0"/>
+                <a:ea typeface="游ゴシック" pitchFamily="34" charset="-122"/>
+                <a:cs typeface="游ゴシック" pitchFamily="34" charset="-120"/>
+              </a:rPr>
+              <a:t>11/7</a:t>
+            </a:r>
+            <a:endParaRPr lang="en-US" sz="1200" dirty="0"/>
+          </a:p>
+        </p:txBody>
+      </p:sp>
+      <p:sp>
+        <p:nvSpPr>
+          <p:cNvPr id="27" name="Text 25"/>
+          <p:cNvSpPr/>
+          <p:nvPr/>
+        </p:nvSpPr>
+        <p:spPr>
+          <a:xfrm>
+            <a:off x="2651760" y="2240280"/>
+            <a:ext cx="1280160" cy="365760"/>
+          </a:xfrm>
+          <a:prstGeom prst="rect">
+            <a:avLst/>
+          </a:prstGeom>
+          <a:noFill/>
+          <a:ln/>
+        </p:spPr>
+        <p:txBody>
+          <a:bodyPr wrap="square" rtlCol="0" anchor="ctr"/>
+          <a:lstStyle/>
+          <a:p>
+            <a:pPr algn="ctr" indent="0" marL="0">
+              <a:buNone/>
+            </a:pPr>
+            <a:r>
+              <a:rPr lang="en-US" sz="1200" b="1" dirty="0">
+                <a:solidFill>
+                  <a:srgbClr val="1A1A2E"/>
+                </a:solidFill>
+                <a:latin typeface="游ゴシック" pitchFamily="34" charset="0"/>
+                <a:ea typeface="游ゴシック" pitchFamily="34" charset="-122"/>
+                <a:cs typeface="游ゴシック" pitchFamily="34" charset="-120"/>
+              </a:rPr>
+              <a:t>7月</a:t>
+            </a:r>
+            <a:endParaRPr lang="en-US" sz="1200" dirty="0"/>
+          </a:p>
+        </p:txBody>
+      </p:sp>
+      <p:sp>
+        <p:nvSpPr>
+          <p:cNvPr id="28" name="Text 26"/>
+          <p:cNvSpPr/>
+          <p:nvPr/>
+        </p:nvSpPr>
+        <p:spPr>
+          <a:xfrm>
+            <a:off x="3931920" y="2240280"/>
+            <a:ext cx="4114800" cy="365760"/>
+          </a:xfrm>
+          <a:prstGeom prst="rect">
+            <a:avLst/>
+          </a:prstGeom>
+          <a:noFill/>
+          <a:ln/>
+        </p:spPr>
+        <p:txBody>
+          <a:bodyPr wrap="square" rtlCol="0" anchor="ctr"/>
+          <a:lstStyle/>
+          <a:p>
+            <a:pPr algn="r" indent="0" marL="0">
+              <a:buNone/>
+            </a:pPr>
+            <a:r>
+              <a:rPr lang="en-US" sz="1300" b="1" dirty="0">
+                <a:solidFill>
+                  <a:srgbClr val="1A1A2E"/>
+                </a:solidFill>
+                <a:latin typeface="游ゴシック" pitchFamily="34" charset="0"/>
+                <a:ea typeface="游ゴシック" pitchFamily="34" charset="-122"/>
+                <a:cs typeface="游ゴシック" pitchFamily="34" charset="-120"/>
+              </a:rPr>
+              <a:t>4,000,000</a:t>
+            </a:r>
+            <a:endParaRPr lang="en-US" sz="1300" dirty="0"/>
+          </a:p>
+        </p:txBody>
+      </p:sp>
+      <p:sp>
+        <p:nvSpPr>
+          <p:cNvPr id="29" name="Shape 27"/>
+          <p:cNvSpPr/>
+          <p:nvPr/>
+        </p:nvSpPr>
+        <p:spPr>
+          <a:xfrm>
+            <a:off x="8206740" y="2313432"/>
+            <a:ext cx="594360" cy="219456"/>
+          </a:xfrm>
+          <a:prstGeom prst="rect">
+            <a:avLst/>
+          </a:prstGeom>
+          <a:solidFill>
+            <a:srgbClr val="E5E7EB"/>
+          </a:solidFill>
+          <a:ln/>
+        </p:spPr>
+      </p:sp>
+      <p:sp>
+        <p:nvSpPr>
+          <p:cNvPr id="30" name="Text 28"/>
+          <p:cNvSpPr/>
+          <p:nvPr/>
+        </p:nvSpPr>
+        <p:spPr>
+          <a:xfrm>
+            <a:off x="8206740" y="2313432"/>
+            <a:ext cx="594360" cy="219456"/>
+          </a:xfrm>
+          <a:prstGeom prst="rect">
+            <a:avLst/>
+          </a:prstGeom>
+          <a:noFill/>
+          <a:ln/>
+        </p:spPr>
+        <p:txBody>
+          <a:bodyPr wrap="square" rtlCol="0" anchor="ctr"/>
+          <a:lstStyle/>
+          <a:p>
+            <a:pPr algn="ctr" indent="0" marL="0">
+              <a:buNone/>
+            </a:pPr>
+            <a:r>
+              <a:rPr lang="en-US" sz="1000" b="1" dirty="0">
                 <a:solidFill>
                   <a:srgbClr val="6B7280"/>
                 </a:solidFill>
@@ -5753,9 +6595,1654 @@
                 <a:ea typeface="游ゴシック" pitchFamily="34" charset="-122"/>
                 <a:cs typeface="游ゴシック" pitchFamily="34" charset="-120"/>
               </a:rPr>
-              <a:t>内容を準備中</a:t>
-            </a:r>
-            <a:endParaRPr lang="en-US" sz="1400" dirty="0"/>
+              <a:t>未</a:t>
+            </a:r>
+            <a:endParaRPr lang="en-US" sz="1000" dirty="0"/>
+          </a:p>
+        </p:txBody>
+      </p:sp>
+      <p:sp>
+        <p:nvSpPr>
+          <p:cNvPr id="31" name="Shape 29"/>
+          <p:cNvSpPr/>
+          <p:nvPr/>
+        </p:nvSpPr>
+        <p:spPr>
+          <a:xfrm>
+            <a:off x="548640" y="2606040"/>
+            <a:ext cx="11091672" cy="365760"/>
+          </a:xfrm>
+          <a:prstGeom prst="rect">
+            <a:avLst/>
+          </a:prstGeom>
+          <a:solidFill>
+            <a:srgbClr val="F5F7FA"/>
+          </a:solidFill>
+          <a:ln/>
+        </p:spPr>
+      </p:sp>
+      <p:sp>
+        <p:nvSpPr>
+          <p:cNvPr id="32" name="Text 30"/>
+          <p:cNvSpPr/>
+          <p:nvPr/>
+        </p:nvSpPr>
+        <p:spPr>
+          <a:xfrm>
+            <a:off x="548640" y="2606040"/>
+            <a:ext cx="1097280" cy="365760"/>
+          </a:xfrm>
+          <a:prstGeom prst="rect">
+            <a:avLst/>
+          </a:prstGeom>
+          <a:noFill/>
+          <a:ln/>
+        </p:spPr>
+        <p:txBody>
+          <a:bodyPr wrap="square" rtlCol="0" anchor="ctr"/>
+          <a:lstStyle/>
+          <a:p>
+            <a:pPr algn="l" indent="0" marL="0">
+              <a:buNone/>
+            </a:pPr>
+            <a:r>
+              <a:rPr lang="en-US" sz="1300" b="1" dirty="0">
+                <a:solidFill>
+                  <a:srgbClr val="1A1A2E"/>
+                </a:solidFill>
+                <a:latin typeface="游ゴシック" pitchFamily="34" charset="0"/>
+                <a:ea typeface="游ゴシック" pitchFamily="34" charset="-122"/>
+                <a:cs typeface="游ゴシック" pitchFamily="34" charset="-120"/>
+              </a:rPr>
+              <a:t>東区</a:t>
+            </a:r>
+            <a:endParaRPr lang="en-US" sz="1300" dirty="0"/>
+          </a:p>
+        </p:txBody>
+      </p:sp>
+      <p:sp>
+        <p:nvSpPr>
+          <p:cNvPr id="33" name="Text 31"/>
+          <p:cNvSpPr/>
+          <p:nvPr/>
+        </p:nvSpPr>
+        <p:spPr>
+          <a:xfrm>
+            <a:off x="1645920" y="2606040"/>
+            <a:ext cx="1005840" cy="365760"/>
+          </a:xfrm>
+          <a:prstGeom prst="rect">
+            <a:avLst/>
+          </a:prstGeom>
+          <a:noFill/>
+          <a:ln/>
+        </p:spPr>
+        <p:txBody>
+          <a:bodyPr wrap="square" rtlCol="0" anchor="ctr"/>
+          <a:lstStyle/>
+          <a:p>
+            <a:pPr algn="ctr" indent="0" marL="0">
+              <a:buNone/>
+            </a:pPr>
+            <a:r>
+              <a:rPr lang="en-US" sz="1200" b="1" dirty="0">
+                <a:solidFill>
+                  <a:srgbClr val="1A1A2E"/>
+                </a:solidFill>
+                <a:latin typeface="游ゴシック" pitchFamily="34" charset="0"/>
+                <a:ea typeface="游ゴシック" pitchFamily="34" charset="-122"/>
+                <a:cs typeface="游ゴシック" pitchFamily="34" charset="-120"/>
+              </a:rPr>
+              <a:t>11/8</a:t>
+            </a:r>
+            <a:endParaRPr lang="en-US" sz="1200" dirty="0"/>
+          </a:p>
+        </p:txBody>
+      </p:sp>
+      <p:sp>
+        <p:nvSpPr>
+          <p:cNvPr id="34" name="Text 32"/>
+          <p:cNvSpPr/>
+          <p:nvPr/>
+        </p:nvSpPr>
+        <p:spPr>
+          <a:xfrm>
+            <a:off x="2651760" y="2606040"/>
+            <a:ext cx="1280160" cy="365760"/>
+          </a:xfrm>
+          <a:prstGeom prst="rect">
+            <a:avLst/>
+          </a:prstGeom>
+          <a:noFill/>
+          <a:ln/>
+        </p:spPr>
+        <p:txBody>
+          <a:bodyPr wrap="square" rtlCol="0" anchor="ctr"/>
+          <a:lstStyle/>
+          <a:p>
+            <a:pPr algn="ctr" indent="0" marL="0">
+              <a:buNone/>
+            </a:pPr>
+            <a:r>
+              <a:rPr lang="en-US" sz="1200" b="1" dirty="0">
+                <a:solidFill>
+                  <a:srgbClr val="1A1A2E"/>
+                </a:solidFill>
+                <a:latin typeface="游ゴシック" pitchFamily="34" charset="0"/>
+                <a:ea typeface="游ゴシック" pitchFamily="34" charset="-122"/>
+                <a:cs typeface="游ゴシック" pitchFamily="34" charset="-120"/>
+              </a:rPr>
+              <a:t>7月</a:t>
+            </a:r>
+            <a:endParaRPr lang="en-US" sz="1200" dirty="0"/>
+          </a:p>
+        </p:txBody>
+      </p:sp>
+      <p:sp>
+        <p:nvSpPr>
+          <p:cNvPr id="35" name="Text 33"/>
+          <p:cNvSpPr/>
+          <p:nvPr/>
+        </p:nvSpPr>
+        <p:spPr>
+          <a:xfrm>
+            <a:off x="3931920" y="2606040"/>
+            <a:ext cx="4114800" cy="365760"/>
+          </a:xfrm>
+          <a:prstGeom prst="rect">
+            <a:avLst/>
+          </a:prstGeom>
+          <a:noFill/>
+          <a:ln/>
+        </p:spPr>
+        <p:txBody>
+          <a:bodyPr wrap="square" rtlCol="0" anchor="ctr"/>
+          <a:lstStyle/>
+          <a:p>
+            <a:pPr algn="r" indent="0" marL="0">
+              <a:buNone/>
+            </a:pPr>
+            <a:r>
+              <a:rPr lang="en-US" sz="1300" b="1" dirty="0">
+                <a:solidFill>
+                  <a:srgbClr val="1A1A2E"/>
+                </a:solidFill>
+                <a:latin typeface="游ゴシック" pitchFamily="34" charset="0"/>
+                <a:ea typeface="游ゴシック" pitchFamily="34" charset="-122"/>
+                <a:cs typeface="游ゴシック" pitchFamily="34" charset="-120"/>
+              </a:rPr>
+              <a:t>4,930,000</a:t>
+            </a:r>
+            <a:endParaRPr lang="en-US" sz="1300" dirty="0"/>
+          </a:p>
+        </p:txBody>
+      </p:sp>
+      <p:sp>
+        <p:nvSpPr>
+          <p:cNvPr id="36" name="Shape 34"/>
+          <p:cNvSpPr/>
+          <p:nvPr/>
+        </p:nvSpPr>
+        <p:spPr>
+          <a:xfrm>
+            <a:off x="8206740" y="2679192"/>
+            <a:ext cx="594360" cy="219456"/>
+          </a:xfrm>
+          <a:prstGeom prst="rect">
+            <a:avLst/>
+          </a:prstGeom>
+          <a:solidFill>
+            <a:srgbClr val="E5E7EB"/>
+          </a:solidFill>
+          <a:ln/>
+        </p:spPr>
+      </p:sp>
+      <p:sp>
+        <p:nvSpPr>
+          <p:cNvPr id="37" name="Text 35"/>
+          <p:cNvSpPr/>
+          <p:nvPr/>
+        </p:nvSpPr>
+        <p:spPr>
+          <a:xfrm>
+            <a:off x="8206740" y="2679192"/>
+            <a:ext cx="594360" cy="219456"/>
+          </a:xfrm>
+          <a:prstGeom prst="rect">
+            <a:avLst/>
+          </a:prstGeom>
+          <a:noFill/>
+          <a:ln/>
+        </p:spPr>
+        <p:txBody>
+          <a:bodyPr wrap="square" rtlCol="0" anchor="ctr"/>
+          <a:lstStyle/>
+          <a:p>
+            <a:pPr algn="ctr" indent="0" marL="0">
+              <a:buNone/>
+            </a:pPr>
+            <a:r>
+              <a:rPr lang="en-US" sz="1000" b="1" dirty="0">
+                <a:solidFill>
+                  <a:srgbClr val="6B7280"/>
+                </a:solidFill>
+                <a:latin typeface="游ゴシック" pitchFamily="34" charset="0"/>
+                <a:ea typeface="游ゴシック" pitchFamily="34" charset="-122"/>
+                <a:cs typeface="游ゴシック" pitchFamily="34" charset="-120"/>
+              </a:rPr>
+              <a:t>未</a:t>
+            </a:r>
+            <a:endParaRPr lang="en-US" sz="1000" dirty="0"/>
+          </a:p>
+        </p:txBody>
+      </p:sp>
+      <p:sp>
+        <p:nvSpPr>
+          <p:cNvPr id="38" name="Shape 36"/>
+          <p:cNvSpPr/>
+          <p:nvPr/>
+        </p:nvSpPr>
+        <p:spPr>
+          <a:xfrm>
+            <a:off x="548640" y="2971800"/>
+            <a:ext cx="11091672" cy="365760"/>
+          </a:xfrm>
+          <a:prstGeom prst="rect">
+            <a:avLst/>
+          </a:prstGeom>
+          <a:solidFill>
+            <a:srgbClr val="FFFFFF"/>
+          </a:solidFill>
+          <a:ln/>
+        </p:spPr>
+      </p:sp>
+      <p:sp>
+        <p:nvSpPr>
+          <p:cNvPr id="39" name="Text 37"/>
+          <p:cNvSpPr/>
+          <p:nvPr/>
+        </p:nvSpPr>
+        <p:spPr>
+          <a:xfrm>
+            <a:off x="548640" y="2971800"/>
+            <a:ext cx="1097280" cy="365760"/>
+          </a:xfrm>
+          <a:prstGeom prst="rect">
+            <a:avLst/>
+          </a:prstGeom>
+          <a:noFill/>
+          <a:ln/>
+        </p:spPr>
+        <p:txBody>
+          <a:bodyPr wrap="square" rtlCol="0" anchor="ctr"/>
+          <a:lstStyle/>
+          <a:p>
+            <a:pPr algn="l" indent="0" marL="0">
+              <a:buNone/>
+            </a:pPr>
+            <a:r>
+              <a:rPr lang="en-US" sz="1300" b="1" dirty="0">
+                <a:solidFill>
+                  <a:srgbClr val="1A1A2E"/>
+                </a:solidFill>
+                <a:latin typeface="游ゴシック" pitchFamily="34" charset="0"/>
+                <a:ea typeface="游ゴシック" pitchFamily="34" charset="-122"/>
+                <a:cs typeface="游ゴシック" pitchFamily="34" charset="-120"/>
+              </a:rPr>
+              <a:t>昭和区</a:t>
+            </a:r>
+            <a:endParaRPr lang="en-US" sz="1300" dirty="0"/>
+          </a:p>
+        </p:txBody>
+      </p:sp>
+      <p:sp>
+        <p:nvSpPr>
+          <p:cNvPr id="40" name="Text 38"/>
+          <p:cNvSpPr/>
+          <p:nvPr/>
+        </p:nvSpPr>
+        <p:spPr>
+          <a:xfrm>
+            <a:off x="1645920" y="2971800"/>
+            <a:ext cx="1005840" cy="365760"/>
+          </a:xfrm>
+          <a:prstGeom prst="rect">
+            <a:avLst/>
+          </a:prstGeom>
+          <a:noFill/>
+          <a:ln/>
+        </p:spPr>
+        <p:txBody>
+          <a:bodyPr wrap="square" rtlCol="0" anchor="ctr"/>
+          <a:lstStyle/>
+          <a:p>
+            <a:pPr algn="ctr" indent="0" marL="0">
+              <a:buNone/>
+            </a:pPr>
+            <a:r>
+              <a:rPr lang="en-US" sz="1200" b="1" dirty="0">
+                <a:solidFill>
+                  <a:srgbClr val="1A1A2E"/>
+                </a:solidFill>
+                <a:latin typeface="游ゴシック" pitchFamily="34" charset="0"/>
+                <a:ea typeface="游ゴシック" pitchFamily="34" charset="-122"/>
+                <a:cs typeface="游ゴシック" pitchFamily="34" charset="-120"/>
+              </a:rPr>
+              <a:t>11/15</a:t>
+            </a:r>
+            <a:endParaRPr lang="en-US" sz="1200" dirty="0"/>
+          </a:p>
+        </p:txBody>
+      </p:sp>
+      <p:sp>
+        <p:nvSpPr>
+          <p:cNvPr id="41" name="Text 39"/>
+          <p:cNvSpPr/>
+          <p:nvPr/>
+        </p:nvSpPr>
+        <p:spPr>
+          <a:xfrm>
+            <a:off x="2651760" y="2971800"/>
+            <a:ext cx="1280160" cy="365760"/>
+          </a:xfrm>
+          <a:prstGeom prst="rect">
+            <a:avLst/>
+          </a:prstGeom>
+          <a:noFill/>
+          <a:ln/>
+        </p:spPr>
+        <p:txBody>
+          <a:bodyPr wrap="square" rtlCol="0" anchor="ctr"/>
+          <a:lstStyle/>
+          <a:p>
+            <a:pPr algn="ctr" indent="0" marL="0">
+              <a:buNone/>
+            </a:pPr>
+            <a:r>
+              <a:rPr lang="en-US" sz="1200" b="1" dirty="0">
+                <a:solidFill>
+                  <a:srgbClr val="1A1A2E"/>
+                </a:solidFill>
+                <a:latin typeface="游ゴシック" pitchFamily="34" charset="0"/>
+                <a:ea typeface="游ゴシック" pitchFamily="34" charset="-122"/>
+                <a:cs typeface="游ゴシック" pitchFamily="34" charset="-120"/>
+              </a:rPr>
+              <a:t>7月</a:t>
+            </a:r>
+            <a:endParaRPr lang="en-US" sz="1200" dirty="0"/>
+          </a:p>
+        </p:txBody>
+      </p:sp>
+      <p:sp>
+        <p:nvSpPr>
+          <p:cNvPr id="42" name="Text 40"/>
+          <p:cNvSpPr/>
+          <p:nvPr/>
+        </p:nvSpPr>
+        <p:spPr>
+          <a:xfrm>
+            <a:off x="3931920" y="2971800"/>
+            <a:ext cx="4114800" cy="365760"/>
+          </a:xfrm>
+          <a:prstGeom prst="rect">
+            <a:avLst/>
+          </a:prstGeom>
+          <a:noFill/>
+          <a:ln/>
+        </p:spPr>
+        <p:txBody>
+          <a:bodyPr wrap="square" rtlCol="0" anchor="ctr"/>
+          <a:lstStyle/>
+          <a:p>
+            <a:pPr algn="r" indent="0" marL="0">
+              <a:buNone/>
+            </a:pPr>
+            <a:r>
+              <a:rPr lang="en-US" sz="1300" b="1" dirty="0">
+                <a:solidFill>
+                  <a:srgbClr val="1A1A2E"/>
+                </a:solidFill>
+                <a:latin typeface="游ゴシック" pitchFamily="34" charset="0"/>
+                <a:ea typeface="游ゴシック" pitchFamily="34" charset="-122"/>
+                <a:cs typeface="游ゴシック" pitchFamily="34" charset="-120"/>
+              </a:rPr>
+              <a:t>4,300,000</a:t>
+            </a:r>
+            <a:endParaRPr lang="en-US" sz="1300" dirty="0"/>
+          </a:p>
+        </p:txBody>
+      </p:sp>
+      <p:sp>
+        <p:nvSpPr>
+          <p:cNvPr id="43" name="Shape 41"/>
+          <p:cNvSpPr/>
+          <p:nvPr/>
+        </p:nvSpPr>
+        <p:spPr>
+          <a:xfrm>
+            <a:off x="8206740" y="3044952"/>
+            <a:ext cx="594360" cy="219456"/>
+          </a:xfrm>
+          <a:prstGeom prst="rect">
+            <a:avLst/>
+          </a:prstGeom>
+          <a:solidFill>
+            <a:srgbClr val="E5E7EB"/>
+          </a:solidFill>
+          <a:ln/>
+        </p:spPr>
+      </p:sp>
+      <p:sp>
+        <p:nvSpPr>
+          <p:cNvPr id="44" name="Text 42"/>
+          <p:cNvSpPr/>
+          <p:nvPr/>
+        </p:nvSpPr>
+        <p:spPr>
+          <a:xfrm>
+            <a:off x="8206740" y="3044952"/>
+            <a:ext cx="594360" cy="219456"/>
+          </a:xfrm>
+          <a:prstGeom prst="rect">
+            <a:avLst/>
+          </a:prstGeom>
+          <a:noFill/>
+          <a:ln/>
+        </p:spPr>
+        <p:txBody>
+          <a:bodyPr wrap="square" rtlCol="0" anchor="ctr"/>
+          <a:lstStyle/>
+          <a:p>
+            <a:pPr algn="ctr" indent="0" marL="0">
+              <a:buNone/>
+            </a:pPr>
+            <a:r>
+              <a:rPr lang="en-US" sz="1000" b="1" dirty="0">
+                <a:solidFill>
+                  <a:srgbClr val="6B7280"/>
+                </a:solidFill>
+                <a:latin typeface="游ゴシック" pitchFamily="34" charset="0"/>
+                <a:ea typeface="游ゴシック" pitchFamily="34" charset="-122"/>
+                <a:cs typeface="游ゴシック" pitchFamily="34" charset="-120"/>
+              </a:rPr>
+              <a:t>未</a:t>
+            </a:r>
+            <a:endParaRPr lang="en-US" sz="1000" dirty="0"/>
+          </a:p>
+        </p:txBody>
+      </p:sp>
+      <p:sp>
+        <p:nvSpPr>
+          <p:cNvPr id="45" name="Shape 43"/>
+          <p:cNvSpPr/>
+          <p:nvPr/>
+        </p:nvSpPr>
+        <p:spPr>
+          <a:xfrm>
+            <a:off x="548640" y="3337560"/>
+            <a:ext cx="11091672" cy="365760"/>
+          </a:xfrm>
+          <a:prstGeom prst="rect">
+            <a:avLst/>
+          </a:prstGeom>
+          <a:solidFill>
+            <a:srgbClr val="F5F7FA"/>
+          </a:solidFill>
+          <a:ln/>
+        </p:spPr>
+      </p:sp>
+      <p:sp>
+        <p:nvSpPr>
+          <p:cNvPr id="46" name="Text 44"/>
+          <p:cNvSpPr/>
+          <p:nvPr/>
+        </p:nvSpPr>
+        <p:spPr>
+          <a:xfrm>
+            <a:off x="548640" y="3337560"/>
+            <a:ext cx="1097280" cy="365760"/>
+          </a:xfrm>
+          <a:prstGeom prst="rect">
+            <a:avLst/>
+          </a:prstGeom>
+          <a:noFill/>
+          <a:ln/>
+        </p:spPr>
+        <p:txBody>
+          <a:bodyPr wrap="square" rtlCol="0" anchor="ctr"/>
+          <a:lstStyle/>
+          <a:p>
+            <a:pPr algn="l" indent="0" marL="0">
+              <a:buNone/>
+            </a:pPr>
+            <a:r>
+              <a:rPr lang="en-US" sz="1300" b="1" dirty="0">
+                <a:solidFill>
+                  <a:srgbClr val="1A1A2E"/>
+                </a:solidFill>
+                <a:latin typeface="游ゴシック" pitchFamily="34" charset="0"/>
+                <a:ea typeface="游ゴシック" pitchFamily="34" charset="-122"/>
+                <a:cs typeface="游ゴシック" pitchFamily="34" charset="-120"/>
+              </a:rPr>
+              <a:t>千種区</a:t>
+            </a:r>
+            <a:endParaRPr lang="en-US" sz="1300" dirty="0"/>
+          </a:p>
+        </p:txBody>
+      </p:sp>
+      <p:sp>
+        <p:nvSpPr>
+          <p:cNvPr id="47" name="Text 45"/>
+          <p:cNvSpPr/>
+          <p:nvPr/>
+        </p:nvSpPr>
+        <p:spPr>
+          <a:xfrm>
+            <a:off x="1645920" y="3337560"/>
+            <a:ext cx="1005840" cy="365760"/>
+          </a:xfrm>
+          <a:prstGeom prst="rect">
+            <a:avLst/>
+          </a:prstGeom>
+          <a:noFill/>
+          <a:ln/>
+        </p:spPr>
+        <p:txBody>
+          <a:bodyPr wrap="square" rtlCol="0" anchor="ctr"/>
+          <a:lstStyle/>
+          <a:p>
+            <a:pPr algn="ctr" indent="0" marL="0">
+              <a:buNone/>
+            </a:pPr>
+            <a:r>
+              <a:rPr lang="en-US" sz="1200" b="1" dirty="0">
+                <a:solidFill>
+                  <a:srgbClr val="1A1A2E"/>
+                </a:solidFill>
+                <a:latin typeface="游ゴシック" pitchFamily="34" charset="0"/>
+                <a:ea typeface="游ゴシック" pitchFamily="34" charset="-122"/>
+                <a:cs typeface="游ゴシック" pitchFamily="34" charset="-120"/>
+              </a:rPr>
+              <a:t>12/5</a:t>
+            </a:r>
+            <a:endParaRPr lang="en-US" sz="1200" dirty="0"/>
+          </a:p>
+        </p:txBody>
+      </p:sp>
+      <p:sp>
+        <p:nvSpPr>
+          <p:cNvPr id="48" name="Text 46"/>
+          <p:cNvSpPr/>
+          <p:nvPr/>
+        </p:nvSpPr>
+        <p:spPr>
+          <a:xfrm>
+            <a:off x="2651760" y="3337560"/>
+            <a:ext cx="1280160" cy="365760"/>
+          </a:xfrm>
+          <a:prstGeom prst="rect">
+            <a:avLst/>
+          </a:prstGeom>
+          <a:noFill/>
+          <a:ln/>
+        </p:spPr>
+        <p:txBody>
+          <a:bodyPr wrap="square" rtlCol="0" anchor="ctr"/>
+          <a:lstStyle/>
+          <a:p>
+            <a:pPr algn="ctr" indent="0" marL="0">
+              <a:buNone/>
+            </a:pPr>
+            <a:r>
+              <a:rPr lang="en-US" sz="1200" b="1" dirty="0">
+                <a:solidFill>
+                  <a:srgbClr val="1A1A2E"/>
+                </a:solidFill>
+                <a:latin typeface="游ゴシック" pitchFamily="34" charset="0"/>
+                <a:ea typeface="游ゴシック" pitchFamily="34" charset="-122"/>
+                <a:cs typeface="游ゴシック" pitchFamily="34" charset="-120"/>
+              </a:rPr>
+              <a:t>7月</a:t>
+            </a:r>
+            <a:endParaRPr lang="en-US" sz="1200" dirty="0"/>
+          </a:p>
+        </p:txBody>
+      </p:sp>
+      <p:sp>
+        <p:nvSpPr>
+          <p:cNvPr id="49" name="Text 47"/>
+          <p:cNvSpPr/>
+          <p:nvPr/>
+        </p:nvSpPr>
+        <p:spPr>
+          <a:xfrm>
+            <a:off x="3931920" y="3337560"/>
+            <a:ext cx="4114800" cy="365760"/>
+          </a:xfrm>
+          <a:prstGeom prst="rect">
+            <a:avLst/>
+          </a:prstGeom>
+          <a:noFill/>
+          <a:ln/>
+        </p:spPr>
+        <p:txBody>
+          <a:bodyPr wrap="square" rtlCol="0" anchor="ctr"/>
+          <a:lstStyle/>
+          <a:p>
+            <a:pPr algn="r" indent="0" marL="0">
+              <a:buNone/>
+            </a:pPr>
+            <a:r>
+              <a:rPr lang="en-US" sz="1300" b="1" dirty="0">
+                <a:solidFill>
+                  <a:srgbClr val="1A1A2E"/>
+                </a:solidFill>
+                <a:latin typeface="游ゴシック" pitchFamily="34" charset="0"/>
+                <a:ea typeface="游ゴシック" pitchFamily="34" charset="-122"/>
+                <a:cs typeface="游ゴシック" pitchFamily="34" charset="-120"/>
+              </a:rPr>
+              <a:t>3,700,000</a:t>
+            </a:r>
+            <a:endParaRPr lang="en-US" sz="1300" dirty="0"/>
+          </a:p>
+        </p:txBody>
+      </p:sp>
+      <p:sp>
+        <p:nvSpPr>
+          <p:cNvPr id="50" name="Shape 48"/>
+          <p:cNvSpPr/>
+          <p:nvPr/>
+        </p:nvSpPr>
+        <p:spPr>
+          <a:xfrm>
+            <a:off x="8206740" y="3410712"/>
+            <a:ext cx="594360" cy="219456"/>
+          </a:xfrm>
+          <a:prstGeom prst="rect">
+            <a:avLst/>
+          </a:prstGeom>
+          <a:solidFill>
+            <a:srgbClr val="E5E7EB"/>
+          </a:solidFill>
+          <a:ln/>
+        </p:spPr>
+      </p:sp>
+      <p:sp>
+        <p:nvSpPr>
+          <p:cNvPr id="51" name="Text 49"/>
+          <p:cNvSpPr/>
+          <p:nvPr/>
+        </p:nvSpPr>
+        <p:spPr>
+          <a:xfrm>
+            <a:off x="8206740" y="3410712"/>
+            <a:ext cx="594360" cy="219456"/>
+          </a:xfrm>
+          <a:prstGeom prst="rect">
+            <a:avLst/>
+          </a:prstGeom>
+          <a:noFill/>
+          <a:ln/>
+        </p:spPr>
+        <p:txBody>
+          <a:bodyPr wrap="square" rtlCol="0" anchor="ctr"/>
+          <a:lstStyle/>
+          <a:p>
+            <a:pPr algn="ctr" indent="0" marL="0">
+              <a:buNone/>
+            </a:pPr>
+            <a:r>
+              <a:rPr lang="en-US" sz="1000" b="1" dirty="0">
+                <a:solidFill>
+                  <a:srgbClr val="6B7280"/>
+                </a:solidFill>
+                <a:latin typeface="游ゴシック" pitchFamily="34" charset="0"/>
+                <a:ea typeface="游ゴシック" pitchFamily="34" charset="-122"/>
+                <a:cs typeface="游ゴシック" pitchFamily="34" charset="-120"/>
+              </a:rPr>
+              <a:t>未</a:t>
+            </a:r>
+            <a:endParaRPr lang="en-US" sz="1000" dirty="0"/>
+          </a:p>
+        </p:txBody>
+      </p:sp>
+      <p:sp>
+        <p:nvSpPr>
+          <p:cNvPr id="52" name="Shape 50"/>
+          <p:cNvSpPr/>
+          <p:nvPr/>
+        </p:nvSpPr>
+        <p:spPr>
+          <a:xfrm>
+            <a:off x="548640" y="3703320"/>
+            <a:ext cx="11091672" cy="365760"/>
+          </a:xfrm>
+          <a:prstGeom prst="rect">
+            <a:avLst/>
+          </a:prstGeom>
+          <a:solidFill>
+            <a:srgbClr val="FFFFFF"/>
+          </a:solidFill>
+          <a:ln/>
+        </p:spPr>
+      </p:sp>
+      <p:sp>
+        <p:nvSpPr>
+          <p:cNvPr id="53" name="Text 51"/>
+          <p:cNvSpPr/>
+          <p:nvPr/>
+        </p:nvSpPr>
+        <p:spPr>
+          <a:xfrm>
+            <a:off x="548640" y="3703320"/>
+            <a:ext cx="1097280" cy="365760"/>
+          </a:xfrm>
+          <a:prstGeom prst="rect">
+            <a:avLst/>
+          </a:prstGeom>
+          <a:noFill/>
+          <a:ln/>
+        </p:spPr>
+        <p:txBody>
+          <a:bodyPr wrap="square" rtlCol="0" anchor="ctr"/>
+          <a:lstStyle/>
+          <a:p>
+            <a:pPr algn="l" indent="0" marL="0">
+              <a:buNone/>
+            </a:pPr>
+            <a:r>
+              <a:rPr lang="en-US" sz="1300" b="1" dirty="0">
+                <a:solidFill>
+                  <a:srgbClr val="1A1A2E"/>
+                </a:solidFill>
+                <a:latin typeface="游ゴシック" pitchFamily="34" charset="0"/>
+                <a:ea typeface="游ゴシック" pitchFamily="34" charset="-122"/>
+                <a:cs typeface="游ゴシック" pitchFamily="34" charset="-120"/>
+              </a:rPr>
+              <a:t>天白区</a:t>
+            </a:r>
+            <a:endParaRPr lang="en-US" sz="1300" dirty="0"/>
+          </a:p>
+        </p:txBody>
+      </p:sp>
+      <p:sp>
+        <p:nvSpPr>
+          <p:cNvPr id="54" name="Text 52"/>
+          <p:cNvSpPr/>
+          <p:nvPr/>
+        </p:nvSpPr>
+        <p:spPr>
+          <a:xfrm>
+            <a:off x="1645920" y="3703320"/>
+            <a:ext cx="1005840" cy="365760"/>
+          </a:xfrm>
+          <a:prstGeom prst="rect">
+            <a:avLst/>
+          </a:prstGeom>
+          <a:noFill/>
+          <a:ln/>
+        </p:spPr>
+        <p:txBody>
+          <a:bodyPr wrap="square" rtlCol="0" anchor="ctr"/>
+          <a:lstStyle/>
+          <a:p>
+            <a:pPr algn="ctr" indent="0" marL="0">
+              <a:buNone/>
+            </a:pPr>
+            <a:r>
+              <a:rPr lang="en-US" sz="1200" b="1" dirty="0">
+                <a:solidFill>
+                  <a:srgbClr val="1A1A2E"/>
+                </a:solidFill>
+                <a:latin typeface="游ゴシック" pitchFamily="34" charset="0"/>
+                <a:ea typeface="游ゴシック" pitchFamily="34" charset="-122"/>
+                <a:cs typeface="游ゴシック" pitchFamily="34" charset="-120"/>
+              </a:rPr>
+              <a:t>12/5</a:t>
+            </a:r>
+            <a:endParaRPr lang="en-US" sz="1200" dirty="0"/>
+          </a:p>
+        </p:txBody>
+      </p:sp>
+      <p:sp>
+        <p:nvSpPr>
+          <p:cNvPr id="55" name="Text 53"/>
+          <p:cNvSpPr/>
+          <p:nvPr/>
+        </p:nvSpPr>
+        <p:spPr>
+          <a:xfrm>
+            <a:off x="2651760" y="3703320"/>
+            <a:ext cx="1280160" cy="365760"/>
+          </a:xfrm>
+          <a:prstGeom prst="rect">
+            <a:avLst/>
+          </a:prstGeom>
+          <a:noFill/>
+          <a:ln/>
+        </p:spPr>
+        <p:txBody>
+          <a:bodyPr wrap="square" rtlCol="0" anchor="ctr"/>
+          <a:lstStyle/>
+          <a:p>
+            <a:pPr algn="ctr" indent="0" marL="0">
+              <a:buNone/>
+            </a:pPr>
+            <a:r>
+              <a:rPr lang="en-US" sz="1200" b="1" dirty="0">
+                <a:solidFill>
+                  <a:srgbClr val="1A1A2E"/>
+                </a:solidFill>
+                <a:latin typeface="游ゴシック" pitchFamily="34" charset="0"/>
+                <a:ea typeface="游ゴシック" pitchFamily="34" charset="-122"/>
+                <a:cs typeface="游ゴシック" pitchFamily="34" charset="-120"/>
+              </a:rPr>
+              <a:t>7月</a:t>
+            </a:r>
+            <a:endParaRPr lang="en-US" sz="1200" dirty="0"/>
+          </a:p>
+        </p:txBody>
+      </p:sp>
+      <p:sp>
+        <p:nvSpPr>
+          <p:cNvPr id="56" name="Text 54"/>
+          <p:cNvSpPr/>
+          <p:nvPr/>
+        </p:nvSpPr>
+        <p:spPr>
+          <a:xfrm>
+            <a:off x="3931920" y="3703320"/>
+            <a:ext cx="4114800" cy="365760"/>
+          </a:xfrm>
+          <a:prstGeom prst="rect">
+            <a:avLst/>
+          </a:prstGeom>
+          <a:noFill/>
+          <a:ln/>
+        </p:spPr>
+        <p:txBody>
+          <a:bodyPr wrap="square" rtlCol="0" anchor="ctr"/>
+          <a:lstStyle/>
+          <a:p>
+            <a:pPr algn="r" indent="0" marL="0">
+              <a:buNone/>
+            </a:pPr>
+            <a:r>
+              <a:rPr lang="en-US" sz="1300" b="1" dirty="0">
+                <a:solidFill>
+                  <a:srgbClr val="1A1A2E"/>
+                </a:solidFill>
+                <a:latin typeface="游ゴシック" pitchFamily="34" charset="0"/>
+                <a:ea typeface="游ゴシック" pitchFamily="34" charset="-122"/>
+                <a:cs typeface="游ゴシック" pitchFamily="34" charset="-120"/>
+              </a:rPr>
+              <a:t>5,200,000</a:t>
+            </a:r>
+            <a:endParaRPr lang="en-US" sz="1300" dirty="0"/>
+          </a:p>
+        </p:txBody>
+      </p:sp>
+      <p:sp>
+        <p:nvSpPr>
+          <p:cNvPr id="57" name="Shape 55"/>
+          <p:cNvSpPr/>
+          <p:nvPr/>
+        </p:nvSpPr>
+        <p:spPr>
+          <a:xfrm>
+            <a:off x="8206740" y="3776472"/>
+            <a:ext cx="594360" cy="219456"/>
+          </a:xfrm>
+          <a:prstGeom prst="rect">
+            <a:avLst/>
+          </a:prstGeom>
+          <a:solidFill>
+            <a:srgbClr val="E5E7EB"/>
+          </a:solidFill>
+          <a:ln/>
+        </p:spPr>
+      </p:sp>
+      <p:sp>
+        <p:nvSpPr>
+          <p:cNvPr id="58" name="Text 56"/>
+          <p:cNvSpPr/>
+          <p:nvPr/>
+        </p:nvSpPr>
+        <p:spPr>
+          <a:xfrm>
+            <a:off x="8206740" y="3776472"/>
+            <a:ext cx="594360" cy="219456"/>
+          </a:xfrm>
+          <a:prstGeom prst="rect">
+            <a:avLst/>
+          </a:prstGeom>
+          <a:noFill/>
+          <a:ln/>
+        </p:spPr>
+        <p:txBody>
+          <a:bodyPr wrap="square" rtlCol="0" anchor="ctr"/>
+          <a:lstStyle/>
+          <a:p>
+            <a:pPr algn="ctr" indent="0" marL="0">
+              <a:buNone/>
+            </a:pPr>
+            <a:r>
+              <a:rPr lang="en-US" sz="1000" b="1" dirty="0">
+                <a:solidFill>
+                  <a:srgbClr val="6B7280"/>
+                </a:solidFill>
+                <a:latin typeface="游ゴシック" pitchFamily="34" charset="0"/>
+                <a:ea typeface="游ゴシック" pitchFamily="34" charset="-122"/>
+                <a:cs typeface="游ゴシック" pitchFamily="34" charset="-120"/>
+              </a:rPr>
+              <a:t>未</a:t>
+            </a:r>
+            <a:endParaRPr lang="en-US" sz="1000" dirty="0"/>
+          </a:p>
+        </p:txBody>
+      </p:sp>
+      <p:sp>
+        <p:nvSpPr>
+          <p:cNvPr id="59" name="Shape 57"/>
+          <p:cNvSpPr/>
+          <p:nvPr/>
+        </p:nvSpPr>
+        <p:spPr>
+          <a:xfrm>
+            <a:off x="548640" y="4069080"/>
+            <a:ext cx="11091672" cy="365760"/>
+          </a:xfrm>
+          <a:prstGeom prst="rect">
+            <a:avLst/>
+          </a:prstGeom>
+          <a:solidFill>
+            <a:srgbClr val="F5F7FA"/>
+          </a:solidFill>
+          <a:ln/>
+        </p:spPr>
+      </p:sp>
+      <p:sp>
+        <p:nvSpPr>
+          <p:cNvPr id="60" name="Text 58"/>
+          <p:cNvSpPr/>
+          <p:nvPr/>
+        </p:nvSpPr>
+        <p:spPr>
+          <a:xfrm>
+            <a:off x="548640" y="4069080"/>
+            <a:ext cx="1097280" cy="365760"/>
+          </a:xfrm>
+          <a:prstGeom prst="rect">
+            <a:avLst/>
+          </a:prstGeom>
+          <a:noFill/>
+          <a:ln/>
+        </p:spPr>
+        <p:txBody>
+          <a:bodyPr wrap="square" rtlCol="0" anchor="ctr"/>
+          <a:lstStyle/>
+          <a:p>
+            <a:pPr algn="l" indent="0" marL="0">
+              <a:buNone/>
+            </a:pPr>
+            <a:r>
+              <a:rPr lang="en-US" sz="1300" b="1" dirty="0">
+                <a:solidFill>
+                  <a:srgbClr val="1A1A2E"/>
+                </a:solidFill>
+                <a:latin typeface="游ゴシック" pitchFamily="34" charset="0"/>
+                <a:ea typeface="游ゴシック" pitchFamily="34" charset="-122"/>
+                <a:cs typeface="游ゴシック" pitchFamily="34" charset="-120"/>
+              </a:rPr>
+              <a:t>守山区</a:t>
+            </a:r>
+            <a:endParaRPr lang="en-US" sz="1300" dirty="0"/>
+          </a:p>
+        </p:txBody>
+      </p:sp>
+      <p:sp>
+        <p:nvSpPr>
+          <p:cNvPr id="61" name="Text 59"/>
+          <p:cNvSpPr/>
+          <p:nvPr/>
+        </p:nvSpPr>
+        <p:spPr>
+          <a:xfrm>
+            <a:off x="1645920" y="4069080"/>
+            <a:ext cx="1005840" cy="365760"/>
+          </a:xfrm>
+          <a:prstGeom prst="rect">
+            <a:avLst/>
+          </a:prstGeom>
+          <a:noFill/>
+          <a:ln/>
+        </p:spPr>
+        <p:txBody>
+          <a:bodyPr wrap="square" rtlCol="0" anchor="ctr"/>
+          <a:lstStyle/>
+          <a:p>
+            <a:pPr algn="ctr" indent="0" marL="0">
+              <a:buNone/>
+            </a:pPr>
+            <a:r>
+              <a:rPr lang="en-US" sz="1200" b="1" dirty="0">
+                <a:solidFill>
+                  <a:srgbClr val="1A1A2E"/>
+                </a:solidFill>
+                <a:latin typeface="游ゴシック" pitchFamily="34" charset="0"/>
+                <a:ea typeface="游ゴシック" pitchFamily="34" charset="-122"/>
+                <a:cs typeface="游ゴシック" pitchFamily="34" charset="-120"/>
+              </a:rPr>
+              <a:t>12/6</a:t>
+            </a:r>
+            <a:endParaRPr lang="en-US" sz="1200" dirty="0"/>
+          </a:p>
+        </p:txBody>
+      </p:sp>
+      <p:sp>
+        <p:nvSpPr>
+          <p:cNvPr id="62" name="Text 60"/>
+          <p:cNvSpPr/>
+          <p:nvPr/>
+        </p:nvSpPr>
+        <p:spPr>
+          <a:xfrm>
+            <a:off x="2651760" y="4069080"/>
+            <a:ext cx="1280160" cy="365760"/>
+          </a:xfrm>
+          <a:prstGeom prst="rect">
+            <a:avLst/>
+          </a:prstGeom>
+          <a:noFill/>
+          <a:ln/>
+        </p:spPr>
+        <p:txBody>
+          <a:bodyPr wrap="square" rtlCol="0" anchor="ctr"/>
+          <a:lstStyle/>
+          <a:p>
+            <a:pPr algn="ctr" indent="0" marL="0">
+              <a:buNone/>
+            </a:pPr>
+            <a:r>
+              <a:rPr lang="en-US" sz="1200" b="1" dirty="0">
+                <a:solidFill>
+                  <a:srgbClr val="1A1A2E"/>
+                </a:solidFill>
+                <a:latin typeface="游ゴシック" pitchFamily="34" charset="0"/>
+                <a:ea typeface="游ゴシック" pitchFamily="34" charset="-122"/>
+                <a:cs typeface="游ゴシック" pitchFamily="34" charset="-120"/>
+              </a:rPr>
+              <a:t>7月</a:t>
+            </a:r>
+            <a:endParaRPr lang="en-US" sz="1200" dirty="0"/>
+          </a:p>
+        </p:txBody>
+      </p:sp>
+      <p:sp>
+        <p:nvSpPr>
+          <p:cNvPr id="63" name="Text 61"/>
+          <p:cNvSpPr/>
+          <p:nvPr/>
+        </p:nvSpPr>
+        <p:spPr>
+          <a:xfrm>
+            <a:off x="3931920" y="4069080"/>
+            <a:ext cx="4114800" cy="365760"/>
+          </a:xfrm>
+          <a:prstGeom prst="rect">
+            <a:avLst/>
+          </a:prstGeom>
+          <a:noFill/>
+          <a:ln/>
+        </p:spPr>
+        <p:txBody>
+          <a:bodyPr wrap="square" rtlCol="0" anchor="ctr"/>
+          <a:lstStyle/>
+          <a:p>
+            <a:pPr algn="r" indent="0" marL="0">
+              <a:buNone/>
+            </a:pPr>
+            <a:r>
+              <a:rPr lang="en-US" sz="1300" b="1" dirty="0">
+                <a:solidFill>
+                  <a:srgbClr val="1A1A2E"/>
+                </a:solidFill>
+                <a:latin typeface="游ゴシック" pitchFamily="34" charset="0"/>
+                <a:ea typeface="游ゴシック" pitchFamily="34" charset="-122"/>
+                <a:cs typeface="游ゴシック" pitchFamily="34" charset="-120"/>
+              </a:rPr>
+              <a:t>4,000,000</a:t>
+            </a:r>
+            <a:endParaRPr lang="en-US" sz="1300" dirty="0"/>
+          </a:p>
+        </p:txBody>
+      </p:sp>
+      <p:sp>
+        <p:nvSpPr>
+          <p:cNvPr id="64" name="Shape 62"/>
+          <p:cNvSpPr/>
+          <p:nvPr/>
+        </p:nvSpPr>
+        <p:spPr>
+          <a:xfrm>
+            <a:off x="8206740" y="4142232"/>
+            <a:ext cx="594360" cy="219456"/>
+          </a:xfrm>
+          <a:prstGeom prst="rect">
+            <a:avLst/>
+          </a:prstGeom>
+          <a:solidFill>
+            <a:srgbClr val="E5E7EB"/>
+          </a:solidFill>
+          <a:ln/>
+        </p:spPr>
+      </p:sp>
+      <p:sp>
+        <p:nvSpPr>
+          <p:cNvPr id="65" name="Text 63"/>
+          <p:cNvSpPr/>
+          <p:nvPr/>
+        </p:nvSpPr>
+        <p:spPr>
+          <a:xfrm>
+            <a:off x="8206740" y="4142232"/>
+            <a:ext cx="594360" cy="219456"/>
+          </a:xfrm>
+          <a:prstGeom prst="rect">
+            <a:avLst/>
+          </a:prstGeom>
+          <a:noFill/>
+          <a:ln/>
+        </p:spPr>
+        <p:txBody>
+          <a:bodyPr wrap="square" rtlCol="0" anchor="ctr"/>
+          <a:lstStyle/>
+          <a:p>
+            <a:pPr algn="ctr" indent="0" marL="0">
+              <a:buNone/>
+            </a:pPr>
+            <a:r>
+              <a:rPr lang="en-US" sz="1000" b="1" dirty="0">
+                <a:solidFill>
+                  <a:srgbClr val="6B7280"/>
+                </a:solidFill>
+                <a:latin typeface="游ゴシック" pitchFamily="34" charset="0"/>
+                <a:ea typeface="游ゴシック" pitchFamily="34" charset="-122"/>
+                <a:cs typeface="游ゴシック" pitchFamily="34" charset="-120"/>
+              </a:rPr>
+              <a:t>未</a:t>
+            </a:r>
+            <a:endParaRPr lang="en-US" sz="1000" dirty="0"/>
+          </a:p>
+        </p:txBody>
+      </p:sp>
+      <p:sp>
+        <p:nvSpPr>
+          <p:cNvPr id="66" name="Shape 64"/>
+          <p:cNvSpPr/>
+          <p:nvPr/>
+        </p:nvSpPr>
+        <p:spPr>
+          <a:xfrm>
+            <a:off x="548640" y="4434840"/>
+            <a:ext cx="11091672" cy="365760"/>
+          </a:xfrm>
+          <a:prstGeom prst="rect">
+            <a:avLst/>
+          </a:prstGeom>
+          <a:solidFill>
+            <a:srgbClr val="FFFFFF"/>
+          </a:solidFill>
+          <a:ln/>
+        </p:spPr>
+      </p:sp>
+      <p:sp>
+        <p:nvSpPr>
+          <p:cNvPr id="67" name="Text 65"/>
+          <p:cNvSpPr/>
+          <p:nvPr/>
+        </p:nvSpPr>
+        <p:spPr>
+          <a:xfrm>
+            <a:off x="548640" y="4434840"/>
+            <a:ext cx="1097280" cy="365760"/>
+          </a:xfrm>
+          <a:prstGeom prst="rect">
+            <a:avLst/>
+          </a:prstGeom>
+          <a:noFill/>
+          <a:ln/>
+        </p:spPr>
+        <p:txBody>
+          <a:bodyPr wrap="square" rtlCol="0" anchor="ctr"/>
+          <a:lstStyle/>
+          <a:p>
+            <a:pPr algn="l" indent="0" marL="0">
+              <a:buNone/>
+            </a:pPr>
+            <a:r>
+              <a:rPr lang="en-US" sz="1300" b="1" dirty="0">
+                <a:solidFill>
+                  <a:srgbClr val="1A1A2E"/>
+                </a:solidFill>
+                <a:latin typeface="游ゴシック" pitchFamily="34" charset="0"/>
+                <a:ea typeface="游ゴシック" pitchFamily="34" charset="-122"/>
+                <a:cs typeface="游ゴシック" pitchFamily="34" charset="-120"/>
+              </a:rPr>
+              <a:t>南区</a:t>
+            </a:r>
+            <a:endParaRPr lang="en-US" sz="1300" dirty="0"/>
+          </a:p>
+        </p:txBody>
+      </p:sp>
+      <p:sp>
+        <p:nvSpPr>
+          <p:cNvPr id="68" name="Text 66"/>
+          <p:cNvSpPr/>
+          <p:nvPr/>
+        </p:nvSpPr>
+        <p:spPr>
+          <a:xfrm>
+            <a:off x="1645920" y="4434840"/>
+            <a:ext cx="1005840" cy="365760"/>
+          </a:xfrm>
+          <a:prstGeom prst="rect">
+            <a:avLst/>
+          </a:prstGeom>
+          <a:noFill/>
+          <a:ln/>
+        </p:spPr>
+        <p:txBody>
+          <a:bodyPr wrap="square" rtlCol="0" anchor="ctr"/>
+          <a:lstStyle/>
+          <a:p>
+            <a:pPr algn="ctr" indent="0" marL="0">
+              <a:buNone/>
+            </a:pPr>
+            <a:r>
+              <a:rPr lang="en-US" sz="1200" b="1" dirty="0">
+                <a:solidFill>
+                  <a:srgbClr val="1A1A2E"/>
+                </a:solidFill>
+                <a:latin typeface="游ゴシック" pitchFamily="34" charset="0"/>
+                <a:ea typeface="游ゴシック" pitchFamily="34" charset="-122"/>
+                <a:cs typeface="游ゴシック" pitchFamily="34" charset="-120"/>
+              </a:rPr>
+              <a:t>2/21</a:t>
+            </a:r>
+            <a:endParaRPr lang="en-US" sz="1200" dirty="0"/>
+          </a:p>
+        </p:txBody>
+      </p:sp>
+      <p:sp>
+        <p:nvSpPr>
+          <p:cNvPr id="69" name="Text 67"/>
+          <p:cNvSpPr/>
+          <p:nvPr/>
+        </p:nvSpPr>
+        <p:spPr>
+          <a:xfrm>
+            <a:off x="2651760" y="4434840"/>
+            <a:ext cx="1280160" cy="365760"/>
+          </a:xfrm>
+          <a:prstGeom prst="rect">
+            <a:avLst/>
+          </a:prstGeom>
+          <a:noFill/>
+          <a:ln/>
+        </p:spPr>
+        <p:txBody>
+          <a:bodyPr wrap="square" rtlCol="0" anchor="ctr"/>
+          <a:lstStyle/>
+          <a:p>
+            <a:pPr algn="ctr" indent="0" marL="0">
+              <a:buNone/>
+            </a:pPr>
+            <a:r>
+              <a:rPr lang="en-US" sz="1200" b="1" dirty="0">
+                <a:solidFill>
+                  <a:srgbClr val="1A1A2E"/>
+                </a:solidFill>
+                <a:latin typeface="游ゴシック" pitchFamily="34" charset="0"/>
+                <a:ea typeface="游ゴシック" pitchFamily="34" charset="-122"/>
+                <a:cs typeface="游ゴシック" pitchFamily="34" charset="-120"/>
+              </a:rPr>
+              <a:t>10月</a:t>
+            </a:r>
+            <a:endParaRPr lang="en-US" sz="1200" dirty="0"/>
+          </a:p>
+        </p:txBody>
+      </p:sp>
+      <p:sp>
+        <p:nvSpPr>
+          <p:cNvPr id="70" name="Text 68"/>
+          <p:cNvSpPr/>
+          <p:nvPr/>
+        </p:nvSpPr>
+        <p:spPr>
+          <a:xfrm>
+            <a:off x="3931920" y="4434840"/>
+            <a:ext cx="4114800" cy="365760"/>
+          </a:xfrm>
+          <a:prstGeom prst="rect">
+            <a:avLst/>
+          </a:prstGeom>
+          <a:noFill/>
+          <a:ln/>
+        </p:spPr>
+        <p:txBody>
+          <a:bodyPr wrap="square" rtlCol="0" anchor="ctr"/>
+          <a:lstStyle/>
+          <a:p>
+            <a:pPr algn="r" indent="0" marL="0">
+              <a:buNone/>
+            </a:pPr>
+            <a:r>
+              <a:rPr lang="en-US" sz="1300" b="1" dirty="0">
+                <a:solidFill>
+                  <a:srgbClr val="1A1A2E"/>
+                </a:solidFill>
+                <a:latin typeface="游ゴシック" pitchFamily="34" charset="0"/>
+                <a:ea typeface="游ゴシック" pitchFamily="34" charset="-122"/>
+                <a:cs typeface="游ゴシック" pitchFamily="34" charset="-120"/>
+              </a:rPr>
+              <a:t>2,200,000</a:t>
+            </a:r>
+            <a:endParaRPr lang="en-US" sz="1300" dirty="0"/>
+          </a:p>
+        </p:txBody>
+      </p:sp>
+      <p:sp>
+        <p:nvSpPr>
+          <p:cNvPr id="71" name="Shape 69"/>
+          <p:cNvSpPr/>
+          <p:nvPr/>
+        </p:nvSpPr>
+        <p:spPr>
+          <a:xfrm>
+            <a:off x="8206740" y="4507992"/>
+            <a:ext cx="594360" cy="219456"/>
+          </a:xfrm>
+          <a:prstGeom prst="rect">
+            <a:avLst/>
+          </a:prstGeom>
+          <a:solidFill>
+            <a:srgbClr val="E5E7EB"/>
+          </a:solidFill>
+          <a:ln/>
+        </p:spPr>
+      </p:sp>
+      <p:sp>
+        <p:nvSpPr>
+          <p:cNvPr id="72" name="Text 70"/>
+          <p:cNvSpPr/>
+          <p:nvPr/>
+        </p:nvSpPr>
+        <p:spPr>
+          <a:xfrm>
+            <a:off x="8206740" y="4507992"/>
+            <a:ext cx="594360" cy="219456"/>
+          </a:xfrm>
+          <a:prstGeom prst="rect">
+            <a:avLst/>
+          </a:prstGeom>
+          <a:noFill/>
+          <a:ln/>
+        </p:spPr>
+        <p:txBody>
+          <a:bodyPr wrap="square" rtlCol="0" anchor="ctr"/>
+          <a:lstStyle/>
+          <a:p>
+            <a:pPr algn="ctr" indent="0" marL="0">
+              <a:buNone/>
+            </a:pPr>
+            <a:r>
+              <a:rPr lang="en-US" sz="1000" b="1" dirty="0">
+                <a:solidFill>
+                  <a:srgbClr val="6B7280"/>
+                </a:solidFill>
+                <a:latin typeface="游ゴシック" pitchFamily="34" charset="0"/>
+                <a:ea typeface="游ゴシック" pitchFamily="34" charset="-122"/>
+                <a:cs typeface="游ゴシック" pitchFamily="34" charset="-120"/>
+              </a:rPr>
+              <a:t>未</a:t>
+            </a:r>
+            <a:endParaRPr lang="en-US" sz="1000" dirty="0"/>
+          </a:p>
+        </p:txBody>
+      </p:sp>
+      <p:sp>
+        <p:nvSpPr>
+          <p:cNvPr id="73" name="Shape 71"/>
+          <p:cNvSpPr/>
+          <p:nvPr/>
+        </p:nvSpPr>
+        <p:spPr>
+          <a:xfrm>
+            <a:off x="548640" y="4800600"/>
+            <a:ext cx="11091672" cy="365760"/>
+          </a:xfrm>
+          <a:prstGeom prst="rect">
+            <a:avLst/>
+          </a:prstGeom>
+          <a:solidFill>
+            <a:srgbClr val="F5F7FA"/>
+          </a:solidFill>
+          <a:ln/>
+        </p:spPr>
+      </p:sp>
+      <p:sp>
+        <p:nvSpPr>
+          <p:cNvPr id="74" name="Text 72"/>
+          <p:cNvSpPr/>
+          <p:nvPr/>
+        </p:nvSpPr>
+        <p:spPr>
+          <a:xfrm>
+            <a:off x="548640" y="4800600"/>
+            <a:ext cx="1097280" cy="365760"/>
+          </a:xfrm>
+          <a:prstGeom prst="rect">
+            <a:avLst/>
+          </a:prstGeom>
+          <a:noFill/>
+          <a:ln/>
+        </p:spPr>
+        <p:txBody>
+          <a:bodyPr wrap="square" rtlCol="0" anchor="ctr"/>
+          <a:lstStyle/>
+          <a:p>
+            <a:pPr algn="l" indent="0" marL="0">
+              <a:buNone/>
+            </a:pPr>
+            <a:r>
+              <a:rPr lang="en-US" sz="1300" b="1" dirty="0">
+                <a:solidFill>
+                  <a:srgbClr val="1A1A2E"/>
+                </a:solidFill>
+                <a:latin typeface="游ゴシック" pitchFamily="34" charset="0"/>
+                <a:ea typeface="游ゴシック" pitchFamily="34" charset="-122"/>
+                <a:cs typeface="游ゴシック" pitchFamily="34" charset="-120"/>
+              </a:rPr>
+              <a:t>中川区</a:t>
+            </a:r>
+            <a:endParaRPr lang="en-US" sz="1300" dirty="0"/>
+          </a:p>
+        </p:txBody>
+      </p:sp>
+      <p:sp>
+        <p:nvSpPr>
+          <p:cNvPr id="75" name="Text 73"/>
+          <p:cNvSpPr/>
+          <p:nvPr/>
+        </p:nvSpPr>
+        <p:spPr>
+          <a:xfrm>
+            <a:off x="1645920" y="4800600"/>
+            <a:ext cx="1005840" cy="365760"/>
+          </a:xfrm>
+          <a:prstGeom prst="rect">
+            <a:avLst/>
+          </a:prstGeom>
+          <a:noFill/>
+          <a:ln/>
+        </p:spPr>
+        <p:txBody>
+          <a:bodyPr wrap="square" rtlCol="0" anchor="ctr"/>
+          <a:lstStyle/>
+          <a:p>
+            <a:pPr algn="ctr" indent="0" marL="0">
+              <a:buNone/>
+            </a:pPr>
+            <a:r>
+              <a:rPr lang="en-US" sz="1200" b="1" dirty="0">
+                <a:solidFill>
+                  <a:srgbClr val="1A1A2E"/>
+                </a:solidFill>
+                <a:latin typeface="游ゴシック" pitchFamily="34" charset="0"/>
+                <a:ea typeface="游ゴシック" pitchFamily="34" charset="-122"/>
+                <a:cs typeface="游ゴシック" pitchFamily="34" charset="-120"/>
+              </a:rPr>
+              <a:t>2/28</a:t>
+            </a:r>
+            <a:endParaRPr lang="en-US" sz="1200" dirty="0"/>
+          </a:p>
+        </p:txBody>
+      </p:sp>
+      <p:sp>
+        <p:nvSpPr>
+          <p:cNvPr id="76" name="Text 74"/>
+          <p:cNvSpPr/>
+          <p:nvPr/>
+        </p:nvSpPr>
+        <p:spPr>
+          <a:xfrm>
+            <a:off x="2651760" y="4800600"/>
+            <a:ext cx="1280160" cy="365760"/>
+          </a:xfrm>
+          <a:prstGeom prst="rect">
+            <a:avLst/>
+          </a:prstGeom>
+          <a:noFill/>
+          <a:ln/>
+        </p:spPr>
+        <p:txBody>
+          <a:bodyPr wrap="square" rtlCol="0" anchor="ctr"/>
+          <a:lstStyle/>
+          <a:p>
+            <a:pPr algn="ctr" indent="0" marL="0">
+              <a:buNone/>
+            </a:pPr>
+            <a:r>
+              <a:rPr lang="en-US" sz="1200" b="1" dirty="0">
+                <a:solidFill>
+                  <a:srgbClr val="1A1A2E"/>
+                </a:solidFill>
+                <a:latin typeface="游ゴシック" pitchFamily="34" charset="0"/>
+                <a:ea typeface="游ゴシック" pitchFamily="34" charset="-122"/>
+                <a:cs typeface="游ゴシック" pitchFamily="34" charset="-120"/>
+              </a:rPr>
+              <a:t>8月頃</a:t>
+            </a:r>
+            <a:endParaRPr lang="en-US" sz="1200" dirty="0"/>
+          </a:p>
+        </p:txBody>
+      </p:sp>
+      <p:sp>
+        <p:nvSpPr>
+          <p:cNvPr id="77" name="Text 75"/>
+          <p:cNvSpPr/>
+          <p:nvPr/>
+        </p:nvSpPr>
+        <p:spPr>
+          <a:xfrm>
+            <a:off x="3931920" y="4800600"/>
+            <a:ext cx="4114800" cy="365760"/>
+          </a:xfrm>
+          <a:prstGeom prst="rect">
+            <a:avLst/>
+          </a:prstGeom>
+          <a:noFill/>
+          <a:ln/>
+        </p:spPr>
+        <p:txBody>
+          <a:bodyPr wrap="square" rtlCol="0" anchor="ctr"/>
+          <a:lstStyle/>
+          <a:p>
+            <a:pPr algn="r" indent="0" marL="0">
+              <a:buNone/>
+            </a:pPr>
+            <a:r>
+              <a:rPr lang="en-US" sz="1300" b="1" dirty="0">
+                <a:solidFill>
+                  <a:srgbClr val="6B7280"/>
+                </a:solidFill>
+                <a:latin typeface="游ゴシック" pitchFamily="34" charset="0"/>
+                <a:ea typeface="游ゴシック" pitchFamily="34" charset="-122"/>
+                <a:cs typeface="游ゴシック" pitchFamily="34" charset="-120"/>
+              </a:rPr>
+              <a:t>未定</a:t>
+            </a:r>
+            <a:endParaRPr lang="en-US" sz="1300" dirty="0"/>
+          </a:p>
+        </p:txBody>
+      </p:sp>
+      <p:sp>
+        <p:nvSpPr>
+          <p:cNvPr id="78" name="Shape 76"/>
+          <p:cNvSpPr/>
+          <p:nvPr/>
+        </p:nvSpPr>
+        <p:spPr>
+          <a:xfrm>
+            <a:off x="8206740" y="4873752"/>
+            <a:ext cx="594360" cy="219456"/>
+          </a:xfrm>
+          <a:prstGeom prst="rect">
+            <a:avLst/>
+          </a:prstGeom>
+          <a:solidFill>
+            <a:srgbClr val="E5E7EB"/>
+          </a:solidFill>
+          <a:ln/>
+        </p:spPr>
+      </p:sp>
+      <p:sp>
+        <p:nvSpPr>
+          <p:cNvPr id="79" name="Text 77"/>
+          <p:cNvSpPr/>
+          <p:nvPr/>
+        </p:nvSpPr>
+        <p:spPr>
+          <a:xfrm>
+            <a:off x="8206740" y="4873752"/>
+            <a:ext cx="594360" cy="219456"/>
+          </a:xfrm>
+          <a:prstGeom prst="rect">
+            <a:avLst/>
+          </a:prstGeom>
+          <a:noFill/>
+          <a:ln/>
+        </p:spPr>
+        <p:txBody>
+          <a:bodyPr wrap="square" rtlCol="0" anchor="ctr"/>
+          <a:lstStyle/>
+          <a:p>
+            <a:pPr algn="ctr" indent="0" marL="0">
+              <a:buNone/>
+            </a:pPr>
+            <a:r>
+              <a:rPr lang="en-US" sz="1000" b="1" dirty="0">
+                <a:solidFill>
+                  <a:srgbClr val="6B7280"/>
+                </a:solidFill>
+                <a:latin typeface="游ゴシック" pitchFamily="34" charset="0"/>
+                <a:ea typeface="游ゴシック" pitchFamily="34" charset="-122"/>
+                <a:cs typeface="游ゴシック" pitchFamily="34" charset="-120"/>
+              </a:rPr>
+              <a:t>未</a:t>
+            </a:r>
+            <a:endParaRPr lang="en-US" sz="1000" dirty="0"/>
           </a:p>
         </p:txBody>
       </p:sp>

</xml_diff>

<commit_message>
Add 売上トピック slide (slide 4) with agency ranking
東急エージェンシー/サンデーフォーク highlighted, 6 items total

https://claude.ai/code/session_013LUtg8kZ6SCk9upzYYqLj7
</commit_message>
<xml_diff>
--- a/slides/exports/sales-meeting.pptx
+++ b/slides/exports/sales-meeting.pptx
@@ -9,9 +9,10 @@
     <p:sldId id="257" r:id="rId3"/>
     <p:sldId id="258" r:id="rId4"/>
     <p:sldId id="259" r:id="rId5"/>
+    <p:sldId id="260" r:id="rId6"/>
   </p:sldIdLst>
   <p:notesMasterIdLst>
-    <p:notesMasterId r:id="rId6"/>
+    <p:notesMasterId r:id="rId7"/>
   </p:notesMasterIdLst>
   <p:sldSz cx="12192000" cy="6858000"/>
   <p:notesSz cx="6858000" cy="12192000"/>
@@ -793,6 +794,94 @@
             <a:fld id="{F7021451-1387-4CA6-816F-3879F97B5CBC}" type="slidenum">
               <a:rPr lang="en-US"/>
               <a:t>4</a:t>
+            </a:fld>
+            <a:endParaRPr lang="en-US"/>
+          </a:p>
+        </p:txBody>
+      </p:sp>
+    </p:spTree>
+    <p:extLst>
+      <p:ext uri="{BB962C8B-B14F-4D97-AF65-F5344CB8AC3E}">
+        <p14:creationId xmlns:p14="http://schemas.microsoft.com/office/powerpoint/2010/main" val="1024086991"/>
+      </p:ext>
+    </p:extLst>
+  </p:cSld>
+  <p:clrMapOvr>
+    <a:masterClrMapping/>
+  </p:clrMapOvr>
+</p:notes>
+</file>
+
+<file path=ppt/notesSlides/notesSlide5.xml><?xml version="1.0" encoding="utf-8"?>
+<p:notes xmlns:a="http://schemas.openxmlformats.org/drawingml/2006/main" xmlns:r="http://schemas.openxmlformats.org/officeDocument/2006/relationships" xmlns:p="http://schemas.openxmlformats.org/presentationml/2006/main">
+  <p:cSld>
+    <p:spTree>
+      <p:nvGrpSpPr>
+        <p:cNvPr id="1" name=""/>
+        <p:cNvGrpSpPr/>
+        <p:nvPr/>
+      </p:nvGrpSpPr>
+      <p:grpSpPr>
+        <a:xfrm>
+          <a:off x="0" y="0"/>
+          <a:ext cx="0" cy="0"/>
+          <a:chOff x="0" y="0"/>
+          <a:chExt cx="0" cy="0"/>
+        </a:xfrm>
+      </p:grpSpPr>
+      <p:sp>
+        <p:nvSpPr>
+          <p:cNvPr id="2" name="Slide Image Placeholder 1"/>
+          <p:cNvSpPr>
+            <a:spLocks noGrp="1" noRot="1" noChangeAspect="1"/>
+          </p:cNvSpPr>
+          <p:nvPr>
+            <p:ph type="sldImg"/>
+          </p:nvPr>
+        </p:nvSpPr>
+        <p:spPr/>
+      </p:sp>
+      <p:sp>
+        <p:nvSpPr>
+          <p:cNvPr id="3" name="Notes Placeholder 2"/>
+          <p:cNvSpPr>
+            <a:spLocks noGrp="1"/>
+          </p:cNvSpPr>
+          <p:nvPr>
+            <p:ph type="body" idx="1"/>
+          </p:nvPr>
+        </p:nvSpPr>
+        <p:spPr/>
+        <p:txBody>
+          <a:bodyPr/>
+          <a:lstStyle/>
+          <a:p>
+            <a:r>
+              <a:rPr lang="en-US" dirty="0"/>
+              <a:t/>
+            </a:r>
+            <a:endParaRPr lang="en-US" dirty="0"/>
+          </a:p>
+        </p:txBody>
+      </p:sp>
+      <p:sp>
+        <p:nvSpPr>
+          <p:cNvPr id="4" name="Slide Number Placeholder 3"/>
+          <p:cNvSpPr>
+            <a:spLocks noGrp="1"/>
+          </p:cNvSpPr>
+          <p:nvPr>
+            <p:ph type="sldNum" sz="quarter" idx="10"/>
+          </p:nvPr>
+        </p:nvSpPr>
+        <p:spPr/>
+        <p:txBody>
+          <a:bodyPr/>
+          <a:lstStyle/>
+          <a:p>
+            <a:fld id="{F7021451-1387-4CA6-816F-3879F97B5CBC}" type="slidenum">
+              <a:rPr lang="en-US"/>
+              <a:t>5</a:t>
             </a:fld>
             <a:endParaRPr lang="en-US"/>
           </a:p>
@@ -5655,6 +5744,805 @@
                 <a:ea typeface="游ゴシック" pitchFamily="34" charset="-122"/>
                 <a:cs typeface="游ゴシック" pitchFamily="34" charset="-120"/>
               </a:rPr>
+              <a:t>売上トピック</a:t>
+            </a:r>
+            <a:endParaRPr lang="en-US" sz="2600" dirty="0"/>
+          </a:p>
+        </p:txBody>
+      </p:sp>
+      <p:sp>
+        <p:nvSpPr>
+          <p:cNvPr id="3" name="Shape 1"/>
+          <p:cNvSpPr/>
+          <p:nvPr/>
+        </p:nvSpPr>
+        <p:spPr>
+          <a:xfrm>
+            <a:off x="548640" y="960120"/>
+            <a:ext cx="11091672" cy="36576"/>
+          </a:xfrm>
+          <a:prstGeom prst="rect">
+            <a:avLst/>
+          </a:prstGeom>
+          <a:solidFill>
+            <a:srgbClr val="2563EB"/>
+          </a:solidFill>
+          <a:ln/>
+        </p:spPr>
+      </p:sp>
+      <p:sp>
+        <p:nvSpPr>
+          <p:cNvPr id="4" name="Shape 2"/>
+          <p:cNvSpPr/>
+          <p:nvPr/>
+        </p:nvSpPr>
+        <p:spPr>
+          <a:xfrm>
+            <a:off x="548640" y="1234440"/>
+            <a:ext cx="11091672" cy="475488"/>
+          </a:xfrm>
+          <a:prstGeom prst="rect">
+            <a:avLst/>
+          </a:prstGeom>
+          <a:solidFill>
+            <a:srgbClr val="DBEAFE"/>
+          </a:solidFill>
+          <a:ln/>
+        </p:spPr>
+      </p:sp>
+      <p:sp>
+        <p:nvSpPr>
+          <p:cNvPr id="5" name="Shape 3"/>
+          <p:cNvSpPr/>
+          <p:nvPr/>
+        </p:nvSpPr>
+        <p:spPr>
+          <a:xfrm>
+            <a:off x="548640" y="1234440"/>
+            <a:ext cx="41148" cy="475488"/>
+          </a:xfrm>
+          <a:prstGeom prst="rect">
+            <a:avLst/>
+          </a:prstGeom>
+          <a:solidFill>
+            <a:srgbClr val="2563EB"/>
+          </a:solidFill>
+          <a:ln/>
+        </p:spPr>
+      </p:sp>
+      <p:sp>
+        <p:nvSpPr>
+          <p:cNvPr id="6" name="Text 4"/>
+          <p:cNvSpPr/>
+          <p:nvPr/>
+        </p:nvSpPr>
+        <p:spPr>
+          <a:xfrm>
+            <a:off x="713232" y="1234440"/>
+            <a:ext cx="6655003" cy="475488"/>
+          </a:xfrm>
+          <a:prstGeom prst="rect">
+            <a:avLst/>
+          </a:prstGeom>
+          <a:noFill/>
+          <a:ln/>
+        </p:spPr>
+        <p:txBody>
+          <a:bodyPr wrap="square" rtlCol="0" anchor="ctr"/>
+          <a:lstStyle/>
+          <a:p>
+            <a:pPr algn="l" indent="0" marL="0">
+              <a:buNone/>
+            </a:pPr>
+            <a:r>
+              <a:rPr lang="en-US" sz="1500" b="1" dirty="0">
+                <a:solidFill>
+                  <a:srgbClr val="1A1A2E"/>
+                </a:solidFill>
+                <a:latin typeface="游ゴシック" pitchFamily="34" charset="0"/>
+                <a:ea typeface="游ゴシック" pitchFamily="34" charset="-122"/>
+                <a:cs typeface="游ゴシック" pitchFamily="34" charset="-120"/>
+              </a:rPr>
+              <a:t>東急エージェンシー</a:t>
+            </a:r>
+            <a:endParaRPr lang="en-US" sz="1500" dirty="0"/>
+          </a:p>
+        </p:txBody>
+      </p:sp>
+      <p:sp>
+        <p:nvSpPr>
+          <p:cNvPr id="7" name="Text 5"/>
+          <p:cNvSpPr/>
+          <p:nvPr/>
+        </p:nvSpPr>
+        <p:spPr>
+          <a:xfrm>
+            <a:off x="7203643" y="1234440"/>
+            <a:ext cx="4214835" cy="475488"/>
+          </a:xfrm>
+          <a:prstGeom prst="rect">
+            <a:avLst/>
+          </a:prstGeom>
+          <a:noFill/>
+          <a:ln/>
+        </p:spPr>
+        <p:txBody>
+          <a:bodyPr wrap="square" rtlCol="0" anchor="ctr"/>
+          <a:lstStyle/>
+          <a:p>
+            <a:pPr algn="r" indent="0" marL="0">
+              <a:buNone/>
+            </a:pPr>
+            <a:r>
+              <a:rPr lang="en-US" sz="1700" b="1" dirty="0">
+                <a:solidFill>
+                  <a:srgbClr val="2563EB"/>
+                </a:solidFill>
+                <a:latin typeface="游ゴシック" pitchFamily="34" charset="0"/>
+                <a:ea typeface="游ゴシック" pitchFamily="34" charset="-122"/>
+                <a:cs typeface="游ゴシック" pitchFamily="34" charset="-120"/>
+              </a:rPr>
+              <a:t>19,148</a:t>
+            </a:r>
+            <a:endParaRPr lang="en-US" sz="1700" dirty="0"/>
+          </a:p>
+        </p:txBody>
+      </p:sp>
+      <p:sp>
+        <p:nvSpPr>
+          <p:cNvPr id="8" name="Shape 6"/>
+          <p:cNvSpPr/>
+          <p:nvPr/>
+        </p:nvSpPr>
+        <p:spPr>
+          <a:xfrm>
+            <a:off x="548640" y="1801368"/>
+            <a:ext cx="11091672" cy="475488"/>
+          </a:xfrm>
+          <a:prstGeom prst="rect">
+            <a:avLst/>
+          </a:prstGeom>
+          <a:solidFill>
+            <a:srgbClr val="DBEAFE"/>
+          </a:solidFill>
+          <a:ln/>
+        </p:spPr>
+      </p:sp>
+      <p:sp>
+        <p:nvSpPr>
+          <p:cNvPr id="9" name="Shape 7"/>
+          <p:cNvSpPr/>
+          <p:nvPr/>
+        </p:nvSpPr>
+        <p:spPr>
+          <a:xfrm>
+            <a:off x="548640" y="1801368"/>
+            <a:ext cx="41148" cy="475488"/>
+          </a:xfrm>
+          <a:prstGeom prst="rect">
+            <a:avLst/>
+          </a:prstGeom>
+          <a:solidFill>
+            <a:srgbClr val="2563EB"/>
+          </a:solidFill>
+          <a:ln/>
+        </p:spPr>
+      </p:sp>
+      <p:sp>
+        <p:nvSpPr>
+          <p:cNvPr id="10" name="Text 8"/>
+          <p:cNvSpPr/>
+          <p:nvPr/>
+        </p:nvSpPr>
+        <p:spPr>
+          <a:xfrm>
+            <a:off x="713232" y="1801368"/>
+            <a:ext cx="6655003" cy="475488"/>
+          </a:xfrm>
+          <a:prstGeom prst="rect">
+            <a:avLst/>
+          </a:prstGeom>
+          <a:noFill/>
+          <a:ln/>
+        </p:spPr>
+        <p:txBody>
+          <a:bodyPr wrap="square" rtlCol="0" anchor="ctr"/>
+          <a:lstStyle/>
+          <a:p>
+            <a:pPr algn="l" indent="0" marL="0">
+              <a:buNone/>
+            </a:pPr>
+            <a:r>
+              <a:rPr lang="en-US" sz="1500" b="1" dirty="0">
+                <a:solidFill>
+                  <a:srgbClr val="1A1A2E"/>
+                </a:solidFill>
+                <a:latin typeface="游ゴシック" pitchFamily="34" charset="0"/>
+                <a:ea typeface="游ゴシック" pitchFamily="34" charset="-122"/>
+                <a:cs typeface="游ゴシック" pitchFamily="34" charset="-120"/>
+              </a:rPr>
+              <a:t>サンデーフォーク</a:t>
+            </a:r>
+            <a:endParaRPr lang="en-US" sz="1500" dirty="0"/>
+          </a:p>
+        </p:txBody>
+      </p:sp>
+      <p:sp>
+        <p:nvSpPr>
+          <p:cNvPr id="11" name="Text 9"/>
+          <p:cNvSpPr/>
+          <p:nvPr/>
+        </p:nvSpPr>
+        <p:spPr>
+          <a:xfrm>
+            <a:off x="7203643" y="1801368"/>
+            <a:ext cx="4214835" cy="475488"/>
+          </a:xfrm>
+          <a:prstGeom prst="rect">
+            <a:avLst/>
+          </a:prstGeom>
+          <a:noFill/>
+          <a:ln/>
+        </p:spPr>
+        <p:txBody>
+          <a:bodyPr wrap="square" rtlCol="0" anchor="ctr"/>
+          <a:lstStyle/>
+          <a:p>
+            <a:pPr algn="r" indent="0" marL="0">
+              <a:buNone/>
+            </a:pPr>
+            <a:r>
+              <a:rPr lang="en-US" sz="1700" b="1" dirty="0">
+                <a:solidFill>
+                  <a:srgbClr val="2563EB"/>
+                </a:solidFill>
+                <a:latin typeface="游ゴシック" pitchFamily="34" charset="0"/>
+                <a:ea typeface="游ゴシック" pitchFamily="34" charset="-122"/>
+                <a:cs typeface="游ゴシック" pitchFamily="34" charset="-120"/>
+              </a:rPr>
+              <a:t>17,808</a:t>
+            </a:r>
+            <a:endParaRPr lang="en-US" sz="1700" dirty="0"/>
+          </a:p>
+        </p:txBody>
+      </p:sp>
+      <p:sp>
+        <p:nvSpPr>
+          <p:cNvPr id="12" name="Shape 10"/>
+          <p:cNvSpPr/>
+          <p:nvPr/>
+        </p:nvSpPr>
+        <p:spPr>
+          <a:xfrm>
+            <a:off x="548640" y="2368296"/>
+            <a:ext cx="11091672" cy="475488"/>
+          </a:xfrm>
+          <a:prstGeom prst="rect">
+            <a:avLst/>
+          </a:prstGeom>
+          <a:solidFill>
+            <a:srgbClr val="F5F7FA"/>
+          </a:solidFill>
+          <a:ln/>
+        </p:spPr>
+      </p:sp>
+      <p:sp>
+        <p:nvSpPr>
+          <p:cNvPr id="13" name="Shape 11"/>
+          <p:cNvSpPr/>
+          <p:nvPr/>
+        </p:nvSpPr>
+        <p:spPr>
+          <a:xfrm>
+            <a:off x="548640" y="2368296"/>
+            <a:ext cx="41148" cy="475488"/>
+          </a:xfrm>
+          <a:prstGeom prst="rect">
+            <a:avLst/>
+          </a:prstGeom>
+          <a:solidFill>
+            <a:srgbClr val="E0E4EA"/>
+          </a:solidFill>
+          <a:ln/>
+        </p:spPr>
+      </p:sp>
+      <p:sp>
+        <p:nvSpPr>
+          <p:cNvPr id="14" name="Text 12"/>
+          <p:cNvSpPr/>
+          <p:nvPr/>
+        </p:nvSpPr>
+        <p:spPr>
+          <a:xfrm>
+            <a:off x="713232" y="2368296"/>
+            <a:ext cx="6655003" cy="475488"/>
+          </a:xfrm>
+          <a:prstGeom prst="rect">
+            <a:avLst/>
+          </a:prstGeom>
+          <a:noFill/>
+          <a:ln/>
+        </p:spPr>
+        <p:txBody>
+          <a:bodyPr wrap="square" rtlCol="0" anchor="ctr"/>
+          <a:lstStyle/>
+          <a:p>
+            <a:pPr algn="l" indent="0" marL="0">
+              <a:buNone/>
+            </a:pPr>
+            <a:r>
+              <a:rPr lang="en-US" sz="1500" dirty="0">
+                <a:solidFill>
+                  <a:srgbClr val="1A1A2E"/>
+                </a:solidFill>
+                <a:latin typeface="游ゴシック" pitchFamily="34" charset="0"/>
+                <a:ea typeface="游ゴシック" pitchFamily="34" charset="-122"/>
+                <a:cs typeface="游ゴシック" pitchFamily="34" charset="-120"/>
+              </a:rPr>
+              <a:t>スターリーナイト</a:t>
+            </a:r>
+            <a:endParaRPr lang="en-US" sz="1500" dirty="0"/>
+          </a:p>
+        </p:txBody>
+      </p:sp>
+      <p:sp>
+        <p:nvSpPr>
+          <p:cNvPr id="15" name="Text 13"/>
+          <p:cNvSpPr/>
+          <p:nvPr/>
+        </p:nvSpPr>
+        <p:spPr>
+          <a:xfrm>
+            <a:off x="7203643" y="2368296"/>
+            <a:ext cx="4214835" cy="475488"/>
+          </a:xfrm>
+          <a:prstGeom prst="rect">
+            <a:avLst/>
+          </a:prstGeom>
+          <a:noFill/>
+          <a:ln/>
+        </p:spPr>
+        <p:txBody>
+          <a:bodyPr wrap="square" rtlCol="0" anchor="ctr"/>
+          <a:lstStyle/>
+          <a:p>
+            <a:pPr algn="r" indent="0" marL="0">
+              <a:buNone/>
+            </a:pPr>
+            <a:r>
+              <a:rPr lang="en-US" sz="1700" b="1" dirty="0">
+                <a:solidFill>
+                  <a:srgbClr val="1A1A2E"/>
+                </a:solidFill>
+                <a:latin typeface="游ゴシック" pitchFamily="34" charset="0"/>
+                <a:ea typeface="游ゴシック" pitchFamily="34" charset="-122"/>
+                <a:cs typeface="游ゴシック" pitchFamily="34" charset="-120"/>
+              </a:rPr>
+              <a:t>2,708</a:t>
+            </a:r>
+            <a:endParaRPr lang="en-US" sz="1700" dirty="0"/>
+          </a:p>
+        </p:txBody>
+      </p:sp>
+      <p:sp>
+        <p:nvSpPr>
+          <p:cNvPr id="16" name="Shape 14"/>
+          <p:cNvSpPr/>
+          <p:nvPr/>
+        </p:nvSpPr>
+        <p:spPr>
+          <a:xfrm>
+            <a:off x="548640" y="2935224"/>
+            <a:ext cx="11091672" cy="475488"/>
+          </a:xfrm>
+          <a:prstGeom prst="rect">
+            <a:avLst/>
+          </a:prstGeom>
+          <a:solidFill>
+            <a:srgbClr val="F5F7FA"/>
+          </a:solidFill>
+          <a:ln/>
+        </p:spPr>
+      </p:sp>
+      <p:sp>
+        <p:nvSpPr>
+          <p:cNvPr id="17" name="Shape 15"/>
+          <p:cNvSpPr/>
+          <p:nvPr/>
+        </p:nvSpPr>
+        <p:spPr>
+          <a:xfrm>
+            <a:off x="548640" y="2935224"/>
+            <a:ext cx="41148" cy="475488"/>
+          </a:xfrm>
+          <a:prstGeom prst="rect">
+            <a:avLst/>
+          </a:prstGeom>
+          <a:solidFill>
+            <a:srgbClr val="E0E4EA"/>
+          </a:solidFill>
+          <a:ln/>
+        </p:spPr>
+      </p:sp>
+      <p:sp>
+        <p:nvSpPr>
+          <p:cNvPr id="18" name="Text 16"/>
+          <p:cNvSpPr/>
+          <p:nvPr/>
+        </p:nvSpPr>
+        <p:spPr>
+          <a:xfrm>
+            <a:off x="713232" y="2935224"/>
+            <a:ext cx="6655003" cy="475488"/>
+          </a:xfrm>
+          <a:prstGeom prst="rect">
+            <a:avLst/>
+          </a:prstGeom>
+          <a:noFill/>
+          <a:ln/>
+        </p:spPr>
+        <p:txBody>
+          <a:bodyPr wrap="square" rtlCol="0" anchor="ctr"/>
+          <a:lstStyle/>
+          <a:p>
+            <a:pPr algn="l" indent="0" marL="0">
+              <a:buNone/>
+            </a:pPr>
+            <a:r>
+              <a:rPr lang="en-US" sz="1500" dirty="0">
+                <a:solidFill>
+                  <a:srgbClr val="1A1A2E"/>
+                </a:solidFill>
+                <a:latin typeface="游ゴシック" pitchFamily="34" charset="0"/>
+                <a:ea typeface="游ゴシック" pitchFamily="34" charset="-122"/>
+                <a:cs typeface="游ゴシック" pitchFamily="34" charset="-120"/>
+              </a:rPr>
+              <a:t>ハマステージ</a:t>
+            </a:r>
+            <a:endParaRPr lang="en-US" sz="1500" dirty="0"/>
+          </a:p>
+        </p:txBody>
+      </p:sp>
+      <p:sp>
+        <p:nvSpPr>
+          <p:cNvPr id="19" name="Text 17"/>
+          <p:cNvSpPr/>
+          <p:nvPr/>
+        </p:nvSpPr>
+        <p:spPr>
+          <a:xfrm>
+            <a:off x="7203643" y="2935224"/>
+            <a:ext cx="4214835" cy="475488"/>
+          </a:xfrm>
+          <a:prstGeom prst="rect">
+            <a:avLst/>
+          </a:prstGeom>
+          <a:noFill/>
+          <a:ln/>
+        </p:spPr>
+        <p:txBody>
+          <a:bodyPr wrap="square" rtlCol="0" anchor="ctr"/>
+          <a:lstStyle/>
+          <a:p>
+            <a:pPr algn="r" indent="0" marL="0">
+              <a:buNone/>
+            </a:pPr>
+            <a:r>
+              <a:rPr lang="en-US" sz="1700" b="1" dirty="0">
+                <a:solidFill>
+                  <a:srgbClr val="1A1A2E"/>
+                </a:solidFill>
+                <a:latin typeface="游ゴシック" pitchFamily="34" charset="0"/>
+                <a:ea typeface="游ゴシック" pitchFamily="34" charset="-122"/>
+                <a:cs typeface="游ゴシック" pitchFamily="34" charset="-120"/>
+              </a:rPr>
+              <a:t>2,658</a:t>
+            </a:r>
+            <a:endParaRPr lang="en-US" sz="1700" dirty="0"/>
+          </a:p>
+        </p:txBody>
+      </p:sp>
+      <p:sp>
+        <p:nvSpPr>
+          <p:cNvPr id="20" name="Shape 18"/>
+          <p:cNvSpPr/>
+          <p:nvPr/>
+        </p:nvSpPr>
+        <p:spPr>
+          <a:xfrm>
+            <a:off x="548640" y="3502152"/>
+            <a:ext cx="11091672" cy="475488"/>
+          </a:xfrm>
+          <a:prstGeom prst="rect">
+            <a:avLst/>
+          </a:prstGeom>
+          <a:solidFill>
+            <a:srgbClr val="F5F7FA"/>
+          </a:solidFill>
+          <a:ln/>
+        </p:spPr>
+      </p:sp>
+      <p:sp>
+        <p:nvSpPr>
+          <p:cNvPr id="21" name="Shape 19"/>
+          <p:cNvSpPr/>
+          <p:nvPr/>
+        </p:nvSpPr>
+        <p:spPr>
+          <a:xfrm>
+            <a:off x="548640" y="3502152"/>
+            <a:ext cx="41148" cy="475488"/>
+          </a:xfrm>
+          <a:prstGeom prst="rect">
+            <a:avLst/>
+          </a:prstGeom>
+          <a:solidFill>
+            <a:srgbClr val="E0E4EA"/>
+          </a:solidFill>
+          <a:ln/>
+        </p:spPr>
+      </p:sp>
+      <p:sp>
+        <p:nvSpPr>
+          <p:cNvPr id="22" name="Text 20"/>
+          <p:cNvSpPr/>
+          <p:nvPr/>
+        </p:nvSpPr>
+        <p:spPr>
+          <a:xfrm>
+            <a:off x="713232" y="3502152"/>
+            <a:ext cx="6655003" cy="475488"/>
+          </a:xfrm>
+          <a:prstGeom prst="rect">
+            <a:avLst/>
+          </a:prstGeom>
+          <a:noFill/>
+          <a:ln/>
+        </p:spPr>
+        <p:txBody>
+          <a:bodyPr wrap="square" rtlCol="0" anchor="ctr"/>
+          <a:lstStyle/>
+          <a:p>
+            <a:pPr algn="l" indent="0" marL="0">
+              <a:buNone/>
+            </a:pPr>
+            <a:r>
+              <a:rPr lang="en-US" sz="1500" dirty="0">
+                <a:solidFill>
+                  <a:srgbClr val="1A1A2E"/>
+                </a:solidFill>
+                <a:latin typeface="游ゴシック" pitchFamily="34" charset="0"/>
+                <a:ea typeface="游ゴシック" pitchFamily="34" charset="-122"/>
+                <a:cs typeface="游ゴシック" pitchFamily="34" charset="-120"/>
+              </a:rPr>
+              <a:t>アークス</a:t>
+            </a:r>
+            <a:endParaRPr lang="en-US" sz="1500" dirty="0"/>
+          </a:p>
+        </p:txBody>
+      </p:sp>
+      <p:sp>
+        <p:nvSpPr>
+          <p:cNvPr id="23" name="Text 21"/>
+          <p:cNvSpPr/>
+          <p:nvPr/>
+        </p:nvSpPr>
+        <p:spPr>
+          <a:xfrm>
+            <a:off x="7203643" y="3502152"/>
+            <a:ext cx="4214835" cy="475488"/>
+          </a:xfrm>
+          <a:prstGeom prst="rect">
+            <a:avLst/>
+          </a:prstGeom>
+          <a:noFill/>
+          <a:ln/>
+        </p:spPr>
+        <p:txBody>
+          <a:bodyPr wrap="square" rtlCol="0" anchor="ctr"/>
+          <a:lstStyle/>
+          <a:p>
+            <a:pPr algn="r" indent="0" marL="0">
+              <a:buNone/>
+            </a:pPr>
+            <a:r>
+              <a:rPr lang="en-US" sz="1700" b="1" dirty="0">
+                <a:solidFill>
+                  <a:srgbClr val="1A1A2E"/>
+                </a:solidFill>
+                <a:latin typeface="游ゴシック" pitchFamily="34" charset="0"/>
+                <a:ea typeface="游ゴシック" pitchFamily="34" charset="-122"/>
+                <a:cs typeface="游ゴシック" pitchFamily="34" charset="-120"/>
+              </a:rPr>
+              <a:t>1,988</a:t>
+            </a:r>
+            <a:endParaRPr lang="en-US" sz="1700" dirty="0"/>
+          </a:p>
+        </p:txBody>
+      </p:sp>
+      <p:sp>
+        <p:nvSpPr>
+          <p:cNvPr id="24" name="Shape 22"/>
+          <p:cNvSpPr/>
+          <p:nvPr/>
+        </p:nvSpPr>
+        <p:spPr>
+          <a:xfrm>
+            <a:off x="548640" y="4069080"/>
+            <a:ext cx="11091672" cy="475488"/>
+          </a:xfrm>
+          <a:prstGeom prst="rect">
+            <a:avLst/>
+          </a:prstGeom>
+          <a:solidFill>
+            <a:srgbClr val="F5F7FA"/>
+          </a:solidFill>
+          <a:ln/>
+        </p:spPr>
+      </p:sp>
+      <p:sp>
+        <p:nvSpPr>
+          <p:cNvPr id="25" name="Shape 23"/>
+          <p:cNvSpPr/>
+          <p:nvPr/>
+        </p:nvSpPr>
+        <p:spPr>
+          <a:xfrm>
+            <a:off x="548640" y="4069080"/>
+            <a:ext cx="41148" cy="475488"/>
+          </a:xfrm>
+          <a:prstGeom prst="rect">
+            <a:avLst/>
+          </a:prstGeom>
+          <a:solidFill>
+            <a:srgbClr val="E0E4EA"/>
+          </a:solidFill>
+          <a:ln/>
+        </p:spPr>
+      </p:sp>
+      <p:sp>
+        <p:nvSpPr>
+          <p:cNvPr id="26" name="Text 24"/>
+          <p:cNvSpPr/>
+          <p:nvPr/>
+        </p:nvSpPr>
+        <p:spPr>
+          <a:xfrm>
+            <a:off x="713232" y="4069080"/>
+            <a:ext cx="6655003" cy="475488"/>
+          </a:xfrm>
+          <a:prstGeom prst="rect">
+            <a:avLst/>
+          </a:prstGeom>
+          <a:noFill/>
+          <a:ln/>
+        </p:spPr>
+        <p:txBody>
+          <a:bodyPr wrap="square" rtlCol="0" anchor="ctr"/>
+          <a:lstStyle/>
+          <a:p>
+            <a:pPr algn="l" indent="0" marL="0">
+              <a:buNone/>
+            </a:pPr>
+            <a:r>
+              <a:rPr lang="en-US" sz="1500" dirty="0">
+                <a:solidFill>
+                  <a:srgbClr val="1A1A2E"/>
+                </a:solidFill>
+                <a:latin typeface="游ゴシック" pitchFamily="34" charset="0"/>
+                <a:ea typeface="游ゴシック" pitchFamily="34" charset="-122"/>
+                <a:cs typeface="游ゴシック" pitchFamily="34" charset="-120"/>
+              </a:rPr>
+              <a:t>イーキューブ</a:t>
+            </a:r>
+            <a:endParaRPr lang="en-US" sz="1500" dirty="0"/>
+          </a:p>
+        </p:txBody>
+      </p:sp>
+      <p:sp>
+        <p:nvSpPr>
+          <p:cNvPr id="27" name="Text 25"/>
+          <p:cNvSpPr/>
+          <p:nvPr/>
+        </p:nvSpPr>
+        <p:spPr>
+          <a:xfrm>
+            <a:off x="7203643" y="4069080"/>
+            <a:ext cx="4214835" cy="475488"/>
+          </a:xfrm>
+          <a:prstGeom prst="rect">
+            <a:avLst/>
+          </a:prstGeom>
+          <a:noFill/>
+          <a:ln/>
+        </p:spPr>
+        <p:txBody>
+          <a:bodyPr wrap="square" rtlCol="0" anchor="ctr"/>
+          <a:lstStyle/>
+          <a:p>
+            <a:pPr algn="r" indent="0" marL="0">
+              <a:buNone/>
+            </a:pPr>
+            <a:r>
+              <a:rPr lang="en-US" sz="1700" b="1" dirty="0">
+                <a:solidFill>
+                  <a:srgbClr val="1A1A2E"/>
+                </a:solidFill>
+                <a:latin typeface="游ゴシック" pitchFamily="34" charset="0"/>
+                <a:ea typeface="游ゴシック" pitchFamily="34" charset="-122"/>
+                <a:cs typeface="游ゴシック" pitchFamily="34" charset="-120"/>
+              </a:rPr>
+              <a:t>1,608</a:t>
+            </a:r>
+            <a:endParaRPr lang="en-US" sz="1700" dirty="0"/>
+          </a:p>
+        </p:txBody>
+      </p:sp>
+    </p:spTree>
+  </p:cSld>
+  <p:clrMapOvr>
+    <a:masterClrMapping/>
+  </p:clrMapOvr>
+</p:sld>
+</file>
+
+<file path=ppt/slides/slide5.xml><?xml version="1.0" encoding="utf-8"?>
+<p:sld xmlns:a="http://schemas.openxmlformats.org/drawingml/2006/main" xmlns:r="http://schemas.openxmlformats.org/officeDocument/2006/relationships" xmlns:p="http://schemas.openxmlformats.org/presentationml/2006/main">
+  <p:cSld name="Slide 5">
+    <p:bg>
+      <p:bgPr>
+        <a:solidFill>
+          <a:srgbClr val="FFFFFF"/>
+        </a:solidFill>
+      </p:bgPr>
+    </p:bg>
+    <p:spTree>
+      <p:nvGrpSpPr>
+        <p:cNvPr id="1" name=""/>
+        <p:cNvGrpSpPr/>
+        <p:nvPr/>
+      </p:nvGrpSpPr>
+      <p:grpSpPr>
+        <a:xfrm>
+          <a:off x="0" y="0"/>
+          <a:ext cx="0" cy="0"/>
+          <a:chOff x="0" y="0"/>
+          <a:chExt cx="0" cy="0"/>
+        </a:xfrm>
+      </p:grpSpPr>
+      <p:sp>
+        <p:nvSpPr>
+          <p:cNvPr id="2" name="Text 0"/>
+          <p:cNvSpPr/>
+          <p:nvPr/>
+        </p:nvSpPr>
+        <p:spPr>
+          <a:xfrm>
+            <a:off x="548640" y="274320"/>
+            <a:ext cx="11091672" cy="594360"/>
+          </a:xfrm>
+          <a:prstGeom prst="rect">
+            <a:avLst/>
+          </a:prstGeom>
+          <a:noFill/>
+          <a:ln/>
+        </p:spPr>
+        <p:txBody>
+          <a:bodyPr wrap="square" rtlCol="0" anchor="t"/>
+          <a:lstStyle/>
+          <a:p>
+            <a:pPr algn="l" indent="0" marL="0">
+              <a:buNone/>
+            </a:pPr>
+            <a:r>
+              <a:rPr lang="en-US" sz="2600" b="1" dirty="0">
+                <a:solidFill>
+                  <a:srgbClr val="1A1A2E"/>
+                </a:solidFill>
+                <a:latin typeface="游ゴシック" pitchFamily="34" charset="0"/>
+                <a:ea typeface="游ゴシック" pitchFamily="34" charset="-122"/>
+                <a:cs typeface="游ゴシック" pitchFamily="34" charset="-120"/>
+              </a:rPr>
               <a:t>区民祭り 受注管理（10区）</a:t>
             </a:r>
             <a:endParaRPr lang="en-US" sz="2600" dirty="0"/>

</xml_diff>